<commit_message>
changed help document and font for input boxes
</commit_message>
<xml_diff>
--- a/ExtractCautionsForEM/bin/Debug/bin/ExtractCautionsFromEngineManualTool.pptx
+++ b/ExtractCautionsForEM/bin/Debug/bin/ExtractCautionsFromEngineManualTool.pptx
@@ -18,9 +18,9 @@
     <p:sldId id="964" r:id="rId9"/>
     <p:sldId id="928" r:id="rId10"/>
     <p:sldId id="966" r:id="rId11"/>
-    <p:sldId id="967" r:id="rId12"/>
-    <p:sldId id="968" r:id="rId13"/>
-    <p:sldId id="962" r:id="rId14"/>
+    <p:sldId id="968" r:id="rId12"/>
+    <p:sldId id="969" r:id="rId13"/>
+    <p:sldId id="970" r:id="rId14"/>
     <p:sldId id="960" r:id="rId15"/>
     <p:sldId id="961" r:id="rId16"/>
     <p:sldId id="840" r:id="rId17"/>
@@ -341,7 +341,7 @@
               <a:pPr>
                 <a:defRPr/>
               </a:pPr>
-              <a:t>8/18/2026</a:t>
+              <a:t>8/19/2026</a:t>
             </a:fld>
             <a:endParaRPr lang="en-GB" dirty="0"/>
           </a:p>
@@ -559,7 +559,7 @@
               <a:pPr>
                 <a:defRPr/>
               </a:pPr>
-              <a:t>8/18/2026</a:t>
+              <a:t>8/19/2026</a:t>
             </a:fld>
             <a:endParaRPr lang="en-GB" dirty="0"/>
           </a:p>
@@ -1541,103 +1541,6 @@
             <p:ph type="sldImg"/>
           </p:nvPr>
         </p:nvSpPr>
-        <p:spPr>
-          <a:xfrm>
-            <a:off x="420688" y="744538"/>
-            <a:ext cx="5956300" cy="3722687"/>
-          </a:xfrm>
-        </p:spPr>
-        <p:txBody>
-          <a:bodyPr/>
-          <a:lstStyle/>
-          <a:p>
-            <a:endParaRPr lang="en-US"/>
-          </a:p>
-        </p:txBody>
-      </p:sp>
-      <p:sp>
-        <p:nvSpPr>
-          <p:cNvPr id="3" name="Notes Placeholder 2"/>
-          <p:cNvSpPr>
-            <a:spLocks noGrp="1"/>
-          </p:cNvSpPr>
-          <p:nvPr>
-            <p:ph type="body" idx="1"/>
-          </p:nvPr>
-        </p:nvSpPr>
-        <p:spPr/>
-        <p:txBody>
-          <a:bodyPr/>
-          <a:lstStyle/>
-          <a:p>
-            <a:endParaRPr lang="en-US" dirty="0"/>
-          </a:p>
-        </p:txBody>
-      </p:sp>
-      <p:sp>
-        <p:nvSpPr>
-          <p:cNvPr id="4" name="Slide Number Placeholder 3"/>
-          <p:cNvSpPr>
-            <a:spLocks noGrp="1"/>
-          </p:cNvSpPr>
-          <p:nvPr>
-            <p:ph type="sldNum" sz="quarter" idx="10"/>
-          </p:nvPr>
-        </p:nvSpPr>
-        <p:spPr/>
-        <p:txBody>
-          <a:bodyPr/>
-          <a:lstStyle/>
-          <a:p>
-            <a:fld id="{32B34421-655C-4564-82BB-49845E235FC0}" type="slidenum">
-              <a:rPr lang="en-GB" altLang="en-US" smtClean="0"/>
-              <a:pPr/>
-              <a:t>9</a:t>
-            </a:fld>
-            <a:endParaRPr lang="en-GB" altLang="en-US"/>
-          </a:p>
-        </p:txBody>
-      </p:sp>
-    </p:spTree>
-    <p:extLst>
-      <p:ext uri="{BB962C8B-B14F-4D97-AF65-F5344CB8AC3E}">
-        <p14:creationId xmlns:p14="http://schemas.microsoft.com/office/powerpoint/2010/main" val="1449990888"/>
-      </p:ext>
-    </p:extLst>
-  </p:cSld>
-  <p:clrMapOvr>
-    <a:masterClrMapping/>
-  </p:clrMapOvr>
-</p:notes>
-</file>
-
-<file path=ppt/notesSlides/notesSlide7.xml><?xml version="1.0" encoding="utf-8"?>
-<p:notes xmlns:a="http://schemas.openxmlformats.org/drawingml/2006/main" xmlns:r="http://schemas.openxmlformats.org/officeDocument/2006/relationships" xmlns:p="http://schemas.openxmlformats.org/presentationml/2006/main">
-  <p:cSld>
-    <p:spTree>
-      <p:nvGrpSpPr>
-        <p:cNvPr id="1" name=""/>
-        <p:cNvGrpSpPr/>
-        <p:nvPr/>
-      </p:nvGrpSpPr>
-      <p:grpSpPr>
-        <a:xfrm>
-          <a:off x="0" y="0"/>
-          <a:ext cx="0" cy="0"/>
-          <a:chOff x="0" y="0"/>
-          <a:chExt cx="0" cy="0"/>
-        </a:xfrm>
-      </p:grpSpPr>
-      <p:sp>
-        <p:nvSpPr>
-          <p:cNvPr id="2" name="Slide Image Placeholder 1"/>
-          <p:cNvSpPr>
-            <a:spLocks noGrp="1" noRot="1" noChangeAspect="1"/>
-          </p:cNvSpPr>
-          <p:nvPr>
-            <p:ph type="sldImg"/>
-          </p:nvPr>
-        </p:nvSpPr>
         <p:spPr/>
         <p:txBody>
           <a:bodyPr/>
@@ -3393,7 +3296,7 @@
               <a:pPr eaLnBrk="1" hangingPunct="1">
                 <a:defRPr/>
               </a:pPr>
-              <a:t>8/18/2026</a:t>
+              <a:t>8/19/2026</a:t>
             </a:fld>
             <a:endParaRPr lang="en-GB" dirty="0">
               <a:solidFill>
@@ -3827,7 +3730,7 @@
               <a:pPr eaLnBrk="1" hangingPunct="1">
                 <a:defRPr/>
               </a:pPr>
-              <a:t>8/18/2026</a:t>
+              <a:t>8/19/2026</a:t>
             </a:fld>
             <a:endParaRPr lang="en-GB" dirty="0">
               <a:solidFill>
@@ -4285,7 +4188,7 @@
               <a:pPr eaLnBrk="1" hangingPunct="1">
                 <a:defRPr/>
               </a:pPr>
-              <a:t>8/18/2026</a:t>
+              <a:t>8/19/2026</a:t>
             </a:fld>
             <a:endParaRPr lang="en-GB" dirty="0">
               <a:solidFill>
@@ -4715,7 +4618,7 @@
               <a:pPr eaLnBrk="1" hangingPunct="1">
                 <a:defRPr/>
               </a:pPr>
-              <a:t>8/18/2026</a:t>
+              <a:t>8/19/2026</a:t>
             </a:fld>
             <a:endParaRPr lang="en-GB" dirty="0">
               <a:solidFill>
@@ -5322,7 +5225,7 @@
               <a:pPr eaLnBrk="1" hangingPunct="1">
                 <a:defRPr/>
               </a:pPr>
-              <a:t>8/18/2026</a:t>
+              <a:t>8/19/2026</a:t>
             </a:fld>
             <a:endParaRPr lang="en-GB" dirty="0">
               <a:solidFill>
@@ -8734,7 +8637,7 @@
               <a:pPr eaLnBrk="1" hangingPunct="1">
                 <a:defRPr/>
               </a:pPr>
-              <a:t>8/18/2026</a:t>
+              <a:t>8/19/2026</a:t>
             </a:fld>
             <a:endParaRPr lang="en-GB" dirty="0">
               <a:solidFill>
@@ -9549,7 +9452,7 @@
               <a:pPr eaLnBrk="1" hangingPunct="1">
                 <a:defRPr/>
               </a:pPr>
-              <a:t>8/18/2026</a:t>
+              <a:t>8/19/2026</a:t>
             </a:fld>
             <a:endParaRPr lang="en-GB" dirty="0">
               <a:solidFill>
@@ -10370,7 +10273,7 @@
               <a:pPr eaLnBrk="1" hangingPunct="1">
                 <a:defRPr/>
               </a:pPr>
-              <a:t>8/18/2026</a:t>
+              <a:t>8/19/2026</a:t>
             </a:fld>
             <a:endParaRPr lang="en-GB" dirty="0">
               <a:solidFill>
@@ -12222,7 +12125,7 @@
               <a:pPr eaLnBrk="1" hangingPunct="1">
                 <a:defRPr/>
               </a:pPr>
-              <a:t>8/18/2026</a:t>
+              <a:t>8/19/2026</a:t>
             </a:fld>
             <a:endParaRPr lang="en-GB" dirty="0">
               <a:solidFill>
@@ -12743,7 +12646,7 @@
               <a:pPr eaLnBrk="1" hangingPunct="1">
                 <a:defRPr/>
               </a:pPr>
-              <a:t>8/18/2026</a:t>
+              <a:t>8/19/2026</a:t>
             </a:fld>
             <a:endParaRPr lang="en-GB" dirty="0">
               <a:solidFill>
@@ -13265,7 +13168,7 @@
               <a:pPr eaLnBrk="1" hangingPunct="1">
                 <a:defRPr/>
               </a:pPr>
-              <a:t>8/18/2026</a:t>
+              <a:t>8/19/2026</a:t>
             </a:fld>
             <a:endParaRPr lang="en-GB" dirty="0">
               <a:solidFill>
@@ -14893,7 +14796,7 @@
               <a:pPr eaLnBrk="1" hangingPunct="1">
                 <a:defRPr/>
               </a:pPr>
-              <a:t>8/18/2026</a:t>
+              <a:t>8/19/2026</a:t>
             </a:fld>
             <a:endParaRPr lang="en-GB" dirty="0">
               <a:solidFill>
@@ -17409,7 +17312,7 @@
               <a:pPr eaLnBrk="1" hangingPunct="1">
                 <a:defRPr/>
               </a:pPr>
-              <a:t>8/18/2026</a:t>
+              <a:t>8/19/2026</a:t>
             </a:fld>
             <a:endParaRPr lang="en-GB" dirty="0">
               <a:solidFill>
@@ -17987,7 +17890,7 @@
               <a:pPr eaLnBrk="1" hangingPunct="1">
                 <a:defRPr/>
               </a:pPr>
-              <a:t>8/18/2026</a:t>
+              <a:t>8/19/2026</a:t>
             </a:fld>
             <a:endParaRPr lang="en-GB" dirty="0">
               <a:solidFill>
@@ -18702,7 +18605,7 @@
               <a:pPr eaLnBrk="1" hangingPunct="1">
                 <a:defRPr/>
               </a:pPr>
-              <a:t>8/18/2026</a:t>
+              <a:t>8/19/2026</a:t>
             </a:fld>
             <a:endParaRPr lang="en-GB" dirty="0">
               <a:solidFill>
@@ -19414,7 +19317,7 @@
               <a:pPr eaLnBrk="1" hangingPunct="1">
                 <a:defRPr/>
               </a:pPr>
-              <a:t>8/18/2026</a:t>
+              <a:t>8/19/2026</a:t>
             </a:fld>
             <a:endParaRPr lang="en-GB" dirty="0">
               <a:solidFill>
@@ -19848,7 +19751,7 @@
               <a:pPr eaLnBrk="1" hangingPunct="1">
                 <a:defRPr/>
               </a:pPr>
-              <a:t>8/18/2026</a:t>
+              <a:t>8/19/2026</a:t>
             </a:fld>
             <a:endParaRPr lang="en-GB" dirty="0">
               <a:solidFill>
@@ -20306,7 +20209,7 @@
               <a:pPr eaLnBrk="1" hangingPunct="1">
                 <a:defRPr/>
               </a:pPr>
-              <a:t>8/18/2026</a:t>
+              <a:t>8/19/2026</a:t>
             </a:fld>
             <a:endParaRPr lang="en-GB" dirty="0">
               <a:solidFill>
@@ -21919,7 +21822,7 @@
               <a:pPr eaLnBrk="1" hangingPunct="1">
                 <a:defRPr/>
               </a:pPr>
-              <a:t>8/18/2026</a:t>
+              <a:t>8/19/2026</a:t>
             </a:fld>
             <a:endParaRPr lang="en-GB" dirty="0">
               <a:solidFill>
@@ -27540,7 +27443,7 @@
               <a:pPr eaLnBrk="1" hangingPunct="1">
                 <a:defRPr/>
               </a:pPr>
-              <a:t>8/18/2026</a:t>
+              <a:t>8/19/2026</a:t>
             </a:fld>
             <a:endParaRPr lang="en-GB" dirty="0">
               <a:solidFill>
@@ -30056,7 +29959,7 @@
               <a:pPr eaLnBrk="1" hangingPunct="1">
                 <a:defRPr/>
               </a:pPr>
-              <a:t>8/18/2026</a:t>
+              <a:t>8/19/2026</a:t>
             </a:fld>
             <a:endParaRPr lang="en-GB" dirty="0">
               <a:solidFill>
@@ -30634,7 +30537,7 @@
               <a:pPr eaLnBrk="1" hangingPunct="1">
                 <a:defRPr/>
               </a:pPr>
-              <a:t>8/18/2026</a:t>
+              <a:t>8/19/2026</a:t>
             </a:fld>
             <a:endParaRPr lang="en-GB" dirty="0">
               <a:solidFill>
@@ -31349,7 +31252,7 @@
               <a:pPr eaLnBrk="1" hangingPunct="1">
                 <a:defRPr/>
               </a:pPr>
-              <a:t>8/18/2026</a:t>
+              <a:t>8/19/2026</a:t>
             </a:fld>
             <a:endParaRPr lang="en-GB" dirty="0">
               <a:solidFill>
@@ -35765,7 +35668,7 @@
           <p:nvPr>
             <p:extLst>
               <p:ext uri="{D42A27DB-BD31-4B8C-83A1-F6EECF244321}">
-                <p14:modId xmlns:p14="http://schemas.microsoft.com/office/powerpoint/2010/main" val="186655459"/>
+                <p14:modId xmlns:p14="http://schemas.microsoft.com/office/powerpoint/2010/main" val="4067141589"/>
               </p:ext>
             </p:extLst>
           </p:nvPr>
@@ -35886,7 +35789,7 @@
                           <a:cs typeface="Arial" panose="020B0604020202020204" pitchFamily="34" charset="0"/>
                           <a:hlinkClick r:id="rId3" action="ppaction://hlinksldjump"/>
                         </a:rPr>
-                        <a:t>Objectives and background </a:t>
+                        <a:t>Background and Objective </a:t>
                       </a:r>
                       <a:endParaRPr lang="en-US" sz="1300" b="0" u="sng" kern="1200" dirty="0">
                         <a:solidFill>
@@ -36108,7 +36011,7 @@
                         <a:rPr lang="en-US" sz="1300" u="sng" dirty="0">
                           <a:hlinkClick r:id="rId5" action="ppaction://hlinksldjump"/>
                         </a:rPr>
-                        <a:t>5</a:t>
+                        <a:t>5-6</a:t>
                       </a:r>
                       <a:endParaRPr lang="en-US" sz="1300" u="sng" dirty="0"/>
                     </a:p>
@@ -36168,7 +36071,7 @@
                         <a:rPr lang="en-US" sz="1300" u="sng" dirty="0">
                           <a:hlinkClick r:id="rId6" action="ppaction://hlinksldjump"/>
                         </a:rPr>
-                        <a:t>6</a:t>
+                        <a:t>7</a:t>
                       </a:r>
                       <a:endParaRPr lang="en-US" sz="1300" u="sng" dirty="0"/>
                     </a:p>
@@ -36261,7 +36164,7 @@
                         <a:rPr lang="en-US" sz="1300" u="sng" dirty="0">
                           <a:hlinkClick r:id="rId7" action="ppaction://hlinksldjump"/>
                         </a:rPr>
-                        <a:t>7</a:t>
+                        <a:t>8-9</a:t>
                       </a:r>
                       <a:endParaRPr lang="en-US" sz="1300" u="sng" dirty="0"/>
                     </a:p>
@@ -36311,7 +36214,7 @@
                         <a:defRPr/>
                       </a:pPr>
                       <a:r>
-                        <a:rPr lang="en-US" sz="1300" b="0" u="sng" kern="1200" dirty="0">
+                        <a:rPr lang="en-US" sz="1300" b="0" u="sng" kern="1200">
                           <a:solidFill>
                             <a:schemeClr val="dk1"/>
                           </a:solidFill>
@@ -36319,8 +36222,16 @@
                           <a:ea typeface="+mn-ea"/>
                           <a:cs typeface="Arial" panose="020B0604020202020204" pitchFamily="34" charset="0"/>
                         </a:rPr>
-                        <a:t>Outputs</a:t>
+                        <a:t>Output</a:t>
                       </a:r>
+                      <a:endParaRPr lang="en-US" sz="1300" b="0" u="sng" kern="1200" dirty="0">
+                        <a:solidFill>
+                          <a:schemeClr val="dk1"/>
+                        </a:solidFill>
+                        <a:latin typeface="Arial" panose="020B0604020202020204" pitchFamily="34" charset="0"/>
+                        <a:ea typeface="+mn-ea"/>
+                        <a:cs typeface="Arial" panose="020B0604020202020204" pitchFamily="34" charset="0"/>
+                      </a:endParaRPr>
                     </a:p>
                   </a:txBody>
                   <a:tcPr/>
@@ -36334,7 +36245,7 @@
                         <a:rPr lang="en-US" u="sng" dirty="0">
                           <a:hlinkClick r:id="rId8" action="ppaction://hlinksldjump"/>
                         </a:rPr>
-                        <a:t>8</a:t>
+                        <a:t>10</a:t>
                       </a:r>
                       <a:endParaRPr lang="en-US" u="sng" dirty="0"/>
                     </a:p>
@@ -36407,7 +36318,7 @@
                         <a:rPr lang="en-US" u="sng" dirty="0">
                           <a:hlinkClick r:id="rId9" action="ppaction://hlinksldjump"/>
                         </a:rPr>
-                        <a:t>9</a:t>
+                        <a:t>11</a:t>
                       </a:r>
                       <a:endParaRPr lang="en-US" u="sng" dirty="0"/>
                     </a:p>
@@ -38269,1007 +38180,6 @@
           <p:cNvPr id="4" name="Slide Number Placeholder 3">
             <a:extLst>
               <a:ext uri="{FF2B5EF4-FFF2-40B4-BE49-F238E27FC236}">
-                <a16:creationId xmlns:a16="http://schemas.microsoft.com/office/drawing/2014/main" id="{37190AB7-4611-CF18-E90A-A89ECAE92FD7}"/>
-              </a:ext>
-            </a:extLst>
-          </p:cNvPr>
-          <p:cNvSpPr>
-            <a:spLocks noGrp="1"/>
-          </p:cNvSpPr>
-          <p:nvPr>
-            <p:ph type="sldNum" sz="quarter" idx="14"/>
-          </p:nvPr>
-        </p:nvSpPr>
-        <p:spPr/>
-        <p:txBody>
-          <a:bodyPr/>
-          <a:lstStyle/>
-          <a:p>
-            <a:fld id="{8A4A04CF-1BC9-4C63-AE06-A38D4D08020F}" type="slidenum">
-              <a:rPr lang="en-GB" altLang="en-US" smtClean="0"/>
-              <a:pPr/>
-              <a:t>7</a:t>
-            </a:fld>
-            <a:endParaRPr lang="en-GB" altLang="en-US" dirty="0"/>
-          </a:p>
-        </p:txBody>
-      </p:sp>
-      <p:pic>
-        <p:nvPicPr>
-          <p:cNvPr id="6" name="Picture 5">
-            <a:extLst>
-              <a:ext uri="{FF2B5EF4-FFF2-40B4-BE49-F238E27FC236}">
-                <a16:creationId xmlns:a16="http://schemas.microsoft.com/office/drawing/2014/main" id="{33BA9F1F-AAAE-BB87-BF6D-9A0995C176E0}"/>
-              </a:ext>
-            </a:extLst>
-          </p:cNvPr>
-          <p:cNvPicPr>
-            <a:picLocks noChangeAspect="1"/>
-          </p:cNvPicPr>
-          <p:nvPr/>
-        </p:nvPicPr>
-        <p:blipFill>
-          <a:blip r:embed="rId2"/>
-          <a:stretch>
-            <a:fillRect/>
-          </a:stretch>
-        </p:blipFill>
-        <p:spPr>
-          <a:xfrm>
-            <a:off x="513783" y="1419024"/>
-            <a:ext cx="8116433" cy="2876951"/>
-          </a:xfrm>
-          <a:prstGeom prst="rect">
-            <a:avLst/>
-          </a:prstGeom>
-        </p:spPr>
-      </p:pic>
-      <p:sp>
-        <p:nvSpPr>
-          <p:cNvPr id="7" name="Content Placeholder 4">
-            <a:extLst>
-              <a:ext uri="{FF2B5EF4-FFF2-40B4-BE49-F238E27FC236}">
-                <a16:creationId xmlns:a16="http://schemas.microsoft.com/office/drawing/2014/main" id="{15CAB771-F840-70F2-B604-F2770598908E}"/>
-              </a:ext>
-            </a:extLst>
-          </p:cNvPr>
-          <p:cNvSpPr txBox="1">
-            <a:spLocks/>
-          </p:cNvSpPr>
-          <p:nvPr/>
-        </p:nvSpPr>
-        <p:spPr bwMode="auto">
-          <a:xfrm>
-            <a:off x="5958845" y="1061958"/>
-            <a:ext cx="1682553" cy="173038"/>
-          </a:xfrm>
-          <a:prstGeom prst="rect">
-            <a:avLst/>
-          </a:prstGeom>
-          <a:noFill/>
-          <a:ln>
-            <a:noFill/>
-          </a:ln>
-          <a:extLst>
-            <a:ext uri="{909E8E84-426E-40DD-AFC4-6F175D3DCCD1}">
-              <a14:hiddenFill xmlns:a14="http://schemas.microsoft.com/office/drawing/2010/main">
-                <a:solidFill>
-                  <a:srgbClr val="FFFFFF"/>
-                </a:solidFill>
-              </a14:hiddenFill>
-            </a:ext>
-            <a:ext uri="{91240B29-F687-4F45-9708-019B960494DF}">
-              <a14:hiddenLine xmlns:a14="http://schemas.microsoft.com/office/drawing/2010/main" w="9525">
-                <a:solidFill>
-                  <a:srgbClr val="000000"/>
-                </a:solidFill>
-                <a:miter lim="800000"/>
-                <a:headEnd/>
-                <a:tailEnd/>
-              </a14:hiddenLine>
-            </a:ext>
-          </a:extLst>
-        </p:spPr>
-        <p:txBody>
-          <a:bodyPr vert="horz" wrap="square" lIns="0" tIns="0" rIns="0" bIns="0" numCol="1" anchor="t" anchorCtr="0" compatLnSpc="1">
-            <a:prstTxWarp prst="textNoShape">
-              <a:avLst/>
-            </a:prstTxWarp>
-            <a:noAutofit/>
-          </a:bodyPr>
-          <a:lstStyle>
-            <a:lvl1pPr marL="342900" indent="-342900" algn="l" defTabSz="685800" rtl="0" eaLnBrk="0" fontAlgn="base" hangingPunct="0">
-              <a:lnSpc>
-                <a:spcPct val="90000"/>
-              </a:lnSpc>
-              <a:spcBef>
-                <a:spcPct val="0"/>
-              </a:spcBef>
-              <a:spcAft>
-                <a:spcPts val="600"/>
-              </a:spcAft>
-              <a:defRPr sz="1800" b="1" kern="1200">
-                <a:solidFill>
-                  <a:srgbClr val="00A5DF"/>
-                </a:solidFill>
-                <a:latin typeface="+mn-lt"/>
-                <a:ea typeface="MS PGothic" pitchFamily="34" charset="-128"/>
-                <a:cs typeface="ＭＳ Ｐゴシック" charset="0"/>
-              </a:defRPr>
-            </a:lvl1pPr>
-            <a:lvl2pPr marL="742950" indent="-285750" algn="l" defTabSz="685800" rtl="0" eaLnBrk="0" fontAlgn="base" hangingPunct="0">
-              <a:lnSpc>
-                <a:spcPct val="90000"/>
-              </a:lnSpc>
-              <a:spcBef>
-                <a:spcPct val="0"/>
-              </a:spcBef>
-              <a:spcAft>
-                <a:spcPts val="600"/>
-              </a:spcAft>
-              <a:buSzPct val="80000"/>
-              <a:buFont typeface="Arial" panose="020B0604020202020204" pitchFamily="34" charset="0"/>
-              <a:defRPr sz="1800" kern="1200">
-                <a:solidFill>
-                  <a:srgbClr val="00A5DF"/>
-                </a:solidFill>
-                <a:latin typeface="+mn-lt"/>
-                <a:ea typeface="MS PGothic" pitchFamily="34" charset="-128"/>
-                <a:cs typeface="+mn-cs"/>
-              </a:defRPr>
-            </a:lvl2pPr>
-            <a:lvl3pPr marL="180975" indent="-180975" algn="l" defTabSz="685800" rtl="0" eaLnBrk="0" fontAlgn="base" hangingPunct="0">
-              <a:lnSpc>
-                <a:spcPct val="90000"/>
-              </a:lnSpc>
-              <a:spcBef>
-                <a:spcPct val="0"/>
-              </a:spcBef>
-              <a:spcAft>
-                <a:spcPts val="600"/>
-              </a:spcAft>
-              <a:buSzPct val="100000"/>
-              <a:buFont typeface="Lucida Grande"/>
-              <a:buChar char="-"/>
-              <a:defRPr sz="1800" kern="1200">
-                <a:solidFill>
-                  <a:srgbClr val="00A5DF"/>
-                </a:solidFill>
-                <a:latin typeface="+mn-lt"/>
-                <a:ea typeface="MS PGothic" pitchFamily="34" charset="-128"/>
-                <a:cs typeface="+mn-cs"/>
-              </a:defRPr>
-            </a:lvl3pPr>
-            <a:lvl4pPr marL="363538" indent="-182563" algn="l" defTabSz="685800" rtl="0" eaLnBrk="0" fontAlgn="base" hangingPunct="0">
-              <a:lnSpc>
-                <a:spcPct val="90000"/>
-              </a:lnSpc>
-              <a:spcBef>
-                <a:spcPct val="0"/>
-              </a:spcBef>
-              <a:spcAft>
-                <a:spcPts val="600"/>
-              </a:spcAft>
-              <a:buSzPct val="100000"/>
-              <a:buFont typeface="Lucida Grande"/>
-              <a:buChar char="-"/>
-              <a:defRPr sz="1800" kern="1200">
-                <a:solidFill>
-                  <a:srgbClr val="00A5DF"/>
-                </a:solidFill>
-                <a:latin typeface="+mn-lt"/>
-                <a:ea typeface="MS PGothic" pitchFamily="34" charset="-128"/>
-                <a:cs typeface="+mn-cs"/>
-              </a:defRPr>
-            </a:lvl4pPr>
-            <a:lvl5pPr marL="534988" indent="-171450" algn="l" defTabSz="685800" rtl="0" eaLnBrk="0" fontAlgn="base" hangingPunct="0">
-              <a:lnSpc>
-                <a:spcPct val="90000"/>
-              </a:lnSpc>
-              <a:spcBef>
-                <a:spcPct val="0"/>
-              </a:spcBef>
-              <a:spcAft>
-                <a:spcPts val="600"/>
-              </a:spcAft>
-              <a:buSzPct val="100000"/>
-              <a:buFont typeface="Lucida Grande"/>
-              <a:buChar char="-"/>
-              <a:defRPr sz="1800" kern="1200">
-                <a:solidFill>
-                  <a:srgbClr val="00A5DF"/>
-                </a:solidFill>
-                <a:latin typeface="+mn-lt"/>
-                <a:ea typeface="MS PGothic" pitchFamily="34" charset="-128"/>
-                <a:cs typeface="+mn-cs"/>
-              </a:defRPr>
-            </a:lvl5pPr>
-            <a:lvl6pPr marL="1885950" indent="-171450" algn="l" defTabSz="685800" rtl="0" eaLnBrk="1" latinLnBrk="0" hangingPunct="1">
-              <a:lnSpc>
-                <a:spcPct val="90000"/>
-              </a:lnSpc>
-              <a:spcBef>
-                <a:spcPts val="375"/>
-              </a:spcBef>
-              <a:buFont typeface="Arial" panose="020B0604020202020204" pitchFamily="34" charset="0"/>
-              <a:buChar char="•"/>
-              <a:defRPr sz="1350" kern="1200">
-                <a:solidFill>
-                  <a:schemeClr val="tx1"/>
-                </a:solidFill>
-                <a:latin typeface="+mn-lt"/>
-                <a:ea typeface="+mn-ea"/>
-                <a:cs typeface="+mn-cs"/>
-              </a:defRPr>
-            </a:lvl6pPr>
-            <a:lvl7pPr marL="2228850" indent="-171450" algn="l" defTabSz="685800" rtl="0" eaLnBrk="1" latinLnBrk="0" hangingPunct="1">
-              <a:lnSpc>
-                <a:spcPct val="90000"/>
-              </a:lnSpc>
-              <a:spcBef>
-                <a:spcPts val="375"/>
-              </a:spcBef>
-              <a:buFont typeface="Arial" panose="020B0604020202020204" pitchFamily="34" charset="0"/>
-              <a:buChar char="•"/>
-              <a:defRPr sz="1350" kern="1200">
-                <a:solidFill>
-                  <a:schemeClr val="tx1"/>
-                </a:solidFill>
-                <a:latin typeface="+mn-lt"/>
-                <a:ea typeface="+mn-ea"/>
-                <a:cs typeface="+mn-cs"/>
-              </a:defRPr>
-            </a:lvl7pPr>
-            <a:lvl8pPr marL="2571750" indent="-171450" algn="l" defTabSz="685800" rtl="0" eaLnBrk="1" latinLnBrk="0" hangingPunct="1">
-              <a:lnSpc>
-                <a:spcPct val="90000"/>
-              </a:lnSpc>
-              <a:spcBef>
-                <a:spcPts val="375"/>
-              </a:spcBef>
-              <a:buFont typeface="Arial" panose="020B0604020202020204" pitchFamily="34" charset="0"/>
-              <a:buChar char="•"/>
-              <a:defRPr sz="1350" kern="1200">
-                <a:solidFill>
-                  <a:schemeClr val="tx1"/>
-                </a:solidFill>
-                <a:latin typeface="+mn-lt"/>
-                <a:ea typeface="+mn-ea"/>
-                <a:cs typeface="+mn-cs"/>
-              </a:defRPr>
-            </a:lvl8pPr>
-            <a:lvl9pPr marL="2914650" indent="-171450" algn="l" defTabSz="685800" rtl="0" eaLnBrk="1" latinLnBrk="0" hangingPunct="1">
-              <a:lnSpc>
-                <a:spcPct val="90000"/>
-              </a:lnSpc>
-              <a:spcBef>
-                <a:spcPts val="375"/>
-              </a:spcBef>
-              <a:buFont typeface="Arial" panose="020B0604020202020204" pitchFamily="34" charset="0"/>
-              <a:buChar char="•"/>
-              <a:defRPr sz="1350" kern="1200">
-                <a:solidFill>
-                  <a:schemeClr val="tx1"/>
-                </a:solidFill>
-                <a:latin typeface="+mn-lt"/>
-                <a:ea typeface="+mn-ea"/>
-                <a:cs typeface="+mn-cs"/>
-              </a:defRPr>
-            </a:lvl9pPr>
-          </a:lstStyle>
-          <a:p>
-            <a:pPr marL="0" indent="0"/>
-            <a:r>
-              <a:rPr lang="en-US" sz="1400" dirty="0">
-                <a:solidFill>
-                  <a:schemeClr val="bg2">
-                    <a:lumMod val="10000"/>
-                  </a:schemeClr>
-                </a:solidFill>
-              </a:rPr>
-              <a:t>Module Type</a:t>
-            </a:r>
-          </a:p>
-        </p:txBody>
-      </p:sp>
-      <p:cxnSp>
-        <p:nvCxnSpPr>
-          <p:cNvPr id="8" name="Straight Arrow Connector 7">
-            <a:extLst>
-              <a:ext uri="{FF2B5EF4-FFF2-40B4-BE49-F238E27FC236}">
-                <a16:creationId xmlns:a16="http://schemas.microsoft.com/office/drawing/2014/main" id="{56D39289-E87D-9A08-AD5C-650AA38B3B58}"/>
-              </a:ext>
-            </a:extLst>
-          </p:cNvPr>
-          <p:cNvCxnSpPr>
-            <a:cxnSpLocks/>
-          </p:cNvCxnSpPr>
-          <p:nvPr/>
-        </p:nvCxnSpPr>
-        <p:spPr>
-          <a:xfrm>
-            <a:off x="6501008" y="1234996"/>
-            <a:ext cx="0" cy="1282736"/>
-          </a:xfrm>
-          <a:prstGeom prst="straightConnector1">
-            <a:avLst/>
-          </a:prstGeom>
-          <a:ln w="12700" cmpd="sng">
-            <a:tailEnd type="triangle"/>
-          </a:ln>
-          <a:effectLst/>
-        </p:spPr>
-        <p:style>
-          <a:lnRef idx="1">
-            <a:schemeClr val="accent1"/>
-          </a:lnRef>
-          <a:fillRef idx="0">
-            <a:schemeClr val="accent1"/>
-          </a:fillRef>
-          <a:effectRef idx="0">
-            <a:schemeClr val="accent1"/>
-          </a:effectRef>
-          <a:fontRef idx="minor">
-            <a:schemeClr val="tx1"/>
-          </a:fontRef>
-        </p:style>
-      </p:cxnSp>
-      <p:sp>
-        <p:nvSpPr>
-          <p:cNvPr id="9" name="Content Placeholder 4">
-            <a:extLst>
-              <a:ext uri="{FF2B5EF4-FFF2-40B4-BE49-F238E27FC236}">
-                <a16:creationId xmlns:a16="http://schemas.microsoft.com/office/drawing/2014/main" id="{20B31163-F497-977B-97CE-4DEF7F6EAD53}"/>
-              </a:ext>
-            </a:extLst>
-          </p:cNvPr>
-          <p:cNvSpPr txBox="1">
-            <a:spLocks/>
-          </p:cNvSpPr>
-          <p:nvPr/>
-        </p:nvSpPr>
-        <p:spPr bwMode="auto">
-          <a:xfrm>
-            <a:off x="5988278" y="4075287"/>
-            <a:ext cx="2007706" cy="173038"/>
-          </a:xfrm>
-          <a:prstGeom prst="rect">
-            <a:avLst/>
-          </a:prstGeom>
-          <a:noFill/>
-          <a:ln>
-            <a:noFill/>
-          </a:ln>
-          <a:extLst>
-            <a:ext uri="{909E8E84-426E-40DD-AFC4-6F175D3DCCD1}">
-              <a14:hiddenFill xmlns:a14="http://schemas.microsoft.com/office/drawing/2010/main">
-                <a:solidFill>
-                  <a:srgbClr val="FFFFFF"/>
-                </a:solidFill>
-              </a14:hiddenFill>
-            </a:ext>
-            <a:ext uri="{91240B29-F687-4F45-9708-019B960494DF}">
-              <a14:hiddenLine xmlns:a14="http://schemas.microsoft.com/office/drawing/2010/main" w="9525">
-                <a:solidFill>
-                  <a:srgbClr val="000000"/>
-                </a:solidFill>
-                <a:miter lim="800000"/>
-                <a:headEnd/>
-                <a:tailEnd/>
-              </a14:hiddenLine>
-            </a:ext>
-          </a:extLst>
-        </p:spPr>
-        <p:txBody>
-          <a:bodyPr vert="horz" wrap="square" lIns="0" tIns="0" rIns="0" bIns="0" numCol="1" anchor="t" anchorCtr="0" compatLnSpc="1">
-            <a:prstTxWarp prst="textNoShape">
-              <a:avLst/>
-            </a:prstTxWarp>
-            <a:noAutofit/>
-          </a:bodyPr>
-          <a:lstStyle>
-            <a:lvl1pPr marL="342900" indent="-342900" algn="l" defTabSz="685800" rtl="0" eaLnBrk="0" fontAlgn="base" hangingPunct="0">
-              <a:lnSpc>
-                <a:spcPct val="90000"/>
-              </a:lnSpc>
-              <a:spcBef>
-                <a:spcPct val="0"/>
-              </a:spcBef>
-              <a:spcAft>
-                <a:spcPts val="600"/>
-              </a:spcAft>
-              <a:defRPr sz="1800" b="1" kern="1200">
-                <a:solidFill>
-                  <a:srgbClr val="00A5DF"/>
-                </a:solidFill>
-                <a:latin typeface="+mn-lt"/>
-                <a:ea typeface="MS PGothic" pitchFamily="34" charset="-128"/>
-                <a:cs typeface="ＭＳ Ｐゴシック" charset="0"/>
-              </a:defRPr>
-            </a:lvl1pPr>
-            <a:lvl2pPr marL="742950" indent="-285750" algn="l" defTabSz="685800" rtl="0" eaLnBrk="0" fontAlgn="base" hangingPunct="0">
-              <a:lnSpc>
-                <a:spcPct val="90000"/>
-              </a:lnSpc>
-              <a:spcBef>
-                <a:spcPct val="0"/>
-              </a:spcBef>
-              <a:spcAft>
-                <a:spcPts val="600"/>
-              </a:spcAft>
-              <a:buSzPct val="80000"/>
-              <a:buFont typeface="Arial" panose="020B0604020202020204" pitchFamily="34" charset="0"/>
-              <a:defRPr sz="1800" kern="1200">
-                <a:solidFill>
-                  <a:srgbClr val="00A5DF"/>
-                </a:solidFill>
-                <a:latin typeface="+mn-lt"/>
-                <a:ea typeface="MS PGothic" pitchFamily="34" charset="-128"/>
-                <a:cs typeface="+mn-cs"/>
-              </a:defRPr>
-            </a:lvl2pPr>
-            <a:lvl3pPr marL="180975" indent="-180975" algn="l" defTabSz="685800" rtl="0" eaLnBrk="0" fontAlgn="base" hangingPunct="0">
-              <a:lnSpc>
-                <a:spcPct val="90000"/>
-              </a:lnSpc>
-              <a:spcBef>
-                <a:spcPct val="0"/>
-              </a:spcBef>
-              <a:spcAft>
-                <a:spcPts val="600"/>
-              </a:spcAft>
-              <a:buSzPct val="100000"/>
-              <a:buFont typeface="Lucida Grande"/>
-              <a:buChar char="-"/>
-              <a:defRPr sz="1800" kern="1200">
-                <a:solidFill>
-                  <a:srgbClr val="00A5DF"/>
-                </a:solidFill>
-                <a:latin typeface="+mn-lt"/>
-                <a:ea typeface="MS PGothic" pitchFamily="34" charset="-128"/>
-                <a:cs typeface="+mn-cs"/>
-              </a:defRPr>
-            </a:lvl3pPr>
-            <a:lvl4pPr marL="363538" indent="-182563" algn="l" defTabSz="685800" rtl="0" eaLnBrk="0" fontAlgn="base" hangingPunct="0">
-              <a:lnSpc>
-                <a:spcPct val="90000"/>
-              </a:lnSpc>
-              <a:spcBef>
-                <a:spcPct val="0"/>
-              </a:spcBef>
-              <a:spcAft>
-                <a:spcPts val="600"/>
-              </a:spcAft>
-              <a:buSzPct val="100000"/>
-              <a:buFont typeface="Lucida Grande"/>
-              <a:buChar char="-"/>
-              <a:defRPr sz="1800" kern="1200">
-                <a:solidFill>
-                  <a:srgbClr val="00A5DF"/>
-                </a:solidFill>
-                <a:latin typeface="+mn-lt"/>
-                <a:ea typeface="MS PGothic" pitchFamily="34" charset="-128"/>
-                <a:cs typeface="+mn-cs"/>
-              </a:defRPr>
-            </a:lvl4pPr>
-            <a:lvl5pPr marL="534988" indent="-171450" algn="l" defTabSz="685800" rtl="0" eaLnBrk="0" fontAlgn="base" hangingPunct="0">
-              <a:lnSpc>
-                <a:spcPct val="90000"/>
-              </a:lnSpc>
-              <a:spcBef>
-                <a:spcPct val="0"/>
-              </a:spcBef>
-              <a:spcAft>
-                <a:spcPts val="600"/>
-              </a:spcAft>
-              <a:buSzPct val="100000"/>
-              <a:buFont typeface="Lucida Grande"/>
-              <a:buChar char="-"/>
-              <a:defRPr sz="1800" kern="1200">
-                <a:solidFill>
-                  <a:srgbClr val="00A5DF"/>
-                </a:solidFill>
-                <a:latin typeface="+mn-lt"/>
-                <a:ea typeface="MS PGothic" pitchFamily="34" charset="-128"/>
-                <a:cs typeface="+mn-cs"/>
-              </a:defRPr>
-            </a:lvl5pPr>
-            <a:lvl6pPr marL="1885950" indent="-171450" algn="l" defTabSz="685800" rtl="0" eaLnBrk="1" latinLnBrk="0" hangingPunct="1">
-              <a:lnSpc>
-                <a:spcPct val="90000"/>
-              </a:lnSpc>
-              <a:spcBef>
-                <a:spcPts val="375"/>
-              </a:spcBef>
-              <a:buFont typeface="Arial" panose="020B0604020202020204" pitchFamily="34" charset="0"/>
-              <a:buChar char="•"/>
-              <a:defRPr sz="1350" kern="1200">
-                <a:solidFill>
-                  <a:schemeClr val="tx1"/>
-                </a:solidFill>
-                <a:latin typeface="+mn-lt"/>
-                <a:ea typeface="+mn-ea"/>
-                <a:cs typeface="+mn-cs"/>
-              </a:defRPr>
-            </a:lvl6pPr>
-            <a:lvl7pPr marL="2228850" indent="-171450" algn="l" defTabSz="685800" rtl="0" eaLnBrk="1" latinLnBrk="0" hangingPunct="1">
-              <a:lnSpc>
-                <a:spcPct val="90000"/>
-              </a:lnSpc>
-              <a:spcBef>
-                <a:spcPts val="375"/>
-              </a:spcBef>
-              <a:buFont typeface="Arial" panose="020B0604020202020204" pitchFamily="34" charset="0"/>
-              <a:buChar char="•"/>
-              <a:defRPr sz="1350" kern="1200">
-                <a:solidFill>
-                  <a:schemeClr val="tx1"/>
-                </a:solidFill>
-                <a:latin typeface="+mn-lt"/>
-                <a:ea typeface="+mn-ea"/>
-                <a:cs typeface="+mn-cs"/>
-              </a:defRPr>
-            </a:lvl7pPr>
-            <a:lvl8pPr marL="2571750" indent="-171450" algn="l" defTabSz="685800" rtl="0" eaLnBrk="1" latinLnBrk="0" hangingPunct="1">
-              <a:lnSpc>
-                <a:spcPct val="90000"/>
-              </a:lnSpc>
-              <a:spcBef>
-                <a:spcPts val="375"/>
-              </a:spcBef>
-              <a:buFont typeface="Arial" panose="020B0604020202020204" pitchFamily="34" charset="0"/>
-              <a:buChar char="•"/>
-              <a:defRPr sz="1350" kern="1200">
-                <a:solidFill>
-                  <a:schemeClr val="tx1"/>
-                </a:solidFill>
-                <a:latin typeface="+mn-lt"/>
-                <a:ea typeface="+mn-ea"/>
-                <a:cs typeface="+mn-cs"/>
-              </a:defRPr>
-            </a:lvl8pPr>
-            <a:lvl9pPr marL="2914650" indent="-171450" algn="l" defTabSz="685800" rtl="0" eaLnBrk="1" latinLnBrk="0" hangingPunct="1">
-              <a:lnSpc>
-                <a:spcPct val="90000"/>
-              </a:lnSpc>
-              <a:spcBef>
-                <a:spcPts val="375"/>
-              </a:spcBef>
-              <a:buFont typeface="Arial" panose="020B0604020202020204" pitchFamily="34" charset="0"/>
-              <a:buChar char="•"/>
-              <a:defRPr sz="1350" kern="1200">
-                <a:solidFill>
-                  <a:schemeClr val="tx1"/>
-                </a:solidFill>
-                <a:latin typeface="+mn-lt"/>
-                <a:ea typeface="+mn-ea"/>
-                <a:cs typeface="+mn-cs"/>
-              </a:defRPr>
-            </a:lvl9pPr>
-          </a:lstStyle>
-          <a:p>
-            <a:pPr marL="0" indent="0"/>
-            <a:r>
-              <a:rPr lang="en-US" sz="1400" dirty="0">
-                <a:solidFill>
-                  <a:schemeClr val="bg2">
-                    <a:lumMod val="10000"/>
-                  </a:schemeClr>
-                </a:solidFill>
-              </a:rPr>
-              <a:t> Report Output location</a:t>
-            </a:r>
-          </a:p>
-        </p:txBody>
-      </p:sp>
-      <p:cxnSp>
-        <p:nvCxnSpPr>
-          <p:cNvPr id="10" name="Straight Arrow Connector 9">
-            <a:extLst>
-              <a:ext uri="{FF2B5EF4-FFF2-40B4-BE49-F238E27FC236}">
-                <a16:creationId xmlns:a16="http://schemas.microsoft.com/office/drawing/2014/main" id="{EC2F8D41-F147-4ACA-1FDD-62C22656C40E}"/>
-              </a:ext>
-            </a:extLst>
-          </p:cNvPr>
-          <p:cNvCxnSpPr>
-            <a:cxnSpLocks/>
-          </p:cNvCxnSpPr>
-          <p:nvPr/>
-        </p:nvCxnSpPr>
-        <p:spPr>
-          <a:xfrm flipV="1">
-            <a:off x="6653408" y="3433176"/>
-            <a:ext cx="0" cy="575153"/>
-          </a:xfrm>
-          <a:prstGeom prst="straightConnector1">
-            <a:avLst/>
-          </a:prstGeom>
-          <a:ln w="12700" cmpd="sng">
-            <a:tailEnd type="triangle"/>
-          </a:ln>
-          <a:effectLst/>
-        </p:spPr>
-        <p:style>
-          <a:lnRef idx="1">
-            <a:schemeClr val="accent1"/>
-          </a:lnRef>
-          <a:fillRef idx="0">
-            <a:schemeClr val="accent1"/>
-          </a:fillRef>
-          <a:effectRef idx="0">
-            <a:schemeClr val="accent1"/>
-          </a:effectRef>
-          <a:fontRef idx="minor">
-            <a:schemeClr val="tx1"/>
-          </a:fontRef>
-        </p:style>
-      </p:cxnSp>
-      <p:sp>
-        <p:nvSpPr>
-          <p:cNvPr id="11" name="Content Placeholder 4">
-            <a:extLst>
-              <a:ext uri="{FF2B5EF4-FFF2-40B4-BE49-F238E27FC236}">
-                <a16:creationId xmlns:a16="http://schemas.microsoft.com/office/drawing/2014/main" id="{A0EAECB7-4564-6868-AC7B-42CC103B20C9}"/>
-              </a:ext>
-            </a:extLst>
-          </p:cNvPr>
-          <p:cNvSpPr txBox="1">
-            <a:spLocks/>
-          </p:cNvSpPr>
-          <p:nvPr/>
-        </p:nvSpPr>
-        <p:spPr bwMode="auto">
-          <a:xfrm>
-            <a:off x="5309578" y="3856125"/>
-            <a:ext cx="1682553" cy="173038"/>
-          </a:xfrm>
-          <a:prstGeom prst="rect">
-            <a:avLst/>
-          </a:prstGeom>
-          <a:noFill/>
-          <a:ln>
-            <a:noFill/>
-          </a:ln>
-          <a:extLst>
-            <a:ext uri="{909E8E84-426E-40DD-AFC4-6F175D3DCCD1}">
-              <a14:hiddenFill xmlns:a14="http://schemas.microsoft.com/office/drawing/2010/main">
-                <a:solidFill>
-                  <a:srgbClr val="FFFFFF"/>
-                </a:solidFill>
-              </a14:hiddenFill>
-            </a:ext>
-            <a:ext uri="{91240B29-F687-4F45-9708-019B960494DF}">
-              <a14:hiddenLine xmlns:a14="http://schemas.microsoft.com/office/drawing/2010/main" w="9525">
-                <a:solidFill>
-                  <a:srgbClr val="000000"/>
-                </a:solidFill>
-                <a:miter lim="800000"/>
-                <a:headEnd/>
-                <a:tailEnd/>
-              </a14:hiddenLine>
-            </a:ext>
-          </a:extLst>
-        </p:spPr>
-        <p:txBody>
-          <a:bodyPr vert="horz" wrap="square" lIns="0" tIns="0" rIns="0" bIns="0" numCol="1" anchor="t" anchorCtr="0" compatLnSpc="1">
-            <a:prstTxWarp prst="textNoShape">
-              <a:avLst/>
-            </a:prstTxWarp>
-            <a:noAutofit/>
-          </a:bodyPr>
-          <a:lstStyle>
-            <a:lvl1pPr marL="342900" indent="-342900" algn="l" defTabSz="685800" rtl="0" eaLnBrk="0" fontAlgn="base" hangingPunct="0">
-              <a:lnSpc>
-                <a:spcPct val="90000"/>
-              </a:lnSpc>
-              <a:spcBef>
-                <a:spcPct val="0"/>
-              </a:spcBef>
-              <a:spcAft>
-                <a:spcPts val="600"/>
-              </a:spcAft>
-              <a:defRPr sz="1800" b="1" kern="1200">
-                <a:solidFill>
-                  <a:srgbClr val="00A5DF"/>
-                </a:solidFill>
-                <a:latin typeface="+mn-lt"/>
-                <a:ea typeface="MS PGothic" pitchFamily="34" charset="-128"/>
-                <a:cs typeface="ＭＳ Ｐゴシック" charset="0"/>
-              </a:defRPr>
-            </a:lvl1pPr>
-            <a:lvl2pPr marL="742950" indent="-285750" algn="l" defTabSz="685800" rtl="0" eaLnBrk="0" fontAlgn="base" hangingPunct="0">
-              <a:lnSpc>
-                <a:spcPct val="90000"/>
-              </a:lnSpc>
-              <a:spcBef>
-                <a:spcPct val="0"/>
-              </a:spcBef>
-              <a:spcAft>
-                <a:spcPts val="600"/>
-              </a:spcAft>
-              <a:buSzPct val="80000"/>
-              <a:buFont typeface="Arial" panose="020B0604020202020204" pitchFamily="34" charset="0"/>
-              <a:defRPr sz="1800" kern="1200">
-                <a:solidFill>
-                  <a:srgbClr val="00A5DF"/>
-                </a:solidFill>
-                <a:latin typeface="+mn-lt"/>
-                <a:ea typeface="MS PGothic" pitchFamily="34" charset="-128"/>
-                <a:cs typeface="+mn-cs"/>
-              </a:defRPr>
-            </a:lvl2pPr>
-            <a:lvl3pPr marL="180975" indent="-180975" algn="l" defTabSz="685800" rtl="0" eaLnBrk="0" fontAlgn="base" hangingPunct="0">
-              <a:lnSpc>
-                <a:spcPct val="90000"/>
-              </a:lnSpc>
-              <a:spcBef>
-                <a:spcPct val="0"/>
-              </a:spcBef>
-              <a:spcAft>
-                <a:spcPts val="600"/>
-              </a:spcAft>
-              <a:buSzPct val="100000"/>
-              <a:buFont typeface="Lucida Grande"/>
-              <a:buChar char="-"/>
-              <a:defRPr sz="1800" kern="1200">
-                <a:solidFill>
-                  <a:srgbClr val="00A5DF"/>
-                </a:solidFill>
-                <a:latin typeface="+mn-lt"/>
-                <a:ea typeface="MS PGothic" pitchFamily="34" charset="-128"/>
-                <a:cs typeface="+mn-cs"/>
-              </a:defRPr>
-            </a:lvl3pPr>
-            <a:lvl4pPr marL="363538" indent="-182563" algn="l" defTabSz="685800" rtl="0" eaLnBrk="0" fontAlgn="base" hangingPunct="0">
-              <a:lnSpc>
-                <a:spcPct val="90000"/>
-              </a:lnSpc>
-              <a:spcBef>
-                <a:spcPct val="0"/>
-              </a:spcBef>
-              <a:spcAft>
-                <a:spcPts val="600"/>
-              </a:spcAft>
-              <a:buSzPct val="100000"/>
-              <a:buFont typeface="Lucida Grande"/>
-              <a:buChar char="-"/>
-              <a:defRPr sz="1800" kern="1200">
-                <a:solidFill>
-                  <a:srgbClr val="00A5DF"/>
-                </a:solidFill>
-                <a:latin typeface="+mn-lt"/>
-                <a:ea typeface="MS PGothic" pitchFamily="34" charset="-128"/>
-                <a:cs typeface="+mn-cs"/>
-              </a:defRPr>
-            </a:lvl4pPr>
-            <a:lvl5pPr marL="534988" indent="-171450" algn="l" defTabSz="685800" rtl="0" eaLnBrk="0" fontAlgn="base" hangingPunct="0">
-              <a:lnSpc>
-                <a:spcPct val="90000"/>
-              </a:lnSpc>
-              <a:spcBef>
-                <a:spcPct val="0"/>
-              </a:spcBef>
-              <a:spcAft>
-                <a:spcPts val="600"/>
-              </a:spcAft>
-              <a:buSzPct val="100000"/>
-              <a:buFont typeface="Lucida Grande"/>
-              <a:buChar char="-"/>
-              <a:defRPr sz="1800" kern="1200">
-                <a:solidFill>
-                  <a:srgbClr val="00A5DF"/>
-                </a:solidFill>
-                <a:latin typeface="+mn-lt"/>
-                <a:ea typeface="MS PGothic" pitchFamily="34" charset="-128"/>
-                <a:cs typeface="+mn-cs"/>
-              </a:defRPr>
-            </a:lvl5pPr>
-            <a:lvl6pPr marL="1885950" indent="-171450" algn="l" defTabSz="685800" rtl="0" eaLnBrk="1" latinLnBrk="0" hangingPunct="1">
-              <a:lnSpc>
-                <a:spcPct val="90000"/>
-              </a:lnSpc>
-              <a:spcBef>
-                <a:spcPts val="375"/>
-              </a:spcBef>
-              <a:buFont typeface="Arial" panose="020B0604020202020204" pitchFamily="34" charset="0"/>
-              <a:buChar char="•"/>
-              <a:defRPr sz="1350" kern="1200">
-                <a:solidFill>
-                  <a:schemeClr val="tx1"/>
-                </a:solidFill>
-                <a:latin typeface="+mn-lt"/>
-                <a:ea typeface="+mn-ea"/>
-                <a:cs typeface="+mn-cs"/>
-              </a:defRPr>
-            </a:lvl6pPr>
-            <a:lvl7pPr marL="2228850" indent="-171450" algn="l" defTabSz="685800" rtl="0" eaLnBrk="1" latinLnBrk="0" hangingPunct="1">
-              <a:lnSpc>
-                <a:spcPct val="90000"/>
-              </a:lnSpc>
-              <a:spcBef>
-                <a:spcPts val="375"/>
-              </a:spcBef>
-              <a:buFont typeface="Arial" panose="020B0604020202020204" pitchFamily="34" charset="0"/>
-              <a:buChar char="•"/>
-              <a:defRPr sz="1350" kern="1200">
-                <a:solidFill>
-                  <a:schemeClr val="tx1"/>
-                </a:solidFill>
-                <a:latin typeface="+mn-lt"/>
-                <a:ea typeface="+mn-ea"/>
-                <a:cs typeface="+mn-cs"/>
-              </a:defRPr>
-            </a:lvl7pPr>
-            <a:lvl8pPr marL="2571750" indent="-171450" algn="l" defTabSz="685800" rtl="0" eaLnBrk="1" latinLnBrk="0" hangingPunct="1">
-              <a:lnSpc>
-                <a:spcPct val="90000"/>
-              </a:lnSpc>
-              <a:spcBef>
-                <a:spcPts val="375"/>
-              </a:spcBef>
-              <a:buFont typeface="Arial" panose="020B0604020202020204" pitchFamily="34" charset="0"/>
-              <a:buChar char="•"/>
-              <a:defRPr sz="1350" kern="1200">
-                <a:solidFill>
-                  <a:schemeClr val="tx1"/>
-                </a:solidFill>
-                <a:latin typeface="+mn-lt"/>
-                <a:ea typeface="+mn-ea"/>
-                <a:cs typeface="+mn-cs"/>
-              </a:defRPr>
-            </a:lvl8pPr>
-            <a:lvl9pPr marL="2914650" indent="-171450" algn="l" defTabSz="685800" rtl="0" eaLnBrk="1" latinLnBrk="0" hangingPunct="1">
-              <a:lnSpc>
-                <a:spcPct val="90000"/>
-              </a:lnSpc>
-              <a:spcBef>
-                <a:spcPts val="375"/>
-              </a:spcBef>
-              <a:buFont typeface="Arial" panose="020B0604020202020204" pitchFamily="34" charset="0"/>
-              <a:buChar char="•"/>
-              <a:defRPr sz="1350" kern="1200">
-                <a:solidFill>
-                  <a:schemeClr val="tx1"/>
-                </a:solidFill>
-                <a:latin typeface="+mn-lt"/>
-                <a:ea typeface="+mn-ea"/>
-                <a:cs typeface="+mn-cs"/>
-              </a:defRPr>
-            </a:lvl9pPr>
-          </a:lstStyle>
-          <a:p>
-            <a:pPr marL="0" indent="0"/>
-            <a:r>
-              <a:rPr lang="en-US" sz="1400" dirty="0">
-                <a:solidFill>
-                  <a:schemeClr val="bg2">
-                    <a:lumMod val="10000"/>
-                  </a:schemeClr>
-                </a:solidFill>
-              </a:rPr>
-              <a:t>Module Link</a:t>
-            </a:r>
-          </a:p>
-        </p:txBody>
-      </p:sp>
-      <p:cxnSp>
-        <p:nvCxnSpPr>
-          <p:cNvPr id="12" name="Straight Arrow Connector 11">
-            <a:extLst>
-              <a:ext uri="{FF2B5EF4-FFF2-40B4-BE49-F238E27FC236}">
-                <a16:creationId xmlns:a16="http://schemas.microsoft.com/office/drawing/2014/main" id="{C7B2C1FC-7831-0949-FEAF-15EE06227ECF}"/>
-              </a:ext>
-            </a:extLst>
-          </p:cNvPr>
-          <p:cNvCxnSpPr>
-            <a:cxnSpLocks/>
-          </p:cNvCxnSpPr>
-          <p:nvPr/>
-        </p:nvCxnSpPr>
-        <p:spPr>
-          <a:xfrm flipV="1">
-            <a:off x="5803728" y="3056351"/>
-            <a:ext cx="0" cy="753650"/>
-          </a:xfrm>
-          <a:prstGeom prst="straightConnector1">
-            <a:avLst/>
-          </a:prstGeom>
-          <a:ln w="12700" cmpd="sng">
-            <a:tailEnd type="triangle"/>
-          </a:ln>
-          <a:effectLst/>
-        </p:spPr>
-        <p:style>
-          <a:lnRef idx="1">
-            <a:schemeClr val="accent1"/>
-          </a:lnRef>
-          <a:fillRef idx="0">
-            <a:schemeClr val="accent1"/>
-          </a:fillRef>
-          <a:effectRef idx="0">
-            <a:schemeClr val="accent1"/>
-          </a:effectRef>
-          <a:fontRef idx="minor">
-            <a:schemeClr val="tx1"/>
-          </a:fontRef>
-        </p:style>
-      </p:cxnSp>
-      <p:sp>
-        <p:nvSpPr>
-          <p:cNvPr id="13" name="Title 4">
-            <a:extLst>
-              <a:ext uri="{FF2B5EF4-FFF2-40B4-BE49-F238E27FC236}">
-                <a16:creationId xmlns:a16="http://schemas.microsoft.com/office/drawing/2014/main" id="{ED26AC27-C11D-7C0D-675E-57059858486C}"/>
-              </a:ext>
-            </a:extLst>
-          </p:cNvPr>
-          <p:cNvSpPr>
-            <a:spLocks noGrp="1"/>
-          </p:cNvSpPr>
-          <p:nvPr>
-            <p:ph type="title"/>
-          </p:nvPr>
-        </p:nvSpPr>
-        <p:spPr>
-          <a:xfrm>
-            <a:off x="513783" y="388890"/>
-            <a:ext cx="8001934" cy="476744"/>
-          </a:xfrm>
-        </p:spPr>
-        <p:txBody>
-          <a:bodyPr anchor="ctr"/>
-          <a:lstStyle/>
-          <a:p>
-            <a:pPr eaLnBrk="1" hangingPunct="1">
-              <a:lnSpc>
-                <a:spcPct val="110000"/>
-              </a:lnSpc>
-            </a:pPr>
-            <a:r>
-              <a:rPr lang="en-US" altLang="en-US" sz="1800" dirty="0">
-                <a:latin typeface="Effra" pitchFamily="34" charset="0"/>
-                <a:cs typeface="Effra" pitchFamily="34" charset="0"/>
-              </a:rPr>
-              <a:t>Inputs</a:t>
-            </a:r>
-          </a:p>
-        </p:txBody>
-      </p:sp>
-    </p:spTree>
-    <p:extLst>
-      <p:ext uri="{BB962C8B-B14F-4D97-AF65-F5344CB8AC3E}">
-        <p14:creationId xmlns:p14="http://schemas.microsoft.com/office/powerpoint/2010/main" val="1471962703"/>
-      </p:ext>
-    </p:extLst>
-  </p:cSld>
-  <p:clrMapOvr>
-    <a:masterClrMapping/>
-  </p:clrMapOvr>
-</p:sld>
-</file>
-
-<file path=ppt/slides/slide8.xml><?xml version="1.0" encoding="utf-8"?>
-<p:sld xmlns:a="http://schemas.openxmlformats.org/drawingml/2006/main" xmlns:r="http://schemas.openxmlformats.org/officeDocument/2006/relationships" xmlns:p="http://schemas.openxmlformats.org/presentationml/2006/main">
-  <p:cSld>
-    <p:spTree>
-      <p:nvGrpSpPr>
-        <p:cNvPr id="1" name=""/>
-        <p:cNvGrpSpPr/>
-        <p:nvPr/>
-      </p:nvGrpSpPr>
-      <p:grpSpPr>
-        <a:xfrm>
-          <a:off x="0" y="0"/>
-          <a:ext cx="0" cy="0"/>
-          <a:chOff x="0" y="0"/>
-          <a:chExt cx="0" cy="0"/>
-        </a:xfrm>
-      </p:grpSpPr>
-      <p:sp>
-        <p:nvSpPr>
-          <p:cNvPr id="4" name="Slide Number Placeholder 3">
-            <a:extLst>
-              <a:ext uri="{FF2B5EF4-FFF2-40B4-BE49-F238E27FC236}">
                 <a16:creationId xmlns:a16="http://schemas.microsoft.com/office/drawing/2014/main" id="{AD9AF4C9-4EC5-A3F1-7353-9590EF673363}"/>
               </a:ext>
             </a:extLst>
@@ -39289,7 +38199,7 @@
             <a:fld id="{8A4A04CF-1BC9-4C63-AE06-A38D4D08020F}" type="slidenum">
               <a:rPr lang="en-GB" altLang="en-US" smtClean="0"/>
               <a:pPr/>
-              <a:t>8</a:t>
+              <a:t>7</a:t>
             </a:fld>
             <a:endParaRPr lang="en-GB" altLang="en-US" dirty="0"/>
           </a:p>
@@ -40249,6 +39159,385 @@
 </p:sld>
 </file>
 
+<file path=ppt/slides/slide8.xml><?xml version="1.0" encoding="utf-8"?>
+<p:sld xmlns:a="http://schemas.openxmlformats.org/drawingml/2006/main" xmlns:r="http://schemas.openxmlformats.org/officeDocument/2006/relationships" xmlns:p="http://schemas.openxmlformats.org/presentationml/2006/main">
+  <p:cSld>
+    <p:spTree>
+      <p:nvGrpSpPr>
+        <p:cNvPr id="1" name=""/>
+        <p:cNvGrpSpPr/>
+        <p:nvPr/>
+      </p:nvGrpSpPr>
+      <p:grpSpPr>
+        <a:xfrm>
+          <a:off x="0" y="0"/>
+          <a:ext cx="0" cy="0"/>
+          <a:chOff x="0" y="0"/>
+          <a:chExt cx="0" cy="0"/>
+        </a:xfrm>
+      </p:grpSpPr>
+      <p:sp>
+        <p:nvSpPr>
+          <p:cNvPr id="4" name="Slide Number Placeholder 3">
+            <a:extLst>
+              <a:ext uri="{FF2B5EF4-FFF2-40B4-BE49-F238E27FC236}">
+                <a16:creationId xmlns:a16="http://schemas.microsoft.com/office/drawing/2014/main" id="{10AC30D0-07E0-3C53-56C6-57FA03F3C0D0}"/>
+              </a:ext>
+            </a:extLst>
+          </p:cNvPr>
+          <p:cNvSpPr>
+            <a:spLocks noGrp="1"/>
+          </p:cNvSpPr>
+          <p:nvPr>
+            <p:ph type="sldNum" sz="quarter" idx="14"/>
+          </p:nvPr>
+        </p:nvSpPr>
+        <p:spPr/>
+        <p:txBody>
+          <a:bodyPr/>
+          <a:lstStyle/>
+          <a:p>
+            <a:fld id="{8A4A04CF-1BC9-4C63-AE06-A38D4D08020F}" type="slidenum">
+              <a:rPr lang="en-GB" altLang="en-US" smtClean="0"/>
+              <a:pPr/>
+              <a:t>8</a:t>
+            </a:fld>
+            <a:endParaRPr lang="en-GB" altLang="en-US" dirty="0"/>
+          </a:p>
+        </p:txBody>
+      </p:sp>
+      <p:sp>
+        <p:nvSpPr>
+          <p:cNvPr id="6" name="TextBox 5">
+            <a:extLst>
+              <a:ext uri="{FF2B5EF4-FFF2-40B4-BE49-F238E27FC236}">
+                <a16:creationId xmlns:a16="http://schemas.microsoft.com/office/drawing/2014/main" id="{4B90843F-D45B-A9A3-C1D4-21AD8C2C6377}"/>
+              </a:ext>
+            </a:extLst>
+          </p:cNvPr>
+          <p:cNvSpPr txBox="1"/>
+          <p:nvPr/>
+        </p:nvSpPr>
+        <p:spPr>
+          <a:xfrm>
+            <a:off x="162839" y="629229"/>
+            <a:ext cx="9144000" cy="4832092"/>
+          </a:xfrm>
+          <a:prstGeom prst="rect">
+            <a:avLst/>
+          </a:prstGeom>
+          <a:noFill/>
+        </p:spPr>
+        <p:txBody>
+          <a:bodyPr wrap="square">
+            <a:spAutoFit/>
+          </a:bodyPr>
+          <a:lstStyle/>
+          <a:p>
+            <a:pPr>
+              <a:buNone/>
+            </a:pPr>
+            <a:r>
+              <a:rPr lang="en-US" b="1" dirty="0"/>
+              <a:t>1. Module Selection</a:t>
+            </a:r>
+          </a:p>
+          <a:p>
+            <a:pPr>
+              <a:buNone/>
+            </a:pPr>
+            <a:r>
+              <a:rPr lang="en-US" dirty="0">
+                <a:solidFill>
+                  <a:srgbClr val="00B0F0"/>
+                </a:solidFill>
+              </a:rPr>
+              <a:t>The Module Type drop-down list allows the user to select the Engine Manual document from which cautions will be extracted.</a:t>
+            </a:r>
+          </a:p>
+          <a:p>
+            <a:pPr>
+              <a:buNone/>
+            </a:pPr>
+            <a:endParaRPr lang="en-US" dirty="0">
+              <a:solidFill>
+                <a:srgbClr val="00B0F0"/>
+              </a:solidFill>
+            </a:endParaRPr>
+          </a:p>
+          <a:p>
+            <a:pPr>
+              <a:buNone/>
+            </a:pPr>
+            <a:r>
+              <a:rPr lang="en-US" dirty="0">
+                <a:solidFill>
+                  <a:srgbClr val="00B0F0"/>
+                </a:solidFill>
+              </a:rPr>
+              <a:t>Available options:</a:t>
+            </a:r>
+          </a:p>
+          <a:p>
+            <a:pPr>
+              <a:buFont typeface="Arial" panose="020B0604020202020204" pitchFamily="34" charset="0"/>
+              <a:buChar char="•"/>
+            </a:pPr>
+            <a:r>
+              <a:rPr lang="en-US" dirty="0">
+                <a:solidFill>
+                  <a:srgbClr val="00B0F0"/>
+                </a:solidFill>
+              </a:rPr>
+              <a:t>Engine Manual</a:t>
+            </a:r>
+          </a:p>
+          <a:p>
+            <a:pPr>
+              <a:buFont typeface="Arial" panose="020B0604020202020204" pitchFamily="34" charset="0"/>
+              <a:buChar char="•"/>
+            </a:pPr>
+            <a:r>
+              <a:rPr lang="en-US" dirty="0">
+                <a:solidFill>
+                  <a:srgbClr val="00B0F0"/>
+                </a:solidFill>
+              </a:rPr>
+              <a:t>Engine Manual CIR</a:t>
+            </a:r>
+          </a:p>
+          <a:p>
+            <a:pPr>
+              <a:buFont typeface="Arial" panose="020B0604020202020204" pitchFamily="34" charset="0"/>
+              <a:buChar char="•"/>
+            </a:pPr>
+            <a:r>
+              <a:rPr lang="en-US" dirty="0">
+                <a:solidFill>
+                  <a:srgbClr val="00B0F0"/>
+                </a:solidFill>
+              </a:rPr>
+              <a:t>SP 72-31</a:t>
+            </a:r>
+          </a:p>
+          <a:p>
+            <a:pPr>
+              <a:buFont typeface="Arial" panose="020B0604020202020204" pitchFamily="34" charset="0"/>
+              <a:buChar char="•"/>
+            </a:pPr>
+            <a:r>
+              <a:rPr lang="en-US" dirty="0">
+                <a:solidFill>
+                  <a:srgbClr val="00B0F0"/>
+                </a:solidFill>
+              </a:rPr>
+              <a:t>SP 72-51</a:t>
+            </a:r>
+          </a:p>
+          <a:p>
+            <a:pPr>
+              <a:buNone/>
+            </a:pPr>
+            <a:r>
+              <a:rPr lang="en-US" dirty="0">
+                <a:solidFill>
+                  <a:srgbClr val="00B0F0"/>
+                </a:solidFill>
+              </a:rPr>
+              <a:t>Select the appropriate manual type before entering the Engine Manual link.</a:t>
+            </a:r>
+          </a:p>
+          <a:p>
+            <a:pPr>
+              <a:buNone/>
+            </a:pPr>
+            <a:endParaRPr lang="en-US" dirty="0">
+              <a:solidFill>
+                <a:srgbClr val="00B0F0"/>
+              </a:solidFill>
+            </a:endParaRPr>
+          </a:p>
+          <a:p>
+            <a:pPr>
+              <a:buNone/>
+            </a:pPr>
+            <a:r>
+              <a:rPr lang="en-US" b="1" dirty="0"/>
+              <a:t>2. Engine Manual Link</a:t>
+            </a:r>
+          </a:p>
+          <a:p>
+            <a:pPr>
+              <a:buNone/>
+            </a:pPr>
+            <a:r>
+              <a:rPr lang="en-US" dirty="0">
+                <a:solidFill>
+                  <a:srgbClr val="00B0F0"/>
+                </a:solidFill>
+              </a:rPr>
+              <a:t>The Engine Manual Link field is used to enter the URL of the module page from which cautions need to be extracted.</a:t>
+            </a:r>
+          </a:p>
+          <a:p>
+            <a:pPr>
+              <a:buNone/>
+            </a:pPr>
+            <a:endParaRPr lang="en-US" dirty="0">
+              <a:solidFill>
+                <a:srgbClr val="00B0F0"/>
+              </a:solidFill>
+            </a:endParaRPr>
+          </a:p>
+          <a:p>
+            <a:pPr>
+              <a:buNone/>
+            </a:pPr>
+            <a:r>
+              <a:rPr lang="en-US" dirty="0">
+                <a:solidFill>
+                  <a:srgbClr val="00B0F0"/>
+                </a:solidFill>
+              </a:rPr>
+              <a:t>Example:</a:t>
+            </a:r>
+          </a:p>
+          <a:p>
+            <a:r>
+              <a:rPr lang="pt-BR" dirty="0">
+                <a:solidFill>
+                  <a:srgbClr val="00B0F0"/>
+                </a:solidFill>
+              </a:rPr>
+              <a:t>http://127.0.0.1:8000/PW1000G-77445-19453-00/PW1000G-77445-15653-00.html                    (EM_CIR)</a:t>
+            </a:r>
+          </a:p>
+          <a:p>
+            <a:r>
+              <a:rPr lang="pt-BR" dirty="0">
+                <a:solidFill>
+                  <a:srgbClr val="00B0F0"/>
+                </a:solidFill>
+              </a:rPr>
+              <a:t>http://127.0.0.1:8001/PW1000G-77445-19453-00/PW1000G-77445-16992-00.html                    (EM)</a:t>
+            </a:r>
+          </a:p>
+          <a:p>
+            <a:r>
+              <a:rPr lang="en-US" dirty="0">
+                <a:solidFill>
+                  <a:srgbClr val="00B0F0"/>
+                </a:solidFill>
+              </a:rPr>
+              <a:t>http://127.0.0.1:8002/PW1000G-77445-19155-00/                                                                                                     (SP_CIR_72_35)</a:t>
+            </a:r>
+          </a:p>
+          <a:p>
+            <a:r>
+              <a:rPr lang="en-US" dirty="0">
+                <a:solidFill>
+                  <a:srgbClr val="00B0F0"/>
+                </a:solidFill>
+                <a:hlinkClick r:id="rId2">
+                  <a:extLst>
+                    <a:ext uri="{A12FA001-AC4F-418D-AE19-62706E023703}">
+                      <ahyp:hlinkClr xmlns:ahyp="http://schemas.microsoft.com/office/drawing/2018/hyperlinkcolor" val="tx"/>
+                    </a:ext>
+                  </a:extLst>
+                </a:hlinkClick>
+              </a:rPr>
+              <a:t>http://127.0.0.1:8003/PW1000G-77445-19156-00/</a:t>
+            </a:r>
+            <a:r>
+              <a:rPr lang="en-US" dirty="0">
+                <a:solidFill>
+                  <a:srgbClr val="00B0F0"/>
+                </a:solidFill>
+              </a:rPr>
+              <a:t>                                                                                                     (SP_CIR_72_51)</a:t>
+            </a:r>
+          </a:p>
+          <a:p>
+            <a:endParaRPr lang="en-US" dirty="0">
+              <a:solidFill>
+                <a:srgbClr val="00B0F0"/>
+              </a:solidFill>
+            </a:endParaRPr>
+          </a:p>
+          <a:p>
+            <a:pPr>
+              <a:buNone/>
+            </a:pPr>
+            <a:endParaRPr lang="en-US" dirty="0">
+              <a:solidFill>
+                <a:srgbClr val="00B0F0"/>
+              </a:solidFill>
+            </a:endParaRPr>
+          </a:p>
+          <a:p>
+            <a:pPr>
+              <a:buNone/>
+            </a:pPr>
+            <a:endParaRPr lang="en-US" dirty="0"/>
+          </a:p>
+        </p:txBody>
+      </p:sp>
+      <p:sp>
+        <p:nvSpPr>
+          <p:cNvPr id="9" name="Title 4">
+            <a:extLst>
+              <a:ext uri="{FF2B5EF4-FFF2-40B4-BE49-F238E27FC236}">
+                <a16:creationId xmlns:a16="http://schemas.microsoft.com/office/drawing/2014/main" id="{B4BED2CD-EDBB-8546-8A39-C0464029600B}"/>
+              </a:ext>
+            </a:extLst>
+          </p:cNvPr>
+          <p:cNvSpPr>
+            <a:spLocks noGrp="1"/>
+          </p:cNvSpPr>
+          <p:nvPr>
+            <p:ph type="title"/>
+          </p:nvPr>
+        </p:nvSpPr>
+        <p:spPr>
+          <a:xfrm>
+            <a:off x="268459" y="129978"/>
+            <a:ext cx="6564050" cy="499251"/>
+          </a:xfrm>
+        </p:spPr>
+        <p:txBody>
+          <a:bodyPr anchor="ctr"/>
+          <a:lstStyle/>
+          <a:p>
+            <a:pPr eaLnBrk="1" hangingPunct="1">
+              <a:lnSpc>
+                <a:spcPct val="110000"/>
+              </a:lnSpc>
+            </a:pPr>
+            <a:r>
+              <a:rPr lang="en-US" altLang="en-US" sz="1800" dirty="0">
+                <a:latin typeface="Effra" pitchFamily="34" charset="0"/>
+              </a:rPr>
+              <a:t>Tool functionality</a:t>
+            </a:r>
+            <a:endParaRPr lang="en-US" altLang="en-US" sz="1600" dirty="0">
+              <a:latin typeface="Effra" pitchFamily="34" charset="0"/>
+            </a:endParaRPr>
+          </a:p>
+        </p:txBody>
+      </p:sp>
+    </p:spTree>
+    <p:extLst>
+      <p:ext uri="{BB962C8B-B14F-4D97-AF65-F5344CB8AC3E}">
+        <p14:creationId xmlns:p14="http://schemas.microsoft.com/office/powerpoint/2010/main" val="629378473"/>
+      </p:ext>
+    </p:extLst>
+  </p:cSld>
+  <p:clrMapOvr>
+    <a:masterClrMapping/>
+  </p:clrMapOvr>
+</p:sld>
+</file>
+
 <file path=ppt/slides/slide9.xml><?xml version="1.0" encoding="utf-8"?>
 <p:sld xmlns:a="http://schemas.openxmlformats.org/drawingml/2006/main" xmlns:r="http://schemas.openxmlformats.org/officeDocument/2006/relationships" xmlns:p="http://schemas.openxmlformats.org/presentationml/2006/main">
   <p:cSld>
@@ -40268,44 +39557,13 @@
       </p:grpSpPr>
       <p:sp>
         <p:nvSpPr>
-          <p:cNvPr id="20482" name="Title 4"/>
-          <p:cNvSpPr>
-            <a:spLocks noGrp="1"/>
-          </p:cNvSpPr>
-          <p:nvPr>
-            <p:ph type="title"/>
-          </p:nvPr>
-        </p:nvSpPr>
-        <p:spPr>
-          <a:xfrm>
-            <a:off x="406245" y="220189"/>
-            <a:ext cx="6564050" cy="499251"/>
-          </a:xfrm>
-        </p:spPr>
-        <p:txBody>
-          <a:bodyPr anchor="ctr"/>
-          <a:lstStyle/>
-          <a:p>
-            <a:pPr eaLnBrk="1" hangingPunct="1">
-              <a:lnSpc>
-                <a:spcPct val="110000"/>
-              </a:lnSpc>
-            </a:pPr>
-            <a:r>
-              <a:rPr lang="en-US" altLang="en-US" sz="1800" dirty="0">
-                <a:latin typeface="Effra" pitchFamily="34" charset="0"/>
-              </a:rPr>
-              <a:t>Tool functionality</a:t>
-            </a:r>
-            <a:endParaRPr lang="en-US" altLang="en-US" sz="1600" dirty="0">
-              <a:latin typeface="Effra" pitchFamily="34" charset="0"/>
-            </a:endParaRPr>
-          </a:p>
-        </p:txBody>
-      </p:sp>
-      <p:sp>
-        <p:nvSpPr>
-          <p:cNvPr id="20483" name="Slide Number Placeholder 1"/>
+          <p:cNvPr id="4" name="Slide Number Placeholder 3">
+            <a:extLst>
+              <a:ext uri="{FF2B5EF4-FFF2-40B4-BE49-F238E27FC236}">
+                <a16:creationId xmlns:a16="http://schemas.microsoft.com/office/drawing/2014/main" id="{7DBFB500-BDE9-AF4D-7E46-5542A0782CE2}"/>
+              </a:ext>
+            </a:extLst>
+          </p:cNvPr>
           <p:cNvSpPr>
             <a:spLocks noGrp="1"/>
           </p:cNvSpPr>
@@ -40313,177 +39571,26 @@
             <p:ph type="sldNum" sz="quarter" idx="14"/>
           </p:nvPr>
         </p:nvSpPr>
-        <p:spPr bwMode="auto">
-          <a:noFill/>
-          <a:extLst>
-            <a:ext uri="{909E8E84-426E-40DD-AFC4-6F175D3DCCD1}">
-              <a14:hiddenFill xmlns:a14="http://schemas.microsoft.com/office/drawing/2010/main">
-                <a:solidFill>
-                  <a:srgbClr val="FFFFFF"/>
-                </a:solidFill>
-              </a14:hiddenFill>
-            </a:ext>
-            <a:ext uri="{91240B29-F687-4F45-9708-019B960494DF}">
-              <a14:hiddenLine xmlns:a14="http://schemas.microsoft.com/office/drawing/2010/main" w="9525">
-                <a:solidFill>
-                  <a:srgbClr val="000000"/>
-                </a:solidFill>
-                <a:miter lim="800000"/>
-                <a:headEnd/>
-                <a:tailEnd/>
-              </a14:hiddenLine>
-            </a:ext>
-          </a:extLst>
-        </p:spPr>
+        <p:spPr/>
         <p:txBody>
-          <a:bodyPr vert="horz" wrap="square" lIns="48768" tIns="24384" rIns="48768" bIns="24384" numCol="1" anchor="t" anchorCtr="0" compatLnSpc="1">
-            <a:prstTxWarp prst="textNoShape">
-              <a:avLst/>
-            </a:prstTxWarp>
-          </a:bodyPr>
-          <a:lstStyle>
-            <a:lvl1pPr defTabSz="380173">
-              <a:defRPr sz="746" b="1">
-                <a:solidFill>
-                  <a:srgbClr val="00A5DF"/>
-                </a:solidFill>
-                <a:latin typeface="Effra" pitchFamily="34" charset="0"/>
-                <a:ea typeface="MS PGothic" pitchFamily="34" charset="-128"/>
-              </a:defRPr>
-            </a:lvl1pPr>
-            <a:lvl2pPr defTabSz="380173">
-              <a:defRPr sz="746">
-                <a:solidFill>
-                  <a:srgbClr val="00A5DF"/>
-                </a:solidFill>
-                <a:latin typeface="Effra" pitchFamily="34" charset="0"/>
-                <a:ea typeface="MS PGothic" pitchFamily="34" charset="-128"/>
-              </a:defRPr>
-            </a:lvl2pPr>
-            <a:lvl3pPr marL="609630" indent="-121926" defTabSz="380173">
-              <a:defRPr sz="746">
-                <a:solidFill>
-                  <a:srgbClr val="00A5DF"/>
-                </a:solidFill>
-                <a:latin typeface="Effra" pitchFamily="34" charset="0"/>
-                <a:ea typeface="MS PGothic" pitchFamily="34" charset="-128"/>
-              </a:defRPr>
-            </a:lvl3pPr>
-            <a:lvl4pPr marL="853482" indent="-121926" defTabSz="380173">
-              <a:defRPr sz="746">
-                <a:solidFill>
-                  <a:srgbClr val="00A5DF"/>
-                </a:solidFill>
-                <a:latin typeface="Effra" pitchFamily="34" charset="0"/>
-                <a:ea typeface="MS PGothic" pitchFamily="34" charset="-128"/>
-              </a:defRPr>
-            </a:lvl4pPr>
-            <a:lvl5pPr marL="1097335" indent="-121926" defTabSz="380173">
-              <a:defRPr sz="746">
-                <a:solidFill>
-                  <a:srgbClr val="00A5DF"/>
-                </a:solidFill>
-                <a:latin typeface="Effra" pitchFamily="34" charset="0"/>
-                <a:ea typeface="MS PGothic" pitchFamily="34" charset="-128"/>
-              </a:defRPr>
-            </a:lvl5pPr>
-            <a:lvl6pPr marL="1341187" indent="-121926" defTabSz="380173" eaLnBrk="0" fontAlgn="base" hangingPunct="0">
-              <a:spcBef>
-                <a:spcPct val="0"/>
-              </a:spcBef>
-              <a:spcAft>
-                <a:spcPts val="320"/>
-              </a:spcAft>
-              <a:buSzPct val="100000"/>
-              <a:buFont typeface="Lucida Grande"/>
-              <a:buChar char="-"/>
-              <a:defRPr sz="746">
-                <a:solidFill>
-                  <a:srgbClr val="00A5DF"/>
-                </a:solidFill>
-                <a:latin typeface="Effra" pitchFamily="34" charset="0"/>
-                <a:ea typeface="MS PGothic" pitchFamily="34" charset="-128"/>
-              </a:defRPr>
-            </a:lvl6pPr>
-            <a:lvl7pPr marL="1585039" indent="-121926" defTabSz="380173" eaLnBrk="0" fontAlgn="base" hangingPunct="0">
-              <a:spcBef>
-                <a:spcPct val="0"/>
-              </a:spcBef>
-              <a:spcAft>
-                <a:spcPts val="320"/>
-              </a:spcAft>
-              <a:buSzPct val="100000"/>
-              <a:buFont typeface="Lucida Grande"/>
-              <a:buChar char="-"/>
-              <a:defRPr sz="746">
-                <a:solidFill>
-                  <a:srgbClr val="00A5DF"/>
-                </a:solidFill>
-                <a:latin typeface="Effra" pitchFamily="34" charset="0"/>
-                <a:ea typeface="MS PGothic" pitchFamily="34" charset="-128"/>
-              </a:defRPr>
-            </a:lvl7pPr>
-            <a:lvl8pPr marL="1828891" indent="-121926" defTabSz="380173" eaLnBrk="0" fontAlgn="base" hangingPunct="0">
-              <a:spcBef>
-                <a:spcPct val="0"/>
-              </a:spcBef>
-              <a:spcAft>
-                <a:spcPts val="320"/>
-              </a:spcAft>
-              <a:buSzPct val="100000"/>
-              <a:buFont typeface="Lucida Grande"/>
-              <a:buChar char="-"/>
-              <a:defRPr sz="746">
-                <a:solidFill>
-                  <a:srgbClr val="00A5DF"/>
-                </a:solidFill>
-                <a:latin typeface="Effra" pitchFamily="34" charset="0"/>
-                <a:ea typeface="MS PGothic" pitchFamily="34" charset="-128"/>
-              </a:defRPr>
-            </a:lvl8pPr>
-            <a:lvl9pPr marL="2072744" indent="-121926" defTabSz="380173" eaLnBrk="0" fontAlgn="base" hangingPunct="0">
-              <a:spcBef>
-                <a:spcPct val="0"/>
-              </a:spcBef>
-              <a:spcAft>
-                <a:spcPts val="320"/>
-              </a:spcAft>
-              <a:buSzPct val="100000"/>
-              <a:buFont typeface="Lucida Grande"/>
-              <a:buChar char="-"/>
-              <a:defRPr sz="746">
-                <a:solidFill>
-                  <a:srgbClr val="00A5DF"/>
-                </a:solidFill>
-                <a:latin typeface="Effra" pitchFamily="34" charset="0"/>
-                <a:ea typeface="MS PGothic" pitchFamily="34" charset="-128"/>
-              </a:defRPr>
-            </a:lvl9pPr>
-          </a:lstStyle>
-          <a:p>
-            <a:fld id="{68C891C2-9A0D-45EC-8340-ED50EC073E9A}" type="slidenum">
-              <a:rPr lang="en-GB" altLang="en-US" sz="800" b="0">
-                <a:solidFill>
-                  <a:schemeClr val="tx1"/>
-                </a:solidFill>
-              </a:rPr>
+          <a:bodyPr/>
+          <a:lstStyle/>
+          <a:p>
+            <a:fld id="{8A4A04CF-1BC9-4C63-AE06-A38D4D08020F}" type="slidenum">
+              <a:rPr lang="en-GB" altLang="en-US" smtClean="0"/>
               <a:pPr/>
               <a:t>9</a:t>
             </a:fld>
-            <a:endParaRPr lang="en-GB" altLang="en-US" sz="800" b="0" dirty="0">
-              <a:solidFill>
-                <a:schemeClr val="tx1"/>
-              </a:solidFill>
-            </a:endParaRPr>
+            <a:endParaRPr lang="en-GB" altLang="en-US" dirty="0"/>
           </a:p>
         </p:txBody>
       </p:sp>
       <p:sp>
         <p:nvSpPr>
-          <p:cNvPr id="5" name="TextBox 4">
+          <p:cNvPr id="6" name="TextBox 5">
             <a:extLst>
               <a:ext uri="{FF2B5EF4-FFF2-40B4-BE49-F238E27FC236}">
-                <a16:creationId xmlns:a16="http://schemas.microsoft.com/office/drawing/2014/main" id="{A96795B0-2F2B-4107-85D2-5872E5D1AA57}"/>
+                <a16:creationId xmlns:a16="http://schemas.microsoft.com/office/drawing/2014/main" id="{B186E202-FDEB-9DFD-B5F1-B56151B9E1B4}"/>
               </a:ext>
             </a:extLst>
           </p:cNvPr>
@@ -40492,8 +39599,8 @@
         </p:nvSpPr>
         <p:spPr>
           <a:xfrm>
-            <a:off x="406245" y="768600"/>
-            <a:ext cx="8593376" cy="609141"/>
+            <a:off x="363538" y="700413"/>
+            <a:ext cx="8442259" cy="4401205"/>
           </a:xfrm>
           <a:prstGeom prst="rect">
             <a:avLst/>
@@ -40501,17 +39608,19 @@
           <a:noFill/>
         </p:spPr>
         <p:txBody>
-          <a:bodyPr wrap="square" lIns="0" tIns="0" rIns="0" bIns="0" rtlCol="0">
+          <a:bodyPr wrap="square">
             <a:spAutoFit/>
           </a:bodyPr>
           <a:lstStyle/>
           <a:p>
-            <a:pPr marL="152408" indent="-152408">
-              <a:lnSpc>
-                <a:spcPct val="150000"/>
-              </a:lnSpc>
-              <a:buFont typeface="Wingdings" panose="05000000000000000000" pitchFamily="2" charset="2"/>
-              <a:buChar char="Ø"/>
+            <a:pPr>
+              <a:buNone/>
+            </a:pPr>
+            <a:endParaRPr lang="en-US" sz="1400" b="1" dirty="0"/>
+          </a:p>
+          <a:p>
+            <a:pPr>
+              <a:buNone/>
             </a:pPr>
             <a:r>
               <a:rPr lang="en-US" dirty="0">
@@ -40519,16 +39628,59 @@
                   <a:srgbClr val="00B0F0"/>
                 </a:solidFill>
               </a:rPr>
-              <a:t>Provide the required inputs and click on Fetch Cautions button</a:t>
+              <a:t>Ensure that the Engine Manual link corresponds to the module type selected in the drop-down list.</a:t>
             </a:r>
           </a:p>
           <a:p>
-            <a:pPr marL="152408" indent="-152408">
-              <a:lnSpc>
-                <a:spcPct val="150000"/>
-              </a:lnSpc>
-              <a:buFont typeface="Wingdings" panose="05000000000000000000" pitchFamily="2" charset="2"/>
-              <a:buChar char="Ø"/>
+            <a:pPr>
+              <a:buNone/>
+            </a:pPr>
+            <a:endParaRPr lang="en-US" dirty="0">
+              <a:solidFill>
+                <a:srgbClr val="00B0F0"/>
+              </a:solidFill>
+            </a:endParaRPr>
+          </a:p>
+          <a:p>
+            <a:pPr>
+              <a:buNone/>
+            </a:pPr>
+            <a:r>
+              <a:rPr lang="en-US" b="1" dirty="0">
+                <a:solidFill>
+                  <a:srgbClr val="FF0000"/>
+                </a:solidFill>
+              </a:rPr>
+              <a:t>NOTE</a:t>
+            </a:r>
+            <a:r>
+              <a:rPr lang="en-US" dirty="0">
+                <a:solidFill>
+                  <a:srgbClr val="00B0F0"/>
+                </a:solidFill>
+              </a:rPr>
+              <a:t> :  The port numbers may change</a:t>
+            </a:r>
+            <a:endParaRPr lang="en-US" b="1" dirty="0"/>
+          </a:p>
+          <a:p>
+            <a:pPr>
+              <a:buNone/>
+            </a:pPr>
+            <a:endParaRPr lang="en-US" sz="1400" b="1" dirty="0"/>
+          </a:p>
+          <a:p>
+            <a:pPr>
+              <a:buNone/>
+            </a:pPr>
+            <a:r>
+              <a:rPr lang="en-US" sz="1400" b="1" dirty="0"/>
+              <a:t>3. Output Location</a:t>
+            </a:r>
+          </a:p>
+          <a:p>
+            <a:pPr>
+              <a:buNone/>
             </a:pPr>
             <a:r>
               <a:rPr lang="en-US" dirty="0">
@@ -40536,7 +39688,163 @@
                   <a:srgbClr val="00B0F0"/>
                 </a:solidFill>
               </a:rPr>
-              <a:t>Tool will generate the list of cautions for the selected module.</a:t>
+              <a:t>The Output location specifies the path where the extracted caution report will be generated.</a:t>
+            </a:r>
+          </a:p>
+          <a:p>
+            <a:pPr>
+              <a:buNone/>
+            </a:pPr>
+            <a:r>
+              <a:rPr lang="en-US" dirty="0">
+                <a:solidFill>
+                  <a:srgbClr val="00B0F0"/>
+                </a:solidFill>
+              </a:rPr>
+              <a:t>Users may enter the full file path or browse to the desired location.</a:t>
+            </a:r>
+          </a:p>
+          <a:p>
+            <a:pPr>
+              <a:buNone/>
+            </a:pPr>
+            <a:r>
+              <a:rPr lang="en-US" dirty="0">
+                <a:solidFill>
+                  <a:srgbClr val="00B0F0"/>
+                </a:solidFill>
+              </a:rPr>
+              <a:t>Example:</a:t>
+            </a:r>
+          </a:p>
+          <a:p>
+            <a:pPr rtl="0">
+              <a:buNone/>
+            </a:pPr>
+            <a:r>
+              <a:rPr lang="en-US" dirty="0">
+                <a:solidFill>
+                  <a:srgbClr val="00B0F0"/>
+                </a:solidFill>
+              </a:rPr>
+              <a:t>D:\Reports\CautionList.xlsx</a:t>
+            </a:r>
+          </a:p>
+          <a:p>
+            <a:pPr rtl="0">
+              <a:buNone/>
+            </a:pPr>
+            <a:endParaRPr lang="en-US" dirty="0">
+              <a:latin typeface="Courier New" panose="02070309020205020404" pitchFamily="49" charset="0"/>
+            </a:endParaRPr>
+          </a:p>
+          <a:p>
+            <a:pPr rtl="0">
+              <a:buNone/>
+            </a:pPr>
+            <a:endParaRPr lang="en-US" sz="1400" dirty="0">
+              <a:latin typeface="Courier New" panose="02070309020205020404" pitchFamily="49" charset="0"/>
+            </a:endParaRPr>
+          </a:p>
+          <a:p>
+            <a:pPr>
+              <a:buNone/>
+            </a:pPr>
+            <a:r>
+              <a:rPr lang="en-US" sz="1400" b="1" dirty="0"/>
+              <a:t>4. Fetch Cautions Button</a:t>
+            </a:r>
+          </a:p>
+          <a:p>
+            <a:pPr>
+              <a:buNone/>
+            </a:pPr>
+            <a:r>
+              <a:rPr lang="en-US" dirty="0">
+                <a:solidFill>
+                  <a:srgbClr val="00B0F0"/>
+                </a:solidFill>
+              </a:rPr>
+              <a:t>Click Fetch Cautions to begin the extraction process.</a:t>
+            </a:r>
+          </a:p>
+          <a:p>
+            <a:pPr>
+              <a:buNone/>
+            </a:pPr>
+            <a:endParaRPr lang="en-US" dirty="0">
+              <a:solidFill>
+                <a:srgbClr val="00B0F0"/>
+              </a:solidFill>
+            </a:endParaRPr>
+          </a:p>
+          <a:p>
+            <a:pPr>
+              <a:buNone/>
+            </a:pPr>
+            <a:r>
+              <a:rPr lang="en-US" dirty="0">
+                <a:solidFill>
+                  <a:srgbClr val="00B0F0"/>
+                </a:solidFill>
+              </a:rPr>
+              <a:t>The tool will:</a:t>
+            </a:r>
+          </a:p>
+          <a:p>
+            <a:pPr>
+              <a:buFont typeface="+mj-lt"/>
+              <a:buAutoNum type="arabicPeriod"/>
+            </a:pPr>
+            <a:r>
+              <a:rPr lang="en-US" dirty="0">
+                <a:solidFill>
+                  <a:srgbClr val="00B0F0"/>
+                </a:solidFill>
+              </a:rPr>
+              <a:t>Open the specified page in the background.</a:t>
+            </a:r>
+          </a:p>
+          <a:p>
+            <a:pPr>
+              <a:buFont typeface="+mj-lt"/>
+              <a:buAutoNum type="arabicPeriod"/>
+            </a:pPr>
+            <a:r>
+              <a:rPr lang="en-US" dirty="0">
+                <a:solidFill>
+                  <a:srgbClr val="00B0F0"/>
+                </a:solidFill>
+              </a:rPr>
+              <a:t>Scan the Engine Manual Page for caution statements.</a:t>
+            </a:r>
+          </a:p>
+          <a:p>
+            <a:pPr>
+              <a:buFont typeface="+mj-lt"/>
+              <a:buAutoNum type="arabicPeriod"/>
+            </a:pPr>
+            <a:r>
+              <a:rPr lang="en-US" dirty="0">
+                <a:solidFill>
+                  <a:srgbClr val="00B0F0"/>
+                </a:solidFill>
+              </a:rPr>
+              <a:t>Extract all identified cautions.</a:t>
+            </a:r>
+          </a:p>
+          <a:p>
+            <a:pPr>
+              <a:buFont typeface="+mj-lt"/>
+              <a:buAutoNum type="arabicPeriod"/>
+            </a:pPr>
+            <a:r>
+              <a:rPr lang="en-US" dirty="0">
+                <a:solidFill>
+                  <a:srgbClr val="00B0F0"/>
+                </a:solidFill>
+              </a:rPr>
+              <a:t>Generate the report at the specified location.</a:t>
             </a:r>
           </a:p>
         </p:txBody>
@@ -40544,7 +39852,7 @@
     </p:spTree>
     <p:extLst>
       <p:ext uri="{BB962C8B-B14F-4D97-AF65-F5344CB8AC3E}">
-        <p14:creationId xmlns:p14="http://schemas.microsoft.com/office/powerpoint/2010/main" val="3656437298"/>
+        <p14:creationId xmlns:p14="http://schemas.microsoft.com/office/powerpoint/2010/main" val="1365765025"/>
       </p:ext>
     </p:extLst>
   </p:cSld>

</xml_diff>

<commit_message>
Changed date and code to include EM & CIR for SP 72-35 and SP 72-51
</commit_message>
<xml_diff>
--- a/ExtractCautionsForEM/bin/Debug/bin/ExtractCautionsFromEngineManualTool.pptx
+++ b/ExtractCautionsForEM/bin/Debug/bin/ExtractCautionsFromEngineManualTool.pptx
@@ -6,10 +6,10 @@
     <p:sldMasterId id="2147483812" r:id="rId5"/>
   </p:sldMasterIdLst>
   <p:notesMasterIdLst>
-    <p:notesMasterId r:id="rId18"/>
+    <p:notesMasterId r:id="rId22"/>
   </p:notesMasterIdLst>
   <p:handoutMasterIdLst>
-    <p:handoutMasterId r:id="rId19"/>
+    <p:handoutMasterId r:id="rId23"/>
   </p:handoutMasterIdLst>
   <p:sldIdLst>
     <p:sldId id="342" r:id="rId6"/>
@@ -18,17 +18,21 @@
     <p:sldId id="964" r:id="rId9"/>
     <p:sldId id="928" r:id="rId10"/>
     <p:sldId id="966" r:id="rId11"/>
-    <p:sldId id="968" r:id="rId12"/>
+    <p:sldId id="972" r:id="rId12"/>
     <p:sldId id="969" r:id="rId13"/>
-    <p:sldId id="970" r:id="rId14"/>
-    <p:sldId id="960" r:id="rId15"/>
-    <p:sldId id="961" r:id="rId16"/>
-    <p:sldId id="840" r:id="rId17"/>
+    <p:sldId id="973" r:id="rId14"/>
+    <p:sldId id="974" r:id="rId15"/>
+    <p:sldId id="975" r:id="rId16"/>
+    <p:sldId id="976" r:id="rId17"/>
+    <p:sldId id="970" r:id="rId18"/>
+    <p:sldId id="960" r:id="rId19"/>
+    <p:sldId id="961" r:id="rId20"/>
+    <p:sldId id="840" r:id="rId21"/>
   </p:sldIdLst>
   <p:sldSz cx="9144000" cy="5715000" type="screen16x10"/>
   <p:notesSz cx="6797675" cy="9926638"/>
   <p:custDataLst>
-    <p:tags r:id="rId20"/>
+    <p:tags r:id="rId24"/>
   </p:custDataLst>
   <p:defaultTextStyle>
     <a:defPPr>
@@ -341,7 +345,7 @@
               <a:pPr>
                 <a:defRPr/>
               </a:pPr>
-              <a:t>8/19/2026</a:t>
+              <a:t>8/20/2026</a:t>
             </a:fld>
             <a:endParaRPr lang="en-GB" dirty="0"/>
           </a:p>
@@ -559,7 +563,7 @@
               <a:pPr>
                 <a:defRPr/>
               </a:pPr>
-              <a:t>8/19/2026</a:t>
+              <a:t>8/20/2026</a:t>
             </a:fld>
             <a:endParaRPr lang="en-GB" dirty="0"/>
           </a:p>
@@ -1587,7 +1591,7 @@
             <a:fld id="{32B34421-655C-4564-82BB-49845E235FC0}" type="slidenum">
               <a:rPr lang="en-GB" altLang="en-US" smtClean="0"/>
               <a:pPr/>
-              <a:t>10</a:t>
+              <a:t>14</a:t>
             </a:fld>
             <a:endParaRPr lang="en-GB" altLang="en-US"/>
           </a:p>
@@ -3296,7 +3300,7 @@
               <a:pPr eaLnBrk="1" hangingPunct="1">
                 <a:defRPr/>
               </a:pPr>
-              <a:t>8/19/2026</a:t>
+              <a:t>8/20/2026</a:t>
             </a:fld>
             <a:endParaRPr lang="en-GB" dirty="0">
               <a:solidFill>
@@ -3730,7 +3734,7 @@
               <a:pPr eaLnBrk="1" hangingPunct="1">
                 <a:defRPr/>
               </a:pPr>
-              <a:t>8/19/2026</a:t>
+              <a:t>8/20/2026</a:t>
             </a:fld>
             <a:endParaRPr lang="en-GB" dirty="0">
               <a:solidFill>
@@ -4188,7 +4192,7 @@
               <a:pPr eaLnBrk="1" hangingPunct="1">
                 <a:defRPr/>
               </a:pPr>
-              <a:t>8/19/2026</a:t>
+              <a:t>8/20/2026</a:t>
             </a:fld>
             <a:endParaRPr lang="en-GB" dirty="0">
               <a:solidFill>
@@ -4618,7 +4622,7 @@
               <a:pPr eaLnBrk="1" hangingPunct="1">
                 <a:defRPr/>
               </a:pPr>
-              <a:t>8/19/2026</a:t>
+              <a:t>8/20/2026</a:t>
             </a:fld>
             <a:endParaRPr lang="en-GB" dirty="0">
               <a:solidFill>
@@ -5225,7 +5229,7 @@
               <a:pPr eaLnBrk="1" hangingPunct="1">
                 <a:defRPr/>
               </a:pPr>
-              <a:t>8/19/2026</a:t>
+              <a:t>8/20/2026</a:t>
             </a:fld>
             <a:endParaRPr lang="en-GB" dirty="0">
               <a:solidFill>
@@ -8637,7 +8641,7 @@
               <a:pPr eaLnBrk="1" hangingPunct="1">
                 <a:defRPr/>
               </a:pPr>
-              <a:t>8/19/2026</a:t>
+              <a:t>8/20/2026</a:t>
             </a:fld>
             <a:endParaRPr lang="en-GB" dirty="0">
               <a:solidFill>
@@ -9452,7 +9456,7 @@
               <a:pPr eaLnBrk="1" hangingPunct="1">
                 <a:defRPr/>
               </a:pPr>
-              <a:t>8/19/2026</a:t>
+              <a:t>8/20/2026</a:t>
             </a:fld>
             <a:endParaRPr lang="en-GB" dirty="0">
               <a:solidFill>
@@ -10273,7 +10277,7 @@
               <a:pPr eaLnBrk="1" hangingPunct="1">
                 <a:defRPr/>
               </a:pPr>
-              <a:t>8/19/2026</a:t>
+              <a:t>8/20/2026</a:t>
             </a:fld>
             <a:endParaRPr lang="en-GB" dirty="0">
               <a:solidFill>
@@ -12125,7 +12129,7 @@
               <a:pPr eaLnBrk="1" hangingPunct="1">
                 <a:defRPr/>
               </a:pPr>
-              <a:t>8/19/2026</a:t>
+              <a:t>8/20/2026</a:t>
             </a:fld>
             <a:endParaRPr lang="en-GB" dirty="0">
               <a:solidFill>
@@ -12646,7 +12650,7 @@
               <a:pPr eaLnBrk="1" hangingPunct="1">
                 <a:defRPr/>
               </a:pPr>
-              <a:t>8/19/2026</a:t>
+              <a:t>8/20/2026</a:t>
             </a:fld>
             <a:endParaRPr lang="en-GB" dirty="0">
               <a:solidFill>
@@ -13168,7 +13172,7 @@
               <a:pPr eaLnBrk="1" hangingPunct="1">
                 <a:defRPr/>
               </a:pPr>
-              <a:t>8/19/2026</a:t>
+              <a:t>8/20/2026</a:t>
             </a:fld>
             <a:endParaRPr lang="en-GB" dirty="0">
               <a:solidFill>
@@ -14796,7 +14800,7 @@
               <a:pPr eaLnBrk="1" hangingPunct="1">
                 <a:defRPr/>
               </a:pPr>
-              <a:t>8/19/2026</a:t>
+              <a:t>8/20/2026</a:t>
             </a:fld>
             <a:endParaRPr lang="en-GB" dirty="0">
               <a:solidFill>
@@ -17312,7 +17316,7 @@
               <a:pPr eaLnBrk="1" hangingPunct="1">
                 <a:defRPr/>
               </a:pPr>
-              <a:t>8/19/2026</a:t>
+              <a:t>8/20/2026</a:t>
             </a:fld>
             <a:endParaRPr lang="en-GB" dirty="0">
               <a:solidFill>
@@ -17890,7 +17894,7 @@
               <a:pPr eaLnBrk="1" hangingPunct="1">
                 <a:defRPr/>
               </a:pPr>
-              <a:t>8/19/2026</a:t>
+              <a:t>8/20/2026</a:t>
             </a:fld>
             <a:endParaRPr lang="en-GB" dirty="0">
               <a:solidFill>
@@ -18605,7 +18609,7 @@
               <a:pPr eaLnBrk="1" hangingPunct="1">
                 <a:defRPr/>
               </a:pPr>
-              <a:t>8/19/2026</a:t>
+              <a:t>8/20/2026</a:t>
             </a:fld>
             <a:endParaRPr lang="en-GB" dirty="0">
               <a:solidFill>
@@ -19317,7 +19321,7 @@
               <a:pPr eaLnBrk="1" hangingPunct="1">
                 <a:defRPr/>
               </a:pPr>
-              <a:t>8/19/2026</a:t>
+              <a:t>8/20/2026</a:t>
             </a:fld>
             <a:endParaRPr lang="en-GB" dirty="0">
               <a:solidFill>
@@ -19751,7 +19755,7 @@
               <a:pPr eaLnBrk="1" hangingPunct="1">
                 <a:defRPr/>
               </a:pPr>
-              <a:t>8/19/2026</a:t>
+              <a:t>8/20/2026</a:t>
             </a:fld>
             <a:endParaRPr lang="en-GB" dirty="0">
               <a:solidFill>
@@ -20209,7 +20213,7 @@
               <a:pPr eaLnBrk="1" hangingPunct="1">
                 <a:defRPr/>
               </a:pPr>
-              <a:t>8/19/2026</a:t>
+              <a:t>8/20/2026</a:t>
             </a:fld>
             <a:endParaRPr lang="en-GB" dirty="0">
               <a:solidFill>
@@ -21822,7 +21826,7 @@
               <a:pPr eaLnBrk="1" hangingPunct="1">
                 <a:defRPr/>
               </a:pPr>
-              <a:t>8/19/2026</a:t>
+              <a:t>8/20/2026</a:t>
             </a:fld>
             <a:endParaRPr lang="en-GB" dirty="0">
               <a:solidFill>
@@ -27443,7 +27447,7 @@
               <a:pPr eaLnBrk="1" hangingPunct="1">
                 <a:defRPr/>
               </a:pPr>
-              <a:t>8/19/2026</a:t>
+              <a:t>8/20/2026</a:t>
             </a:fld>
             <a:endParaRPr lang="en-GB" dirty="0">
               <a:solidFill>
@@ -29959,7 +29963,7 @@
               <a:pPr eaLnBrk="1" hangingPunct="1">
                 <a:defRPr/>
               </a:pPr>
-              <a:t>8/19/2026</a:t>
+              <a:t>8/20/2026</a:t>
             </a:fld>
             <a:endParaRPr lang="en-GB" dirty="0">
               <a:solidFill>
@@ -30537,7 +30541,7 @@
               <a:pPr eaLnBrk="1" hangingPunct="1">
                 <a:defRPr/>
               </a:pPr>
-              <a:t>8/19/2026</a:t>
+              <a:t>8/20/2026</a:t>
             </a:fld>
             <a:endParaRPr lang="en-GB" dirty="0">
               <a:solidFill>
@@ -31252,7 +31256,7 @@
               <a:pPr eaLnBrk="1" hangingPunct="1">
                 <a:defRPr/>
               </a:pPr>
-              <a:t>8/19/2026</a:t>
+              <a:t>8/20/2026</a:t>
             </a:fld>
             <a:endParaRPr lang="en-GB" dirty="0">
               <a:solidFill>
@@ -33553,7 +33557,7 @@
             </a:pPr>
             <a:r>
               <a:rPr lang="en-US" altLang="ja-JP" sz="2800" b="1" dirty="0"/>
-              <a:t>EXTRACT Cautions FROM ENGINE MANUAL Tool</a:t>
+              <a:t>PW1100G Inspection Task_Caution Extraction Tool</a:t>
             </a:r>
             <a:endParaRPr lang="en-GB" altLang="en-US" sz="1800" b="1" dirty="0">
               <a:latin typeface="Arial" panose="020B0604020202020204" pitchFamily="34" charset="0"/>
@@ -33642,7 +33646,7 @@
                   <a:schemeClr val="bg1"/>
                 </a:solidFill>
               </a:rPr>
-              <a:t>Last Update : 19-August-26</a:t>
+              <a:t>Last Update : 20-August-26</a:t>
             </a:r>
           </a:p>
         </p:txBody>
@@ -33656,6 +33660,781 @@
 </file>
 
 <file path=ppt/slides/slide10.xml><?xml version="1.0" encoding="utf-8"?>
+<p:sld xmlns:a="http://schemas.openxmlformats.org/drawingml/2006/main" xmlns:r="http://schemas.openxmlformats.org/officeDocument/2006/relationships" xmlns:p="http://schemas.openxmlformats.org/presentationml/2006/main">
+  <p:cSld>
+    <p:spTree>
+      <p:nvGrpSpPr>
+        <p:cNvPr id="1" name="">
+          <a:extLst>
+            <a:ext uri="{FF2B5EF4-FFF2-40B4-BE49-F238E27FC236}">
+              <a16:creationId xmlns:a16="http://schemas.microsoft.com/office/drawing/2014/main" id="{73259BF7-5E3B-A5EC-BA60-FED597D05DCF}"/>
+            </a:ext>
+          </a:extLst>
+        </p:cNvPr>
+        <p:cNvGrpSpPr/>
+        <p:nvPr/>
+      </p:nvGrpSpPr>
+      <p:grpSpPr>
+        <a:xfrm>
+          <a:off x="0" y="0"/>
+          <a:ext cx="0" cy="0"/>
+          <a:chOff x="0" y="0"/>
+          <a:chExt cx="0" cy="0"/>
+        </a:xfrm>
+      </p:grpSpPr>
+      <p:sp>
+        <p:nvSpPr>
+          <p:cNvPr id="4" name="Slide Number Placeholder 3">
+            <a:extLst>
+              <a:ext uri="{FF2B5EF4-FFF2-40B4-BE49-F238E27FC236}">
+                <a16:creationId xmlns:a16="http://schemas.microsoft.com/office/drawing/2014/main" id="{55001240-5C4F-1D6D-516B-E2C8C020ABCD}"/>
+              </a:ext>
+            </a:extLst>
+          </p:cNvPr>
+          <p:cNvSpPr>
+            <a:spLocks noGrp="1"/>
+          </p:cNvSpPr>
+          <p:nvPr>
+            <p:ph type="sldNum" sz="quarter" idx="14"/>
+          </p:nvPr>
+        </p:nvSpPr>
+        <p:spPr/>
+        <p:txBody>
+          <a:bodyPr/>
+          <a:lstStyle/>
+          <a:p>
+            <a:fld id="{8A4A04CF-1BC9-4C63-AE06-A38D4D08020F}" type="slidenum">
+              <a:rPr lang="en-GB" altLang="en-US" smtClean="0"/>
+              <a:pPr/>
+              <a:t>10</a:t>
+            </a:fld>
+            <a:endParaRPr lang="en-GB" altLang="en-US" dirty="0"/>
+          </a:p>
+        </p:txBody>
+      </p:sp>
+      <p:sp>
+        <p:nvSpPr>
+          <p:cNvPr id="5" name="Title 4">
+            <a:extLst>
+              <a:ext uri="{FF2B5EF4-FFF2-40B4-BE49-F238E27FC236}">
+                <a16:creationId xmlns:a16="http://schemas.microsoft.com/office/drawing/2014/main" id="{0878DDE8-F29F-E921-5F7B-8DC6E7A8631C}"/>
+              </a:ext>
+            </a:extLst>
+          </p:cNvPr>
+          <p:cNvSpPr>
+            <a:spLocks noGrp="1"/>
+          </p:cNvSpPr>
+          <p:nvPr>
+            <p:ph type="title"/>
+          </p:nvPr>
+        </p:nvSpPr>
+        <p:spPr>
+          <a:xfrm>
+            <a:off x="268459" y="129978"/>
+            <a:ext cx="6564050" cy="499251"/>
+          </a:xfrm>
+        </p:spPr>
+        <p:txBody>
+          <a:bodyPr anchor="ctr"/>
+          <a:lstStyle/>
+          <a:p>
+            <a:pPr eaLnBrk="1" hangingPunct="1">
+              <a:lnSpc>
+                <a:spcPct val="110000"/>
+              </a:lnSpc>
+            </a:pPr>
+            <a:r>
+              <a:rPr lang="en-US" altLang="en-US" sz="1800" dirty="0">
+                <a:latin typeface="Effra" pitchFamily="34" charset="0"/>
+              </a:rPr>
+              <a:t>EM CIR Link</a:t>
+            </a:r>
+            <a:endParaRPr lang="en-US" altLang="en-US" sz="1600" dirty="0">
+              <a:latin typeface="Effra" pitchFamily="34" charset="0"/>
+            </a:endParaRPr>
+          </a:p>
+        </p:txBody>
+      </p:sp>
+      <p:pic>
+        <p:nvPicPr>
+          <p:cNvPr id="7" name="Picture 6">
+            <a:extLst>
+              <a:ext uri="{FF2B5EF4-FFF2-40B4-BE49-F238E27FC236}">
+                <a16:creationId xmlns:a16="http://schemas.microsoft.com/office/drawing/2014/main" id="{2F6B00C0-9659-36F7-74EE-69C579A355A8}"/>
+              </a:ext>
+            </a:extLst>
+          </p:cNvPr>
+          <p:cNvPicPr>
+            <a:picLocks noChangeAspect="1"/>
+          </p:cNvPicPr>
+          <p:nvPr/>
+        </p:nvPicPr>
+        <p:blipFill>
+          <a:blip r:embed="rId2"/>
+          <a:stretch>
+            <a:fillRect/>
+          </a:stretch>
+        </p:blipFill>
+        <p:spPr>
+          <a:xfrm>
+            <a:off x="268459" y="629228"/>
+            <a:ext cx="8712704" cy="4637021"/>
+          </a:xfrm>
+          <a:prstGeom prst="rect">
+            <a:avLst/>
+          </a:prstGeom>
+        </p:spPr>
+      </p:pic>
+    </p:spTree>
+    <p:extLst>
+      <p:ext uri="{BB962C8B-B14F-4D97-AF65-F5344CB8AC3E}">
+        <p14:creationId xmlns:p14="http://schemas.microsoft.com/office/powerpoint/2010/main" val="2823888027"/>
+      </p:ext>
+    </p:extLst>
+  </p:cSld>
+  <p:clrMapOvr>
+    <a:masterClrMapping/>
+  </p:clrMapOvr>
+</p:sld>
+</file>
+
+<file path=ppt/slides/slide11.xml><?xml version="1.0" encoding="utf-8"?>
+<p:sld xmlns:a="http://schemas.openxmlformats.org/drawingml/2006/main" xmlns:r="http://schemas.openxmlformats.org/officeDocument/2006/relationships" xmlns:p="http://schemas.openxmlformats.org/presentationml/2006/main">
+  <p:cSld>
+    <p:spTree>
+      <p:nvGrpSpPr>
+        <p:cNvPr id="1" name="">
+          <a:extLst>
+            <a:ext uri="{FF2B5EF4-FFF2-40B4-BE49-F238E27FC236}">
+              <a16:creationId xmlns:a16="http://schemas.microsoft.com/office/drawing/2014/main" id="{FE423C14-5863-810C-9802-BF541C8EB56B}"/>
+            </a:ext>
+          </a:extLst>
+        </p:cNvPr>
+        <p:cNvGrpSpPr/>
+        <p:nvPr/>
+      </p:nvGrpSpPr>
+      <p:grpSpPr>
+        <a:xfrm>
+          <a:off x="0" y="0"/>
+          <a:ext cx="0" cy="0"/>
+          <a:chOff x="0" y="0"/>
+          <a:chExt cx="0" cy="0"/>
+        </a:xfrm>
+      </p:grpSpPr>
+      <p:sp>
+        <p:nvSpPr>
+          <p:cNvPr id="4" name="Slide Number Placeholder 3">
+            <a:extLst>
+              <a:ext uri="{FF2B5EF4-FFF2-40B4-BE49-F238E27FC236}">
+                <a16:creationId xmlns:a16="http://schemas.microsoft.com/office/drawing/2014/main" id="{5863C7CE-F30C-7B04-F4F0-A3DFE92CED73}"/>
+              </a:ext>
+            </a:extLst>
+          </p:cNvPr>
+          <p:cNvSpPr>
+            <a:spLocks noGrp="1"/>
+          </p:cNvSpPr>
+          <p:nvPr>
+            <p:ph type="sldNum" sz="quarter" idx="14"/>
+          </p:nvPr>
+        </p:nvSpPr>
+        <p:spPr/>
+        <p:txBody>
+          <a:bodyPr/>
+          <a:lstStyle/>
+          <a:p>
+            <a:fld id="{8A4A04CF-1BC9-4C63-AE06-A38D4D08020F}" type="slidenum">
+              <a:rPr lang="en-GB" altLang="en-US" smtClean="0"/>
+              <a:pPr/>
+              <a:t>11</a:t>
+            </a:fld>
+            <a:endParaRPr lang="en-GB" altLang="en-US" dirty="0"/>
+          </a:p>
+        </p:txBody>
+      </p:sp>
+      <p:sp>
+        <p:nvSpPr>
+          <p:cNvPr id="5" name="Title 4">
+            <a:extLst>
+              <a:ext uri="{FF2B5EF4-FFF2-40B4-BE49-F238E27FC236}">
+                <a16:creationId xmlns:a16="http://schemas.microsoft.com/office/drawing/2014/main" id="{B86E6185-53F0-CDFA-A12B-7DD7263D2531}"/>
+              </a:ext>
+            </a:extLst>
+          </p:cNvPr>
+          <p:cNvSpPr>
+            <a:spLocks noGrp="1"/>
+          </p:cNvSpPr>
+          <p:nvPr>
+            <p:ph type="title"/>
+          </p:nvPr>
+        </p:nvSpPr>
+        <p:spPr>
+          <a:xfrm>
+            <a:off x="268459" y="129978"/>
+            <a:ext cx="6564050" cy="499251"/>
+          </a:xfrm>
+        </p:spPr>
+        <p:txBody>
+          <a:bodyPr anchor="ctr"/>
+          <a:lstStyle/>
+          <a:p>
+            <a:pPr eaLnBrk="1" hangingPunct="1">
+              <a:lnSpc>
+                <a:spcPct val="110000"/>
+              </a:lnSpc>
+            </a:pPr>
+            <a:r>
+              <a:rPr lang="en-US" altLang="en-US" sz="1800" dirty="0">
+                <a:latin typeface="Effra" pitchFamily="34" charset="0"/>
+              </a:rPr>
+              <a:t>SP 72-35 (EM &amp; CIR) Link</a:t>
+            </a:r>
+            <a:endParaRPr lang="en-US" altLang="en-US" sz="1600" dirty="0">
+              <a:latin typeface="Effra" pitchFamily="34" charset="0"/>
+            </a:endParaRPr>
+          </a:p>
+        </p:txBody>
+      </p:sp>
+      <p:pic>
+        <p:nvPicPr>
+          <p:cNvPr id="7" name="Picture 6">
+            <a:extLst>
+              <a:ext uri="{FF2B5EF4-FFF2-40B4-BE49-F238E27FC236}">
+                <a16:creationId xmlns:a16="http://schemas.microsoft.com/office/drawing/2014/main" id="{0D35DE5A-78DD-20D9-0FE0-623B283ABFB4}"/>
+              </a:ext>
+            </a:extLst>
+          </p:cNvPr>
+          <p:cNvPicPr>
+            <a:picLocks noChangeAspect="1"/>
+          </p:cNvPicPr>
+          <p:nvPr/>
+        </p:nvPicPr>
+        <p:blipFill>
+          <a:blip r:embed="rId2"/>
+          <a:stretch>
+            <a:fillRect/>
+          </a:stretch>
+        </p:blipFill>
+        <p:spPr>
+          <a:xfrm>
+            <a:off x="268460" y="629228"/>
+            <a:ext cx="8336922" cy="4682547"/>
+          </a:xfrm>
+          <a:prstGeom prst="rect">
+            <a:avLst/>
+          </a:prstGeom>
+        </p:spPr>
+      </p:pic>
+    </p:spTree>
+    <p:extLst>
+      <p:ext uri="{BB962C8B-B14F-4D97-AF65-F5344CB8AC3E}">
+        <p14:creationId xmlns:p14="http://schemas.microsoft.com/office/powerpoint/2010/main" val="3725909667"/>
+      </p:ext>
+    </p:extLst>
+  </p:cSld>
+  <p:clrMapOvr>
+    <a:masterClrMapping/>
+  </p:clrMapOvr>
+</p:sld>
+</file>
+
+<file path=ppt/slides/slide12.xml><?xml version="1.0" encoding="utf-8"?>
+<p:sld xmlns:a="http://schemas.openxmlformats.org/drawingml/2006/main" xmlns:r="http://schemas.openxmlformats.org/officeDocument/2006/relationships" xmlns:p="http://schemas.openxmlformats.org/presentationml/2006/main">
+  <p:cSld>
+    <p:spTree>
+      <p:nvGrpSpPr>
+        <p:cNvPr id="1" name="">
+          <a:extLst>
+            <a:ext uri="{FF2B5EF4-FFF2-40B4-BE49-F238E27FC236}">
+              <a16:creationId xmlns:a16="http://schemas.microsoft.com/office/drawing/2014/main" id="{8C813E11-F218-5104-89B6-19014B5C4DD9}"/>
+            </a:ext>
+          </a:extLst>
+        </p:cNvPr>
+        <p:cNvGrpSpPr/>
+        <p:nvPr/>
+      </p:nvGrpSpPr>
+      <p:grpSpPr>
+        <a:xfrm>
+          <a:off x="0" y="0"/>
+          <a:ext cx="0" cy="0"/>
+          <a:chOff x="0" y="0"/>
+          <a:chExt cx="0" cy="0"/>
+        </a:xfrm>
+      </p:grpSpPr>
+      <p:sp>
+        <p:nvSpPr>
+          <p:cNvPr id="4" name="Slide Number Placeholder 3">
+            <a:extLst>
+              <a:ext uri="{FF2B5EF4-FFF2-40B4-BE49-F238E27FC236}">
+                <a16:creationId xmlns:a16="http://schemas.microsoft.com/office/drawing/2014/main" id="{D6D627D9-8126-284A-C9AE-7DB5A30B8162}"/>
+              </a:ext>
+            </a:extLst>
+          </p:cNvPr>
+          <p:cNvSpPr>
+            <a:spLocks noGrp="1"/>
+          </p:cNvSpPr>
+          <p:nvPr>
+            <p:ph type="sldNum" sz="quarter" idx="14"/>
+          </p:nvPr>
+        </p:nvSpPr>
+        <p:spPr/>
+        <p:txBody>
+          <a:bodyPr/>
+          <a:lstStyle/>
+          <a:p>
+            <a:fld id="{8A4A04CF-1BC9-4C63-AE06-A38D4D08020F}" type="slidenum">
+              <a:rPr lang="en-GB" altLang="en-US" smtClean="0"/>
+              <a:pPr/>
+              <a:t>12</a:t>
+            </a:fld>
+            <a:endParaRPr lang="en-GB" altLang="en-US" dirty="0"/>
+          </a:p>
+        </p:txBody>
+      </p:sp>
+      <p:sp>
+        <p:nvSpPr>
+          <p:cNvPr id="5" name="Title 4">
+            <a:extLst>
+              <a:ext uri="{FF2B5EF4-FFF2-40B4-BE49-F238E27FC236}">
+                <a16:creationId xmlns:a16="http://schemas.microsoft.com/office/drawing/2014/main" id="{8C8B5A71-67E1-7616-942F-16BCB2D4C044}"/>
+              </a:ext>
+            </a:extLst>
+          </p:cNvPr>
+          <p:cNvSpPr>
+            <a:spLocks noGrp="1"/>
+          </p:cNvSpPr>
+          <p:nvPr>
+            <p:ph type="title"/>
+          </p:nvPr>
+        </p:nvSpPr>
+        <p:spPr>
+          <a:xfrm>
+            <a:off x="268459" y="129978"/>
+            <a:ext cx="6564050" cy="499251"/>
+          </a:xfrm>
+        </p:spPr>
+        <p:txBody>
+          <a:bodyPr anchor="ctr"/>
+          <a:lstStyle/>
+          <a:p>
+            <a:pPr eaLnBrk="1" hangingPunct="1">
+              <a:lnSpc>
+                <a:spcPct val="110000"/>
+              </a:lnSpc>
+            </a:pPr>
+            <a:r>
+              <a:rPr lang="en-US" altLang="en-US" sz="1800" dirty="0">
+                <a:latin typeface="Effra" pitchFamily="34" charset="0"/>
+              </a:rPr>
+              <a:t>SP 72-51 (EM &amp; CIR) Link</a:t>
+            </a:r>
+            <a:endParaRPr lang="en-US" altLang="en-US" sz="1600" dirty="0">
+              <a:latin typeface="Effra" pitchFamily="34" charset="0"/>
+            </a:endParaRPr>
+          </a:p>
+        </p:txBody>
+      </p:sp>
+      <p:pic>
+        <p:nvPicPr>
+          <p:cNvPr id="7" name="Picture 6">
+            <a:extLst>
+              <a:ext uri="{FF2B5EF4-FFF2-40B4-BE49-F238E27FC236}">
+                <a16:creationId xmlns:a16="http://schemas.microsoft.com/office/drawing/2014/main" id="{FB092EED-EF48-D7F9-D997-831D9F815DF7}"/>
+              </a:ext>
+            </a:extLst>
+          </p:cNvPr>
+          <p:cNvPicPr>
+            <a:picLocks noChangeAspect="1"/>
+          </p:cNvPicPr>
+          <p:nvPr/>
+        </p:nvPicPr>
+        <p:blipFill>
+          <a:blip r:embed="rId2"/>
+          <a:stretch>
+            <a:fillRect/>
+          </a:stretch>
+        </p:blipFill>
+        <p:spPr>
+          <a:xfrm>
+            <a:off x="268459" y="629228"/>
+            <a:ext cx="8236714" cy="4855585"/>
+          </a:xfrm>
+          <a:prstGeom prst="rect">
+            <a:avLst/>
+          </a:prstGeom>
+        </p:spPr>
+      </p:pic>
+    </p:spTree>
+    <p:extLst>
+      <p:ext uri="{BB962C8B-B14F-4D97-AF65-F5344CB8AC3E}">
+        <p14:creationId xmlns:p14="http://schemas.microsoft.com/office/powerpoint/2010/main" val="3852631643"/>
+      </p:ext>
+    </p:extLst>
+  </p:cSld>
+  <p:clrMapOvr>
+    <a:masterClrMapping/>
+  </p:clrMapOvr>
+</p:sld>
+</file>
+
+<file path=ppt/slides/slide13.xml><?xml version="1.0" encoding="utf-8"?>
+<p:sld xmlns:a="http://schemas.openxmlformats.org/drawingml/2006/main" xmlns:r="http://schemas.openxmlformats.org/officeDocument/2006/relationships" xmlns:p="http://schemas.openxmlformats.org/presentationml/2006/main">
+  <p:cSld>
+    <p:spTree>
+      <p:nvGrpSpPr>
+        <p:cNvPr id="1" name=""/>
+        <p:cNvGrpSpPr/>
+        <p:nvPr/>
+      </p:nvGrpSpPr>
+      <p:grpSpPr>
+        <a:xfrm>
+          <a:off x="0" y="0"/>
+          <a:ext cx="0" cy="0"/>
+          <a:chOff x="0" y="0"/>
+          <a:chExt cx="0" cy="0"/>
+        </a:xfrm>
+      </p:grpSpPr>
+      <p:sp>
+        <p:nvSpPr>
+          <p:cNvPr id="4" name="Slide Number Placeholder 3">
+            <a:extLst>
+              <a:ext uri="{FF2B5EF4-FFF2-40B4-BE49-F238E27FC236}">
+                <a16:creationId xmlns:a16="http://schemas.microsoft.com/office/drawing/2014/main" id="{7DBFB500-BDE9-AF4D-7E46-5542A0782CE2}"/>
+              </a:ext>
+            </a:extLst>
+          </p:cNvPr>
+          <p:cNvSpPr>
+            <a:spLocks noGrp="1"/>
+          </p:cNvSpPr>
+          <p:nvPr>
+            <p:ph type="sldNum" sz="quarter" idx="14"/>
+          </p:nvPr>
+        </p:nvSpPr>
+        <p:spPr/>
+        <p:txBody>
+          <a:bodyPr/>
+          <a:lstStyle/>
+          <a:p>
+            <a:fld id="{8A4A04CF-1BC9-4C63-AE06-A38D4D08020F}" type="slidenum">
+              <a:rPr lang="en-GB" altLang="en-US" smtClean="0"/>
+              <a:pPr/>
+              <a:t>13</a:t>
+            </a:fld>
+            <a:endParaRPr lang="en-GB" altLang="en-US" dirty="0"/>
+          </a:p>
+        </p:txBody>
+      </p:sp>
+      <p:sp>
+        <p:nvSpPr>
+          <p:cNvPr id="6" name="TextBox 5">
+            <a:extLst>
+              <a:ext uri="{FF2B5EF4-FFF2-40B4-BE49-F238E27FC236}">
+                <a16:creationId xmlns:a16="http://schemas.microsoft.com/office/drawing/2014/main" id="{B186E202-FDEB-9DFD-B5F1-B56151B9E1B4}"/>
+              </a:ext>
+            </a:extLst>
+          </p:cNvPr>
+          <p:cNvSpPr txBox="1"/>
+          <p:nvPr/>
+        </p:nvSpPr>
+        <p:spPr>
+          <a:xfrm>
+            <a:off x="363538" y="700413"/>
+            <a:ext cx="8442259" cy="4616648"/>
+          </a:xfrm>
+          <a:prstGeom prst="rect">
+            <a:avLst/>
+          </a:prstGeom>
+          <a:noFill/>
+        </p:spPr>
+        <p:txBody>
+          <a:bodyPr wrap="square">
+            <a:spAutoFit/>
+          </a:bodyPr>
+          <a:lstStyle/>
+          <a:p>
+            <a:pPr>
+              <a:buNone/>
+            </a:pPr>
+            <a:endParaRPr lang="en-US" sz="1400" b="1" dirty="0"/>
+          </a:p>
+          <a:p>
+            <a:pPr>
+              <a:buNone/>
+            </a:pPr>
+            <a:r>
+              <a:rPr lang="en-US" dirty="0">
+                <a:solidFill>
+                  <a:srgbClr val="00B0F0"/>
+                </a:solidFill>
+              </a:rPr>
+              <a:t>Ensure that the Engine Manual link corresponds to the Manual type selected in the drop-down list.</a:t>
+            </a:r>
+          </a:p>
+          <a:p>
+            <a:pPr>
+              <a:buNone/>
+            </a:pPr>
+            <a:endParaRPr lang="en-US" dirty="0">
+              <a:solidFill>
+                <a:srgbClr val="00B0F0"/>
+              </a:solidFill>
+            </a:endParaRPr>
+          </a:p>
+          <a:p>
+            <a:pPr>
+              <a:buNone/>
+            </a:pPr>
+            <a:r>
+              <a:rPr lang="en-US" b="1" dirty="0">
+                <a:solidFill>
+                  <a:srgbClr val="FF0000"/>
+                </a:solidFill>
+              </a:rPr>
+              <a:t>NOTE</a:t>
+            </a:r>
+            <a:r>
+              <a:rPr lang="en-US" dirty="0">
+                <a:solidFill>
+                  <a:srgbClr val="00B0F0"/>
+                </a:solidFill>
+              </a:rPr>
+              <a:t> :  The port numbers may change</a:t>
+            </a:r>
+            <a:endParaRPr lang="en-US" b="1" dirty="0"/>
+          </a:p>
+          <a:p>
+            <a:pPr>
+              <a:buNone/>
+            </a:pPr>
+            <a:endParaRPr lang="en-US" sz="1400" b="1" dirty="0"/>
+          </a:p>
+          <a:p>
+            <a:pPr>
+              <a:buNone/>
+            </a:pPr>
+            <a:r>
+              <a:rPr lang="en-US" sz="1400" b="1" dirty="0"/>
+              <a:t>3. Output Location</a:t>
+            </a:r>
+          </a:p>
+          <a:p>
+            <a:pPr>
+              <a:buNone/>
+            </a:pPr>
+            <a:r>
+              <a:rPr lang="en-US" dirty="0">
+                <a:solidFill>
+                  <a:srgbClr val="00B0F0"/>
+                </a:solidFill>
+              </a:rPr>
+              <a:t>The Output location specifies the path where the </a:t>
+            </a:r>
+            <a:r>
+              <a:rPr lang="en-US">
+                <a:solidFill>
+                  <a:srgbClr val="00B0F0"/>
+                </a:solidFill>
+              </a:rPr>
+              <a:t>extracted Cautions </a:t>
+            </a:r>
+            <a:r>
+              <a:rPr lang="en-US" dirty="0">
+                <a:solidFill>
+                  <a:srgbClr val="00B0F0"/>
+                </a:solidFill>
+              </a:rPr>
+              <a:t>report will be generated.</a:t>
+            </a:r>
+          </a:p>
+          <a:p>
+            <a:pPr>
+              <a:buNone/>
+            </a:pPr>
+            <a:r>
+              <a:rPr lang="en-US" dirty="0">
+                <a:solidFill>
+                  <a:srgbClr val="00B0F0"/>
+                </a:solidFill>
+              </a:rPr>
+              <a:t>Users may enter the full file path or browse to the desired location.</a:t>
+            </a:r>
+          </a:p>
+          <a:p>
+            <a:pPr>
+              <a:buNone/>
+            </a:pPr>
+            <a:endParaRPr lang="en-US" dirty="0">
+              <a:solidFill>
+                <a:srgbClr val="00B0F0"/>
+              </a:solidFill>
+            </a:endParaRPr>
+          </a:p>
+          <a:p>
+            <a:pPr>
+              <a:buNone/>
+            </a:pPr>
+            <a:r>
+              <a:rPr lang="en-US" dirty="0">
+                <a:solidFill>
+                  <a:srgbClr val="00B0F0"/>
+                </a:solidFill>
+              </a:rPr>
+              <a:t>Example:</a:t>
+            </a:r>
+          </a:p>
+          <a:p>
+            <a:pPr rtl="0">
+              <a:buNone/>
+            </a:pPr>
+            <a:r>
+              <a:rPr lang="en-US" dirty="0">
+                <a:solidFill>
+                  <a:srgbClr val="00B0F0"/>
+                </a:solidFill>
+              </a:rPr>
+              <a:t>D:\Reports\CautionList.xlsx</a:t>
+            </a:r>
+          </a:p>
+          <a:p>
+            <a:pPr rtl="0">
+              <a:buNone/>
+            </a:pPr>
+            <a:endParaRPr lang="en-US" dirty="0">
+              <a:latin typeface="Courier New" panose="02070309020205020404" pitchFamily="49" charset="0"/>
+            </a:endParaRPr>
+          </a:p>
+          <a:p>
+            <a:pPr rtl="0">
+              <a:buNone/>
+            </a:pPr>
+            <a:endParaRPr lang="en-US" sz="1400" dirty="0">
+              <a:latin typeface="Courier New" panose="02070309020205020404" pitchFamily="49" charset="0"/>
+            </a:endParaRPr>
+          </a:p>
+          <a:p>
+            <a:pPr>
+              <a:buNone/>
+            </a:pPr>
+            <a:r>
+              <a:rPr lang="en-US" sz="1400" b="1" dirty="0"/>
+              <a:t>4. </a:t>
+            </a:r>
+            <a:r>
+              <a:rPr lang="en-US" b="1" dirty="0"/>
+              <a:t>Run</a:t>
+            </a:r>
+            <a:r>
+              <a:rPr lang="en-US" sz="1400" b="1" dirty="0"/>
+              <a:t> Button</a:t>
+            </a:r>
+          </a:p>
+          <a:p>
+            <a:pPr>
+              <a:buNone/>
+            </a:pPr>
+            <a:r>
+              <a:rPr lang="en-US" dirty="0">
+                <a:solidFill>
+                  <a:srgbClr val="00B0F0"/>
+                </a:solidFill>
+              </a:rPr>
+              <a:t>Click Run Button to begin the extraction process.</a:t>
+            </a:r>
+          </a:p>
+          <a:p>
+            <a:pPr>
+              <a:buNone/>
+            </a:pPr>
+            <a:endParaRPr lang="en-US" dirty="0">
+              <a:solidFill>
+                <a:srgbClr val="00B0F0"/>
+              </a:solidFill>
+            </a:endParaRPr>
+          </a:p>
+          <a:p>
+            <a:pPr>
+              <a:buNone/>
+            </a:pPr>
+            <a:r>
+              <a:rPr lang="en-US" dirty="0">
+                <a:solidFill>
+                  <a:srgbClr val="00B0F0"/>
+                </a:solidFill>
+              </a:rPr>
+              <a:t>The tool will:</a:t>
+            </a:r>
+          </a:p>
+          <a:p>
+            <a:pPr>
+              <a:buFont typeface="+mj-lt"/>
+              <a:buAutoNum type="arabicPeriod"/>
+            </a:pPr>
+            <a:r>
+              <a:rPr lang="en-US" dirty="0">
+                <a:solidFill>
+                  <a:srgbClr val="00B0F0"/>
+                </a:solidFill>
+              </a:rPr>
+              <a:t>Open the specified Manual Link in the background.</a:t>
+            </a:r>
+          </a:p>
+          <a:p>
+            <a:pPr>
+              <a:buFont typeface="+mj-lt"/>
+              <a:buAutoNum type="arabicPeriod"/>
+            </a:pPr>
+            <a:r>
+              <a:rPr lang="en-US" dirty="0">
+                <a:solidFill>
+                  <a:srgbClr val="00B0F0"/>
+                </a:solidFill>
+              </a:rPr>
+              <a:t>Scan the Link for caution statements.</a:t>
+            </a:r>
+          </a:p>
+          <a:p>
+            <a:pPr>
+              <a:buFont typeface="+mj-lt"/>
+              <a:buAutoNum type="arabicPeriod"/>
+            </a:pPr>
+            <a:r>
+              <a:rPr lang="en-US" dirty="0">
+                <a:solidFill>
+                  <a:srgbClr val="00B0F0"/>
+                </a:solidFill>
+              </a:rPr>
+              <a:t>Extract all identified cautions.</a:t>
+            </a:r>
+          </a:p>
+          <a:p>
+            <a:pPr>
+              <a:buFont typeface="+mj-lt"/>
+              <a:buAutoNum type="arabicPeriod"/>
+            </a:pPr>
+            <a:r>
+              <a:rPr lang="en-US" dirty="0">
+                <a:solidFill>
+                  <a:srgbClr val="00B0F0"/>
+                </a:solidFill>
+              </a:rPr>
+              <a:t>Generate the report at the specified location.</a:t>
+            </a:r>
+          </a:p>
+        </p:txBody>
+      </p:sp>
+    </p:spTree>
+    <p:extLst>
+      <p:ext uri="{BB962C8B-B14F-4D97-AF65-F5344CB8AC3E}">
+        <p14:creationId xmlns:p14="http://schemas.microsoft.com/office/powerpoint/2010/main" val="1365765025"/>
+      </p:ext>
+    </p:extLst>
+  </p:cSld>
+  <p:clrMapOvr>
+    <a:masterClrMapping/>
+  </p:clrMapOvr>
+</p:sld>
+</file>
+
+<file path=ppt/slides/slide14.xml><?xml version="1.0" encoding="utf-8"?>
 <p:sld xmlns:a="http://schemas.openxmlformats.org/drawingml/2006/main" xmlns:r="http://schemas.openxmlformats.org/officeDocument/2006/relationships" xmlns:p="http://schemas.openxmlformats.org/presentationml/2006/main">
   <p:cSld>
     <p:spTree>
@@ -33731,7 +34510,7 @@
             <a:fld id="{8A4A04CF-1BC9-4C63-AE06-A38D4D08020F}" type="slidenum">
               <a:rPr lang="en-GB" altLang="en-US" smtClean="0"/>
               <a:pPr/>
-              <a:t>10</a:t>
+              <a:t>14</a:t>
             </a:fld>
             <a:endParaRPr lang="en-GB" altLang="en-US" dirty="0"/>
           </a:p>
@@ -34303,7 +35082,7 @@
 </p:sld>
 </file>
 
-<file path=ppt/slides/slide11.xml><?xml version="1.0" encoding="utf-8"?>
+<file path=ppt/slides/slide15.xml><?xml version="1.0" encoding="utf-8"?>
 <p:sld xmlns:a="http://schemas.openxmlformats.org/drawingml/2006/main" xmlns:r="http://schemas.openxmlformats.org/officeDocument/2006/relationships" xmlns:p="http://schemas.openxmlformats.org/presentationml/2006/main">
   <p:cSld>
     <p:spTree>
@@ -34449,7 +35228,7 @@
             <a:fld id="{8A4A04CF-1BC9-4C63-AE06-A38D4D08020F}" type="slidenum">
               <a:rPr lang="en-GB" altLang="en-US" smtClean="0"/>
               <a:pPr/>
-              <a:t>11</a:t>
+              <a:t>15</a:t>
             </a:fld>
             <a:endParaRPr lang="en-GB" altLang="en-US" dirty="0"/>
           </a:p>
@@ -34708,7 +35487,7 @@
 </p:sld>
 </file>
 
-<file path=ppt/slides/slide12.xml><?xml version="1.0" encoding="utf-8"?>
+<file path=ppt/slides/slide16.xml><?xml version="1.0" encoding="utf-8"?>
 <p:sld xmlns:a="http://schemas.openxmlformats.org/drawingml/2006/main" xmlns:r="http://schemas.openxmlformats.org/officeDocument/2006/relationships" xmlns:p="http://schemas.openxmlformats.org/presentationml/2006/main">
   <p:cSld>
     <p:spTree>
@@ -35198,7 +35977,7 @@
             <a:fld id="{82DD3993-69B2-42D4-A33C-1B42906A94F6}" type="slidenum">
               <a:rPr lang="en-GB" altLang="en-US" smtClean="0"/>
               <a:pPr/>
-              <a:t>12</a:t>
+              <a:t>16</a:t>
             </a:fld>
             <a:endParaRPr lang="en-GB" altLang="en-US"/>
           </a:p>
@@ -35668,7 +36447,7 @@
           <p:nvPr>
             <p:extLst>
               <p:ext uri="{D42A27DB-BD31-4B8C-83A1-F6EECF244321}">
-                <p14:modId xmlns:p14="http://schemas.microsoft.com/office/powerpoint/2010/main" val="4067141589"/>
+                <p14:modId xmlns:p14="http://schemas.microsoft.com/office/powerpoint/2010/main" val="415363521"/>
               </p:ext>
             </p:extLst>
           </p:nvPr>
@@ -36164,7 +36943,7 @@
                         <a:rPr lang="en-US" sz="1300" u="sng" dirty="0">
                           <a:hlinkClick r:id="rId7" action="ppaction://hlinksldjump"/>
                         </a:rPr>
-                        <a:t>8-9</a:t>
+                        <a:t>8-13</a:t>
                       </a:r>
                       <a:endParaRPr lang="en-US" sz="1300" u="sng" dirty="0"/>
                     </a:p>
@@ -36245,7 +37024,7 @@
                         <a:rPr lang="en-US" u="sng" dirty="0">
                           <a:hlinkClick r:id="rId8" action="ppaction://hlinksldjump"/>
                         </a:rPr>
-                        <a:t>10</a:t>
+                        <a:t>14</a:t>
                       </a:r>
                       <a:endParaRPr lang="en-US" u="sng" dirty="0"/>
                     </a:p>
@@ -36318,7 +37097,7 @@
                         <a:rPr lang="en-US" u="sng" dirty="0">
                           <a:hlinkClick r:id="rId9" action="ppaction://hlinksldjump"/>
                         </a:rPr>
-                        <a:t>11</a:t>
+                        <a:t>15</a:t>
                       </a:r>
                       <a:endParaRPr lang="en-US" u="sng" dirty="0"/>
                     </a:p>
@@ -36664,7 +37443,7 @@
                   <a:schemeClr val="accent2"/>
                 </a:solidFill>
               </a:rPr>
-              <a:t>SP 72-35</a:t>
+              <a:t>SP 72-35 (EM &amp; CIR)</a:t>
             </a:r>
           </a:p>
           <a:p>
@@ -36673,13 +37452,18 @@
               <a:buChar char="•"/>
             </a:pPr>
             <a:r>
-              <a:rPr lang="en-US" sz="1400" b="0" dirty="0">
+              <a:rPr lang="en-US" sz="1400" b="0">
                 <a:solidFill>
                   <a:schemeClr val="accent2"/>
                 </a:solidFill>
               </a:rPr>
-              <a:t>SP 72-51</a:t>
+              <a:t>SP 72-51 (EM &amp; CIR)</a:t>
             </a:r>
+            <a:endParaRPr lang="en-US" sz="1400" b="0" dirty="0">
+              <a:solidFill>
+                <a:schemeClr val="accent2"/>
+              </a:solidFill>
+            </a:endParaRPr>
           </a:p>
           <a:p>
             <a:endParaRPr lang="en-US" sz="1400" b="0" dirty="0">
@@ -37285,7 +38069,7 @@
           <p:nvPr>
             <p:extLst>
               <p:ext uri="{D42A27DB-BD31-4B8C-83A1-F6EECF244321}">
-                <p14:modId xmlns:p14="http://schemas.microsoft.com/office/powerpoint/2010/main" val="1419842571"/>
+                <p14:modId xmlns:p14="http://schemas.microsoft.com/office/powerpoint/2010/main" val="2609532532"/>
               </p:ext>
             </p:extLst>
           </p:nvPr>
@@ -37395,7 +38179,7 @@
                       <a:pPr algn="ctr"/>
                       <a:r>
                         <a:rPr lang="en-US" dirty="0"/>
-                        <a:t>19-Aug-2026</a:t>
+                        <a:t>20-Aug-2026</a:t>
                       </a:r>
                     </a:p>
                   </a:txBody>
@@ -37491,7 +38275,7 @@
             </a:r>
             <a:r>
               <a:rPr lang="en-US" sz="1600" dirty="0"/>
-              <a:t>Extract Cautions From Engine Manual Tool</a:t>
+              <a:t>PW1100G Inspection Task_Caution Extraction Tool</a:t>
             </a:r>
             <a:r>
               <a:rPr lang="en-US" sz="1600" b="0" dirty="0"/>
@@ -37753,7 +38537,7 @@
         </p:nvSpPr>
         <p:spPr>
           <a:xfrm>
-            <a:off x="3842748" y="5290914"/>
+            <a:off x="3842748" y="4783136"/>
             <a:ext cx="1863029" cy="193899"/>
           </a:xfrm>
           <a:prstGeom prst="rect">
@@ -37884,10 +38668,10 @@
       </p:sp>
       <p:pic>
         <p:nvPicPr>
-          <p:cNvPr id="3" name="Picture 2">
+          <p:cNvPr id="8" name="Picture 7">
             <a:extLst>
               <a:ext uri="{FF2B5EF4-FFF2-40B4-BE49-F238E27FC236}">
-                <a16:creationId xmlns:a16="http://schemas.microsoft.com/office/drawing/2014/main" id="{E8C67DC2-4835-3BB5-8E85-37F94A6333B1}"/>
+                <a16:creationId xmlns:a16="http://schemas.microsoft.com/office/drawing/2014/main" id="{BA70ECE1-F3FC-3CB5-E158-3AFBE1B39C9D}"/>
               </a:ext>
             </a:extLst>
           </p:cNvPr>
@@ -37904,8 +38688,8 @@
         </p:blipFill>
         <p:spPr>
           <a:xfrm>
-            <a:off x="1090126" y="1419024"/>
-            <a:ext cx="6963747" cy="2876951"/>
+            <a:off x="580468" y="1266603"/>
+            <a:ext cx="7983064" cy="3181794"/>
           </a:xfrm>
           <a:prstGeom prst="rect">
             <a:avLst/>
@@ -37986,7 +38770,7 @@
         </p:nvSpPr>
         <p:spPr>
           <a:xfrm>
-            <a:off x="3842748" y="5290914"/>
+            <a:off x="3880326" y="4690949"/>
             <a:ext cx="1863029" cy="193899"/>
           </a:xfrm>
           <a:prstGeom prst="rect">
@@ -38117,10 +38901,10 @@
       </p:sp>
       <p:pic>
         <p:nvPicPr>
-          <p:cNvPr id="3" name="Picture 2">
+          <p:cNvPr id="5" name="Picture 4">
             <a:extLst>
               <a:ext uri="{FF2B5EF4-FFF2-40B4-BE49-F238E27FC236}">
-                <a16:creationId xmlns:a16="http://schemas.microsoft.com/office/drawing/2014/main" id="{653C374F-6078-6C1D-7450-98C1E669DD25}"/>
+                <a16:creationId xmlns:a16="http://schemas.microsoft.com/office/drawing/2014/main" id="{C605929B-3343-BA97-6880-A48E400BED6F}"/>
               </a:ext>
             </a:extLst>
           </p:cNvPr>
@@ -38137,8 +38921,8 @@
         </p:blipFill>
         <p:spPr>
           <a:xfrm>
-            <a:off x="1090126" y="1419024"/>
-            <a:ext cx="6963747" cy="2876951"/>
+            <a:off x="561415" y="1257076"/>
+            <a:ext cx="8021169" cy="3200847"/>
           </a:xfrm>
           <a:prstGeom prst="rect">
             <a:avLst/>
@@ -38163,7 +38947,13 @@
   <p:cSld>
     <p:spTree>
       <p:nvGrpSpPr>
-        <p:cNvPr id="1" name=""/>
+        <p:cNvPr id="1" name="">
+          <a:extLst>
+            <a:ext uri="{FF2B5EF4-FFF2-40B4-BE49-F238E27FC236}">
+              <a16:creationId xmlns:a16="http://schemas.microsoft.com/office/drawing/2014/main" id="{385E64BD-2267-3199-21AD-D54C015170EC}"/>
+            </a:ext>
+          </a:extLst>
+        </p:cNvPr>
         <p:cNvGrpSpPr/>
         <p:nvPr/>
       </p:nvGrpSpPr>
@@ -38180,7 +38970,7 @@
           <p:cNvPr id="4" name="Slide Number Placeholder 3">
             <a:extLst>
               <a:ext uri="{FF2B5EF4-FFF2-40B4-BE49-F238E27FC236}">
-                <a16:creationId xmlns:a16="http://schemas.microsoft.com/office/drawing/2014/main" id="{AD9AF4C9-4EC5-A3F1-7353-9590EF673363}"/>
+                <a16:creationId xmlns:a16="http://schemas.microsoft.com/office/drawing/2014/main" id="{E20EE235-0306-A9D7-5438-CA515C81DEB3}"/>
               </a:ext>
             </a:extLst>
           </p:cNvPr>
@@ -38205,12 +38995,155 @@
           </a:p>
         </p:txBody>
       </p:sp>
+      <p:sp>
+        <p:nvSpPr>
+          <p:cNvPr id="6" name="TextBox 5">
+            <a:extLst>
+              <a:ext uri="{FF2B5EF4-FFF2-40B4-BE49-F238E27FC236}">
+                <a16:creationId xmlns:a16="http://schemas.microsoft.com/office/drawing/2014/main" id="{82017D97-0658-BB4A-5A8B-7C81D30AA730}"/>
+              </a:ext>
+            </a:extLst>
+          </p:cNvPr>
+          <p:cNvSpPr txBox="1"/>
+          <p:nvPr/>
+        </p:nvSpPr>
+        <p:spPr>
+          <a:xfrm>
+            <a:off x="3880326" y="4690949"/>
+            <a:ext cx="1863029" cy="193899"/>
+          </a:xfrm>
+          <a:prstGeom prst="rect">
+            <a:avLst/>
+          </a:prstGeom>
+          <a:ln>
+            <a:headEnd type="none" w="med" len="med"/>
+            <a:tailEnd type="triangle" w="med" len="med"/>
+          </a:ln>
+        </p:spPr>
+        <p:style>
+          <a:lnRef idx="2">
+            <a:schemeClr val="accent1">
+              <a:shade val="50000"/>
+            </a:schemeClr>
+          </a:lnRef>
+          <a:fillRef idx="1">
+            <a:schemeClr val="accent1"/>
+          </a:fillRef>
+          <a:effectRef idx="0">
+            <a:schemeClr val="accent1"/>
+          </a:effectRef>
+          <a:fontRef idx="minor">
+            <a:schemeClr val="lt1"/>
+          </a:fontRef>
+        </p:style>
+        <p:txBody>
+          <a:bodyPr wrap="square" lIns="0" tIns="0" rIns="0" bIns="0" rtlCol="0">
+            <a:spAutoFit/>
+          </a:bodyPr>
+          <a:lstStyle>
+            <a:defPPr>
+              <a:defRPr lang="en-US"/>
+            </a:defPPr>
+            <a:lvl1pPr>
+              <a:lnSpc>
+                <a:spcPct val="90000"/>
+              </a:lnSpc>
+              <a:defRPr>
+                <a:solidFill>
+                  <a:schemeClr val="lt1"/>
+                </a:solidFill>
+                <a:latin typeface="+mn-lt"/>
+                <a:ea typeface="+mn-ea"/>
+              </a:defRPr>
+            </a:lvl1pPr>
+            <a:lvl2pPr>
+              <a:defRPr>
+                <a:solidFill>
+                  <a:schemeClr val="lt1"/>
+                </a:solidFill>
+                <a:latin typeface="+mn-lt"/>
+                <a:ea typeface="+mn-ea"/>
+              </a:defRPr>
+            </a:lvl2pPr>
+            <a:lvl3pPr>
+              <a:defRPr>
+                <a:solidFill>
+                  <a:schemeClr val="lt1"/>
+                </a:solidFill>
+                <a:latin typeface="+mn-lt"/>
+                <a:ea typeface="+mn-ea"/>
+              </a:defRPr>
+            </a:lvl3pPr>
+            <a:lvl4pPr>
+              <a:defRPr>
+                <a:solidFill>
+                  <a:schemeClr val="lt1"/>
+                </a:solidFill>
+                <a:latin typeface="+mn-lt"/>
+                <a:ea typeface="+mn-ea"/>
+              </a:defRPr>
+            </a:lvl4pPr>
+            <a:lvl5pPr>
+              <a:defRPr>
+                <a:solidFill>
+                  <a:schemeClr val="lt1"/>
+                </a:solidFill>
+                <a:latin typeface="+mn-lt"/>
+                <a:ea typeface="+mn-ea"/>
+              </a:defRPr>
+            </a:lvl5pPr>
+            <a:lvl6pPr>
+              <a:defRPr>
+                <a:solidFill>
+                  <a:schemeClr val="lt1"/>
+                </a:solidFill>
+                <a:latin typeface="+mn-lt"/>
+                <a:ea typeface="+mn-ea"/>
+              </a:defRPr>
+            </a:lvl6pPr>
+            <a:lvl7pPr>
+              <a:defRPr>
+                <a:solidFill>
+                  <a:schemeClr val="lt1"/>
+                </a:solidFill>
+                <a:latin typeface="+mn-lt"/>
+                <a:ea typeface="+mn-ea"/>
+              </a:defRPr>
+            </a:lvl7pPr>
+            <a:lvl8pPr>
+              <a:defRPr>
+                <a:solidFill>
+                  <a:schemeClr val="lt1"/>
+                </a:solidFill>
+                <a:latin typeface="+mn-lt"/>
+                <a:ea typeface="+mn-ea"/>
+              </a:defRPr>
+            </a:lvl8pPr>
+            <a:lvl9pPr>
+              <a:defRPr>
+                <a:solidFill>
+                  <a:schemeClr val="lt1"/>
+                </a:solidFill>
+                <a:latin typeface="+mn-lt"/>
+                <a:ea typeface="+mn-ea"/>
+              </a:defRPr>
+            </a:lvl9pPr>
+          </a:lstStyle>
+          <a:p>
+            <a:pPr algn="ctr"/>
+            <a:r>
+              <a:rPr lang="en-US" dirty="0"/>
+              <a:t>Tool User Interface</a:t>
+            </a:r>
+          </a:p>
+        </p:txBody>
+      </p:sp>
       <p:pic>
         <p:nvPicPr>
-          <p:cNvPr id="6" name="Picture 5">
+          <p:cNvPr id="5" name="Picture 4">
             <a:extLst>
               <a:ext uri="{FF2B5EF4-FFF2-40B4-BE49-F238E27FC236}">
-                <a16:creationId xmlns:a16="http://schemas.microsoft.com/office/drawing/2014/main" id="{808B26C1-6061-6024-8062-EF492BD064CF}"/>
+                <a16:creationId xmlns:a16="http://schemas.microsoft.com/office/drawing/2014/main" id="{5B7B31AD-DD0E-E566-5E35-7E09EE8EFE14}"/>
               </a:ext>
             </a:extLst>
           </p:cNvPr>
@@ -38227,8 +39160,8 @@
         </p:blipFill>
         <p:spPr>
           <a:xfrm>
-            <a:off x="1090126" y="1419024"/>
-            <a:ext cx="6963747" cy="2876951"/>
+            <a:off x="561415" y="1257076"/>
+            <a:ext cx="8021169" cy="3200847"/>
           </a:xfrm>
           <a:prstGeom prst="rect">
             <a:avLst/>
@@ -38237,10 +39170,10 @@
       </p:pic>
       <p:sp>
         <p:nvSpPr>
-          <p:cNvPr id="7" name="Title 4">
+          <p:cNvPr id="2" name="Title 4">
             <a:extLst>
               <a:ext uri="{FF2B5EF4-FFF2-40B4-BE49-F238E27FC236}">
-                <a16:creationId xmlns:a16="http://schemas.microsoft.com/office/drawing/2014/main" id="{1DECADAB-4846-C761-6AE6-5B0D3D1346C8}"/>
+                <a16:creationId xmlns:a16="http://schemas.microsoft.com/office/drawing/2014/main" id="{1473469A-7B51-8214-7384-41F6C75A2937}"/>
               </a:ext>
             </a:extLst>
           </p:cNvPr>
@@ -38278,10 +39211,10 @@
       </p:sp>
       <p:sp>
         <p:nvSpPr>
-          <p:cNvPr id="8" name="Content Placeholder 4">
+          <p:cNvPr id="3" name="Content Placeholder 4">
             <a:extLst>
               <a:ext uri="{FF2B5EF4-FFF2-40B4-BE49-F238E27FC236}">
-                <a16:creationId xmlns:a16="http://schemas.microsoft.com/office/drawing/2014/main" id="{2E29002A-33EF-9FDA-6F20-A3ED5CC20678}"/>
+                <a16:creationId xmlns:a16="http://schemas.microsoft.com/office/drawing/2014/main" id="{73D6628C-5BD7-C347-5684-BE627FDF2952}"/>
               </a:ext>
             </a:extLst>
           </p:cNvPr>
@@ -38519,17 +39452,17 @@
                   </a:schemeClr>
                 </a:solidFill>
               </a:rPr>
-              <a:t>Module Type</a:t>
+              <a:t>Manual Type</a:t>
             </a:r>
           </a:p>
         </p:txBody>
       </p:sp>
       <p:cxnSp>
         <p:nvCxnSpPr>
-          <p:cNvPr id="9" name="Straight Arrow Connector 8">
+          <p:cNvPr id="7" name="Straight Arrow Connector 6">
             <a:extLst>
               <a:ext uri="{FF2B5EF4-FFF2-40B4-BE49-F238E27FC236}">
-                <a16:creationId xmlns:a16="http://schemas.microsoft.com/office/drawing/2014/main" id="{56D6CB02-F1A4-C4C6-321D-7F573E8D4186}"/>
+                <a16:creationId xmlns:a16="http://schemas.microsoft.com/office/drawing/2014/main" id="{E06BAE63-1B60-2EC0-DE58-2B329C360537}"/>
               </a:ext>
             </a:extLst>
           </p:cNvPr>
@@ -38568,10 +39501,10 @@
       </p:cxnSp>
       <p:sp>
         <p:nvSpPr>
-          <p:cNvPr id="10" name="Content Placeholder 4">
+          <p:cNvPr id="8" name="Content Placeholder 4">
             <a:extLst>
               <a:ext uri="{FF2B5EF4-FFF2-40B4-BE49-F238E27FC236}">
-                <a16:creationId xmlns:a16="http://schemas.microsoft.com/office/drawing/2014/main" id="{E4620103-A586-70CE-E30D-A01702303F6C}"/>
+                <a16:creationId xmlns:a16="http://schemas.microsoft.com/office/drawing/2014/main" id="{4117D06D-F9CD-3074-7D94-902BFA66EDCD}"/>
               </a:ext>
             </a:extLst>
           </p:cNvPr>
@@ -38816,10 +39749,10 @@
       </p:sp>
       <p:cxnSp>
         <p:nvCxnSpPr>
-          <p:cNvPr id="11" name="Straight Arrow Connector 10">
+          <p:cNvPr id="9" name="Straight Arrow Connector 8">
             <a:extLst>
               <a:ext uri="{FF2B5EF4-FFF2-40B4-BE49-F238E27FC236}">
-                <a16:creationId xmlns:a16="http://schemas.microsoft.com/office/drawing/2014/main" id="{6811A494-7B2A-9E4F-D8E2-717F56AC22C8}"/>
+                <a16:creationId xmlns:a16="http://schemas.microsoft.com/office/drawing/2014/main" id="{63F6998A-11A6-AB03-6A7B-757047C77F29}"/>
               </a:ext>
             </a:extLst>
           </p:cNvPr>
@@ -38858,10 +39791,10 @@
       </p:cxnSp>
       <p:sp>
         <p:nvSpPr>
-          <p:cNvPr id="12" name="Content Placeholder 4">
+          <p:cNvPr id="10" name="Content Placeholder 4">
             <a:extLst>
               <a:ext uri="{FF2B5EF4-FFF2-40B4-BE49-F238E27FC236}">
-                <a16:creationId xmlns:a16="http://schemas.microsoft.com/office/drawing/2014/main" id="{7CFFDB85-CFC1-DB57-131F-901ABCDAC914}"/>
+                <a16:creationId xmlns:a16="http://schemas.microsoft.com/office/drawing/2014/main" id="{5EEDD626-E5F0-C202-70C5-3236D17DB463}"/>
               </a:ext>
             </a:extLst>
           </p:cNvPr>
@@ -39099,17 +40032,17 @@
                   </a:schemeClr>
                 </a:solidFill>
               </a:rPr>
-              <a:t>Module Link</a:t>
+              <a:t>Manual Link</a:t>
             </a:r>
           </a:p>
         </p:txBody>
       </p:sp>
       <p:cxnSp>
         <p:nvCxnSpPr>
-          <p:cNvPr id="13" name="Straight Arrow Connector 12">
+          <p:cNvPr id="11" name="Straight Arrow Connector 10">
             <a:extLst>
               <a:ext uri="{FF2B5EF4-FFF2-40B4-BE49-F238E27FC236}">
-                <a16:creationId xmlns:a16="http://schemas.microsoft.com/office/drawing/2014/main" id="{26F2477A-37D0-5C94-CF69-6AC03E684ABB}"/>
+                <a16:creationId xmlns:a16="http://schemas.microsoft.com/office/drawing/2014/main" id="{5A519752-AA78-1328-F701-3FB85197C400}"/>
               </a:ext>
             </a:extLst>
           </p:cNvPr>
@@ -39149,7 +40082,7 @@
     </p:spTree>
     <p:extLst>
       <p:ext uri="{BB962C8B-B14F-4D97-AF65-F5344CB8AC3E}">
-        <p14:creationId xmlns:p14="http://schemas.microsoft.com/office/powerpoint/2010/main" val="2599099495"/>
+        <p14:creationId xmlns:p14="http://schemas.microsoft.com/office/powerpoint/2010/main" val="2578814489"/>
       </p:ext>
     </p:extLst>
   </p:cSld>
@@ -39221,7 +40154,7 @@
         <p:spPr>
           <a:xfrm>
             <a:off x="162839" y="629229"/>
-            <a:ext cx="9144000" cy="4832092"/>
+            <a:ext cx="9144000" cy="4616648"/>
           </a:xfrm>
           <a:prstGeom prst="rect">
             <a:avLst/>
@@ -39239,7 +40172,7 @@
             </a:pPr>
             <a:r>
               <a:rPr lang="en-US" b="1" dirty="0"/>
-              <a:t>1. Module Selection</a:t>
+              <a:t>1. Manual Selection</a:t>
             </a:r>
           </a:p>
           <a:p>
@@ -39252,7 +40185,7 @@
                   <a:srgbClr val="00B0F0"/>
                 </a:solidFill>
               </a:rPr>
-              <a:t>The Module Type drop-down list allows the user to select the Engine Manual document from which cautions will be extracted.</a:t>
+              <a:t>The Manual Type drop-down list allows the user to select the Manual from which cautions will be extracted.</a:t>
             </a:r>
           </a:p>
           <a:p>
@@ -39317,7 +40250,7 @@
                   <a:srgbClr val="00B0F0"/>
                 </a:solidFill>
               </a:rPr>
-              <a:t>SP 72-31</a:t>
+              <a:t>SP 72-31 (EM &amp; CIR)</a:t>
             </a:r>
           </a:p>
           <a:p>
@@ -39331,7 +40264,7 @@
                   <a:srgbClr val="00B0F0"/>
                 </a:solidFill>
               </a:rPr>
-              <a:t>SP 72-51</a:t>
+              <a:t>SP 72-51 (EM &amp; CIR)</a:t>
             </a:r>
           </a:p>
           <a:p>
@@ -39344,7 +40277,7 @@
                   <a:srgbClr val="00B0F0"/>
                 </a:solidFill>
               </a:rPr>
-              <a:t>Select the appropriate manual type before entering the Engine Manual link.</a:t>
+              <a:t>Select the appropriate Manual type before entering the Manual link.</a:t>
             </a:r>
           </a:p>
           <a:p>
@@ -39363,7 +40296,7 @@
             </a:pPr>
             <a:r>
               <a:rPr lang="en-US" b="1" dirty="0"/>
-              <a:t>2. Engine Manual Link</a:t>
+              <a:t>2. Manual Link</a:t>
             </a:r>
           </a:p>
           <a:p>
@@ -39376,7 +40309,7 @@
                   <a:srgbClr val="00B0F0"/>
                 </a:solidFill>
               </a:rPr>
-              <a:t>The Engine Manual Link field is used to enter the URL of the module page from which cautions need to be extracted.</a:t>
+              <a:t>The Manual Link field is used to enter the URL of the Manual page from which cautions need to be extracted.</a:t>
             </a:r>
           </a:p>
           <a:p>
@@ -39403,14 +40336,22 @@
             </a:r>
           </a:p>
           <a:p>
+            <a:pPr>
+              <a:buNone/>
+            </a:pPr>
             <a:r>
               <a:rPr lang="pt-BR" dirty="0">
                 <a:solidFill>
                   <a:srgbClr val="00B0F0"/>
                 </a:solidFill>
               </a:rPr>
-              <a:t>http://127.0.0.1:8000/PW1000G-77445-19453-00/PW1000G-77445-15653-00.html                    (EM_CIR)</a:t>
+              <a:t>http://127.0.0.1:8000/PW1000G-77445-19453-00/PW1000G-77445-16992-00.html                - EM</a:t>
             </a:r>
+            <a:endParaRPr lang="en-US" dirty="0">
+              <a:solidFill>
+                <a:srgbClr val="00B0F0"/>
+              </a:solidFill>
+            </a:endParaRPr>
           </a:p>
           <a:p>
             <a:r>
@@ -39419,7 +40360,7 @@
                   <a:srgbClr val="00B0F0"/>
                 </a:solidFill>
               </a:rPr>
-              <a:t>http://127.0.0.1:8001/PW1000G-77445-19453-00/PW1000G-77445-16992-00.html                    (EM)</a:t>
+              <a:t>http://127.0.0.1:8000/PW1000G-77445-19453-00/PW1000G-77445-15653-00.html                - EM-CIR</a:t>
             </a:r>
           </a:p>
           <a:p>
@@ -39429,7 +40370,7 @@
                   <a:srgbClr val="00B0F0"/>
                 </a:solidFill>
               </a:rPr>
-              <a:t>http://127.0.0.1:8002/PW1000G-77445-19155-00/                                                                                                     (SP_CIR_72_35)</a:t>
+              <a:t>http://127.0.0.1:8002/PW1000G-77445-19155-00/                                                                                                 - SP 72-35 (EM &amp; CIR)</a:t>
             </a:r>
           </a:p>
           <a:p>
@@ -39454,7 +40395,7 @@
                   <a:srgbClr val="00B0F0"/>
                 </a:solidFill>
               </a:rPr>
-              <a:t>                                                                                                     (SP_CIR_72_51)</a:t>
+              <a:t>                                                                                                 - SP 72-51 (EM &amp; CIR)</a:t>
             </a:r>
           </a:p>
           <a:p>
@@ -39560,7 +40501,7 @@
           <p:cNvPr id="4" name="Slide Number Placeholder 3">
             <a:extLst>
               <a:ext uri="{FF2B5EF4-FFF2-40B4-BE49-F238E27FC236}">
-                <a16:creationId xmlns:a16="http://schemas.microsoft.com/office/drawing/2014/main" id="{7DBFB500-BDE9-AF4D-7E46-5542A0782CE2}"/>
+                <a16:creationId xmlns:a16="http://schemas.microsoft.com/office/drawing/2014/main" id="{01903E69-1DBD-E723-5A61-78C87FCBAB7A}"/>
               </a:ext>
             </a:extLst>
           </p:cNvPr>
@@ -39587,272 +40528,81 @@
       </p:sp>
       <p:sp>
         <p:nvSpPr>
-          <p:cNvPr id="6" name="TextBox 5">
+          <p:cNvPr id="5" name="Title 4">
             <a:extLst>
               <a:ext uri="{FF2B5EF4-FFF2-40B4-BE49-F238E27FC236}">
-                <a16:creationId xmlns:a16="http://schemas.microsoft.com/office/drawing/2014/main" id="{B186E202-FDEB-9DFD-B5F1-B56151B9E1B4}"/>
+                <a16:creationId xmlns:a16="http://schemas.microsoft.com/office/drawing/2014/main" id="{4438A4B2-67F0-7B67-E8EA-4014654147F0}"/>
               </a:ext>
             </a:extLst>
           </p:cNvPr>
-          <p:cNvSpPr txBox="1"/>
-          <p:nvPr/>
+          <p:cNvSpPr>
+            <a:spLocks noGrp="1"/>
+          </p:cNvSpPr>
+          <p:nvPr>
+            <p:ph type="title"/>
+          </p:nvPr>
         </p:nvSpPr>
         <p:spPr>
           <a:xfrm>
-            <a:off x="363538" y="700413"/>
-            <a:ext cx="8442259" cy="4401205"/>
+            <a:off x="268459" y="129978"/>
+            <a:ext cx="6564050" cy="499251"/>
+          </a:xfrm>
+        </p:spPr>
+        <p:txBody>
+          <a:bodyPr anchor="ctr"/>
+          <a:lstStyle/>
+          <a:p>
+            <a:pPr eaLnBrk="1" hangingPunct="1">
+              <a:lnSpc>
+                <a:spcPct val="110000"/>
+              </a:lnSpc>
+            </a:pPr>
+            <a:r>
+              <a:rPr lang="en-US" altLang="en-US" sz="1800" dirty="0">
+                <a:latin typeface="Effra" pitchFamily="34" charset="0"/>
+              </a:rPr>
+              <a:t>EM Link</a:t>
+            </a:r>
+            <a:endParaRPr lang="en-US" altLang="en-US" sz="1600" dirty="0">
+              <a:latin typeface="Effra" pitchFamily="34" charset="0"/>
+            </a:endParaRPr>
+          </a:p>
+        </p:txBody>
+      </p:sp>
+      <p:pic>
+        <p:nvPicPr>
+          <p:cNvPr id="7" name="Picture 6">
+            <a:extLst>
+              <a:ext uri="{FF2B5EF4-FFF2-40B4-BE49-F238E27FC236}">
+                <a16:creationId xmlns:a16="http://schemas.microsoft.com/office/drawing/2014/main" id="{7908E21E-A92B-905D-ED59-D25871E29FC0}"/>
+              </a:ext>
+            </a:extLst>
+          </p:cNvPr>
+          <p:cNvPicPr>
+            <a:picLocks noChangeAspect="1"/>
+          </p:cNvPicPr>
+          <p:nvPr/>
+        </p:nvPicPr>
+        <p:blipFill>
+          <a:blip r:embed="rId2"/>
+          <a:stretch>
+            <a:fillRect/>
+          </a:stretch>
+        </p:blipFill>
+        <p:spPr>
+          <a:xfrm>
+            <a:off x="268458" y="629229"/>
+            <a:ext cx="8512003" cy="4935534"/>
           </a:xfrm>
           <a:prstGeom prst="rect">
             <a:avLst/>
           </a:prstGeom>
-          <a:noFill/>
         </p:spPr>
-        <p:txBody>
-          <a:bodyPr wrap="square">
-            <a:spAutoFit/>
-          </a:bodyPr>
-          <a:lstStyle/>
-          <a:p>
-            <a:pPr>
-              <a:buNone/>
-            </a:pPr>
-            <a:endParaRPr lang="en-US" sz="1400" b="1" dirty="0"/>
-          </a:p>
-          <a:p>
-            <a:pPr>
-              <a:buNone/>
-            </a:pPr>
-            <a:r>
-              <a:rPr lang="en-US" dirty="0">
-                <a:solidFill>
-                  <a:srgbClr val="00B0F0"/>
-                </a:solidFill>
-              </a:rPr>
-              <a:t>Ensure that the Engine Manual link corresponds to the module type selected in the drop-down list.</a:t>
-            </a:r>
-          </a:p>
-          <a:p>
-            <a:pPr>
-              <a:buNone/>
-            </a:pPr>
-            <a:endParaRPr lang="en-US" dirty="0">
-              <a:solidFill>
-                <a:srgbClr val="00B0F0"/>
-              </a:solidFill>
-            </a:endParaRPr>
-          </a:p>
-          <a:p>
-            <a:pPr>
-              <a:buNone/>
-            </a:pPr>
-            <a:r>
-              <a:rPr lang="en-US" b="1" dirty="0">
-                <a:solidFill>
-                  <a:srgbClr val="FF0000"/>
-                </a:solidFill>
-              </a:rPr>
-              <a:t>NOTE</a:t>
-            </a:r>
-            <a:r>
-              <a:rPr lang="en-US" dirty="0">
-                <a:solidFill>
-                  <a:srgbClr val="00B0F0"/>
-                </a:solidFill>
-              </a:rPr>
-              <a:t> :  The port numbers may change</a:t>
-            </a:r>
-            <a:endParaRPr lang="en-US" b="1" dirty="0"/>
-          </a:p>
-          <a:p>
-            <a:pPr>
-              <a:buNone/>
-            </a:pPr>
-            <a:endParaRPr lang="en-US" sz="1400" b="1" dirty="0"/>
-          </a:p>
-          <a:p>
-            <a:pPr>
-              <a:buNone/>
-            </a:pPr>
-            <a:r>
-              <a:rPr lang="en-US" sz="1400" b="1" dirty="0"/>
-              <a:t>3. Output Location</a:t>
-            </a:r>
-          </a:p>
-          <a:p>
-            <a:pPr>
-              <a:buNone/>
-            </a:pPr>
-            <a:r>
-              <a:rPr lang="en-US" dirty="0">
-                <a:solidFill>
-                  <a:srgbClr val="00B0F0"/>
-                </a:solidFill>
-              </a:rPr>
-              <a:t>The Output location specifies the path where the extracted caution report will be generated.</a:t>
-            </a:r>
-          </a:p>
-          <a:p>
-            <a:pPr>
-              <a:buNone/>
-            </a:pPr>
-            <a:r>
-              <a:rPr lang="en-US" dirty="0">
-                <a:solidFill>
-                  <a:srgbClr val="00B0F0"/>
-                </a:solidFill>
-              </a:rPr>
-              <a:t>Users may enter the full file path or browse to the desired location.</a:t>
-            </a:r>
-          </a:p>
-          <a:p>
-            <a:pPr>
-              <a:buNone/>
-            </a:pPr>
-            <a:r>
-              <a:rPr lang="en-US" dirty="0">
-                <a:solidFill>
-                  <a:srgbClr val="00B0F0"/>
-                </a:solidFill>
-              </a:rPr>
-              <a:t>Example:</a:t>
-            </a:r>
-          </a:p>
-          <a:p>
-            <a:pPr rtl="0">
-              <a:buNone/>
-            </a:pPr>
-            <a:r>
-              <a:rPr lang="en-US" dirty="0">
-                <a:solidFill>
-                  <a:srgbClr val="00B0F0"/>
-                </a:solidFill>
-              </a:rPr>
-              <a:t>D:\Reports\CautionList.xlsx</a:t>
-            </a:r>
-          </a:p>
-          <a:p>
-            <a:pPr rtl="0">
-              <a:buNone/>
-            </a:pPr>
-            <a:endParaRPr lang="en-US" dirty="0">
-              <a:latin typeface="Courier New" panose="02070309020205020404" pitchFamily="49" charset="0"/>
-            </a:endParaRPr>
-          </a:p>
-          <a:p>
-            <a:pPr rtl="0">
-              <a:buNone/>
-            </a:pPr>
-            <a:endParaRPr lang="en-US" sz="1400" dirty="0">
-              <a:latin typeface="Courier New" panose="02070309020205020404" pitchFamily="49" charset="0"/>
-            </a:endParaRPr>
-          </a:p>
-          <a:p>
-            <a:pPr>
-              <a:buNone/>
-            </a:pPr>
-            <a:r>
-              <a:rPr lang="en-US" sz="1400" b="1" dirty="0"/>
-              <a:t>4. Fetch Cautions Button</a:t>
-            </a:r>
-          </a:p>
-          <a:p>
-            <a:pPr>
-              <a:buNone/>
-            </a:pPr>
-            <a:r>
-              <a:rPr lang="en-US" dirty="0">
-                <a:solidFill>
-                  <a:srgbClr val="00B0F0"/>
-                </a:solidFill>
-              </a:rPr>
-              <a:t>Click Fetch Cautions to begin the extraction process.</a:t>
-            </a:r>
-          </a:p>
-          <a:p>
-            <a:pPr>
-              <a:buNone/>
-            </a:pPr>
-            <a:endParaRPr lang="en-US" dirty="0">
-              <a:solidFill>
-                <a:srgbClr val="00B0F0"/>
-              </a:solidFill>
-            </a:endParaRPr>
-          </a:p>
-          <a:p>
-            <a:pPr>
-              <a:buNone/>
-            </a:pPr>
-            <a:r>
-              <a:rPr lang="en-US" dirty="0">
-                <a:solidFill>
-                  <a:srgbClr val="00B0F0"/>
-                </a:solidFill>
-              </a:rPr>
-              <a:t>The tool will:</a:t>
-            </a:r>
-          </a:p>
-          <a:p>
-            <a:pPr>
-              <a:buFont typeface="+mj-lt"/>
-              <a:buAutoNum type="arabicPeriod"/>
-            </a:pPr>
-            <a:r>
-              <a:rPr lang="en-US" dirty="0">
-                <a:solidFill>
-                  <a:srgbClr val="00B0F0"/>
-                </a:solidFill>
-              </a:rPr>
-              <a:t>Open the specified page in the background.</a:t>
-            </a:r>
-          </a:p>
-          <a:p>
-            <a:pPr>
-              <a:buFont typeface="+mj-lt"/>
-              <a:buAutoNum type="arabicPeriod"/>
-            </a:pPr>
-            <a:r>
-              <a:rPr lang="en-US" dirty="0">
-                <a:solidFill>
-                  <a:srgbClr val="00B0F0"/>
-                </a:solidFill>
-              </a:rPr>
-              <a:t>Scan the Engine Manual Page for caution statements.</a:t>
-            </a:r>
-          </a:p>
-          <a:p>
-            <a:pPr>
-              <a:buFont typeface="+mj-lt"/>
-              <a:buAutoNum type="arabicPeriod"/>
-            </a:pPr>
-            <a:r>
-              <a:rPr lang="en-US" dirty="0">
-                <a:solidFill>
-                  <a:srgbClr val="00B0F0"/>
-                </a:solidFill>
-              </a:rPr>
-              <a:t>Extract all identified cautions.</a:t>
-            </a:r>
-          </a:p>
-          <a:p>
-            <a:pPr>
-              <a:buFont typeface="+mj-lt"/>
-              <a:buAutoNum type="arabicPeriod"/>
-            </a:pPr>
-            <a:r>
-              <a:rPr lang="en-US" dirty="0">
-                <a:solidFill>
-                  <a:srgbClr val="00B0F0"/>
-                </a:solidFill>
-              </a:rPr>
-              <a:t>Generate the report at the specified location.</a:t>
-            </a:r>
-          </a:p>
-        </p:txBody>
-      </p:sp>
+      </p:pic>
     </p:spTree>
     <p:extLst>
       <p:ext uri="{BB962C8B-B14F-4D97-AF65-F5344CB8AC3E}">
-        <p14:creationId xmlns:p14="http://schemas.microsoft.com/office/powerpoint/2010/main" val="1365765025"/>
+        <p14:creationId xmlns:p14="http://schemas.microsoft.com/office/powerpoint/2010/main" val="433742190"/>
       </p:ext>
     </p:extLst>
   </p:cSld>
@@ -41057,34 +41807,6 @@
 </file>
 
 <file path=customXml/item1.xml><?xml version="1.0" encoding="utf-8"?>
-<?mso-contentType ?>
-<FormTemplates xmlns="http://schemas.microsoft.com/sharepoint/v3/contenttype/forms">
-  <Display>DocumentLibraryForm</Display>
-  <Edit>DocumentLibraryForm</Edit>
-  <New>DocumentLibraryForm</New>
-</FormTemplates>
-</file>
-
-<file path=customXml/item2.xml><?xml version="1.0" encoding="utf-8"?>
-<p:properties xmlns:p="http://schemas.microsoft.com/office/2006/metadata/properties" xmlns:xsi="http://www.w3.org/2001/XMLSchema-instance" xmlns:pc="http://schemas.microsoft.com/office/infopath/2007/PartnerControls">
-  <documentManagement>
-    <TaxCatchAll xmlns="077667ae-fd08-4bd8-a603-c9f8c202c5e0">
-      <Value>2720</Value>
-    </TaxCatchAll>
-    <KpiDescription xmlns="http://schemas.microsoft.com/sharepoint/v3" xsi:nil="true"/>
-    <DocumentTypeTaxHTField0 xmlns="2613b0ce-4e5a-4068-84c6-4aae3ccc9c8a">
-      <Terms xmlns="http://schemas.microsoft.com/office/infopath/2007/PartnerControls">
-        <TermInfo xmlns="http://schemas.microsoft.com/office/infopath/2007/PartnerControls">
-          <TermName xmlns="http://schemas.microsoft.com/office/infopath/2007/PartnerControls">Presentation</TermName>
-          <TermId xmlns="http://schemas.microsoft.com/office/infopath/2007/PartnerControls">c7776749-3f71-458e-9ba5-93d6c492bea1</TermId>
-        </TermInfo>
-      </Terms>
-    </DocumentTypeTaxHTField0>
-  </documentManagement>
-</p:properties>
-</file>
-
-<file path=customXml/item3.xml><?xml version="1.0" encoding="utf-8"?>
 <ct:contentTypeSchema xmlns:ct="http://schemas.microsoft.com/office/2006/metadata/contentType" xmlns:ma="http://schemas.microsoft.com/office/2006/metadata/properties/metaAttributes" ct:_="" ma:_="" ma:contentTypeName="Document" ma:contentTypeID="0x010100AADF239F2ED0534CBEE452B336985728" ma:contentTypeVersion="4" ma:contentTypeDescription="Create a new document." ma:contentTypeScope="" ma:versionID="6a7824fc007c3b206678c4e4d6201abd">
   <xsd:schema xmlns:xsd="http://www.w3.org/2001/XMLSchema" xmlns:xs="http://www.w3.org/2001/XMLSchema" xmlns:p="http://schemas.microsoft.com/office/2006/metadata/properties" xmlns:ns1="http://schemas.microsoft.com/sharepoint/v3" xmlns:ns2="2613b0ce-4e5a-4068-84c6-4aae3ccc9c8a" xmlns:ns3="077667ae-fd08-4bd8-a603-c9f8c202c5e0" targetNamespace="http://schemas.microsoft.com/office/2006/metadata/properties" ma:root="true" ma:fieldsID="86c3fa7aeb19401307e35c1f80bf319a" ns1:_="" ns2:_="" ns3:_="">
     <xsd:import namespace="http://schemas.microsoft.com/sharepoint/v3"/>
@@ -41242,10 +41964,50 @@
 </ct:contentTypeSchema>
 </file>
 
+<file path=customXml/item2.xml><?xml version="1.0" encoding="utf-8"?>
+<p:properties xmlns:p="http://schemas.microsoft.com/office/2006/metadata/properties" xmlns:xsi="http://www.w3.org/2001/XMLSchema-instance" xmlns:pc="http://schemas.microsoft.com/office/infopath/2007/PartnerControls">
+  <documentManagement>
+    <TaxCatchAll xmlns="077667ae-fd08-4bd8-a603-c9f8c202c5e0">
+      <Value>2720</Value>
+    </TaxCatchAll>
+    <KpiDescription xmlns="http://schemas.microsoft.com/sharepoint/v3" xsi:nil="true"/>
+    <DocumentTypeTaxHTField0 xmlns="2613b0ce-4e5a-4068-84c6-4aae3ccc9c8a">
+      <Terms xmlns="http://schemas.microsoft.com/office/infopath/2007/PartnerControls">
+        <TermInfo xmlns="http://schemas.microsoft.com/office/infopath/2007/PartnerControls">
+          <TermName xmlns="http://schemas.microsoft.com/office/infopath/2007/PartnerControls">Presentation</TermName>
+          <TermId xmlns="http://schemas.microsoft.com/office/infopath/2007/PartnerControls">c7776749-3f71-458e-9ba5-93d6c492bea1</TermId>
+        </TermInfo>
+      </Terms>
+    </DocumentTypeTaxHTField0>
+  </documentManagement>
+</p:properties>
+</file>
+
+<file path=customXml/item3.xml><?xml version="1.0" encoding="utf-8"?>
+<?mso-contentType ?>
+<FormTemplates xmlns="http://schemas.microsoft.com/sharepoint/v3/contenttype/forms">
+  <Display>DocumentLibraryForm</Display>
+  <Edit>DocumentLibraryForm</Edit>
+  <New>DocumentLibraryForm</New>
+</FormTemplates>
+</file>
+
 <file path=customXml/itemProps1.xml><?xml version="1.0" encoding="utf-8"?>
-<ds:datastoreItem xmlns:ds="http://schemas.openxmlformats.org/officeDocument/2006/customXml" ds:itemID="{EC84B35E-1715-4D43-A2FB-C60A34588830}">
+<ds:datastoreItem xmlns:ds="http://schemas.openxmlformats.org/officeDocument/2006/customXml" ds:itemID="{51FB943C-7FAA-4048-9A7F-254B30072A5E}">
   <ds:schemaRefs>
-    <ds:schemaRef ds:uri="http://schemas.microsoft.com/sharepoint/v3/contenttype/forms"/>
+    <ds:schemaRef ds:uri="http://schemas.microsoft.com/office/2006/metadata/contentType"/>
+    <ds:schemaRef ds:uri="http://schemas.microsoft.com/office/2006/metadata/properties/metaAttributes"/>
+    <ds:schemaRef ds:uri="http://www.w3.org/2001/XMLSchema"/>
+    <ds:schemaRef ds:uri="http://schemas.microsoft.com/office/2006/metadata/properties"/>
+    <ds:schemaRef ds:uri="http://schemas.microsoft.com/sharepoint/v3"/>
+    <ds:schemaRef ds:uri="2613b0ce-4e5a-4068-84c6-4aae3ccc9c8a"/>
+    <ds:schemaRef ds:uri="077667ae-fd08-4bd8-a603-c9f8c202c5e0"/>
+    <ds:schemaRef ds:uri="http://schemas.microsoft.com/office/2006/documentManagement/types"/>
+    <ds:schemaRef ds:uri="http://schemas.microsoft.com/office/infopath/2007/PartnerControls"/>
+    <ds:schemaRef ds:uri="http://schemas.openxmlformats.org/package/2006/metadata/core-properties"/>
+    <ds:schemaRef ds:uri="http://purl.org/dc/elements/1.1/"/>
+    <ds:schemaRef ds:uri="http://purl.org/dc/terms/"/>
+    <ds:schemaRef ds:uri="http://schemas.microsoft.com/internal/obd"/>
   </ds:schemaRefs>
 </ds:datastoreItem>
 </file>
@@ -41269,21 +42031,9 @@
 </file>
 
 <file path=customXml/itemProps3.xml><?xml version="1.0" encoding="utf-8"?>
-<ds:datastoreItem xmlns:ds="http://schemas.openxmlformats.org/officeDocument/2006/customXml" ds:itemID="{51FB943C-7FAA-4048-9A7F-254B30072A5E}">
+<ds:datastoreItem xmlns:ds="http://schemas.openxmlformats.org/officeDocument/2006/customXml" ds:itemID="{EC84B35E-1715-4D43-A2FB-C60A34588830}">
   <ds:schemaRefs>
-    <ds:schemaRef ds:uri="http://schemas.microsoft.com/office/2006/metadata/contentType"/>
-    <ds:schemaRef ds:uri="http://schemas.microsoft.com/office/2006/metadata/properties/metaAttributes"/>
-    <ds:schemaRef ds:uri="http://www.w3.org/2001/XMLSchema"/>
-    <ds:schemaRef ds:uri="http://schemas.microsoft.com/office/2006/metadata/properties"/>
-    <ds:schemaRef ds:uri="http://schemas.microsoft.com/sharepoint/v3"/>
-    <ds:schemaRef ds:uri="2613b0ce-4e5a-4068-84c6-4aae3ccc9c8a"/>
-    <ds:schemaRef ds:uri="077667ae-fd08-4bd8-a603-c9f8c202c5e0"/>
-    <ds:schemaRef ds:uri="http://schemas.microsoft.com/office/2006/documentManagement/types"/>
-    <ds:schemaRef ds:uri="http://schemas.microsoft.com/office/infopath/2007/PartnerControls"/>
-    <ds:schemaRef ds:uri="http://schemas.openxmlformats.org/package/2006/metadata/core-properties"/>
-    <ds:schemaRef ds:uri="http://purl.org/dc/elements/1.1/"/>
-    <ds:schemaRef ds:uri="http://purl.org/dc/terms/"/>
-    <ds:schemaRef ds:uri="http://schemas.microsoft.com/internal/obd"/>
+    <ds:schemaRef ds:uri="http://schemas.microsoft.com/sharepoint/v3/contenttype/forms"/>
   </ds:schemaRefs>
 </ds:datastoreItem>
 </file>
</xml_diff>

<commit_message>
Fixed ppt & pdf and fetching 3xx information code pages for Engine Manual Links
</commit_message>
<xml_diff>
--- a/ExtractCautionsForEM/bin/Debug/bin/ExtractCautionsFromEngineManualTool.pptx
+++ b/ExtractCautionsForEM/bin/Debug/bin/ExtractCautionsFromEngineManualTool.pptx
@@ -345,7 +345,7 @@
               <a:pPr>
                 <a:defRPr/>
               </a:pPr>
-              <a:t>8/20/2026</a:t>
+              <a:t>8/24/2026</a:t>
             </a:fld>
             <a:endParaRPr lang="en-GB" dirty="0"/>
           </a:p>
@@ -563,7 +563,7 @@
               <a:pPr>
                 <a:defRPr/>
               </a:pPr>
-              <a:t>8/20/2026</a:t>
+              <a:t>8/24/2026</a:t>
             </a:fld>
             <a:endParaRPr lang="en-GB" dirty="0"/>
           </a:p>
@@ -3300,7 +3300,7 @@
               <a:pPr eaLnBrk="1" hangingPunct="1">
                 <a:defRPr/>
               </a:pPr>
-              <a:t>8/20/2026</a:t>
+              <a:t>8/24/2026</a:t>
             </a:fld>
             <a:endParaRPr lang="en-GB" dirty="0">
               <a:solidFill>
@@ -3734,7 +3734,7 @@
               <a:pPr eaLnBrk="1" hangingPunct="1">
                 <a:defRPr/>
               </a:pPr>
-              <a:t>8/20/2026</a:t>
+              <a:t>8/24/2026</a:t>
             </a:fld>
             <a:endParaRPr lang="en-GB" dirty="0">
               <a:solidFill>
@@ -4192,7 +4192,7 @@
               <a:pPr eaLnBrk="1" hangingPunct="1">
                 <a:defRPr/>
               </a:pPr>
-              <a:t>8/20/2026</a:t>
+              <a:t>8/24/2026</a:t>
             </a:fld>
             <a:endParaRPr lang="en-GB" dirty="0">
               <a:solidFill>
@@ -4622,7 +4622,7 @@
               <a:pPr eaLnBrk="1" hangingPunct="1">
                 <a:defRPr/>
               </a:pPr>
-              <a:t>8/20/2026</a:t>
+              <a:t>8/24/2026</a:t>
             </a:fld>
             <a:endParaRPr lang="en-GB" dirty="0">
               <a:solidFill>
@@ -5229,7 +5229,7 @@
               <a:pPr eaLnBrk="1" hangingPunct="1">
                 <a:defRPr/>
               </a:pPr>
-              <a:t>8/20/2026</a:t>
+              <a:t>8/24/2026</a:t>
             </a:fld>
             <a:endParaRPr lang="en-GB" dirty="0">
               <a:solidFill>
@@ -8641,7 +8641,7 @@
               <a:pPr eaLnBrk="1" hangingPunct="1">
                 <a:defRPr/>
               </a:pPr>
-              <a:t>8/20/2026</a:t>
+              <a:t>8/24/2026</a:t>
             </a:fld>
             <a:endParaRPr lang="en-GB" dirty="0">
               <a:solidFill>
@@ -9456,7 +9456,7 @@
               <a:pPr eaLnBrk="1" hangingPunct="1">
                 <a:defRPr/>
               </a:pPr>
-              <a:t>8/20/2026</a:t>
+              <a:t>8/24/2026</a:t>
             </a:fld>
             <a:endParaRPr lang="en-GB" dirty="0">
               <a:solidFill>
@@ -10277,7 +10277,7 @@
               <a:pPr eaLnBrk="1" hangingPunct="1">
                 <a:defRPr/>
               </a:pPr>
-              <a:t>8/20/2026</a:t>
+              <a:t>8/24/2026</a:t>
             </a:fld>
             <a:endParaRPr lang="en-GB" dirty="0">
               <a:solidFill>
@@ -12129,7 +12129,7 @@
               <a:pPr eaLnBrk="1" hangingPunct="1">
                 <a:defRPr/>
               </a:pPr>
-              <a:t>8/20/2026</a:t>
+              <a:t>8/24/2026</a:t>
             </a:fld>
             <a:endParaRPr lang="en-GB" dirty="0">
               <a:solidFill>
@@ -12650,7 +12650,7 @@
               <a:pPr eaLnBrk="1" hangingPunct="1">
                 <a:defRPr/>
               </a:pPr>
-              <a:t>8/20/2026</a:t>
+              <a:t>8/24/2026</a:t>
             </a:fld>
             <a:endParaRPr lang="en-GB" dirty="0">
               <a:solidFill>
@@ -13172,7 +13172,7 @@
               <a:pPr eaLnBrk="1" hangingPunct="1">
                 <a:defRPr/>
               </a:pPr>
-              <a:t>8/20/2026</a:t>
+              <a:t>8/24/2026</a:t>
             </a:fld>
             <a:endParaRPr lang="en-GB" dirty="0">
               <a:solidFill>
@@ -14800,7 +14800,7 @@
               <a:pPr eaLnBrk="1" hangingPunct="1">
                 <a:defRPr/>
               </a:pPr>
-              <a:t>8/20/2026</a:t>
+              <a:t>8/24/2026</a:t>
             </a:fld>
             <a:endParaRPr lang="en-GB" dirty="0">
               <a:solidFill>
@@ -17316,7 +17316,7 @@
               <a:pPr eaLnBrk="1" hangingPunct="1">
                 <a:defRPr/>
               </a:pPr>
-              <a:t>8/20/2026</a:t>
+              <a:t>8/24/2026</a:t>
             </a:fld>
             <a:endParaRPr lang="en-GB" dirty="0">
               <a:solidFill>
@@ -17894,7 +17894,7 @@
               <a:pPr eaLnBrk="1" hangingPunct="1">
                 <a:defRPr/>
               </a:pPr>
-              <a:t>8/20/2026</a:t>
+              <a:t>8/24/2026</a:t>
             </a:fld>
             <a:endParaRPr lang="en-GB" dirty="0">
               <a:solidFill>
@@ -18609,7 +18609,7 @@
               <a:pPr eaLnBrk="1" hangingPunct="1">
                 <a:defRPr/>
               </a:pPr>
-              <a:t>8/20/2026</a:t>
+              <a:t>8/24/2026</a:t>
             </a:fld>
             <a:endParaRPr lang="en-GB" dirty="0">
               <a:solidFill>
@@ -19321,7 +19321,7 @@
               <a:pPr eaLnBrk="1" hangingPunct="1">
                 <a:defRPr/>
               </a:pPr>
-              <a:t>8/20/2026</a:t>
+              <a:t>8/24/2026</a:t>
             </a:fld>
             <a:endParaRPr lang="en-GB" dirty="0">
               <a:solidFill>
@@ -19755,7 +19755,7 @@
               <a:pPr eaLnBrk="1" hangingPunct="1">
                 <a:defRPr/>
               </a:pPr>
-              <a:t>8/20/2026</a:t>
+              <a:t>8/24/2026</a:t>
             </a:fld>
             <a:endParaRPr lang="en-GB" dirty="0">
               <a:solidFill>
@@ -20213,7 +20213,7 @@
               <a:pPr eaLnBrk="1" hangingPunct="1">
                 <a:defRPr/>
               </a:pPr>
-              <a:t>8/20/2026</a:t>
+              <a:t>8/24/2026</a:t>
             </a:fld>
             <a:endParaRPr lang="en-GB" dirty="0">
               <a:solidFill>
@@ -21826,7 +21826,7 @@
               <a:pPr eaLnBrk="1" hangingPunct="1">
                 <a:defRPr/>
               </a:pPr>
-              <a:t>8/20/2026</a:t>
+              <a:t>8/24/2026</a:t>
             </a:fld>
             <a:endParaRPr lang="en-GB" dirty="0">
               <a:solidFill>
@@ -27447,7 +27447,7 @@
               <a:pPr eaLnBrk="1" hangingPunct="1">
                 <a:defRPr/>
               </a:pPr>
-              <a:t>8/20/2026</a:t>
+              <a:t>8/24/2026</a:t>
             </a:fld>
             <a:endParaRPr lang="en-GB" dirty="0">
               <a:solidFill>
@@ -29963,7 +29963,7 @@
               <a:pPr eaLnBrk="1" hangingPunct="1">
                 <a:defRPr/>
               </a:pPr>
-              <a:t>8/20/2026</a:t>
+              <a:t>8/24/2026</a:t>
             </a:fld>
             <a:endParaRPr lang="en-GB" dirty="0">
               <a:solidFill>
@@ -30541,7 +30541,7 @@
               <a:pPr eaLnBrk="1" hangingPunct="1">
                 <a:defRPr/>
               </a:pPr>
-              <a:t>8/20/2026</a:t>
+              <a:t>8/24/2026</a:t>
             </a:fld>
             <a:endParaRPr lang="en-GB" dirty="0">
               <a:solidFill>
@@ -31256,7 +31256,7 @@
               <a:pPr eaLnBrk="1" hangingPunct="1">
                 <a:defRPr/>
               </a:pPr>
-              <a:t>8/20/2026</a:t>
+              <a:t>8/24/2026</a:t>
             </a:fld>
             <a:endParaRPr lang="en-GB" dirty="0">
               <a:solidFill>
@@ -33646,7 +33646,7 @@
                   <a:schemeClr val="bg1"/>
                 </a:solidFill>
               </a:rPr>
-              <a:t>Last Update : 20-August-26</a:t>
+              <a:t>Last Update : 25-August-26</a:t>
             </a:r>
           </a:p>
         </p:txBody>
@@ -33777,8 +33777,8 @@
         </p:blipFill>
         <p:spPr>
           <a:xfrm>
-            <a:off x="268459" y="629228"/>
-            <a:ext cx="8712704" cy="4637021"/>
+            <a:off x="268459" y="629229"/>
+            <a:ext cx="8311869" cy="4456338"/>
           </a:xfrm>
           <a:prstGeom prst="rect">
             <a:avLst/>
@@ -33916,14 +33916,95 @@
         </p:blipFill>
         <p:spPr>
           <a:xfrm>
-            <a:off x="268460" y="629228"/>
-            <a:ext cx="8336922" cy="4682547"/>
+            <a:off x="317785" y="629229"/>
+            <a:ext cx="5607028" cy="3541937"/>
           </a:xfrm>
           <a:prstGeom prst="rect">
             <a:avLst/>
           </a:prstGeom>
         </p:spPr>
       </p:pic>
+      <p:sp>
+        <p:nvSpPr>
+          <p:cNvPr id="3" name="TextBox 2">
+            <a:extLst>
+              <a:ext uri="{FF2B5EF4-FFF2-40B4-BE49-F238E27FC236}">
+                <a16:creationId xmlns:a16="http://schemas.microsoft.com/office/drawing/2014/main" id="{BF991C23-5EB1-74AB-36DA-FB336259AD83}"/>
+              </a:ext>
+            </a:extLst>
+          </p:cNvPr>
+          <p:cNvSpPr txBox="1"/>
+          <p:nvPr/>
+        </p:nvSpPr>
+        <p:spPr>
+          <a:xfrm>
+            <a:off x="518980" y="4258329"/>
+            <a:ext cx="8424604" cy="738664"/>
+          </a:xfrm>
+          <a:prstGeom prst="rect">
+            <a:avLst/>
+          </a:prstGeom>
+          <a:noFill/>
+        </p:spPr>
+        <p:txBody>
+          <a:bodyPr wrap="square">
+            <a:spAutoFit/>
+          </a:bodyPr>
+          <a:lstStyle/>
+          <a:p>
+            <a:r>
+              <a:rPr lang="en-US" sz="1400" dirty="0">
+                <a:solidFill>
+                  <a:srgbClr val="00B0F0"/>
+                </a:solidFill>
+              </a:rPr>
+              <a:t>For SP 72-35 Manual Link, Cautions are retrieved from </a:t>
+            </a:r>
+            <a:r>
+              <a:rPr lang="en-US" sz="1400" b="1" dirty="0">
+                <a:solidFill>
+                  <a:srgbClr val="00B0F0"/>
+                </a:solidFill>
+              </a:rPr>
+              <a:t>Engine Manual </a:t>
+            </a:r>
+            <a:r>
+              <a:rPr lang="en-US" sz="1400" dirty="0">
+                <a:solidFill>
+                  <a:srgbClr val="00B0F0"/>
+                </a:solidFill>
+              </a:rPr>
+              <a:t>&amp; </a:t>
+            </a:r>
+            <a:r>
+              <a:rPr lang="en-US" sz="1400" b="1" dirty="0">
+                <a:solidFill>
+                  <a:srgbClr val="00B0F0"/>
+                </a:solidFill>
+              </a:rPr>
+              <a:t>CIR</a:t>
+            </a:r>
+            <a:r>
+              <a:rPr lang="en-US" sz="1400" dirty="0">
+                <a:solidFill>
+                  <a:srgbClr val="00B0F0"/>
+                </a:solidFill>
+              </a:rPr>
+              <a:t>.</a:t>
+            </a:r>
+          </a:p>
+          <a:p>
+            <a:r>
+              <a:rPr lang="en-US" dirty="0">
+                <a:solidFill>
+                  <a:srgbClr val="00B0F0"/>
+                </a:solidFill>
+              </a:rPr>
+              <a:t>For the Engine Manual link, only tasks with INFORMATION CODE "-3xx" are fetched, and cautions are extracted from those task pages.</a:t>
+            </a:r>
+          </a:p>
+        </p:txBody>
+      </p:sp>
     </p:spTree>
     <p:extLst>
       <p:ext uri="{BB962C8B-B14F-4D97-AF65-F5344CB8AC3E}">
@@ -34055,14 +34136,95 @@
         </p:blipFill>
         <p:spPr>
           <a:xfrm>
-            <a:off x="268459" y="629228"/>
-            <a:ext cx="8236714" cy="4855585"/>
+            <a:off x="325679" y="629228"/>
+            <a:ext cx="5574081" cy="3529413"/>
           </a:xfrm>
           <a:prstGeom prst="rect">
             <a:avLst/>
           </a:prstGeom>
         </p:spPr>
       </p:pic>
+      <p:sp>
+        <p:nvSpPr>
+          <p:cNvPr id="3" name="TextBox 2">
+            <a:extLst>
+              <a:ext uri="{FF2B5EF4-FFF2-40B4-BE49-F238E27FC236}">
+                <a16:creationId xmlns:a16="http://schemas.microsoft.com/office/drawing/2014/main" id="{234DD181-9965-E758-F4F0-CEB6D74B472F}"/>
+              </a:ext>
+            </a:extLst>
+          </p:cNvPr>
+          <p:cNvSpPr txBox="1"/>
+          <p:nvPr/>
+        </p:nvSpPr>
+        <p:spPr>
+          <a:xfrm>
+            <a:off x="518980" y="4258329"/>
+            <a:ext cx="8424604" cy="738664"/>
+          </a:xfrm>
+          <a:prstGeom prst="rect">
+            <a:avLst/>
+          </a:prstGeom>
+          <a:noFill/>
+        </p:spPr>
+        <p:txBody>
+          <a:bodyPr wrap="square">
+            <a:spAutoFit/>
+          </a:bodyPr>
+          <a:lstStyle/>
+          <a:p>
+            <a:r>
+              <a:rPr lang="en-US" sz="1400" dirty="0">
+                <a:solidFill>
+                  <a:srgbClr val="00B0F0"/>
+                </a:solidFill>
+              </a:rPr>
+              <a:t>For SP 72-51 Manual Link, Cautions are retrieved from </a:t>
+            </a:r>
+            <a:r>
+              <a:rPr lang="en-US" sz="1400" b="1" dirty="0">
+                <a:solidFill>
+                  <a:srgbClr val="00B0F0"/>
+                </a:solidFill>
+              </a:rPr>
+              <a:t>Engine Manual</a:t>
+            </a:r>
+            <a:r>
+              <a:rPr lang="en-US" sz="1400" dirty="0">
+                <a:solidFill>
+                  <a:srgbClr val="00B0F0"/>
+                </a:solidFill>
+              </a:rPr>
+              <a:t> &amp; </a:t>
+            </a:r>
+            <a:r>
+              <a:rPr lang="en-US" sz="1400" b="1" dirty="0">
+                <a:solidFill>
+                  <a:srgbClr val="00B0F0"/>
+                </a:solidFill>
+              </a:rPr>
+              <a:t>CIR</a:t>
+            </a:r>
+            <a:r>
+              <a:rPr lang="en-US" sz="1400" dirty="0">
+                <a:solidFill>
+                  <a:srgbClr val="00B0F0"/>
+                </a:solidFill>
+              </a:rPr>
+              <a:t>.</a:t>
+            </a:r>
+          </a:p>
+          <a:p>
+            <a:r>
+              <a:rPr lang="en-US" dirty="0">
+                <a:solidFill>
+                  <a:srgbClr val="00B0F0"/>
+                </a:solidFill>
+              </a:rPr>
+              <a:t>For the Engine Manual link, only tasks with INFORMATION CODE "-3xx" are fetched, and cautions are extracted from those task pages.</a:t>
+            </a:r>
+          </a:p>
+        </p:txBody>
+      </p:sp>
     </p:spTree>
     <p:extLst>
       <p:ext uri="{BB962C8B-B14F-4D97-AF65-F5344CB8AC3E}">
@@ -34226,23 +34388,7 @@
                   <a:srgbClr val="00B0F0"/>
                 </a:solidFill>
               </a:rPr>
-              <a:t>The Output location specifies the path where the </a:t>
-            </a:r>
-            <a:r>
-              <a:rPr lang="en-US">
-                <a:solidFill>
-                  <a:srgbClr val="00B0F0"/>
-                </a:solidFill>
-              </a:rPr>
-              <a:t>extracted Cautions </a:t>
-            </a:r>
-            <a:r>
-              <a:rPr lang="en-US" dirty="0">
-                <a:solidFill>
-                  <a:srgbClr val="00B0F0"/>
-                </a:solidFill>
-              </a:rPr>
-              <a:t>report will be generated.</a:t>
+              <a:t>The Output location specifies the path where the extracted Cautions report will be generated.</a:t>
             </a:r>
           </a:p>
           <a:p>
@@ -34364,7 +34510,7 @@
             </a:r>
           </a:p>
           <a:p>
-            <a:pPr>
+            <a:pPr marL="342900" indent="-342900">
               <a:buFont typeface="+mj-lt"/>
               <a:buAutoNum type="arabicPeriod"/>
             </a:pPr>
@@ -34378,7 +34524,7 @@
             </a:r>
           </a:p>
           <a:p>
-            <a:pPr>
+            <a:pPr marL="342900" indent="-342900">
               <a:buFont typeface="+mj-lt"/>
               <a:buAutoNum type="arabicPeriod"/>
             </a:pPr>
@@ -34388,11 +34534,11 @@
                   <a:srgbClr val="00B0F0"/>
                 </a:solidFill>
               </a:rPr>
-              <a:t>Scan the Link for caution statements.</a:t>
+              <a:t>Scan the Link for task pages.</a:t>
             </a:r>
           </a:p>
           <a:p>
-            <a:pPr>
+            <a:pPr marL="342900" indent="-342900">
               <a:buFont typeface="+mj-lt"/>
               <a:buAutoNum type="arabicPeriod"/>
             </a:pPr>
@@ -34402,11 +34548,11 @@
                   <a:srgbClr val="00B0F0"/>
                 </a:solidFill>
               </a:rPr>
-              <a:t>Extract all identified cautions.</a:t>
+              <a:t>Extract cautions from these task pages.</a:t>
             </a:r>
           </a:p>
           <a:p>
-            <a:pPr>
+            <a:pPr marL="342900" indent="-342900">
               <a:buFont typeface="+mj-lt"/>
               <a:buAutoNum type="arabicPeriod"/>
             </a:pPr>
@@ -38069,7 +38215,7 @@
           <p:nvPr>
             <p:extLst>
               <p:ext uri="{D42A27DB-BD31-4B8C-83A1-F6EECF244321}">
-                <p14:modId xmlns:p14="http://schemas.microsoft.com/office/powerpoint/2010/main" val="2609532532"/>
+                <p14:modId xmlns:p14="http://schemas.microsoft.com/office/powerpoint/2010/main" val="1567092569"/>
               </p:ext>
             </p:extLst>
           </p:nvPr>
@@ -38179,7 +38325,7 @@
                       <a:pPr algn="ctr"/>
                       <a:r>
                         <a:rPr lang="en-US" dirty="0"/>
-                        <a:t>20-Aug-2026</a:t>
+                        <a:t>25-Aug-2026</a:t>
                       </a:r>
                     </a:p>
                   </a:txBody>
@@ -40591,14 +40737,53 @@
         </p:blipFill>
         <p:spPr>
           <a:xfrm>
-            <a:off x="268458" y="629229"/>
-            <a:ext cx="8512003" cy="4935534"/>
+            <a:off x="268458" y="513567"/>
+            <a:ext cx="8512287" cy="4101950"/>
           </a:xfrm>
           <a:prstGeom prst="rect">
             <a:avLst/>
           </a:prstGeom>
         </p:spPr>
       </p:pic>
+      <p:sp>
+        <p:nvSpPr>
+          <p:cNvPr id="3" name="TextBox 2">
+            <a:extLst>
+              <a:ext uri="{FF2B5EF4-FFF2-40B4-BE49-F238E27FC236}">
+                <a16:creationId xmlns:a16="http://schemas.microsoft.com/office/drawing/2014/main" id="{B81FF75A-05C9-DF48-736C-3E8B23D8E0CF}"/>
+              </a:ext>
+            </a:extLst>
+          </p:cNvPr>
+          <p:cNvSpPr txBox="1"/>
+          <p:nvPr/>
+        </p:nvSpPr>
+        <p:spPr>
+          <a:xfrm>
+            <a:off x="481402" y="4788555"/>
+            <a:ext cx="8424604" cy="523220"/>
+          </a:xfrm>
+          <a:prstGeom prst="rect">
+            <a:avLst/>
+          </a:prstGeom>
+          <a:noFill/>
+        </p:spPr>
+        <p:txBody>
+          <a:bodyPr wrap="square">
+            <a:spAutoFit/>
+          </a:bodyPr>
+          <a:lstStyle/>
+          <a:p>
+            <a:r>
+              <a:rPr lang="en-US" dirty="0">
+                <a:solidFill>
+                  <a:srgbClr val="00B0F0"/>
+                </a:solidFill>
+              </a:rPr>
+              <a:t>For the Engine Manual link, only tasks with INFORMATION CODE "-3xx" are fetched, and cautions are extracted from those task pages.</a:t>
+            </a:r>
+          </a:p>
+        </p:txBody>
+      </p:sp>
     </p:spTree>
     <p:extLst>
       <p:ext uri="{BB962C8B-B14F-4D97-AF65-F5344CB8AC3E}">
@@ -41807,6 +41992,15 @@
 </file>
 
 <file path=customXml/item1.xml><?xml version="1.0" encoding="utf-8"?>
+<?mso-contentType ?>
+<FormTemplates xmlns="http://schemas.microsoft.com/sharepoint/v3/contenttype/forms">
+  <Display>DocumentLibraryForm</Display>
+  <Edit>DocumentLibraryForm</Edit>
+  <New>DocumentLibraryForm</New>
+</FormTemplates>
+</file>
+
+<file path=customXml/item2.xml><?xml version="1.0" encoding="utf-8"?>
 <ct:contentTypeSchema xmlns:ct="http://schemas.microsoft.com/office/2006/metadata/contentType" xmlns:ma="http://schemas.microsoft.com/office/2006/metadata/properties/metaAttributes" ct:_="" ma:_="" ma:contentTypeName="Document" ma:contentTypeID="0x010100AADF239F2ED0534CBEE452B336985728" ma:contentTypeVersion="4" ma:contentTypeDescription="Create a new document." ma:contentTypeScope="" ma:versionID="6a7824fc007c3b206678c4e4d6201abd">
   <xsd:schema xmlns:xsd="http://www.w3.org/2001/XMLSchema" xmlns:xs="http://www.w3.org/2001/XMLSchema" xmlns:p="http://schemas.microsoft.com/office/2006/metadata/properties" xmlns:ns1="http://schemas.microsoft.com/sharepoint/v3" xmlns:ns2="2613b0ce-4e5a-4068-84c6-4aae3ccc9c8a" xmlns:ns3="077667ae-fd08-4bd8-a603-c9f8c202c5e0" targetNamespace="http://schemas.microsoft.com/office/2006/metadata/properties" ma:root="true" ma:fieldsID="86c3fa7aeb19401307e35c1f80bf319a" ns1:_="" ns2:_="" ns3:_="">
     <xsd:import namespace="http://schemas.microsoft.com/sharepoint/v3"/>
@@ -41964,7 +42158,7 @@
 </ct:contentTypeSchema>
 </file>
 
-<file path=customXml/item2.xml><?xml version="1.0" encoding="utf-8"?>
+<file path=customXml/item3.xml><?xml version="1.0" encoding="utf-8"?>
 <p:properties xmlns:p="http://schemas.microsoft.com/office/2006/metadata/properties" xmlns:xsi="http://www.w3.org/2001/XMLSchema-instance" xmlns:pc="http://schemas.microsoft.com/office/infopath/2007/PartnerControls">
   <documentManagement>
     <TaxCatchAll xmlns="077667ae-fd08-4bd8-a603-c9f8c202c5e0">
@@ -41983,16 +42177,15 @@
 </p:properties>
 </file>
 
-<file path=customXml/item3.xml><?xml version="1.0" encoding="utf-8"?>
-<?mso-contentType ?>
-<FormTemplates xmlns="http://schemas.microsoft.com/sharepoint/v3/contenttype/forms">
-  <Display>DocumentLibraryForm</Display>
-  <Edit>DocumentLibraryForm</Edit>
-  <New>DocumentLibraryForm</New>
-</FormTemplates>
+<file path=customXml/itemProps1.xml><?xml version="1.0" encoding="utf-8"?>
+<ds:datastoreItem xmlns:ds="http://schemas.openxmlformats.org/officeDocument/2006/customXml" ds:itemID="{EC84B35E-1715-4D43-A2FB-C60A34588830}">
+  <ds:schemaRefs>
+    <ds:schemaRef ds:uri="http://schemas.microsoft.com/sharepoint/v3/contenttype/forms"/>
+  </ds:schemaRefs>
+</ds:datastoreItem>
 </file>
 
-<file path=customXml/itemProps1.xml><?xml version="1.0" encoding="utf-8"?>
+<file path=customXml/itemProps2.xml><?xml version="1.0" encoding="utf-8"?>
 <ds:datastoreItem xmlns:ds="http://schemas.openxmlformats.org/officeDocument/2006/customXml" ds:itemID="{51FB943C-7FAA-4048-9A7F-254B30072A5E}">
   <ds:schemaRefs>
     <ds:schemaRef ds:uri="http://schemas.microsoft.com/office/2006/metadata/contentType"/>
@@ -42012,7 +42205,7 @@
 </ds:datastoreItem>
 </file>
 
-<file path=customXml/itemProps2.xml><?xml version="1.0" encoding="utf-8"?>
+<file path=customXml/itemProps3.xml><?xml version="1.0" encoding="utf-8"?>
 <ds:datastoreItem xmlns:ds="http://schemas.openxmlformats.org/officeDocument/2006/customXml" ds:itemID="{05FFBBF1-4683-4EE9-8FE4-EED661D9A09E}">
   <ds:schemaRefs>
     <ds:schemaRef ds:uri="http://schemas.microsoft.com/office/2006/metadata/properties"/>
@@ -42028,12 +42221,4 @@
     <ds:schemaRef ds:uri="http://purl.org/dc/elements/1.1/"/>
   </ds:schemaRefs>
 </ds:datastoreItem>
-</file>
-
-<file path=customXml/itemProps3.xml><?xml version="1.0" encoding="utf-8"?>
-<ds:datastoreItem xmlns:ds="http://schemas.openxmlformats.org/officeDocument/2006/customXml" ds:itemID="{EC84B35E-1715-4D43-A2FB-C60A34588830}">
-  <ds:schemaRefs>
-    <ds:schemaRef ds:uri="http://schemas.microsoft.com/sharepoint/v3/contenttype/forms"/>
-  </ds:schemaRefs>
-</ds:datastoreItem>
 </file>
</xml_diff>

<commit_message>
Changed label and gave Sheet names
</commit_message>
<xml_diff>
--- a/ExtractCautionsForEM/bin/Debug/bin/ExtractCautionsFromEngineManualTool.pptx
+++ b/ExtractCautionsForEM/bin/Debug/bin/ExtractCautionsFromEngineManualTool.pptx
@@ -6,10 +6,10 @@
     <p:sldMasterId id="2147483812" r:id="rId5"/>
   </p:sldMasterIdLst>
   <p:notesMasterIdLst>
-    <p:notesMasterId r:id="rId22"/>
+    <p:notesMasterId r:id="rId27"/>
   </p:notesMasterIdLst>
   <p:handoutMasterIdLst>
-    <p:handoutMasterId r:id="rId23"/>
+    <p:handoutMasterId r:id="rId28"/>
   </p:handoutMasterIdLst>
   <p:sldIdLst>
     <p:sldId id="342" r:id="rId6"/>
@@ -25,14 +25,19 @@
     <p:sldId id="975" r:id="rId16"/>
     <p:sldId id="976" r:id="rId17"/>
     <p:sldId id="970" r:id="rId18"/>
-    <p:sldId id="960" r:id="rId19"/>
-    <p:sldId id="961" r:id="rId20"/>
-    <p:sldId id="840" r:id="rId21"/>
+    <p:sldId id="977" r:id="rId19"/>
+    <p:sldId id="960" r:id="rId20"/>
+    <p:sldId id="978" r:id="rId21"/>
+    <p:sldId id="981" r:id="rId22"/>
+    <p:sldId id="979" r:id="rId23"/>
+    <p:sldId id="980" r:id="rId24"/>
+    <p:sldId id="961" r:id="rId25"/>
+    <p:sldId id="840" r:id="rId26"/>
   </p:sldIdLst>
   <p:sldSz cx="9144000" cy="5715000" type="screen16x10"/>
   <p:notesSz cx="6797675" cy="9926638"/>
   <p:custDataLst>
-    <p:tags r:id="rId24"/>
+    <p:tags r:id="rId29"/>
   </p:custDataLst>
   <p:defaultTextStyle>
     <a:defPPr>
@@ -345,7 +350,7 @@
               <a:pPr>
                 <a:defRPr/>
               </a:pPr>
-              <a:t>8/24/2026</a:t>
+              <a:t>8/25/2026</a:t>
             </a:fld>
             <a:endParaRPr lang="en-GB" dirty="0"/>
           </a:p>
@@ -563,7 +568,7 @@
               <a:pPr>
                 <a:defRPr/>
               </a:pPr>
-              <a:t>8/24/2026</a:t>
+              <a:t>8/25/2026</a:t>
             </a:fld>
             <a:endParaRPr lang="en-GB" dirty="0"/>
           </a:p>
@@ -1591,7 +1596,7 @@
             <a:fld id="{32B34421-655C-4564-82BB-49845E235FC0}" type="slidenum">
               <a:rPr lang="en-GB" altLang="en-US" smtClean="0"/>
               <a:pPr/>
-              <a:t>14</a:t>
+              <a:t>15</a:t>
             </a:fld>
             <a:endParaRPr lang="en-GB" altLang="en-US"/>
           </a:p>
@@ -3300,7 +3305,7 @@
               <a:pPr eaLnBrk="1" hangingPunct="1">
                 <a:defRPr/>
               </a:pPr>
-              <a:t>8/24/2026</a:t>
+              <a:t>8/25/2026</a:t>
             </a:fld>
             <a:endParaRPr lang="en-GB" dirty="0">
               <a:solidFill>
@@ -3734,7 +3739,7 @@
               <a:pPr eaLnBrk="1" hangingPunct="1">
                 <a:defRPr/>
               </a:pPr>
-              <a:t>8/24/2026</a:t>
+              <a:t>8/25/2026</a:t>
             </a:fld>
             <a:endParaRPr lang="en-GB" dirty="0">
               <a:solidFill>
@@ -4192,7 +4197,7 @@
               <a:pPr eaLnBrk="1" hangingPunct="1">
                 <a:defRPr/>
               </a:pPr>
-              <a:t>8/24/2026</a:t>
+              <a:t>8/25/2026</a:t>
             </a:fld>
             <a:endParaRPr lang="en-GB" dirty="0">
               <a:solidFill>
@@ -4622,7 +4627,7 @@
               <a:pPr eaLnBrk="1" hangingPunct="1">
                 <a:defRPr/>
               </a:pPr>
-              <a:t>8/24/2026</a:t>
+              <a:t>8/25/2026</a:t>
             </a:fld>
             <a:endParaRPr lang="en-GB" dirty="0">
               <a:solidFill>
@@ -5229,7 +5234,7 @@
               <a:pPr eaLnBrk="1" hangingPunct="1">
                 <a:defRPr/>
               </a:pPr>
-              <a:t>8/24/2026</a:t>
+              <a:t>8/25/2026</a:t>
             </a:fld>
             <a:endParaRPr lang="en-GB" dirty="0">
               <a:solidFill>
@@ -8641,7 +8646,7 @@
               <a:pPr eaLnBrk="1" hangingPunct="1">
                 <a:defRPr/>
               </a:pPr>
-              <a:t>8/24/2026</a:t>
+              <a:t>8/25/2026</a:t>
             </a:fld>
             <a:endParaRPr lang="en-GB" dirty="0">
               <a:solidFill>
@@ -9456,7 +9461,7 @@
               <a:pPr eaLnBrk="1" hangingPunct="1">
                 <a:defRPr/>
               </a:pPr>
-              <a:t>8/24/2026</a:t>
+              <a:t>8/25/2026</a:t>
             </a:fld>
             <a:endParaRPr lang="en-GB" dirty="0">
               <a:solidFill>
@@ -10277,7 +10282,7 @@
               <a:pPr eaLnBrk="1" hangingPunct="1">
                 <a:defRPr/>
               </a:pPr>
-              <a:t>8/24/2026</a:t>
+              <a:t>8/25/2026</a:t>
             </a:fld>
             <a:endParaRPr lang="en-GB" dirty="0">
               <a:solidFill>
@@ -12129,7 +12134,7 @@
               <a:pPr eaLnBrk="1" hangingPunct="1">
                 <a:defRPr/>
               </a:pPr>
-              <a:t>8/24/2026</a:t>
+              <a:t>8/25/2026</a:t>
             </a:fld>
             <a:endParaRPr lang="en-GB" dirty="0">
               <a:solidFill>
@@ -12650,7 +12655,7 @@
               <a:pPr eaLnBrk="1" hangingPunct="1">
                 <a:defRPr/>
               </a:pPr>
-              <a:t>8/24/2026</a:t>
+              <a:t>8/25/2026</a:t>
             </a:fld>
             <a:endParaRPr lang="en-GB" dirty="0">
               <a:solidFill>
@@ -13172,7 +13177,7 @@
               <a:pPr eaLnBrk="1" hangingPunct="1">
                 <a:defRPr/>
               </a:pPr>
-              <a:t>8/24/2026</a:t>
+              <a:t>8/25/2026</a:t>
             </a:fld>
             <a:endParaRPr lang="en-GB" dirty="0">
               <a:solidFill>
@@ -14800,7 +14805,7 @@
               <a:pPr eaLnBrk="1" hangingPunct="1">
                 <a:defRPr/>
               </a:pPr>
-              <a:t>8/24/2026</a:t>
+              <a:t>8/25/2026</a:t>
             </a:fld>
             <a:endParaRPr lang="en-GB" dirty="0">
               <a:solidFill>
@@ -17316,7 +17321,7 @@
               <a:pPr eaLnBrk="1" hangingPunct="1">
                 <a:defRPr/>
               </a:pPr>
-              <a:t>8/24/2026</a:t>
+              <a:t>8/25/2026</a:t>
             </a:fld>
             <a:endParaRPr lang="en-GB" dirty="0">
               <a:solidFill>
@@ -17894,7 +17899,7 @@
               <a:pPr eaLnBrk="1" hangingPunct="1">
                 <a:defRPr/>
               </a:pPr>
-              <a:t>8/24/2026</a:t>
+              <a:t>8/25/2026</a:t>
             </a:fld>
             <a:endParaRPr lang="en-GB" dirty="0">
               <a:solidFill>
@@ -18609,7 +18614,7 @@
               <a:pPr eaLnBrk="1" hangingPunct="1">
                 <a:defRPr/>
               </a:pPr>
-              <a:t>8/24/2026</a:t>
+              <a:t>8/25/2026</a:t>
             </a:fld>
             <a:endParaRPr lang="en-GB" dirty="0">
               <a:solidFill>
@@ -19321,7 +19326,7 @@
               <a:pPr eaLnBrk="1" hangingPunct="1">
                 <a:defRPr/>
               </a:pPr>
-              <a:t>8/24/2026</a:t>
+              <a:t>8/25/2026</a:t>
             </a:fld>
             <a:endParaRPr lang="en-GB" dirty="0">
               <a:solidFill>
@@ -19755,7 +19760,7 @@
               <a:pPr eaLnBrk="1" hangingPunct="1">
                 <a:defRPr/>
               </a:pPr>
-              <a:t>8/24/2026</a:t>
+              <a:t>8/25/2026</a:t>
             </a:fld>
             <a:endParaRPr lang="en-GB" dirty="0">
               <a:solidFill>
@@ -20213,7 +20218,7 @@
               <a:pPr eaLnBrk="1" hangingPunct="1">
                 <a:defRPr/>
               </a:pPr>
-              <a:t>8/24/2026</a:t>
+              <a:t>8/25/2026</a:t>
             </a:fld>
             <a:endParaRPr lang="en-GB" dirty="0">
               <a:solidFill>
@@ -21826,7 +21831,7 @@
               <a:pPr eaLnBrk="1" hangingPunct="1">
                 <a:defRPr/>
               </a:pPr>
-              <a:t>8/24/2026</a:t>
+              <a:t>8/25/2026</a:t>
             </a:fld>
             <a:endParaRPr lang="en-GB" dirty="0">
               <a:solidFill>
@@ -27447,7 +27452,7 @@
               <a:pPr eaLnBrk="1" hangingPunct="1">
                 <a:defRPr/>
               </a:pPr>
-              <a:t>8/24/2026</a:t>
+              <a:t>8/25/2026</a:t>
             </a:fld>
             <a:endParaRPr lang="en-GB" dirty="0">
               <a:solidFill>
@@ -29963,7 +29968,7 @@
               <a:pPr eaLnBrk="1" hangingPunct="1">
                 <a:defRPr/>
               </a:pPr>
-              <a:t>8/24/2026</a:t>
+              <a:t>8/25/2026</a:t>
             </a:fld>
             <a:endParaRPr lang="en-GB" dirty="0">
               <a:solidFill>
@@ -30541,7 +30546,7 @@
               <a:pPr eaLnBrk="1" hangingPunct="1">
                 <a:defRPr/>
               </a:pPr>
-              <a:t>8/24/2026</a:t>
+              <a:t>8/25/2026</a:t>
             </a:fld>
             <a:endParaRPr lang="en-GB" dirty="0">
               <a:solidFill>
@@ -31256,7 +31261,7 @@
               <a:pPr eaLnBrk="1" hangingPunct="1">
                 <a:defRPr/>
               </a:pPr>
-              <a:t>8/24/2026</a:t>
+              <a:t>8/25/2026</a:t>
             </a:fld>
             <a:endParaRPr lang="en-GB" dirty="0">
               <a:solidFill>
@@ -33646,7 +33651,7 @@
                   <a:schemeClr val="bg1"/>
                 </a:solidFill>
               </a:rPr>
-              <a:t>Last Update : 25-August-26</a:t>
+              <a:t>Last Update : 26-August-26</a:t>
             </a:r>
           </a:p>
         </p:txBody>
@@ -33924,87 +33929,6 @@
           </a:prstGeom>
         </p:spPr>
       </p:pic>
-      <p:sp>
-        <p:nvSpPr>
-          <p:cNvPr id="3" name="TextBox 2">
-            <a:extLst>
-              <a:ext uri="{FF2B5EF4-FFF2-40B4-BE49-F238E27FC236}">
-                <a16:creationId xmlns:a16="http://schemas.microsoft.com/office/drawing/2014/main" id="{BF991C23-5EB1-74AB-36DA-FB336259AD83}"/>
-              </a:ext>
-            </a:extLst>
-          </p:cNvPr>
-          <p:cNvSpPr txBox="1"/>
-          <p:nvPr/>
-        </p:nvSpPr>
-        <p:spPr>
-          <a:xfrm>
-            <a:off x="518980" y="4258329"/>
-            <a:ext cx="8424604" cy="738664"/>
-          </a:xfrm>
-          <a:prstGeom prst="rect">
-            <a:avLst/>
-          </a:prstGeom>
-          <a:noFill/>
-        </p:spPr>
-        <p:txBody>
-          <a:bodyPr wrap="square">
-            <a:spAutoFit/>
-          </a:bodyPr>
-          <a:lstStyle/>
-          <a:p>
-            <a:r>
-              <a:rPr lang="en-US" sz="1400" dirty="0">
-                <a:solidFill>
-                  <a:srgbClr val="00B0F0"/>
-                </a:solidFill>
-              </a:rPr>
-              <a:t>For SP 72-35 Manual Link, Cautions are retrieved from </a:t>
-            </a:r>
-            <a:r>
-              <a:rPr lang="en-US" sz="1400" b="1" dirty="0">
-                <a:solidFill>
-                  <a:srgbClr val="00B0F0"/>
-                </a:solidFill>
-              </a:rPr>
-              <a:t>Engine Manual </a:t>
-            </a:r>
-            <a:r>
-              <a:rPr lang="en-US" sz="1400" dirty="0">
-                <a:solidFill>
-                  <a:srgbClr val="00B0F0"/>
-                </a:solidFill>
-              </a:rPr>
-              <a:t>&amp; </a:t>
-            </a:r>
-            <a:r>
-              <a:rPr lang="en-US" sz="1400" b="1" dirty="0">
-                <a:solidFill>
-                  <a:srgbClr val="00B0F0"/>
-                </a:solidFill>
-              </a:rPr>
-              <a:t>CIR</a:t>
-            </a:r>
-            <a:r>
-              <a:rPr lang="en-US" sz="1400" dirty="0">
-                <a:solidFill>
-                  <a:srgbClr val="00B0F0"/>
-                </a:solidFill>
-              </a:rPr>
-              <a:t>.</a:t>
-            </a:r>
-          </a:p>
-          <a:p>
-            <a:r>
-              <a:rPr lang="en-US" dirty="0">
-                <a:solidFill>
-                  <a:srgbClr val="00B0F0"/>
-                </a:solidFill>
-              </a:rPr>
-              <a:t>For the Engine Manual link, only tasks with INFORMATION CODE "-3xx" are fetched, and cautions are extracted from those task pages.</a:t>
-            </a:r>
-          </a:p>
-        </p:txBody>
-      </p:sp>
     </p:spTree>
     <p:extLst>
       <p:ext uri="{BB962C8B-B14F-4D97-AF65-F5344CB8AC3E}">
@@ -34144,87 +34068,6 @@
           </a:prstGeom>
         </p:spPr>
       </p:pic>
-      <p:sp>
-        <p:nvSpPr>
-          <p:cNvPr id="3" name="TextBox 2">
-            <a:extLst>
-              <a:ext uri="{FF2B5EF4-FFF2-40B4-BE49-F238E27FC236}">
-                <a16:creationId xmlns:a16="http://schemas.microsoft.com/office/drawing/2014/main" id="{234DD181-9965-E758-F4F0-CEB6D74B472F}"/>
-              </a:ext>
-            </a:extLst>
-          </p:cNvPr>
-          <p:cNvSpPr txBox="1"/>
-          <p:nvPr/>
-        </p:nvSpPr>
-        <p:spPr>
-          <a:xfrm>
-            <a:off x="518980" y="4258329"/>
-            <a:ext cx="8424604" cy="738664"/>
-          </a:xfrm>
-          <a:prstGeom prst="rect">
-            <a:avLst/>
-          </a:prstGeom>
-          <a:noFill/>
-        </p:spPr>
-        <p:txBody>
-          <a:bodyPr wrap="square">
-            <a:spAutoFit/>
-          </a:bodyPr>
-          <a:lstStyle/>
-          <a:p>
-            <a:r>
-              <a:rPr lang="en-US" sz="1400" dirty="0">
-                <a:solidFill>
-                  <a:srgbClr val="00B0F0"/>
-                </a:solidFill>
-              </a:rPr>
-              <a:t>For SP 72-51 Manual Link, Cautions are retrieved from </a:t>
-            </a:r>
-            <a:r>
-              <a:rPr lang="en-US" sz="1400" b="1" dirty="0">
-                <a:solidFill>
-                  <a:srgbClr val="00B0F0"/>
-                </a:solidFill>
-              </a:rPr>
-              <a:t>Engine Manual</a:t>
-            </a:r>
-            <a:r>
-              <a:rPr lang="en-US" sz="1400" dirty="0">
-                <a:solidFill>
-                  <a:srgbClr val="00B0F0"/>
-                </a:solidFill>
-              </a:rPr>
-              <a:t> &amp; </a:t>
-            </a:r>
-            <a:r>
-              <a:rPr lang="en-US" sz="1400" b="1" dirty="0">
-                <a:solidFill>
-                  <a:srgbClr val="00B0F0"/>
-                </a:solidFill>
-              </a:rPr>
-              <a:t>CIR</a:t>
-            </a:r>
-            <a:r>
-              <a:rPr lang="en-US" sz="1400" dirty="0">
-                <a:solidFill>
-                  <a:srgbClr val="00B0F0"/>
-                </a:solidFill>
-              </a:rPr>
-              <a:t>.</a:t>
-            </a:r>
-          </a:p>
-          <a:p>
-            <a:r>
-              <a:rPr lang="en-US" dirty="0">
-                <a:solidFill>
-                  <a:srgbClr val="00B0F0"/>
-                </a:solidFill>
-              </a:rPr>
-              <a:t>For the Engine Manual link, only tasks with INFORMATION CODE "-3xx" are fetched, and cautions are extracted from those task pages.</a:t>
-            </a:r>
-          </a:p>
-        </p:txBody>
-      </p:sp>
     </p:spTree>
     <p:extLst>
       <p:ext uri="{BB962C8B-B14F-4D97-AF65-F5344CB8AC3E}">
@@ -34300,7 +34143,7 @@
         <p:spPr>
           <a:xfrm>
             <a:off x="363538" y="700413"/>
-            <a:ext cx="8442259" cy="4616648"/>
+            <a:ext cx="8442259" cy="4401205"/>
           </a:xfrm>
           <a:prstGeom prst="rect">
             <a:avLst/>
@@ -34549,20 +34392,6 @@
                 </a:solidFill>
               </a:rPr>
               <a:t>Extract cautions from these task pages.</a:t>
-            </a:r>
-          </a:p>
-          <a:p>
-            <a:pPr marL="342900" indent="-342900">
-              <a:buFont typeface="+mj-lt"/>
-              <a:buAutoNum type="arabicPeriod"/>
-            </a:pPr>
-            <a:r>
-              <a:rPr lang="en-US" dirty="0">
-                <a:solidFill>
-                  <a:srgbClr val="00B0F0"/>
-                </a:solidFill>
-              </a:rPr>
-              <a:t>Generate the report at the specified location.</a:t>
             </a:r>
           </a:p>
         </p:txBody>
@@ -34581,6 +34410,387 @@
 </file>
 
 <file path=ppt/slides/slide14.xml><?xml version="1.0" encoding="utf-8"?>
+<p:sld xmlns:a="http://schemas.openxmlformats.org/drawingml/2006/main" xmlns:r="http://schemas.openxmlformats.org/officeDocument/2006/relationships" xmlns:p="http://schemas.openxmlformats.org/presentationml/2006/main">
+  <p:cSld>
+    <p:spTree>
+      <p:nvGrpSpPr>
+        <p:cNvPr id="1" name=""/>
+        <p:cNvGrpSpPr/>
+        <p:nvPr/>
+      </p:nvGrpSpPr>
+      <p:grpSpPr>
+        <a:xfrm>
+          <a:off x="0" y="0"/>
+          <a:ext cx="0" cy="0"/>
+          <a:chOff x="0" y="0"/>
+          <a:chExt cx="0" cy="0"/>
+        </a:xfrm>
+      </p:grpSpPr>
+      <p:sp>
+        <p:nvSpPr>
+          <p:cNvPr id="4" name="Slide Number Placeholder 3">
+            <a:extLst>
+              <a:ext uri="{FF2B5EF4-FFF2-40B4-BE49-F238E27FC236}">
+                <a16:creationId xmlns:a16="http://schemas.microsoft.com/office/drawing/2014/main" id="{5869AC00-F6F0-1F66-5FF9-90123B24A1CF}"/>
+              </a:ext>
+            </a:extLst>
+          </p:cNvPr>
+          <p:cNvSpPr>
+            <a:spLocks noGrp="1"/>
+          </p:cNvSpPr>
+          <p:nvPr>
+            <p:ph type="sldNum" sz="quarter" idx="14"/>
+          </p:nvPr>
+        </p:nvSpPr>
+        <p:spPr/>
+        <p:txBody>
+          <a:bodyPr/>
+          <a:lstStyle/>
+          <a:p>
+            <a:fld id="{8A4A04CF-1BC9-4C63-AE06-A38D4D08020F}" type="slidenum">
+              <a:rPr lang="en-GB" altLang="en-US" smtClean="0"/>
+              <a:pPr/>
+              <a:t>14</a:t>
+            </a:fld>
+            <a:endParaRPr lang="en-GB" altLang="en-US" dirty="0"/>
+          </a:p>
+        </p:txBody>
+      </p:sp>
+      <p:sp>
+        <p:nvSpPr>
+          <p:cNvPr id="8" name="TextBox 7">
+            <a:extLst>
+              <a:ext uri="{FF2B5EF4-FFF2-40B4-BE49-F238E27FC236}">
+                <a16:creationId xmlns:a16="http://schemas.microsoft.com/office/drawing/2014/main" id="{9397C0D7-87AF-761B-FADD-41059DE198A8}"/>
+              </a:ext>
+            </a:extLst>
+          </p:cNvPr>
+          <p:cNvSpPr txBox="1"/>
+          <p:nvPr/>
+        </p:nvSpPr>
+        <p:spPr>
+          <a:xfrm>
+            <a:off x="338203" y="437277"/>
+            <a:ext cx="8442259" cy="5047536"/>
+          </a:xfrm>
+          <a:prstGeom prst="rect">
+            <a:avLst/>
+          </a:prstGeom>
+          <a:noFill/>
+        </p:spPr>
+        <p:txBody>
+          <a:bodyPr wrap="square">
+            <a:spAutoFit/>
+          </a:bodyPr>
+          <a:lstStyle/>
+          <a:p>
+            <a:pPr marL="285750" indent="-285750">
+              <a:buFont typeface="Arial" panose="020B0604020202020204" pitchFamily="34" charset="0"/>
+              <a:buChar char="•"/>
+            </a:pPr>
+            <a:r>
+              <a:rPr lang="en-US" dirty="0">
+                <a:solidFill>
+                  <a:srgbClr val="00B0F0"/>
+                </a:solidFill>
+              </a:rPr>
+              <a:t>If the selected manual link is EM, the output report will contain 2 worksheets:</a:t>
+            </a:r>
+          </a:p>
+          <a:p>
+            <a:pPr marL="641350" lvl="1" indent="-285750">
+              <a:buFont typeface="Arial" panose="020B0604020202020204" pitchFamily="34" charset="0"/>
+              <a:buChar char="•"/>
+            </a:pPr>
+            <a:r>
+              <a:rPr lang="en-US" dirty="0">
+                <a:solidFill>
+                  <a:srgbClr val="00B0F0"/>
+                </a:solidFill>
+              </a:rPr>
+              <a:t>Sheet 1: All EM cautions. </a:t>
+            </a:r>
+          </a:p>
+          <a:p>
+            <a:pPr marL="641350" lvl="1" indent="-285750">
+              <a:buFont typeface="Arial" panose="020B0604020202020204" pitchFamily="34" charset="0"/>
+              <a:buChar char="•"/>
+            </a:pPr>
+            <a:r>
+              <a:rPr lang="en-US" dirty="0">
+                <a:solidFill>
+                  <a:srgbClr val="00B0F0"/>
+                </a:solidFill>
+              </a:rPr>
+              <a:t>Sheet 2: EM Cautions  having Information Code "-3xx".</a:t>
+            </a:r>
+          </a:p>
+          <a:p>
+            <a:pPr marL="342900" indent="-342900">
+              <a:buFont typeface="Arial" panose="020B0604020202020204" pitchFamily="34" charset="0"/>
+              <a:buChar char="•"/>
+            </a:pPr>
+            <a:endParaRPr lang="en-US" dirty="0">
+              <a:solidFill>
+                <a:srgbClr val="00B0F0"/>
+              </a:solidFill>
+            </a:endParaRPr>
+          </a:p>
+          <a:p>
+            <a:pPr marL="285750" indent="-285750">
+              <a:buFont typeface="Arial" panose="020B0604020202020204" pitchFamily="34" charset="0"/>
+              <a:buChar char="•"/>
+            </a:pPr>
+            <a:r>
+              <a:rPr lang="en-US" dirty="0">
+                <a:solidFill>
+                  <a:srgbClr val="00B0F0"/>
+                </a:solidFill>
+              </a:rPr>
+              <a:t>If the selected manual link is EM_CIR, the output report will contain 2 worksheets:</a:t>
+            </a:r>
+          </a:p>
+          <a:p>
+            <a:pPr marL="641350" lvl="1" indent="-285750">
+              <a:buFont typeface="Arial" panose="020B0604020202020204" pitchFamily="34" charset="0"/>
+              <a:buChar char="•"/>
+            </a:pPr>
+            <a:r>
+              <a:rPr lang="en-US" dirty="0">
+                <a:solidFill>
+                  <a:srgbClr val="00B0F0"/>
+                </a:solidFill>
+              </a:rPr>
+              <a:t>Sheet 1: All EM_CIR cautions. </a:t>
+            </a:r>
+          </a:p>
+          <a:p>
+            <a:pPr marL="641350" lvl="1" indent="-285750">
+              <a:buFont typeface="Arial" panose="020B0604020202020204" pitchFamily="34" charset="0"/>
+              <a:buChar char="•"/>
+            </a:pPr>
+            <a:r>
+              <a:rPr lang="en-US" dirty="0">
+                <a:solidFill>
+                  <a:srgbClr val="00B0F0"/>
+                </a:solidFill>
+              </a:rPr>
+              <a:t>Sheet 2: EM_CIR Cautions having Information Code "-3xx".</a:t>
+            </a:r>
+          </a:p>
+          <a:p>
+            <a:pPr marL="342900" indent="-342900">
+              <a:buFont typeface="Arial" panose="020B0604020202020204" pitchFamily="34" charset="0"/>
+              <a:buChar char="•"/>
+            </a:pPr>
+            <a:endParaRPr lang="en-US" dirty="0">
+              <a:solidFill>
+                <a:srgbClr val="00B0F0"/>
+              </a:solidFill>
+            </a:endParaRPr>
+          </a:p>
+          <a:p>
+            <a:pPr marL="285750" indent="-285750">
+              <a:buFont typeface="Arial" panose="020B0604020202020204" pitchFamily="34" charset="0"/>
+              <a:buChar char="•"/>
+            </a:pPr>
+            <a:r>
+              <a:rPr lang="en-US" dirty="0">
+                <a:solidFill>
+                  <a:srgbClr val="00B0F0"/>
+                </a:solidFill>
+              </a:rPr>
+              <a:t>If the selected manual link is SP 72-35, the output report will contain 3 worksheets:</a:t>
+            </a:r>
+          </a:p>
+          <a:p>
+            <a:pPr marL="641350" lvl="1" indent="-285750">
+              <a:buFont typeface="Arial" panose="020B0604020202020204" pitchFamily="34" charset="0"/>
+              <a:buChar char="•"/>
+            </a:pPr>
+            <a:r>
+              <a:rPr lang="en-US" dirty="0">
+                <a:solidFill>
+                  <a:srgbClr val="00B0F0"/>
+                </a:solidFill>
+              </a:rPr>
+              <a:t>Sheet 1: All EM cautions. </a:t>
+            </a:r>
+          </a:p>
+          <a:p>
+            <a:pPr marL="641350" lvl="1" indent="-285750">
+              <a:buFont typeface="Arial" panose="020B0604020202020204" pitchFamily="34" charset="0"/>
+              <a:buChar char="•"/>
+            </a:pPr>
+            <a:r>
+              <a:rPr lang="en-US" dirty="0">
+                <a:solidFill>
+                  <a:srgbClr val="00B0F0"/>
+                </a:solidFill>
+              </a:rPr>
+              <a:t>Sheet 2: All CIR cautions. </a:t>
+            </a:r>
+          </a:p>
+          <a:p>
+            <a:pPr marL="641350" lvl="1" indent="-285750">
+              <a:buFont typeface="Arial" panose="020B0604020202020204" pitchFamily="34" charset="0"/>
+              <a:buChar char="•"/>
+            </a:pPr>
+            <a:r>
+              <a:rPr lang="en-US" dirty="0">
+                <a:solidFill>
+                  <a:srgbClr val="00B0F0"/>
+                </a:solidFill>
+              </a:rPr>
+              <a:t>Sheet 3: EM &amp; CIR Cautions having Information Code "-3xx".</a:t>
+            </a:r>
+          </a:p>
+          <a:p>
+            <a:pPr marL="342900" indent="-342900">
+              <a:buFont typeface="Arial" panose="020B0604020202020204" pitchFamily="34" charset="0"/>
+              <a:buChar char="•"/>
+            </a:pPr>
+            <a:endParaRPr lang="en-US" dirty="0">
+              <a:solidFill>
+                <a:srgbClr val="00B0F0"/>
+              </a:solidFill>
+            </a:endParaRPr>
+          </a:p>
+          <a:p>
+            <a:pPr marL="285750" lvl="0" indent="-285750">
+              <a:buFont typeface="Arial" panose="020B0604020202020204" pitchFamily="34" charset="0"/>
+              <a:buChar char="•"/>
+            </a:pPr>
+            <a:r>
+              <a:rPr lang="en-US" dirty="0">
+                <a:solidFill>
+                  <a:srgbClr val="00B0F0"/>
+                </a:solidFill>
+              </a:rPr>
+              <a:t>If the selected manual link is SP 72-51, the output report will contain 3 worksheets: </a:t>
+            </a:r>
+          </a:p>
+          <a:p>
+            <a:pPr marL="641350" lvl="1" indent="-285750">
+              <a:buFont typeface="Arial" panose="020B0604020202020204" pitchFamily="34" charset="0"/>
+              <a:buChar char="•"/>
+            </a:pPr>
+            <a:r>
+              <a:rPr lang="en-US" dirty="0">
+                <a:solidFill>
+                  <a:srgbClr val="00B0F0"/>
+                </a:solidFill>
+              </a:rPr>
+              <a:t>Sheet 1: All EM cautions. </a:t>
+            </a:r>
+          </a:p>
+          <a:p>
+            <a:pPr marL="641350" lvl="1" indent="-285750">
+              <a:buFont typeface="Arial" panose="020B0604020202020204" pitchFamily="34" charset="0"/>
+              <a:buChar char="•"/>
+            </a:pPr>
+            <a:r>
+              <a:rPr lang="en-US" dirty="0">
+                <a:solidFill>
+                  <a:srgbClr val="00B0F0"/>
+                </a:solidFill>
+              </a:rPr>
+              <a:t>Sheet 2: All CIR cautions. </a:t>
+            </a:r>
+          </a:p>
+          <a:p>
+            <a:pPr marL="641350" lvl="1" indent="-285750">
+              <a:buFont typeface="Arial" panose="020B0604020202020204" pitchFamily="34" charset="0"/>
+              <a:buChar char="•"/>
+            </a:pPr>
+            <a:r>
+              <a:rPr lang="en-US" dirty="0">
+                <a:solidFill>
+                  <a:srgbClr val="00B0F0"/>
+                </a:solidFill>
+              </a:rPr>
+              <a:t>Sheet 3: EM &amp; CIR Cautions having Information Code "-3xx". </a:t>
+            </a:r>
+          </a:p>
+          <a:p>
+            <a:pPr lvl="1" indent="0"/>
+            <a:endParaRPr lang="en-US" dirty="0">
+              <a:solidFill>
+                <a:srgbClr val="00B0F0"/>
+              </a:solidFill>
+            </a:endParaRPr>
+          </a:p>
+          <a:p>
+            <a:pPr lvl="1" indent="0"/>
+            <a:r>
+              <a:rPr lang="en-US" dirty="0">
+                <a:solidFill>
+                  <a:srgbClr val="00B0F0"/>
+                </a:solidFill>
+              </a:rPr>
+              <a:t>4.	Generate the report at the specified location.</a:t>
+            </a:r>
+          </a:p>
+          <a:p>
+            <a:pPr marL="342900" indent="-342900">
+              <a:buFont typeface="Arial" panose="020B0604020202020204" pitchFamily="34" charset="0"/>
+              <a:buChar char="•"/>
+            </a:pPr>
+            <a:endParaRPr lang="en-US" dirty="0">
+              <a:solidFill>
+                <a:srgbClr val="00B0F0"/>
+              </a:solidFill>
+            </a:endParaRPr>
+          </a:p>
+          <a:p>
+            <a:pPr>
+              <a:buNone/>
+            </a:pPr>
+            <a:r>
+              <a:rPr lang="en-US" dirty="0">
+                <a:solidFill>
+                  <a:srgbClr val="00B0F0"/>
+                </a:solidFill>
+              </a:rPr>
+              <a:t> </a:t>
+            </a:r>
+          </a:p>
+          <a:p>
+            <a:pPr>
+              <a:buNone/>
+            </a:pPr>
+            <a:endParaRPr lang="en-US" dirty="0">
+              <a:solidFill>
+                <a:srgbClr val="00B0F0"/>
+              </a:solidFill>
+            </a:endParaRPr>
+          </a:p>
+          <a:p>
+            <a:pPr>
+              <a:buNone/>
+            </a:pPr>
+            <a:endParaRPr lang="en-US" dirty="0">
+              <a:solidFill>
+                <a:srgbClr val="00B0F0"/>
+              </a:solidFill>
+            </a:endParaRPr>
+          </a:p>
+        </p:txBody>
+      </p:sp>
+    </p:spTree>
+    <p:extLst>
+      <p:ext uri="{BB962C8B-B14F-4D97-AF65-F5344CB8AC3E}">
+        <p14:creationId xmlns:p14="http://schemas.microsoft.com/office/powerpoint/2010/main" val="2380596602"/>
+      </p:ext>
+    </p:extLst>
+  </p:cSld>
+  <p:clrMapOvr>
+    <a:masterClrMapping/>
+  </p:clrMapOvr>
+</p:sld>
+</file>
+
+<file path=ppt/slides/slide15.xml><?xml version="1.0" encoding="utf-8"?>
 <p:sld xmlns:a="http://schemas.openxmlformats.org/drawingml/2006/main" xmlns:r="http://schemas.openxmlformats.org/officeDocument/2006/relationships" xmlns:p="http://schemas.openxmlformats.org/presentationml/2006/main">
   <p:cSld>
     <p:spTree>
@@ -34656,7 +34866,7 @@
             <a:fld id="{8A4A04CF-1BC9-4C63-AE06-A38D4D08020F}" type="slidenum">
               <a:rPr lang="en-GB" altLang="en-US" smtClean="0"/>
               <a:pPr/>
-              <a:t>14</a:t>
+              <a:t>15</a:t>
             </a:fld>
             <a:endParaRPr lang="en-GB" altLang="en-US" dirty="0"/>
           </a:p>
@@ -34678,7 +34888,7 @@
         </p:nvSpPr>
         <p:spPr bwMode="auto">
           <a:xfrm>
-            <a:off x="998538" y="709972"/>
+            <a:off x="3954680" y="933534"/>
             <a:ext cx="1682553" cy="173038"/>
           </a:xfrm>
           <a:prstGeom prst="rect">
@@ -35177,8 +35387,8 @@
         </p:blipFill>
         <p:spPr>
           <a:xfrm>
-            <a:off x="998538" y="961321"/>
-            <a:ext cx="1190791" cy="1276528"/>
+            <a:off x="4181920" y="81366"/>
+            <a:ext cx="780158" cy="836329"/>
           </a:xfrm>
           <a:prstGeom prst="rect">
             <a:avLst/>
@@ -35187,10 +35397,10 @@
       </p:pic>
       <p:pic>
         <p:nvPicPr>
-          <p:cNvPr id="3" name="Picture 2">
+          <p:cNvPr id="4" name="Picture 3">
             <a:extLst>
               <a:ext uri="{FF2B5EF4-FFF2-40B4-BE49-F238E27FC236}">
-                <a16:creationId xmlns:a16="http://schemas.microsoft.com/office/drawing/2014/main" id="{8C798E23-871F-5153-9BE6-B3494B5BD0FF}"/>
+                <a16:creationId xmlns:a16="http://schemas.microsoft.com/office/drawing/2014/main" id="{41DF47A3-6765-02AC-9662-3BE4888994E7}"/>
               </a:ext>
             </a:extLst>
           </p:cNvPr>
@@ -35207,185 +35417,20 @@
         </p:blipFill>
         <p:spPr>
           <a:xfrm>
-            <a:off x="169081" y="2455781"/>
-            <a:ext cx="8354860" cy="2855994"/>
+            <a:off x="386817" y="1291754"/>
+            <a:ext cx="8001934" cy="3808854"/>
           </a:xfrm>
           <a:prstGeom prst="rect">
             <a:avLst/>
           </a:prstGeom>
         </p:spPr>
       </p:pic>
-    </p:spTree>
-    <p:extLst>
-      <p:ext uri="{BB962C8B-B14F-4D97-AF65-F5344CB8AC3E}">
-        <p14:creationId xmlns:p14="http://schemas.microsoft.com/office/powerpoint/2010/main" val="157415074"/>
-      </p:ext>
-    </p:extLst>
-  </p:cSld>
-  <p:clrMapOvr>
-    <a:masterClrMapping/>
-  </p:clrMapOvr>
-</p:sld>
-</file>
-
-<file path=ppt/slides/slide15.xml><?xml version="1.0" encoding="utf-8"?>
-<p:sld xmlns:a="http://schemas.openxmlformats.org/drawingml/2006/main" xmlns:r="http://schemas.openxmlformats.org/officeDocument/2006/relationships" xmlns:p="http://schemas.openxmlformats.org/presentationml/2006/main">
-  <p:cSld>
-    <p:spTree>
-      <p:nvGrpSpPr>
-        <p:cNvPr id="1" name=""/>
-        <p:cNvGrpSpPr/>
-        <p:nvPr/>
-      </p:nvGrpSpPr>
-      <p:grpSpPr>
-        <a:xfrm>
-          <a:off x="0" y="0"/>
-          <a:ext cx="0" cy="0"/>
-          <a:chOff x="0" y="0"/>
-          <a:chExt cx="0" cy="0"/>
-        </a:xfrm>
-      </p:grpSpPr>
       <p:sp>
         <p:nvSpPr>
-          <p:cNvPr id="2" name="Content Placeholder 1">
+          <p:cNvPr id="6" name="Content Placeholder 4">
             <a:extLst>
               <a:ext uri="{FF2B5EF4-FFF2-40B4-BE49-F238E27FC236}">
-                <a16:creationId xmlns:a16="http://schemas.microsoft.com/office/drawing/2014/main" id="{1BE494C2-133A-4197-87DB-AFF1D59C4328}"/>
-              </a:ext>
-            </a:extLst>
-          </p:cNvPr>
-          <p:cNvSpPr>
-            <a:spLocks noGrp="1"/>
-          </p:cNvSpPr>
-          <p:nvPr>
-            <p:ph sz="quarter" idx="13"/>
-          </p:nvPr>
-        </p:nvSpPr>
-        <p:spPr>
-          <a:xfrm>
-            <a:off x="2104372" y="1455371"/>
-            <a:ext cx="4935255" cy="1175096"/>
-          </a:xfrm>
-        </p:spPr>
-        <p:txBody>
-          <a:bodyPr/>
-          <a:lstStyle/>
-          <a:p>
-            <a:pPr marL="0" indent="0">
-              <a:lnSpc>
-                <a:spcPct val="150000"/>
-              </a:lnSpc>
-            </a:pPr>
-            <a:r>
-              <a:rPr lang="en-US" sz="1200" dirty="0"/>
-              <a:t>IHI</a:t>
-            </a:r>
-            <a:r>
-              <a:rPr lang="en-US" sz="1200" b="0" dirty="0"/>
-              <a:t>    		Tatsuya Ito-San 	</a:t>
-            </a:r>
-            <a:r>
-              <a:rPr lang="en-US" sz="1200" b="0" dirty="0">
-                <a:hlinkClick r:id="rId2"/>
-              </a:rPr>
-              <a:t>ito0114@ihi-g.com</a:t>
-            </a:r>
-            <a:endParaRPr lang="en-US" sz="1200" b="0" dirty="0"/>
-          </a:p>
-          <a:p>
-            <a:pPr marL="0" indent="0">
-              <a:lnSpc>
-                <a:spcPct val="150000"/>
-              </a:lnSpc>
-            </a:pPr>
-            <a:r>
-              <a:rPr lang="en-US" sz="1200" dirty="0"/>
-              <a:t>CYIENT Onsite </a:t>
-            </a:r>
-            <a:r>
-              <a:rPr lang="en-US" sz="1200" b="0" dirty="0"/>
-              <a:t>	Suraj Prakash</a:t>
-            </a:r>
-            <a:r>
-              <a:rPr lang="en-US" sz="1200" b="0"/>
-              <a:t>	</a:t>
-            </a:r>
-            <a:r>
-              <a:rPr lang="en-US" sz="1200" b="0">
-                <a:hlinkClick r:id="rId3"/>
-              </a:rPr>
-              <a:t>prakash7808@ihi-g.com</a:t>
-            </a:r>
-            <a:endParaRPr lang="en-US" sz="1200" b="0" dirty="0"/>
-          </a:p>
-          <a:p>
-            <a:pPr marL="0" indent="0">
-              <a:lnSpc>
-                <a:spcPct val="150000"/>
-              </a:lnSpc>
-            </a:pPr>
-            <a:r>
-              <a:rPr lang="en-US" sz="1200" dirty="0"/>
-              <a:t>CYIENT Offshore </a:t>
-            </a:r>
-            <a:r>
-              <a:rPr lang="en-US" sz="1200" b="0" dirty="0"/>
-              <a:t>	Veerendra Kotari	</a:t>
-            </a:r>
-            <a:r>
-              <a:rPr lang="en-US" sz="1200" b="0" dirty="0">
-                <a:hlinkClick r:id="rId4"/>
-              </a:rPr>
-              <a:t>Veerendra.Kotari@cyient.com</a:t>
-            </a:r>
-            <a:endParaRPr lang="en-US" sz="1200" b="0" dirty="0"/>
-          </a:p>
-          <a:p>
-            <a:pPr marL="0" indent="0">
-              <a:lnSpc>
-                <a:spcPct val="150000"/>
-              </a:lnSpc>
-            </a:pPr>
-            <a:endParaRPr lang="pt-BR" sz="1200" b="0" dirty="0"/>
-          </a:p>
-        </p:txBody>
-      </p:sp>
-      <p:sp>
-        <p:nvSpPr>
-          <p:cNvPr id="4" name="Slide Number Placeholder 3">
-            <a:extLst>
-              <a:ext uri="{FF2B5EF4-FFF2-40B4-BE49-F238E27FC236}">
-                <a16:creationId xmlns:a16="http://schemas.microsoft.com/office/drawing/2014/main" id="{DB967E03-8311-4878-A0F4-83A51F6C3235}"/>
-              </a:ext>
-            </a:extLst>
-          </p:cNvPr>
-          <p:cNvSpPr>
-            <a:spLocks noGrp="1"/>
-          </p:cNvSpPr>
-          <p:nvPr>
-            <p:ph type="sldNum" sz="quarter" idx="14"/>
-          </p:nvPr>
-        </p:nvSpPr>
-        <p:spPr/>
-        <p:txBody>
-          <a:bodyPr/>
-          <a:lstStyle/>
-          <a:p>
-            <a:fld id="{8A4A04CF-1BC9-4C63-AE06-A38D4D08020F}" type="slidenum">
-              <a:rPr lang="en-GB" altLang="en-US" smtClean="0"/>
-              <a:pPr/>
-              <a:t>15</a:t>
-            </a:fld>
-            <a:endParaRPr lang="en-GB" altLang="en-US" dirty="0"/>
-          </a:p>
-        </p:txBody>
-      </p:sp>
-      <p:sp>
-        <p:nvSpPr>
-          <p:cNvPr id="6" name="Title 2">
-            <a:extLst>
-              <a:ext uri="{FF2B5EF4-FFF2-40B4-BE49-F238E27FC236}">
-                <a16:creationId xmlns:a16="http://schemas.microsoft.com/office/drawing/2014/main" id="{3E22D8D7-B261-487B-BE5C-95FC09F51493}"/>
+                <a16:creationId xmlns:a16="http://schemas.microsoft.com/office/drawing/2014/main" id="{16F84E3C-9029-4FBE-8916-B60EAD38EA98}"/>
               </a:ext>
             </a:extLst>
           </p:cNvPr>
@@ -35396,8 +35441,8 @@
         </p:nvSpPr>
         <p:spPr bwMode="auto">
           <a:xfrm>
-            <a:off x="473902" y="33822"/>
-            <a:ext cx="7965738" cy="448224"/>
+            <a:off x="3546507" y="5162626"/>
+            <a:ext cx="3405438" cy="173038"/>
           </a:xfrm>
           <a:prstGeom prst="rect">
             <a:avLst/>
@@ -35427,13 +35472,14 @@
           </a:extLst>
         </p:spPr>
         <p:txBody>
-          <a:bodyPr vert="horz" wrap="square" lIns="0" tIns="0" rIns="0" bIns="0" numCol="1" anchor="ctr" anchorCtr="0" compatLnSpc="1">
+          <a:bodyPr vert="horz" wrap="square" lIns="0" tIns="0" rIns="0" bIns="0" numCol="1" anchor="t" anchorCtr="0" compatLnSpc="1">
             <a:prstTxWarp prst="textNoShape">
               <a:avLst/>
             </a:prstTxWarp>
+            <a:noAutofit/>
           </a:bodyPr>
           <a:lstStyle>
-            <a:lvl1pPr algn="l" defTabSz="685800" rtl="0" eaLnBrk="0" fontAlgn="base" hangingPunct="0">
+            <a:lvl1pPr marL="342900" indent="-342900" algn="l" defTabSz="685800" rtl="0" eaLnBrk="0" fontAlgn="base" hangingPunct="0">
               <a:lnSpc>
                 <a:spcPct val="90000"/>
               </a:lnSpc>
@@ -35441,18 +35487,18 @@
                 <a:spcPct val="0"/>
               </a:spcBef>
               <a:spcAft>
-                <a:spcPct val="0"/>
-              </a:spcAft>
-              <a:defRPr sz="3000" b="1" kern="1200">
+                <a:spcPts val="600"/>
+              </a:spcAft>
+              <a:defRPr sz="1800" b="1" kern="1200">
                 <a:solidFill>
                   <a:srgbClr val="00A5DF"/>
                 </a:solidFill>
-                <a:latin typeface="Effra"/>
+                <a:latin typeface="+mn-lt"/>
                 <a:ea typeface="MS PGothic" pitchFamily="34" charset="-128"/>
-                <a:cs typeface="Effra"/>
+                <a:cs typeface="ＭＳ Ｐゴシック" charset="0"/>
               </a:defRPr>
             </a:lvl1pPr>
-            <a:lvl2pPr algn="l" defTabSz="685800" rtl="0" eaLnBrk="0" fontAlgn="base" hangingPunct="0">
+            <a:lvl2pPr marL="742950" indent="-285750" algn="l" defTabSz="685800" rtl="0" eaLnBrk="0" fontAlgn="base" hangingPunct="0">
               <a:lnSpc>
                 <a:spcPct val="90000"/>
               </a:lnSpc>
@@ -35460,18 +35506,20 @@
                 <a:spcPct val="0"/>
               </a:spcBef>
               <a:spcAft>
-                <a:spcPct val="0"/>
-              </a:spcAft>
-              <a:defRPr sz="3000" b="1">
+                <a:spcPts val="600"/>
+              </a:spcAft>
+              <a:buSzPct val="80000"/>
+              <a:buFont typeface="Arial" panose="020B0604020202020204" pitchFamily="34" charset="0"/>
+              <a:defRPr sz="1800" kern="1200">
                 <a:solidFill>
                   <a:srgbClr val="00A5DF"/>
                 </a:solidFill>
-                <a:latin typeface="Effra" charset="0"/>
+                <a:latin typeface="+mn-lt"/>
                 <a:ea typeface="MS PGothic" pitchFamily="34" charset="-128"/>
-                <a:cs typeface="Effra" pitchFamily="34" charset="0"/>
+                <a:cs typeface="+mn-cs"/>
               </a:defRPr>
             </a:lvl2pPr>
-            <a:lvl3pPr algn="l" defTabSz="685800" rtl="0" eaLnBrk="0" fontAlgn="base" hangingPunct="0">
+            <a:lvl3pPr marL="180975" indent="-180975" algn="l" defTabSz="685800" rtl="0" eaLnBrk="0" fontAlgn="base" hangingPunct="0">
               <a:lnSpc>
                 <a:spcPct val="90000"/>
               </a:lnSpc>
@@ -35479,18 +35527,21 @@
                 <a:spcPct val="0"/>
               </a:spcBef>
               <a:spcAft>
-                <a:spcPct val="0"/>
-              </a:spcAft>
-              <a:defRPr sz="3000" b="1">
+                <a:spcPts val="600"/>
+              </a:spcAft>
+              <a:buSzPct val="100000"/>
+              <a:buFont typeface="Lucida Grande"/>
+              <a:buChar char="-"/>
+              <a:defRPr sz="1800" kern="1200">
                 <a:solidFill>
                   <a:srgbClr val="00A5DF"/>
                 </a:solidFill>
-                <a:latin typeface="Effra" charset="0"/>
+                <a:latin typeface="+mn-lt"/>
                 <a:ea typeface="MS PGothic" pitchFamily="34" charset="-128"/>
-                <a:cs typeface="Effra" pitchFamily="34" charset="0"/>
+                <a:cs typeface="+mn-cs"/>
               </a:defRPr>
             </a:lvl3pPr>
-            <a:lvl4pPr algn="l" defTabSz="685800" rtl="0" eaLnBrk="0" fontAlgn="base" hangingPunct="0">
+            <a:lvl4pPr marL="363538" indent="-182563" algn="l" defTabSz="685800" rtl="0" eaLnBrk="0" fontAlgn="base" hangingPunct="0">
               <a:lnSpc>
                 <a:spcPct val="90000"/>
               </a:lnSpc>
@@ -35498,18 +35549,21 @@
                 <a:spcPct val="0"/>
               </a:spcBef>
               <a:spcAft>
-                <a:spcPct val="0"/>
-              </a:spcAft>
-              <a:defRPr sz="3000" b="1">
+                <a:spcPts val="600"/>
+              </a:spcAft>
+              <a:buSzPct val="100000"/>
+              <a:buFont typeface="Lucida Grande"/>
+              <a:buChar char="-"/>
+              <a:defRPr sz="1800" kern="1200">
                 <a:solidFill>
                   <a:srgbClr val="00A5DF"/>
                 </a:solidFill>
-                <a:latin typeface="Effra" charset="0"/>
+                <a:latin typeface="+mn-lt"/>
                 <a:ea typeface="MS PGothic" pitchFamily="34" charset="-128"/>
-                <a:cs typeface="Effra" pitchFamily="34" charset="0"/>
+                <a:cs typeface="+mn-cs"/>
               </a:defRPr>
             </a:lvl4pPr>
-            <a:lvl5pPr algn="l" defTabSz="685800" rtl="0" eaLnBrk="0" fontAlgn="base" hangingPunct="0">
+            <a:lvl5pPr marL="534988" indent="-171450" algn="l" defTabSz="685800" rtl="0" eaLnBrk="0" fontAlgn="base" hangingPunct="0">
               <a:lnSpc>
                 <a:spcPct val="90000"/>
               </a:lnSpc>
@@ -35517,105 +35571,104 @@
                 <a:spcPct val="0"/>
               </a:spcBef>
               <a:spcAft>
-                <a:spcPct val="0"/>
-              </a:spcAft>
-              <a:defRPr sz="3000" b="1">
+                <a:spcPts val="600"/>
+              </a:spcAft>
+              <a:buSzPct val="100000"/>
+              <a:buFont typeface="Lucida Grande"/>
+              <a:buChar char="-"/>
+              <a:defRPr sz="1800" kern="1200">
                 <a:solidFill>
                   <a:srgbClr val="00A5DF"/>
                 </a:solidFill>
-                <a:latin typeface="Effra" charset="0"/>
+                <a:latin typeface="+mn-lt"/>
                 <a:ea typeface="MS PGothic" pitchFamily="34" charset="-128"/>
-                <a:cs typeface="Effra" pitchFamily="34" charset="0"/>
+                <a:cs typeface="+mn-cs"/>
               </a:defRPr>
             </a:lvl5pPr>
-            <a:lvl6pPr marL="457200" algn="l" defTabSz="685800" rtl="0" eaLnBrk="1" fontAlgn="base" hangingPunct="1">
+            <a:lvl6pPr marL="1885950" indent="-171450" algn="l" defTabSz="685800" rtl="0" eaLnBrk="1" latinLnBrk="0" hangingPunct="1">
               <a:lnSpc>
                 <a:spcPct val="90000"/>
               </a:lnSpc>
               <a:spcBef>
-                <a:spcPct val="0"/>
-              </a:spcBef>
-              <a:spcAft>
-                <a:spcPct val="0"/>
-              </a:spcAft>
-              <a:defRPr sz="2500" b="1">
-                <a:solidFill>
-                  <a:schemeClr val="accent1"/>
-                </a:solidFill>
-                <a:latin typeface="Effra" charset="0"/>
-                <a:ea typeface="ＭＳ Ｐゴシック" charset="0"/>
-                <a:cs typeface="ＭＳ Ｐゴシック" charset="0"/>
+                <a:spcPts val="375"/>
+              </a:spcBef>
+              <a:buFont typeface="Arial" panose="020B0604020202020204" pitchFamily="34" charset="0"/>
+              <a:buChar char="•"/>
+              <a:defRPr sz="1350" kern="1200">
+                <a:solidFill>
+                  <a:schemeClr val="tx1"/>
+                </a:solidFill>
+                <a:latin typeface="+mn-lt"/>
+                <a:ea typeface="+mn-ea"/>
+                <a:cs typeface="+mn-cs"/>
               </a:defRPr>
             </a:lvl6pPr>
-            <a:lvl7pPr marL="914400" algn="l" defTabSz="685800" rtl="0" eaLnBrk="1" fontAlgn="base" hangingPunct="1">
+            <a:lvl7pPr marL="2228850" indent="-171450" algn="l" defTabSz="685800" rtl="0" eaLnBrk="1" latinLnBrk="0" hangingPunct="1">
               <a:lnSpc>
                 <a:spcPct val="90000"/>
               </a:lnSpc>
               <a:spcBef>
-                <a:spcPct val="0"/>
-              </a:spcBef>
-              <a:spcAft>
-                <a:spcPct val="0"/>
-              </a:spcAft>
-              <a:defRPr sz="2500" b="1">
-                <a:solidFill>
-                  <a:schemeClr val="accent1"/>
-                </a:solidFill>
-                <a:latin typeface="Effra" charset="0"/>
-                <a:ea typeface="ＭＳ Ｐゴシック" charset="0"/>
-                <a:cs typeface="ＭＳ Ｐゴシック" charset="0"/>
+                <a:spcPts val="375"/>
+              </a:spcBef>
+              <a:buFont typeface="Arial" panose="020B0604020202020204" pitchFamily="34" charset="0"/>
+              <a:buChar char="•"/>
+              <a:defRPr sz="1350" kern="1200">
+                <a:solidFill>
+                  <a:schemeClr val="tx1"/>
+                </a:solidFill>
+                <a:latin typeface="+mn-lt"/>
+                <a:ea typeface="+mn-ea"/>
+                <a:cs typeface="+mn-cs"/>
               </a:defRPr>
             </a:lvl7pPr>
-            <a:lvl8pPr marL="1371600" algn="l" defTabSz="685800" rtl="0" eaLnBrk="1" fontAlgn="base" hangingPunct="1">
+            <a:lvl8pPr marL="2571750" indent="-171450" algn="l" defTabSz="685800" rtl="0" eaLnBrk="1" latinLnBrk="0" hangingPunct="1">
               <a:lnSpc>
                 <a:spcPct val="90000"/>
               </a:lnSpc>
               <a:spcBef>
-                <a:spcPct val="0"/>
-              </a:spcBef>
-              <a:spcAft>
-                <a:spcPct val="0"/>
-              </a:spcAft>
-              <a:defRPr sz="2500" b="1">
-                <a:solidFill>
-                  <a:schemeClr val="accent1"/>
-                </a:solidFill>
-                <a:latin typeface="Effra" charset="0"/>
-                <a:ea typeface="ＭＳ Ｐゴシック" charset="0"/>
-                <a:cs typeface="ＭＳ Ｐゴシック" charset="0"/>
+                <a:spcPts val="375"/>
+              </a:spcBef>
+              <a:buFont typeface="Arial" panose="020B0604020202020204" pitchFamily="34" charset="0"/>
+              <a:buChar char="•"/>
+              <a:defRPr sz="1350" kern="1200">
+                <a:solidFill>
+                  <a:schemeClr val="tx1"/>
+                </a:solidFill>
+                <a:latin typeface="+mn-lt"/>
+                <a:ea typeface="+mn-ea"/>
+                <a:cs typeface="+mn-cs"/>
               </a:defRPr>
             </a:lvl8pPr>
-            <a:lvl9pPr marL="1828800" algn="l" defTabSz="685800" rtl="0" eaLnBrk="1" fontAlgn="base" hangingPunct="1">
+            <a:lvl9pPr marL="2914650" indent="-171450" algn="l" defTabSz="685800" rtl="0" eaLnBrk="1" latinLnBrk="0" hangingPunct="1">
               <a:lnSpc>
                 <a:spcPct val="90000"/>
               </a:lnSpc>
               <a:spcBef>
-                <a:spcPct val="0"/>
-              </a:spcBef>
-              <a:spcAft>
-                <a:spcPct val="0"/>
-              </a:spcAft>
-              <a:defRPr sz="2500" b="1">
-                <a:solidFill>
-                  <a:schemeClr val="accent1"/>
-                </a:solidFill>
-                <a:latin typeface="Effra" charset="0"/>
-                <a:ea typeface="ＭＳ Ｐゴシック" charset="0"/>
-                <a:cs typeface="ＭＳ Ｐゴシック" charset="0"/>
+                <a:spcPts val="375"/>
+              </a:spcBef>
+              <a:buFont typeface="Arial" panose="020B0604020202020204" pitchFamily="34" charset="0"/>
+              <a:buChar char="•"/>
+              <a:defRPr sz="1350" kern="1200">
+                <a:solidFill>
+                  <a:schemeClr val="tx1"/>
+                </a:solidFill>
+                <a:latin typeface="+mn-lt"/>
+                <a:ea typeface="+mn-ea"/>
+                <a:cs typeface="+mn-cs"/>
               </a:defRPr>
             </a:lvl9pPr>
           </a:lstStyle>
           <a:p>
-            <a:pPr eaLnBrk="1" hangingPunct="1">
-              <a:lnSpc>
-                <a:spcPct val="110000"/>
-              </a:lnSpc>
-            </a:pPr>
+            <a:pPr marL="0" indent="0"/>
             <a:r>
-              <a:rPr lang="en-US" sz="1800" dirty="0">
-                <a:latin typeface="Effra" pitchFamily="34" charset="0"/>
+              <a:rPr lang="en-US" sz="1400" dirty="0">
+                <a:solidFill>
+                  <a:schemeClr val="bg2">
+                    <a:lumMod val="10000"/>
+                  </a:schemeClr>
+                </a:solidFill>
               </a:rPr>
-              <a:t>Contact</a:t>
+              <a:t>EM Cautions Report</a:t>
             </a:r>
           </a:p>
         </p:txBody>
@@ -35623,7 +35676,7 @@
     </p:spTree>
     <p:extLst>
       <p:ext uri="{BB962C8B-B14F-4D97-AF65-F5344CB8AC3E}">
-        <p14:creationId xmlns:p14="http://schemas.microsoft.com/office/powerpoint/2010/main" val="3638767675"/>
+        <p14:creationId xmlns:p14="http://schemas.microsoft.com/office/powerpoint/2010/main" val="157415074"/>
       </p:ext>
     </p:extLst>
   </p:cSld>
@@ -35652,16 +35705,82 @@
       </p:grpSpPr>
       <p:sp>
         <p:nvSpPr>
-          <p:cNvPr id="80898" name="Rectangle 4"/>
+          <p:cNvPr id="4" name="Slide Number Placeholder 3">
+            <a:extLst>
+              <a:ext uri="{FF2B5EF4-FFF2-40B4-BE49-F238E27FC236}">
+                <a16:creationId xmlns:a16="http://schemas.microsoft.com/office/drawing/2014/main" id="{C50D90F6-75EC-E32F-C3AF-577A84C8A957}"/>
+              </a:ext>
+            </a:extLst>
+          </p:cNvPr>
           <p:cNvSpPr>
-            <a:spLocks noChangeArrowheads="1"/>
+            <a:spLocks noGrp="1"/>
+          </p:cNvSpPr>
+          <p:nvPr>
+            <p:ph type="sldNum" sz="quarter" idx="14"/>
+          </p:nvPr>
+        </p:nvSpPr>
+        <p:spPr/>
+        <p:txBody>
+          <a:bodyPr/>
+          <a:lstStyle/>
+          <a:p>
+            <a:fld id="{8A4A04CF-1BC9-4C63-AE06-A38D4D08020F}" type="slidenum">
+              <a:rPr lang="en-GB" altLang="en-US" smtClean="0"/>
+              <a:pPr/>
+              <a:t>16</a:t>
+            </a:fld>
+            <a:endParaRPr lang="en-GB" altLang="en-US" dirty="0"/>
+          </a:p>
+        </p:txBody>
+      </p:sp>
+      <p:pic>
+        <p:nvPicPr>
+          <p:cNvPr id="6" name="Picture 5">
+            <a:extLst>
+              <a:ext uri="{FF2B5EF4-FFF2-40B4-BE49-F238E27FC236}">
+                <a16:creationId xmlns:a16="http://schemas.microsoft.com/office/drawing/2014/main" id="{945C1F14-7675-8444-48AB-C2A67E2CF3E5}"/>
+              </a:ext>
+            </a:extLst>
+          </p:cNvPr>
+          <p:cNvPicPr>
+            <a:picLocks noChangeAspect="1"/>
+          </p:cNvPicPr>
+          <p:nvPr/>
+        </p:nvPicPr>
+        <p:blipFill>
+          <a:blip r:embed="rId2"/>
+          <a:stretch>
+            <a:fillRect/>
+          </a:stretch>
+        </p:blipFill>
+        <p:spPr>
+          <a:xfrm>
+            <a:off x="137786" y="364316"/>
+            <a:ext cx="8793272" cy="4635639"/>
+          </a:xfrm>
+          <a:prstGeom prst="rect">
+            <a:avLst/>
+          </a:prstGeom>
+        </p:spPr>
+      </p:pic>
+      <p:sp>
+        <p:nvSpPr>
+          <p:cNvPr id="8" name="Content Placeholder 4">
+            <a:extLst>
+              <a:ext uri="{FF2B5EF4-FFF2-40B4-BE49-F238E27FC236}">
+                <a16:creationId xmlns:a16="http://schemas.microsoft.com/office/drawing/2014/main" id="{DE040982-B801-8A26-942A-E076325F7EA5}"/>
+              </a:ext>
+            </a:extLst>
+          </p:cNvPr>
+          <p:cNvSpPr txBox="1">
+            <a:spLocks/>
           </p:cNvSpPr>
           <p:nvPr/>
         </p:nvSpPr>
         <p:spPr bwMode="auto">
           <a:xfrm>
-            <a:off x="655638" y="1122363"/>
-            <a:ext cx="2754985" cy="707886"/>
+            <a:off x="3453639" y="5112522"/>
+            <a:ext cx="2421069" cy="173038"/>
           </a:xfrm>
           <a:prstGeom prst="rect">
             <a:avLst/>
@@ -35691,147 +35810,315 @@
           </a:extLst>
         </p:spPr>
         <p:txBody>
-          <a:bodyPr wrap="none">
-            <a:spAutoFit/>
+          <a:bodyPr vert="horz" wrap="square" lIns="0" tIns="0" rIns="0" bIns="0" numCol="1" anchor="t" anchorCtr="0" compatLnSpc="1">
+            <a:prstTxWarp prst="textNoShape">
+              <a:avLst/>
+            </a:prstTxWarp>
+            <a:noAutofit/>
           </a:bodyPr>
           <a:lstStyle>
-            <a:lvl1pPr>
-              <a:defRPr sz="1400">
-                <a:solidFill>
-                  <a:schemeClr val="tx1"/>
-                </a:solidFill>
-                <a:latin typeface="Effra" panose="020B0603020203020204" pitchFamily="34" charset="0"/>
-                <a:ea typeface="MS PGothic" panose="020B0600070205080204" pitchFamily="34" charset="-128"/>
+            <a:lvl1pPr marL="342900" indent="-342900" algn="l" defTabSz="685800" rtl="0" eaLnBrk="0" fontAlgn="base" hangingPunct="0">
+              <a:lnSpc>
+                <a:spcPct val="90000"/>
+              </a:lnSpc>
+              <a:spcBef>
+                <a:spcPct val="0"/>
+              </a:spcBef>
+              <a:spcAft>
+                <a:spcPts val="600"/>
+              </a:spcAft>
+              <a:defRPr sz="1800" b="1" kern="1200">
+                <a:solidFill>
+                  <a:srgbClr val="00A5DF"/>
+                </a:solidFill>
+                <a:latin typeface="+mn-lt"/>
+                <a:ea typeface="MS PGothic" pitchFamily="34" charset="-128"/>
+                <a:cs typeface="ＭＳ Ｐゴシック" charset="0"/>
               </a:defRPr>
             </a:lvl1pPr>
-            <a:lvl2pPr marL="742950" indent="-285750">
-              <a:defRPr sz="1400">
-                <a:solidFill>
-                  <a:schemeClr val="tx1"/>
-                </a:solidFill>
-                <a:latin typeface="Effra" panose="020B0603020203020204" pitchFamily="34" charset="0"/>
-                <a:ea typeface="MS PGothic" panose="020B0600070205080204" pitchFamily="34" charset="-128"/>
+            <a:lvl2pPr marL="742950" indent="-285750" algn="l" defTabSz="685800" rtl="0" eaLnBrk="0" fontAlgn="base" hangingPunct="0">
+              <a:lnSpc>
+                <a:spcPct val="90000"/>
+              </a:lnSpc>
+              <a:spcBef>
+                <a:spcPct val="0"/>
+              </a:spcBef>
+              <a:spcAft>
+                <a:spcPts val="600"/>
+              </a:spcAft>
+              <a:buSzPct val="80000"/>
+              <a:buFont typeface="Arial" panose="020B0604020202020204" pitchFamily="34" charset="0"/>
+              <a:defRPr sz="1800" kern="1200">
+                <a:solidFill>
+                  <a:srgbClr val="00A5DF"/>
+                </a:solidFill>
+                <a:latin typeface="+mn-lt"/>
+                <a:ea typeface="MS PGothic" pitchFamily="34" charset="-128"/>
+                <a:cs typeface="+mn-cs"/>
               </a:defRPr>
             </a:lvl2pPr>
-            <a:lvl3pPr marL="1143000" indent="-228600">
-              <a:defRPr sz="1400">
-                <a:solidFill>
-                  <a:schemeClr val="tx1"/>
-                </a:solidFill>
-                <a:latin typeface="Effra" panose="020B0603020203020204" pitchFamily="34" charset="0"/>
-                <a:ea typeface="MS PGothic" panose="020B0600070205080204" pitchFamily="34" charset="-128"/>
+            <a:lvl3pPr marL="180975" indent="-180975" algn="l" defTabSz="685800" rtl="0" eaLnBrk="0" fontAlgn="base" hangingPunct="0">
+              <a:lnSpc>
+                <a:spcPct val="90000"/>
+              </a:lnSpc>
+              <a:spcBef>
+                <a:spcPct val="0"/>
+              </a:spcBef>
+              <a:spcAft>
+                <a:spcPts val="600"/>
+              </a:spcAft>
+              <a:buSzPct val="100000"/>
+              <a:buFont typeface="Lucida Grande"/>
+              <a:buChar char="-"/>
+              <a:defRPr sz="1800" kern="1200">
+                <a:solidFill>
+                  <a:srgbClr val="00A5DF"/>
+                </a:solidFill>
+                <a:latin typeface="+mn-lt"/>
+                <a:ea typeface="MS PGothic" pitchFamily="34" charset="-128"/>
+                <a:cs typeface="+mn-cs"/>
               </a:defRPr>
             </a:lvl3pPr>
-            <a:lvl4pPr marL="1600200" indent="-228600">
-              <a:defRPr sz="1400">
-                <a:solidFill>
-                  <a:schemeClr val="tx1"/>
-                </a:solidFill>
-                <a:latin typeface="Effra" panose="020B0603020203020204" pitchFamily="34" charset="0"/>
-                <a:ea typeface="MS PGothic" panose="020B0600070205080204" pitchFamily="34" charset="-128"/>
+            <a:lvl4pPr marL="363538" indent="-182563" algn="l" defTabSz="685800" rtl="0" eaLnBrk="0" fontAlgn="base" hangingPunct="0">
+              <a:lnSpc>
+                <a:spcPct val="90000"/>
+              </a:lnSpc>
+              <a:spcBef>
+                <a:spcPct val="0"/>
+              </a:spcBef>
+              <a:spcAft>
+                <a:spcPts val="600"/>
+              </a:spcAft>
+              <a:buSzPct val="100000"/>
+              <a:buFont typeface="Lucida Grande"/>
+              <a:buChar char="-"/>
+              <a:defRPr sz="1800" kern="1200">
+                <a:solidFill>
+                  <a:srgbClr val="00A5DF"/>
+                </a:solidFill>
+                <a:latin typeface="+mn-lt"/>
+                <a:ea typeface="MS PGothic" pitchFamily="34" charset="-128"/>
+                <a:cs typeface="+mn-cs"/>
               </a:defRPr>
             </a:lvl4pPr>
-            <a:lvl5pPr marL="2057400" indent="-228600">
-              <a:defRPr sz="1400">
-                <a:solidFill>
-                  <a:schemeClr val="tx1"/>
-                </a:solidFill>
-                <a:latin typeface="Effra" panose="020B0603020203020204" pitchFamily="34" charset="0"/>
-                <a:ea typeface="MS PGothic" panose="020B0600070205080204" pitchFamily="34" charset="-128"/>
+            <a:lvl5pPr marL="534988" indent="-171450" algn="l" defTabSz="685800" rtl="0" eaLnBrk="0" fontAlgn="base" hangingPunct="0">
+              <a:lnSpc>
+                <a:spcPct val="90000"/>
+              </a:lnSpc>
+              <a:spcBef>
+                <a:spcPct val="0"/>
+              </a:spcBef>
+              <a:spcAft>
+                <a:spcPts val="600"/>
+              </a:spcAft>
+              <a:buSzPct val="100000"/>
+              <a:buFont typeface="Lucida Grande"/>
+              <a:buChar char="-"/>
+              <a:defRPr sz="1800" kern="1200">
+                <a:solidFill>
+                  <a:srgbClr val="00A5DF"/>
+                </a:solidFill>
+                <a:latin typeface="+mn-lt"/>
+                <a:ea typeface="MS PGothic" pitchFamily="34" charset="-128"/>
+                <a:cs typeface="+mn-cs"/>
               </a:defRPr>
             </a:lvl5pPr>
-            <a:lvl6pPr marL="2514600" indent="-228600" defTabSz="712788" eaLnBrk="0" fontAlgn="base" hangingPunct="0">
-              <a:spcBef>
-                <a:spcPct val="0"/>
-              </a:spcBef>
-              <a:spcAft>
-                <a:spcPct val="0"/>
-              </a:spcAft>
-              <a:defRPr sz="1400">
-                <a:solidFill>
-                  <a:schemeClr val="tx1"/>
-                </a:solidFill>
-                <a:latin typeface="Effra" panose="020B0603020203020204" pitchFamily="34" charset="0"/>
-                <a:ea typeface="MS PGothic" panose="020B0600070205080204" pitchFamily="34" charset="-128"/>
+            <a:lvl6pPr marL="1885950" indent="-171450" algn="l" defTabSz="685800" rtl="0" eaLnBrk="1" latinLnBrk="0" hangingPunct="1">
+              <a:lnSpc>
+                <a:spcPct val="90000"/>
+              </a:lnSpc>
+              <a:spcBef>
+                <a:spcPts val="375"/>
+              </a:spcBef>
+              <a:buFont typeface="Arial" panose="020B0604020202020204" pitchFamily="34" charset="0"/>
+              <a:buChar char="•"/>
+              <a:defRPr sz="1350" kern="1200">
+                <a:solidFill>
+                  <a:schemeClr val="tx1"/>
+                </a:solidFill>
+                <a:latin typeface="+mn-lt"/>
+                <a:ea typeface="+mn-ea"/>
+                <a:cs typeface="+mn-cs"/>
               </a:defRPr>
             </a:lvl6pPr>
-            <a:lvl7pPr marL="2971800" indent="-228600" defTabSz="712788" eaLnBrk="0" fontAlgn="base" hangingPunct="0">
-              <a:spcBef>
-                <a:spcPct val="0"/>
-              </a:spcBef>
-              <a:spcAft>
-                <a:spcPct val="0"/>
-              </a:spcAft>
-              <a:defRPr sz="1400">
-                <a:solidFill>
-                  <a:schemeClr val="tx1"/>
-                </a:solidFill>
-                <a:latin typeface="Effra" panose="020B0603020203020204" pitchFamily="34" charset="0"/>
-                <a:ea typeface="MS PGothic" panose="020B0600070205080204" pitchFamily="34" charset="-128"/>
+            <a:lvl7pPr marL="2228850" indent="-171450" algn="l" defTabSz="685800" rtl="0" eaLnBrk="1" latinLnBrk="0" hangingPunct="1">
+              <a:lnSpc>
+                <a:spcPct val="90000"/>
+              </a:lnSpc>
+              <a:spcBef>
+                <a:spcPts val="375"/>
+              </a:spcBef>
+              <a:buFont typeface="Arial" panose="020B0604020202020204" pitchFamily="34" charset="0"/>
+              <a:buChar char="•"/>
+              <a:defRPr sz="1350" kern="1200">
+                <a:solidFill>
+                  <a:schemeClr val="tx1"/>
+                </a:solidFill>
+                <a:latin typeface="+mn-lt"/>
+                <a:ea typeface="+mn-ea"/>
+                <a:cs typeface="+mn-cs"/>
               </a:defRPr>
             </a:lvl7pPr>
-            <a:lvl8pPr marL="3429000" indent="-228600" defTabSz="712788" eaLnBrk="0" fontAlgn="base" hangingPunct="0">
-              <a:spcBef>
-                <a:spcPct val="0"/>
-              </a:spcBef>
-              <a:spcAft>
-                <a:spcPct val="0"/>
-              </a:spcAft>
-              <a:defRPr sz="1400">
-                <a:solidFill>
-                  <a:schemeClr val="tx1"/>
-                </a:solidFill>
-                <a:latin typeface="Effra" panose="020B0603020203020204" pitchFamily="34" charset="0"/>
-                <a:ea typeface="MS PGothic" panose="020B0600070205080204" pitchFamily="34" charset="-128"/>
+            <a:lvl8pPr marL="2571750" indent="-171450" algn="l" defTabSz="685800" rtl="0" eaLnBrk="1" latinLnBrk="0" hangingPunct="1">
+              <a:lnSpc>
+                <a:spcPct val="90000"/>
+              </a:lnSpc>
+              <a:spcBef>
+                <a:spcPts val="375"/>
+              </a:spcBef>
+              <a:buFont typeface="Arial" panose="020B0604020202020204" pitchFamily="34" charset="0"/>
+              <a:buChar char="•"/>
+              <a:defRPr sz="1350" kern="1200">
+                <a:solidFill>
+                  <a:schemeClr val="tx1"/>
+                </a:solidFill>
+                <a:latin typeface="+mn-lt"/>
+                <a:ea typeface="+mn-ea"/>
+                <a:cs typeface="+mn-cs"/>
               </a:defRPr>
             </a:lvl8pPr>
-            <a:lvl9pPr marL="3886200" indent="-228600" defTabSz="712788" eaLnBrk="0" fontAlgn="base" hangingPunct="0">
-              <a:spcBef>
-                <a:spcPct val="0"/>
-              </a:spcBef>
-              <a:spcAft>
-                <a:spcPct val="0"/>
-              </a:spcAft>
-              <a:defRPr sz="1400">
-                <a:solidFill>
-                  <a:schemeClr val="tx1"/>
-                </a:solidFill>
-                <a:latin typeface="Effra" panose="020B0603020203020204" pitchFamily="34" charset="0"/>
-                <a:ea typeface="MS PGothic" panose="020B0600070205080204" pitchFamily="34" charset="-128"/>
+            <a:lvl9pPr marL="2914650" indent="-171450" algn="l" defTabSz="685800" rtl="0" eaLnBrk="1" latinLnBrk="0" hangingPunct="1">
+              <a:lnSpc>
+                <a:spcPct val="90000"/>
+              </a:lnSpc>
+              <a:spcBef>
+                <a:spcPts val="375"/>
+              </a:spcBef>
+              <a:buFont typeface="Arial" panose="020B0604020202020204" pitchFamily="34" charset="0"/>
+              <a:buChar char="•"/>
+              <a:defRPr sz="1350" kern="1200">
+                <a:solidFill>
+                  <a:schemeClr val="tx1"/>
+                </a:solidFill>
+                <a:latin typeface="+mn-lt"/>
+                <a:ea typeface="+mn-ea"/>
+                <a:cs typeface="+mn-cs"/>
               </a:defRPr>
             </a:lvl9pPr>
           </a:lstStyle>
           <a:p>
-            <a:pPr eaLnBrk="1" hangingPunct="1"/>
+            <a:pPr marL="0" indent="0"/>
             <a:r>
-              <a:rPr lang="en-US" altLang="en-US" sz="4000" b="1" dirty="0">
-                <a:solidFill>
-                  <a:srgbClr val="FFFFFF"/>
-                </a:solidFill>
-                <a:latin typeface="Arial" panose="020B0604020202020204" pitchFamily="34" charset="0"/>
-                <a:cs typeface="Arial" panose="020B0604020202020204" pitchFamily="34" charset="0"/>
+              <a:rPr lang="en-US" sz="1400" dirty="0">
+                <a:solidFill>
+                  <a:schemeClr val="bg2">
+                    <a:lumMod val="10000"/>
+                  </a:schemeClr>
+                </a:solidFill>
               </a:rPr>
-              <a:t>Thank You</a:t>
+              <a:t>EM Cautions (3Series) Report</a:t>
             </a:r>
-            <a:endParaRPr lang="en-US" altLang="en-US" sz="4000" dirty="0">
-              <a:latin typeface="Arial" panose="020B0604020202020204" pitchFamily="34" charset="0"/>
-              <a:cs typeface="Arial" panose="020B0604020202020204" pitchFamily="34" charset="0"/>
-            </a:endParaRPr>
           </a:p>
         </p:txBody>
       </p:sp>
+    </p:spTree>
+    <p:extLst>
+      <p:ext uri="{BB962C8B-B14F-4D97-AF65-F5344CB8AC3E}">
+        <p14:creationId xmlns:p14="http://schemas.microsoft.com/office/powerpoint/2010/main" val="2347026696"/>
+      </p:ext>
+    </p:extLst>
+  </p:cSld>
+  <p:clrMapOvr>
+    <a:masterClrMapping/>
+  </p:clrMapOvr>
+</p:sld>
+</file>
+
+<file path=ppt/slides/slide17.xml><?xml version="1.0" encoding="utf-8"?>
+<p:sld xmlns:a="http://schemas.openxmlformats.org/drawingml/2006/main" xmlns:r="http://schemas.openxmlformats.org/officeDocument/2006/relationships" xmlns:p="http://schemas.openxmlformats.org/presentationml/2006/main">
+  <p:cSld>
+    <p:spTree>
+      <p:nvGrpSpPr>
+        <p:cNvPr id="1" name=""/>
+        <p:cNvGrpSpPr/>
+        <p:nvPr/>
+      </p:nvGrpSpPr>
+      <p:grpSpPr>
+        <a:xfrm>
+          <a:off x="0" y="0"/>
+          <a:ext cx="0" cy="0"/>
+          <a:chOff x="0" y="0"/>
+          <a:chExt cx="0" cy="0"/>
+        </a:xfrm>
+      </p:grpSpPr>
       <p:sp>
         <p:nvSpPr>
-          <p:cNvPr id="80899" name="Rectangle 5"/>
+          <p:cNvPr id="4" name="Slide Number Placeholder 3">
+            <a:extLst>
+              <a:ext uri="{FF2B5EF4-FFF2-40B4-BE49-F238E27FC236}">
+                <a16:creationId xmlns:a16="http://schemas.microsoft.com/office/drawing/2014/main" id="{DF2A63F6-55BC-12A5-D42B-B6C42B7F1F4F}"/>
+              </a:ext>
+            </a:extLst>
+          </p:cNvPr>
           <p:cNvSpPr>
-            <a:spLocks noChangeArrowheads="1"/>
+            <a:spLocks noGrp="1"/>
+          </p:cNvSpPr>
+          <p:nvPr>
+            <p:ph type="sldNum" sz="quarter" idx="14"/>
+          </p:nvPr>
+        </p:nvSpPr>
+        <p:spPr/>
+        <p:txBody>
+          <a:bodyPr/>
+          <a:lstStyle/>
+          <a:p>
+            <a:fld id="{8A4A04CF-1BC9-4C63-AE06-A38D4D08020F}" type="slidenum">
+              <a:rPr lang="en-GB" altLang="en-US" smtClean="0"/>
+              <a:pPr/>
+              <a:t>17</a:t>
+            </a:fld>
+            <a:endParaRPr lang="en-GB" altLang="en-US" dirty="0"/>
+          </a:p>
+        </p:txBody>
+      </p:sp>
+      <p:pic>
+        <p:nvPicPr>
+          <p:cNvPr id="6" name="Picture 5">
+            <a:extLst>
+              <a:ext uri="{FF2B5EF4-FFF2-40B4-BE49-F238E27FC236}">
+                <a16:creationId xmlns:a16="http://schemas.microsoft.com/office/drawing/2014/main" id="{9614D226-2F36-D739-4352-9971A02B3564}"/>
+              </a:ext>
+            </a:extLst>
+          </p:cNvPr>
+          <p:cNvPicPr>
+            <a:picLocks noChangeAspect="1"/>
+          </p:cNvPicPr>
+          <p:nvPr/>
+        </p:nvPicPr>
+        <p:blipFill>
+          <a:blip r:embed="rId2"/>
+          <a:stretch>
+            <a:fillRect/>
+          </a:stretch>
+        </p:blipFill>
+        <p:spPr>
+          <a:xfrm>
+            <a:off x="187890" y="360095"/>
+            <a:ext cx="8693063" cy="4669134"/>
+          </a:xfrm>
+          <a:prstGeom prst="rect">
+            <a:avLst/>
+          </a:prstGeom>
+        </p:spPr>
+      </p:pic>
+      <p:sp>
+        <p:nvSpPr>
+          <p:cNvPr id="8" name="Content Placeholder 4">
+            <a:extLst>
+              <a:ext uri="{FF2B5EF4-FFF2-40B4-BE49-F238E27FC236}">
+                <a16:creationId xmlns:a16="http://schemas.microsoft.com/office/drawing/2014/main" id="{CFAAD46D-049E-25DE-B8B3-7494988939EF}"/>
+              </a:ext>
+            </a:extLst>
+          </p:cNvPr>
+          <p:cNvSpPr txBox="1">
+            <a:spLocks/>
           </p:cNvSpPr>
           <p:nvPr/>
         </p:nvSpPr>
         <p:spPr bwMode="auto">
           <a:xfrm>
-            <a:off x="655638" y="2282825"/>
-            <a:ext cx="2557462" cy="1816100"/>
+            <a:off x="3691631" y="5112522"/>
+            <a:ext cx="3285365" cy="173038"/>
           </a:xfrm>
           <a:prstGeom prst="rect">
             <a:avLst/>
@@ -35861,250 +36148,243 @@
           </a:extLst>
         </p:spPr>
         <p:txBody>
-          <a:bodyPr>
-            <a:spAutoFit/>
+          <a:bodyPr vert="horz" wrap="square" lIns="0" tIns="0" rIns="0" bIns="0" numCol="1" anchor="t" anchorCtr="0" compatLnSpc="1">
+            <a:prstTxWarp prst="textNoShape">
+              <a:avLst/>
+            </a:prstTxWarp>
+            <a:noAutofit/>
           </a:bodyPr>
           <a:lstStyle>
-            <a:lvl1pPr>
-              <a:defRPr sz="1400">
-                <a:solidFill>
-                  <a:schemeClr val="tx1"/>
-                </a:solidFill>
-                <a:latin typeface="Effra" panose="020B0603020203020204" pitchFamily="34" charset="0"/>
-                <a:ea typeface="MS PGothic" panose="020B0600070205080204" pitchFamily="34" charset="-128"/>
+            <a:lvl1pPr marL="342900" indent="-342900" algn="l" defTabSz="685800" rtl="0" eaLnBrk="0" fontAlgn="base" hangingPunct="0">
+              <a:lnSpc>
+                <a:spcPct val="90000"/>
+              </a:lnSpc>
+              <a:spcBef>
+                <a:spcPct val="0"/>
+              </a:spcBef>
+              <a:spcAft>
+                <a:spcPts val="600"/>
+              </a:spcAft>
+              <a:defRPr sz="1800" b="1" kern="1200">
+                <a:solidFill>
+                  <a:srgbClr val="00A5DF"/>
+                </a:solidFill>
+                <a:latin typeface="+mn-lt"/>
+                <a:ea typeface="MS PGothic" pitchFamily="34" charset="-128"/>
+                <a:cs typeface="ＭＳ Ｐゴシック" charset="0"/>
               </a:defRPr>
             </a:lvl1pPr>
-            <a:lvl2pPr marL="742950" indent="-285750">
-              <a:defRPr sz="1400">
-                <a:solidFill>
-                  <a:schemeClr val="tx1"/>
-                </a:solidFill>
-                <a:latin typeface="Effra" panose="020B0603020203020204" pitchFamily="34" charset="0"/>
-                <a:ea typeface="MS PGothic" panose="020B0600070205080204" pitchFamily="34" charset="-128"/>
+            <a:lvl2pPr marL="742950" indent="-285750" algn="l" defTabSz="685800" rtl="0" eaLnBrk="0" fontAlgn="base" hangingPunct="0">
+              <a:lnSpc>
+                <a:spcPct val="90000"/>
+              </a:lnSpc>
+              <a:spcBef>
+                <a:spcPct val="0"/>
+              </a:spcBef>
+              <a:spcAft>
+                <a:spcPts val="600"/>
+              </a:spcAft>
+              <a:buSzPct val="80000"/>
+              <a:buFont typeface="Arial" panose="020B0604020202020204" pitchFamily="34" charset="0"/>
+              <a:defRPr sz="1800" kern="1200">
+                <a:solidFill>
+                  <a:srgbClr val="00A5DF"/>
+                </a:solidFill>
+                <a:latin typeface="+mn-lt"/>
+                <a:ea typeface="MS PGothic" pitchFamily="34" charset="-128"/>
+                <a:cs typeface="+mn-cs"/>
               </a:defRPr>
             </a:lvl2pPr>
-            <a:lvl3pPr marL="1143000" indent="-228600">
-              <a:defRPr sz="1400">
-                <a:solidFill>
-                  <a:schemeClr val="tx1"/>
-                </a:solidFill>
-                <a:latin typeface="Effra" panose="020B0603020203020204" pitchFamily="34" charset="0"/>
-                <a:ea typeface="MS PGothic" panose="020B0600070205080204" pitchFamily="34" charset="-128"/>
+            <a:lvl3pPr marL="180975" indent="-180975" algn="l" defTabSz="685800" rtl="0" eaLnBrk="0" fontAlgn="base" hangingPunct="0">
+              <a:lnSpc>
+                <a:spcPct val="90000"/>
+              </a:lnSpc>
+              <a:spcBef>
+                <a:spcPct val="0"/>
+              </a:spcBef>
+              <a:spcAft>
+                <a:spcPts val="600"/>
+              </a:spcAft>
+              <a:buSzPct val="100000"/>
+              <a:buFont typeface="Lucida Grande"/>
+              <a:buChar char="-"/>
+              <a:defRPr sz="1800" kern="1200">
+                <a:solidFill>
+                  <a:srgbClr val="00A5DF"/>
+                </a:solidFill>
+                <a:latin typeface="+mn-lt"/>
+                <a:ea typeface="MS PGothic" pitchFamily="34" charset="-128"/>
+                <a:cs typeface="+mn-cs"/>
               </a:defRPr>
             </a:lvl3pPr>
-            <a:lvl4pPr marL="1600200" indent="-228600">
-              <a:defRPr sz="1400">
-                <a:solidFill>
-                  <a:schemeClr val="tx1"/>
-                </a:solidFill>
-                <a:latin typeface="Effra" panose="020B0603020203020204" pitchFamily="34" charset="0"/>
-                <a:ea typeface="MS PGothic" panose="020B0600070205080204" pitchFamily="34" charset="-128"/>
+            <a:lvl4pPr marL="363538" indent="-182563" algn="l" defTabSz="685800" rtl="0" eaLnBrk="0" fontAlgn="base" hangingPunct="0">
+              <a:lnSpc>
+                <a:spcPct val="90000"/>
+              </a:lnSpc>
+              <a:spcBef>
+                <a:spcPct val="0"/>
+              </a:spcBef>
+              <a:spcAft>
+                <a:spcPts val="600"/>
+              </a:spcAft>
+              <a:buSzPct val="100000"/>
+              <a:buFont typeface="Lucida Grande"/>
+              <a:buChar char="-"/>
+              <a:defRPr sz="1800" kern="1200">
+                <a:solidFill>
+                  <a:srgbClr val="00A5DF"/>
+                </a:solidFill>
+                <a:latin typeface="+mn-lt"/>
+                <a:ea typeface="MS PGothic" pitchFamily="34" charset="-128"/>
+                <a:cs typeface="+mn-cs"/>
               </a:defRPr>
             </a:lvl4pPr>
-            <a:lvl5pPr marL="2057400" indent="-228600">
-              <a:defRPr sz="1400">
-                <a:solidFill>
-                  <a:schemeClr val="tx1"/>
-                </a:solidFill>
-                <a:latin typeface="Effra" panose="020B0603020203020204" pitchFamily="34" charset="0"/>
-                <a:ea typeface="MS PGothic" panose="020B0600070205080204" pitchFamily="34" charset="-128"/>
+            <a:lvl5pPr marL="534988" indent="-171450" algn="l" defTabSz="685800" rtl="0" eaLnBrk="0" fontAlgn="base" hangingPunct="0">
+              <a:lnSpc>
+                <a:spcPct val="90000"/>
+              </a:lnSpc>
+              <a:spcBef>
+                <a:spcPct val="0"/>
+              </a:spcBef>
+              <a:spcAft>
+                <a:spcPts val="600"/>
+              </a:spcAft>
+              <a:buSzPct val="100000"/>
+              <a:buFont typeface="Lucida Grande"/>
+              <a:buChar char="-"/>
+              <a:defRPr sz="1800" kern="1200">
+                <a:solidFill>
+                  <a:srgbClr val="00A5DF"/>
+                </a:solidFill>
+                <a:latin typeface="+mn-lt"/>
+                <a:ea typeface="MS PGothic" pitchFamily="34" charset="-128"/>
+                <a:cs typeface="+mn-cs"/>
               </a:defRPr>
             </a:lvl5pPr>
-            <a:lvl6pPr marL="2514600" indent="-228600" defTabSz="712788" eaLnBrk="0" fontAlgn="base" hangingPunct="0">
-              <a:spcBef>
-                <a:spcPct val="0"/>
-              </a:spcBef>
-              <a:spcAft>
-                <a:spcPct val="0"/>
-              </a:spcAft>
-              <a:defRPr sz="1400">
-                <a:solidFill>
-                  <a:schemeClr val="tx1"/>
-                </a:solidFill>
-                <a:latin typeface="Effra" panose="020B0603020203020204" pitchFamily="34" charset="0"/>
-                <a:ea typeface="MS PGothic" panose="020B0600070205080204" pitchFamily="34" charset="-128"/>
+            <a:lvl6pPr marL="1885950" indent="-171450" algn="l" defTabSz="685800" rtl="0" eaLnBrk="1" latinLnBrk="0" hangingPunct="1">
+              <a:lnSpc>
+                <a:spcPct val="90000"/>
+              </a:lnSpc>
+              <a:spcBef>
+                <a:spcPts val="375"/>
+              </a:spcBef>
+              <a:buFont typeface="Arial" panose="020B0604020202020204" pitchFamily="34" charset="0"/>
+              <a:buChar char="•"/>
+              <a:defRPr sz="1350" kern="1200">
+                <a:solidFill>
+                  <a:schemeClr val="tx1"/>
+                </a:solidFill>
+                <a:latin typeface="+mn-lt"/>
+                <a:ea typeface="+mn-ea"/>
+                <a:cs typeface="+mn-cs"/>
               </a:defRPr>
             </a:lvl6pPr>
-            <a:lvl7pPr marL="2971800" indent="-228600" defTabSz="712788" eaLnBrk="0" fontAlgn="base" hangingPunct="0">
-              <a:spcBef>
-                <a:spcPct val="0"/>
-              </a:spcBef>
-              <a:spcAft>
-                <a:spcPct val="0"/>
-              </a:spcAft>
-              <a:defRPr sz="1400">
-                <a:solidFill>
-                  <a:schemeClr val="tx1"/>
-                </a:solidFill>
-                <a:latin typeface="Effra" panose="020B0603020203020204" pitchFamily="34" charset="0"/>
-                <a:ea typeface="MS PGothic" panose="020B0600070205080204" pitchFamily="34" charset="-128"/>
+            <a:lvl7pPr marL="2228850" indent="-171450" algn="l" defTabSz="685800" rtl="0" eaLnBrk="1" latinLnBrk="0" hangingPunct="1">
+              <a:lnSpc>
+                <a:spcPct val="90000"/>
+              </a:lnSpc>
+              <a:spcBef>
+                <a:spcPts val="375"/>
+              </a:spcBef>
+              <a:buFont typeface="Arial" panose="020B0604020202020204" pitchFamily="34" charset="0"/>
+              <a:buChar char="•"/>
+              <a:defRPr sz="1350" kern="1200">
+                <a:solidFill>
+                  <a:schemeClr val="tx1"/>
+                </a:solidFill>
+                <a:latin typeface="+mn-lt"/>
+                <a:ea typeface="+mn-ea"/>
+                <a:cs typeface="+mn-cs"/>
               </a:defRPr>
             </a:lvl7pPr>
-            <a:lvl8pPr marL="3429000" indent="-228600" defTabSz="712788" eaLnBrk="0" fontAlgn="base" hangingPunct="0">
-              <a:spcBef>
-                <a:spcPct val="0"/>
-              </a:spcBef>
-              <a:spcAft>
-                <a:spcPct val="0"/>
-              </a:spcAft>
-              <a:defRPr sz="1400">
-                <a:solidFill>
-                  <a:schemeClr val="tx1"/>
-                </a:solidFill>
-                <a:latin typeface="Effra" panose="020B0603020203020204" pitchFamily="34" charset="0"/>
-                <a:ea typeface="MS PGothic" panose="020B0600070205080204" pitchFamily="34" charset="-128"/>
+            <a:lvl8pPr marL="2571750" indent="-171450" algn="l" defTabSz="685800" rtl="0" eaLnBrk="1" latinLnBrk="0" hangingPunct="1">
+              <a:lnSpc>
+                <a:spcPct val="90000"/>
+              </a:lnSpc>
+              <a:spcBef>
+                <a:spcPts val="375"/>
+              </a:spcBef>
+              <a:buFont typeface="Arial" panose="020B0604020202020204" pitchFamily="34" charset="0"/>
+              <a:buChar char="•"/>
+              <a:defRPr sz="1350" kern="1200">
+                <a:solidFill>
+                  <a:schemeClr val="tx1"/>
+                </a:solidFill>
+                <a:latin typeface="+mn-lt"/>
+                <a:ea typeface="+mn-ea"/>
+                <a:cs typeface="+mn-cs"/>
               </a:defRPr>
             </a:lvl8pPr>
-            <a:lvl9pPr marL="3886200" indent="-228600" defTabSz="712788" eaLnBrk="0" fontAlgn="base" hangingPunct="0">
-              <a:spcBef>
-                <a:spcPct val="0"/>
-              </a:spcBef>
-              <a:spcAft>
-                <a:spcPct val="0"/>
-              </a:spcAft>
-              <a:defRPr sz="1400">
-                <a:solidFill>
-                  <a:schemeClr val="tx1"/>
-                </a:solidFill>
-                <a:latin typeface="Effra" panose="020B0603020203020204" pitchFamily="34" charset="0"/>
-                <a:ea typeface="MS PGothic" panose="020B0600070205080204" pitchFamily="34" charset="-128"/>
+            <a:lvl9pPr marL="2914650" indent="-171450" algn="l" defTabSz="685800" rtl="0" eaLnBrk="1" latinLnBrk="0" hangingPunct="1">
+              <a:lnSpc>
+                <a:spcPct val="90000"/>
+              </a:lnSpc>
+              <a:spcBef>
+                <a:spcPts val="375"/>
+              </a:spcBef>
+              <a:buFont typeface="Arial" panose="020B0604020202020204" pitchFamily="34" charset="0"/>
+              <a:buChar char="•"/>
+              <a:defRPr sz="1350" kern="1200">
+                <a:solidFill>
+                  <a:schemeClr val="tx1"/>
+                </a:solidFill>
+                <a:latin typeface="+mn-lt"/>
+                <a:ea typeface="+mn-ea"/>
+                <a:cs typeface="+mn-cs"/>
               </a:defRPr>
             </a:lvl9pPr>
           </a:lstStyle>
           <a:p>
-            <a:pPr eaLnBrk="1" hangingPunct="1"/>
+            <a:pPr marL="0" indent="0"/>
             <a:r>
-              <a:rPr lang="en-US" altLang="en-US" sz="1600" dirty="0">
-                <a:solidFill>
-                  <a:schemeClr val="bg1"/>
-                </a:solidFill>
-                <a:latin typeface="Arial" panose="020B0604020202020204" pitchFamily="34" charset="0"/>
-                <a:cs typeface="Arial" panose="020B0604020202020204" pitchFamily="34" charset="0"/>
+              <a:rPr lang="en-US" sz="1400" dirty="0">
+                <a:solidFill>
+                  <a:schemeClr val="bg2">
+                    <a:lumMod val="10000"/>
+                  </a:schemeClr>
+                </a:solidFill>
               </a:rPr>
-              <a:t>Merci</a:t>
+              <a:t>EM_CIR Cautions Report</a:t>
             </a:r>
-          </a:p>
-          <a:p>
-            <a:pPr eaLnBrk="1" hangingPunct="1"/>
-            <a:r>
-              <a:rPr lang="en-US" altLang="en-US" sz="1600" dirty="0">
-                <a:solidFill>
-                  <a:schemeClr val="bg1"/>
-                </a:solidFill>
-                <a:latin typeface="Arial" panose="020B0604020202020204" pitchFamily="34" charset="0"/>
-                <a:cs typeface="Arial" panose="020B0604020202020204" pitchFamily="34" charset="0"/>
-              </a:rPr>
-              <a:t>Dank u </a:t>
-            </a:r>
-            <a:r>
-              <a:rPr lang="en-US" altLang="en-US" sz="1600" dirty="0" err="1">
-                <a:solidFill>
-                  <a:schemeClr val="bg1"/>
-                </a:solidFill>
-                <a:latin typeface="Arial" panose="020B0604020202020204" pitchFamily="34" charset="0"/>
-                <a:cs typeface="Arial" panose="020B0604020202020204" pitchFamily="34" charset="0"/>
-              </a:rPr>
-              <a:t>wel</a:t>
-            </a:r>
-            <a:endParaRPr lang="en-US" altLang="en-US" sz="1600" dirty="0">
-              <a:solidFill>
-                <a:schemeClr val="bg1"/>
-              </a:solidFill>
-              <a:latin typeface="Arial" panose="020B0604020202020204" pitchFamily="34" charset="0"/>
-              <a:cs typeface="Arial" panose="020B0604020202020204" pitchFamily="34" charset="0"/>
-            </a:endParaRPr>
-          </a:p>
-          <a:p>
-            <a:pPr eaLnBrk="1" hangingPunct="1"/>
-            <a:r>
-              <a:rPr lang="en-US" altLang="en-US" sz="1600" dirty="0" err="1">
-                <a:solidFill>
-                  <a:schemeClr val="bg1"/>
-                </a:solidFill>
-                <a:latin typeface="Arial" panose="020B0604020202020204" pitchFamily="34" charset="0"/>
-                <a:cs typeface="Arial" panose="020B0604020202020204" pitchFamily="34" charset="0"/>
-              </a:rPr>
-              <a:t>Danke</a:t>
-            </a:r>
-            <a:endParaRPr lang="en-US" altLang="en-US" sz="1600" dirty="0">
-              <a:solidFill>
-                <a:schemeClr val="bg1"/>
-              </a:solidFill>
-              <a:latin typeface="Arial" panose="020B0604020202020204" pitchFamily="34" charset="0"/>
-              <a:cs typeface="Arial" panose="020B0604020202020204" pitchFamily="34" charset="0"/>
-            </a:endParaRPr>
-          </a:p>
-          <a:p>
-            <a:pPr eaLnBrk="1" hangingPunct="1"/>
-            <a:r>
-              <a:rPr lang="en-US" altLang="en-US" sz="1600" dirty="0">
-                <a:solidFill>
-                  <a:schemeClr val="bg1"/>
-                </a:solidFill>
-                <a:latin typeface="Arial" panose="020B0604020202020204" pitchFamily="34" charset="0"/>
-                <a:cs typeface="Arial" panose="020B0604020202020204" pitchFamily="34" charset="0"/>
-              </a:rPr>
-              <a:t>Gracias</a:t>
-            </a:r>
-          </a:p>
-          <a:p>
-            <a:pPr eaLnBrk="1" hangingPunct="1"/>
-            <a:r>
-              <a:rPr lang="ja-JP" altLang="en-US" sz="1600" dirty="0">
-                <a:solidFill>
-                  <a:schemeClr val="bg1"/>
-                </a:solidFill>
-                <a:latin typeface="Arial" panose="020B0604020202020204" pitchFamily="34" charset="0"/>
-                <a:cs typeface="Arial" panose="020B0604020202020204" pitchFamily="34" charset="0"/>
-              </a:rPr>
-              <a:t>ありがとうございました</a:t>
-            </a:r>
-            <a:endParaRPr lang="en-US" altLang="ja-JP" sz="1600" dirty="0">
-              <a:solidFill>
-                <a:schemeClr val="bg1"/>
-              </a:solidFill>
-              <a:latin typeface="Arial" panose="020B0604020202020204" pitchFamily="34" charset="0"/>
-              <a:cs typeface="Arial" panose="020B0604020202020204" pitchFamily="34" charset="0"/>
-            </a:endParaRPr>
-          </a:p>
-          <a:p>
-            <a:pPr eaLnBrk="1" hangingPunct="1"/>
-            <a:r>
-              <a:rPr lang="ar-SA" altLang="en-US" sz="1600" b="1" dirty="0">
-                <a:solidFill>
-                  <a:schemeClr val="bg1"/>
-                </a:solidFill>
-                <a:latin typeface="Arial" panose="020B0604020202020204" pitchFamily="34" charset="0"/>
-                <a:cs typeface="Arial" panose="020B0604020202020204" pitchFamily="34" charset="0"/>
-              </a:rPr>
-              <a:t>شكرا</a:t>
-            </a:r>
-            <a:endParaRPr lang="en-US" altLang="en-US" sz="1600" b="1" dirty="0">
-              <a:solidFill>
-                <a:schemeClr val="bg1"/>
-              </a:solidFill>
-              <a:latin typeface="Arial" panose="020B0604020202020204" pitchFamily="34" charset="0"/>
-              <a:cs typeface="Arial" panose="020B0604020202020204" pitchFamily="34" charset="0"/>
-            </a:endParaRPr>
-          </a:p>
-          <a:p>
-            <a:pPr eaLnBrk="1" hangingPunct="1"/>
-            <a:endParaRPr lang="en-US" altLang="en-US" sz="1600" dirty="0">
-              <a:solidFill>
-                <a:schemeClr val="bg1"/>
-              </a:solidFill>
-              <a:latin typeface="Arial" panose="020B0604020202020204" pitchFamily="34" charset="0"/>
-              <a:cs typeface="Arial" panose="020B0604020202020204" pitchFamily="34" charset="0"/>
-            </a:endParaRPr>
           </a:p>
         </p:txBody>
       </p:sp>
+    </p:spTree>
+    <p:extLst>
+      <p:ext uri="{BB962C8B-B14F-4D97-AF65-F5344CB8AC3E}">
+        <p14:creationId xmlns:p14="http://schemas.microsoft.com/office/powerpoint/2010/main" val="3684859353"/>
+      </p:ext>
+    </p:extLst>
+  </p:cSld>
+  <p:clrMapOvr>
+    <a:masterClrMapping/>
+  </p:clrMapOvr>
+</p:sld>
+</file>
+
+<file path=ppt/slides/slide18.xml><?xml version="1.0" encoding="utf-8"?>
+<p:sld xmlns:a="http://schemas.openxmlformats.org/drawingml/2006/main" xmlns:r="http://schemas.openxmlformats.org/officeDocument/2006/relationships" xmlns:p="http://schemas.openxmlformats.org/presentationml/2006/main">
+  <p:cSld>
+    <p:spTree>
+      <p:nvGrpSpPr>
+        <p:cNvPr id="1" name=""/>
+        <p:cNvGrpSpPr/>
+        <p:nvPr/>
+      </p:nvGrpSpPr>
+      <p:grpSpPr>
+        <a:xfrm>
+          <a:off x="0" y="0"/>
+          <a:ext cx="0" cy="0"/>
+          <a:chOff x="0" y="0"/>
+          <a:chExt cx="0" cy="0"/>
+        </a:xfrm>
+      </p:grpSpPr>
       <p:sp>
         <p:nvSpPr>
-          <p:cNvPr id="2" name="Slide Number Placeholder 1">
+          <p:cNvPr id="4" name="Slide Number Placeholder 3">
             <a:extLst>
               <a:ext uri="{FF2B5EF4-FFF2-40B4-BE49-F238E27FC236}">
-                <a16:creationId xmlns:a16="http://schemas.microsoft.com/office/drawing/2014/main" id="{1E2AE2C9-144D-4638-B388-2744DB6B7853}"/>
+                <a16:creationId xmlns:a16="http://schemas.microsoft.com/office/drawing/2014/main" id="{352A1151-758D-32CC-6CAB-AB76FDA4271D}"/>
               </a:ext>
             </a:extLst>
           </p:cNvPr>
@@ -36112,7 +36392,7 @@
             <a:spLocks noGrp="1"/>
           </p:cNvSpPr>
           <p:nvPr>
-            <p:ph type="sldNum" sz="quarter" idx="10"/>
+            <p:ph type="sldNum" sz="quarter" idx="14"/>
           </p:nvPr>
         </p:nvSpPr>
         <p:spPr/>
@@ -36120,19 +36400,635 @@
           <a:bodyPr/>
           <a:lstStyle/>
           <a:p>
-            <a:fld id="{82DD3993-69B2-42D4-A33C-1B42906A94F6}" type="slidenum">
+            <a:fld id="{8A4A04CF-1BC9-4C63-AE06-A38D4D08020F}" type="slidenum">
               <a:rPr lang="en-GB" altLang="en-US" smtClean="0"/>
               <a:pPr/>
-              <a:t>16</a:t>
+              <a:t>18</a:t>
             </a:fld>
-            <a:endParaRPr lang="en-GB" altLang="en-US"/>
+            <a:endParaRPr lang="en-GB" altLang="en-US" dirty="0"/>
+          </a:p>
+        </p:txBody>
+      </p:sp>
+      <p:pic>
+        <p:nvPicPr>
+          <p:cNvPr id="6" name="Picture 5">
+            <a:extLst>
+              <a:ext uri="{FF2B5EF4-FFF2-40B4-BE49-F238E27FC236}">
+                <a16:creationId xmlns:a16="http://schemas.microsoft.com/office/drawing/2014/main" id="{5582F9CE-270D-9AD3-CD3A-7B350775E511}"/>
+              </a:ext>
+            </a:extLst>
+          </p:cNvPr>
+          <p:cNvPicPr>
+            <a:picLocks noChangeAspect="1"/>
+          </p:cNvPicPr>
+          <p:nvPr/>
+        </p:nvPicPr>
+        <p:blipFill>
+          <a:blip r:embed="rId2"/>
+          <a:stretch>
+            <a:fillRect/>
+          </a:stretch>
+        </p:blipFill>
+        <p:spPr>
+          <a:xfrm>
+            <a:off x="200416" y="392609"/>
+            <a:ext cx="8780746" cy="4679261"/>
+          </a:xfrm>
+          <a:prstGeom prst="rect">
+            <a:avLst/>
+          </a:prstGeom>
+        </p:spPr>
+      </p:pic>
+      <p:sp>
+        <p:nvSpPr>
+          <p:cNvPr id="8" name="Content Placeholder 4">
+            <a:extLst>
+              <a:ext uri="{FF2B5EF4-FFF2-40B4-BE49-F238E27FC236}">
+                <a16:creationId xmlns:a16="http://schemas.microsoft.com/office/drawing/2014/main" id="{28C0D28B-29D9-C917-7013-8FC093B9E4EA}"/>
+              </a:ext>
+            </a:extLst>
+          </p:cNvPr>
+          <p:cNvSpPr txBox="1">
+            <a:spLocks/>
+          </p:cNvSpPr>
+          <p:nvPr/>
+        </p:nvSpPr>
+        <p:spPr bwMode="auto">
+          <a:xfrm>
+            <a:off x="3555619" y="5138313"/>
+            <a:ext cx="3246014" cy="258818"/>
+          </a:xfrm>
+          <a:prstGeom prst="rect">
+            <a:avLst/>
+          </a:prstGeom>
+          <a:noFill/>
+          <a:ln>
+            <a:noFill/>
+          </a:ln>
+          <a:extLst>
+            <a:ext uri="{909E8E84-426E-40DD-AFC4-6F175D3DCCD1}">
+              <a14:hiddenFill xmlns:a14="http://schemas.microsoft.com/office/drawing/2010/main">
+                <a:solidFill>
+                  <a:srgbClr val="FFFFFF"/>
+                </a:solidFill>
+              </a14:hiddenFill>
+            </a:ext>
+            <a:ext uri="{91240B29-F687-4F45-9708-019B960494DF}">
+              <a14:hiddenLine xmlns:a14="http://schemas.microsoft.com/office/drawing/2010/main" w="9525">
+                <a:solidFill>
+                  <a:srgbClr val="000000"/>
+                </a:solidFill>
+                <a:miter lim="800000"/>
+                <a:headEnd/>
+                <a:tailEnd/>
+              </a14:hiddenLine>
+            </a:ext>
+          </a:extLst>
+        </p:spPr>
+        <p:txBody>
+          <a:bodyPr vert="horz" wrap="square" lIns="0" tIns="0" rIns="0" bIns="0" numCol="1" anchor="t" anchorCtr="0" compatLnSpc="1">
+            <a:prstTxWarp prst="textNoShape">
+              <a:avLst/>
+            </a:prstTxWarp>
+            <a:noAutofit/>
+          </a:bodyPr>
+          <a:lstStyle>
+            <a:lvl1pPr marL="342900" indent="-342900" algn="l" defTabSz="685800" rtl="0" eaLnBrk="0" fontAlgn="base" hangingPunct="0">
+              <a:lnSpc>
+                <a:spcPct val="90000"/>
+              </a:lnSpc>
+              <a:spcBef>
+                <a:spcPct val="0"/>
+              </a:spcBef>
+              <a:spcAft>
+                <a:spcPts val="600"/>
+              </a:spcAft>
+              <a:defRPr sz="1800" b="1" kern="1200">
+                <a:solidFill>
+                  <a:srgbClr val="00A5DF"/>
+                </a:solidFill>
+                <a:latin typeface="+mn-lt"/>
+                <a:ea typeface="MS PGothic" pitchFamily="34" charset="-128"/>
+                <a:cs typeface="ＭＳ Ｐゴシック" charset="0"/>
+              </a:defRPr>
+            </a:lvl1pPr>
+            <a:lvl2pPr marL="742950" indent="-285750" algn="l" defTabSz="685800" rtl="0" eaLnBrk="0" fontAlgn="base" hangingPunct="0">
+              <a:lnSpc>
+                <a:spcPct val="90000"/>
+              </a:lnSpc>
+              <a:spcBef>
+                <a:spcPct val="0"/>
+              </a:spcBef>
+              <a:spcAft>
+                <a:spcPts val="600"/>
+              </a:spcAft>
+              <a:buSzPct val="80000"/>
+              <a:buFont typeface="Arial" panose="020B0604020202020204" pitchFamily="34" charset="0"/>
+              <a:defRPr sz="1800" kern="1200">
+                <a:solidFill>
+                  <a:srgbClr val="00A5DF"/>
+                </a:solidFill>
+                <a:latin typeface="+mn-lt"/>
+                <a:ea typeface="MS PGothic" pitchFamily="34" charset="-128"/>
+                <a:cs typeface="+mn-cs"/>
+              </a:defRPr>
+            </a:lvl2pPr>
+            <a:lvl3pPr marL="180975" indent="-180975" algn="l" defTabSz="685800" rtl="0" eaLnBrk="0" fontAlgn="base" hangingPunct="0">
+              <a:lnSpc>
+                <a:spcPct val="90000"/>
+              </a:lnSpc>
+              <a:spcBef>
+                <a:spcPct val="0"/>
+              </a:spcBef>
+              <a:spcAft>
+                <a:spcPts val="600"/>
+              </a:spcAft>
+              <a:buSzPct val="100000"/>
+              <a:buFont typeface="Lucida Grande"/>
+              <a:buChar char="-"/>
+              <a:defRPr sz="1800" kern="1200">
+                <a:solidFill>
+                  <a:srgbClr val="00A5DF"/>
+                </a:solidFill>
+                <a:latin typeface="+mn-lt"/>
+                <a:ea typeface="MS PGothic" pitchFamily="34" charset="-128"/>
+                <a:cs typeface="+mn-cs"/>
+              </a:defRPr>
+            </a:lvl3pPr>
+            <a:lvl4pPr marL="363538" indent="-182563" algn="l" defTabSz="685800" rtl="0" eaLnBrk="0" fontAlgn="base" hangingPunct="0">
+              <a:lnSpc>
+                <a:spcPct val="90000"/>
+              </a:lnSpc>
+              <a:spcBef>
+                <a:spcPct val="0"/>
+              </a:spcBef>
+              <a:spcAft>
+                <a:spcPts val="600"/>
+              </a:spcAft>
+              <a:buSzPct val="100000"/>
+              <a:buFont typeface="Lucida Grande"/>
+              <a:buChar char="-"/>
+              <a:defRPr sz="1800" kern="1200">
+                <a:solidFill>
+                  <a:srgbClr val="00A5DF"/>
+                </a:solidFill>
+                <a:latin typeface="+mn-lt"/>
+                <a:ea typeface="MS PGothic" pitchFamily="34" charset="-128"/>
+                <a:cs typeface="+mn-cs"/>
+              </a:defRPr>
+            </a:lvl4pPr>
+            <a:lvl5pPr marL="534988" indent="-171450" algn="l" defTabSz="685800" rtl="0" eaLnBrk="0" fontAlgn="base" hangingPunct="0">
+              <a:lnSpc>
+                <a:spcPct val="90000"/>
+              </a:lnSpc>
+              <a:spcBef>
+                <a:spcPct val="0"/>
+              </a:spcBef>
+              <a:spcAft>
+                <a:spcPts val="600"/>
+              </a:spcAft>
+              <a:buSzPct val="100000"/>
+              <a:buFont typeface="Lucida Grande"/>
+              <a:buChar char="-"/>
+              <a:defRPr sz="1800" kern="1200">
+                <a:solidFill>
+                  <a:srgbClr val="00A5DF"/>
+                </a:solidFill>
+                <a:latin typeface="+mn-lt"/>
+                <a:ea typeface="MS PGothic" pitchFamily="34" charset="-128"/>
+                <a:cs typeface="+mn-cs"/>
+              </a:defRPr>
+            </a:lvl5pPr>
+            <a:lvl6pPr marL="1885950" indent="-171450" algn="l" defTabSz="685800" rtl="0" eaLnBrk="1" latinLnBrk="0" hangingPunct="1">
+              <a:lnSpc>
+                <a:spcPct val="90000"/>
+              </a:lnSpc>
+              <a:spcBef>
+                <a:spcPts val="375"/>
+              </a:spcBef>
+              <a:buFont typeface="Arial" panose="020B0604020202020204" pitchFamily="34" charset="0"/>
+              <a:buChar char="•"/>
+              <a:defRPr sz="1350" kern="1200">
+                <a:solidFill>
+                  <a:schemeClr val="tx1"/>
+                </a:solidFill>
+                <a:latin typeface="+mn-lt"/>
+                <a:ea typeface="+mn-ea"/>
+                <a:cs typeface="+mn-cs"/>
+              </a:defRPr>
+            </a:lvl6pPr>
+            <a:lvl7pPr marL="2228850" indent="-171450" algn="l" defTabSz="685800" rtl="0" eaLnBrk="1" latinLnBrk="0" hangingPunct="1">
+              <a:lnSpc>
+                <a:spcPct val="90000"/>
+              </a:lnSpc>
+              <a:spcBef>
+                <a:spcPts val="375"/>
+              </a:spcBef>
+              <a:buFont typeface="Arial" panose="020B0604020202020204" pitchFamily="34" charset="0"/>
+              <a:buChar char="•"/>
+              <a:defRPr sz="1350" kern="1200">
+                <a:solidFill>
+                  <a:schemeClr val="tx1"/>
+                </a:solidFill>
+                <a:latin typeface="+mn-lt"/>
+                <a:ea typeface="+mn-ea"/>
+                <a:cs typeface="+mn-cs"/>
+              </a:defRPr>
+            </a:lvl7pPr>
+            <a:lvl8pPr marL="2571750" indent="-171450" algn="l" defTabSz="685800" rtl="0" eaLnBrk="1" latinLnBrk="0" hangingPunct="1">
+              <a:lnSpc>
+                <a:spcPct val="90000"/>
+              </a:lnSpc>
+              <a:spcBef>
+                <a:spcPts val="375"/>
+              </a:spcBef>
+              <a:buFont typeface="Arial" panose="020B0604020202020204" pitchFamily="34" charset="0"/>
+              <a:buChar char="•"/>
+              <a:defRPr sz="1350" kern="1200">
+                <a:solidFill>
+                  <a:schemeClr val="tx1"/>
+                </a:solidFill>
+                <a:latin typeface="+mn-lt"/>
+                <a:ea typeface="+mn-ea"/>
+                <a:cs typeface="+mn-cs"/>
+              </a:defRPr>
+            </a:lvl8pPr>
+            <a:lvl9pPr marL="2914650" indent="-171450" algn="l" defTabSz="685800" rtl="0" eaLnBrk="1" latinLnBrk="0" hangingPunct="1">
+              <a:lnSpc>
+                <a:spcPct val="90000"/>
+              </a:lnSpc>
+              <a:spcBef>
+                <a:spcPts val="375"/>
+              </a:spcBef>
+              <a:buFont typeface="Arial" panose="020B0604020202020204" pitchFamily="34" charset="0"/>
+              <a:buChar char="•"/>
+              <a:defRPr sz="1350" kern="1200">
+                <a:solidFill>
+                  <a:schemeClr val="tx1"/>
+                </a:solidFill>
+                <a:latin typeface="+mn-lt"/>
+                <a:ea typeface="+mn-ea"/>
+                <a:cs typeface="+mn-cs"/>
+              </a:defRPr>
+            </a:lvl9pPr>
+          </a:lstStyle>
+          <a:p>
+            <a:pPr marL="0" indent="0"/>
+            <a:r>
+              <a:rPr lang="en-US" sz="1400" dirty="0">
+                <a:solidFill>
+                  <a:schemeClr val="bg2">
+                    <a:lumMod val="10000"/>
+                  </a:schemeClr>
+                </a:solidFill>
+              </a:rPr>
+              <a:t>SP 72-35 Cautions Report</a:t>
+            </a:r>
           </a:p>
         </p:txBody>
       </p:sp>
     </p:spTree>
     <p:extLst>
       <p:ext uri="{BB962C8B-B14F-4D97-AF65-F5344CB8AC3E}">
-        <p14:creationId xmlns:p14="http://schemas.microsoft.com/office/powerpoint/2010/main" val="1995908282"/>
+        <p14:creationId xmlns:p14="http://schemas.microsoft.com/office/powerpoint/2010/main" val="759954440"/>
+      </p:ext>
+    </p:extLst>
+  </p:cSld>
+  <p:clrMapOvr>
+    <a:masterClrMapping/>
+  </p:clrMapOvr>
+</p:sld>
+</file>
+
+<file path=ppt/slides/slide19.xml><?xml version="1.0" encoding="utf-8"?>
+<p:sld xmlns:a="http://schemas.openxmlformats.org/drawingml/2006/main" xmlns:r="http://schemas.openxmlformats.org/officeDocument/2006/relationships" xmlns:p="http://schemas.openxmlformats.org/presentationml/2006/main">
+  <p:cSld>
+    <p:spTree>
+      <p:nvGrpSpPr>
+        <p:cNvPr id="1" name=""/>
+        <p:cNvGrpSpPr/>
+        <p:nvPr/>
+      </p:nvGrpSpPr>
+      <p:grpSpPr>
+        <a:xfrm>
+          <a:off x="0" y="0"/>
+          <a:ext cx="0" cy="0"/>
+          <a:chOff x="0" y="0"/>
+          <a:chExt cx="0" cy="0"/>
+        </a:xfrm>
+      </p:grpSpPr>
+      <p:sp>
+        <p:nvSpPr>
+          <p:cNvPr id="4" name="Slide Number Placeholder 3">
+            <a:extLst>
+              <a:ext uri="{FF2B5EF4-FFF2-40B4-BE49-F238E27FC236}">
+                <a16:creationId xmlns:a16="http://schemas.microsoft.com/office/drawing/2014/main" id="{B759D951-920D-2640-5FA1-D3B32A16C7CD}"/>
+              </a:ext>
+            </a:extLst>
+          </p:cNvPr>
+          <p:cNvSpPr>
+            <a:spLocks noGrp="1"/>
+          </p:cNvSpPr>
+          <p:nvPr>
+            <p:ph type="sldNum" sz="quarter" idx="14"/>
+          </p:nvPr>
+        </p:nvSpPr>
+        <p:spPr/>
+        <p:txBody>
+          <a:bodyPr/>
+          <a:lstStyle/>
+          <a:p>
+            <a:fld id="{8A4A04CF-1BC9-4C63-AE06-A38D4D08020F}" type="slidenum">
+              <a:rPr lang="en-GB" altLang="en-US" smtClean="0"/>
+              <a:pPr/>
+              <a:t>19</a:t>
+            </a:fld>
+            <a:endParaRPr lang="en-GB" altLang="en-US" dirty="0"/>
+          </a:p>
+        </p:txBody>
+      </p:sp>
+      <p:pic>
+        <p:nvPicPr>
+          <p:cNvPr id="6" name="Picture 5">
+            <a:extLst>
+              <a:ext uri="{FF2B5EF4-FFF2-40B4-BE49-F238E27FC236}">
+                <a16:creationId xmlns:a16="http://schemas.microsoft.com/office/drawing/2014/main" id="{7594E130-9C51-19E4-E4AF-DAE50C263CA1}"/>
+              </a:ext>
+            </a:extLst>
+          </p:cNvPr>
+          <p:cNvPicPr>
+            <a:picLocks noChangeAspect="1"/>
+          </p:cNvPicPr>
+          <p:nvPr/>
+        </p:nvPicPr>
+        <p:blipFill>
+          <a:blip r:embed="rId2"/>
+          <a:stretch>
+            <a:fillRect/>
+          </a:stretch>
+        </p:blipFill>
+        <p:spPr>
+          <a:xfrm>
+            <a:off x="187890" y="367557"/>
+            <a:ext cx="8880954" cy="4679261"/>
+          </a:xfrm>
+          <a:prstGeom prst="rect">
+            <a:avLst/>
+          </a:prstGeom>
+        </p:spPr>
+      </p:pic>
+      <p:sp>
+        <p:nvSpPr>
+          <p:cNvPr id="8" name="Content Placeholder 4">
+            <a:extLst>
+              <a:ext uri="{FF2B5EF4-FFF2-40B4-BE49-F238E27FC236}">
+                <a16:creationId xmlns:a16="http://schemas.microsoft.com/office/drawing/2014/main" id="{0F1D5463-554F-34EF-6F42-754FA0AB66C9}"/>
+              </a:ext>
+            </a:extLst>
+          </p:cNvPr>
+          <p:cNvSpPr txBox="1">
+            <a:spLocks/>
+          </p:cNvSpPr>
+          <p:nvPr/>
+        </p:nvSpPr>
+        <p:spPr bwMode="auto">
+          <a:xfrm>
+            <a:off x="3478688" y="5120802"/>
+            <a:ext cx="3961771" cy="378123"/>
+          </a:xfrm>
+          <a:prstGeom prst="rect">
+            <a:avLst/>
+          </a:prstGeom>
+          <a:noFill/>
+          <a:ln>
+            <a:noFill/>
+          </a:ln>
+          <a:extLst>
+            <a:ext uri="{909E8E84-426E-40DD-AFC4-6F175D3DCCD1}">
+              <a14:hiddenFill xmlns:a14="http://schemas.microsoft.com/office/drawing/2010/main">
+                <a:solidFill>
+                  <a:srgbClr val="FFFFFF"/>
+                </a:solidFill>
+              </a14:hiddenFill>
+            </a:ext>
+            <a:ext uri="{91240B29-F687-4F45-9708-019B960494DF}">
+              <a14:hiddenLine xmlns:a14="http://schemas.microsoft.com/office/drawing/2010/main" w="9525">
+                <a:solidFill>
+                  <a:srgbClr val="000000"/>
+                </a:solidFill>
+                <a:miter lim="800000"/>
+                <a:headEnd/>
+                <a:tailEnd/>
+              </a14:hiddenLine>
+            </a:ext>
+          </a:extLst>
+        </p:spPr>
+        <p:txBody>
+          <a:bodyPr vert="horz" wrap="square" lIns="0" tIns="0" rIns="0" bIns="0" numCol="1" anchor="t" anchorCtr="0" compatLnSpc="1">
+            <a:prstTxWarp prst="textNoShape">
+              <a:avLst/>
+            </a:prstTxWarp>
+            <a:noAutofit/>
+          </a:bodyPr>
+          <a:lstStyle>
+            <a:lvl1pPr marL="342900" indent="-342900" algn="l" defTabSz="685800" rtl="0" eaLnBrk="0" fontAlgn="base" hangingPunct="0">
+              <a:lnSpc>
+                <a:spcPct val="90000"/>
+              </a:lnSpc>
+              <a:spcBef>
+                <a:spcPct val="0"/>
+              </a:spcBef>
+              <a:spcAft>
+                <a:spcPts val="600"/>
+              </a:spcAft>
+              <a:defRPr sz="1800" b="1" kern="1200">
+                <a:solidFill>
+                  <a:srgbClr val="00A5DF"/>
+                </a:solidFill>
+                <a:latin typeface="+mn-lt"/>
+                <a:ea typeface="MS PGothic" pitchFamily="34" charset="-128"/>
+                <a:cs typeface="ＭＳ Ｐゴシック" charset="0"/>
+              </a:defRPr>
+            </a:lvl1pPr>
+            <a:lvl2pPr marL="742950" indent="-285750" algn="l" defTabSz="685800" rtl="0" eaLnBrk="0" fontAlgn="base" hangingPunct="0">
+              <a:lnSpc>
+                <a:spcPct val="90000"/>
+              </a:lnSpc>
+              <a:spcBef>
+                <a:spcPct val="0"/>
+              </a:spcBef>
+              <a:spcAft>
+                <a:spcPts val="600"/>
+              </a:spcAft>
+              <a:buSzPct val="80000"/>
+              <a:buFont typeface="Arial" panose="020B0604020202020204" pitchFamily="34" charset="0"/>
+              <a:defRPr sz="1800" kern="1200">
+                <a:solidFill>
+                  <a:srgbClr val="00A5DF"/>
+                </a:solidFill>
+                <a:latin typeface="+mn-lt"/>
+                <a:ea typeface="MS PGothic" pitchFamily="34" charset="-128"/>
+                <a:cs typeface="+mn-cs"/>
+              </a:defRPr>
+            </a:lvl2pPr>
+            <a:lvl3pPr marL="180975" indent="-180975" algn="l" defTabSz="685800" rtl="0" eaLnBrk="0" fontAlgn="base" hangingPunct="0">
+              <a:lnSpc>
+                <a:spcPct val="90000"/>
+              </a:lnSpc>
+              <a:spcBef>
+                <a:spcPct val="0"/>
+              </a:spcBef>
+              <a:spcAft>
+                <a:spcPts val="600"/>
+              </a:spcAft>
+              <a:buSzPct val="100000"/>
+              <a:buFont typeface="Lucida Grande"/>
+              <a:buChar char="-"/>
+              <a:defRPr sz="1800" kern="1200">
+                <a:solidFill>
+                  <a:srgbClr val="00A5DF"/>
+                </a:solidFill>
+                <a:latin typeface="+mn-lt"/>
+                <a:ea typeface="MS PGothic" pitchFamily="34" charset="-128"/>
+                <a:cs typeface="+mn-cs"/>
+              </a:defRPr>
+            </a:lvl3pPr>
+            <a:lvl4pPr marL="363538" indent="-182563" algn="l" defTabSz="685800" rtl="0" eaLnBrk="0" fontAlgn="base" hangingPunct="0">
+              <a:lnSpc>
+                <a:spcPct val="90000"/>
+              </a:lnSpc>
+              <a:spcBef>
+                <a:spcPct val="0"/>
+              </a:spcBef>
+              <a:spcAft>
+                <a:spcPts val="600"/>
+              </a:spcAft>
+              <a:buSzPct val="100000"/>
+              <a:buFont typeface="Lucida Grande"/>
+              <a:buChar char="-"/>
+              <a:defRPr sz="1800" kern="1200">
+                <a:solidFill>
+                  <a:srgbClr val="00A5DF"/>
+                </a:solidFill>
+                <a:latin typeface="+mn-lt"/>
+                <a:ea typeface="MS PGothic" pitchFamily="34" charset="-128"/>
+                <a:cs typeface="+mn-cs"/>
+              </a:defRPr>
+            </a:lvl4pPr>
+            <a:lvl5pPr marL="534988" indent="-171450" algn="l" defTabSz="685800" rtl="0" eaLnBrk="0" fontAlgn="base" hangingPunct="0">
+              <a:lnSpc>
+                <a:spcPct val="90000"/>
+              </a:lnSpc>
+              <a:spcBef>
+                <a:spcPct val="0"/>
+              </a:spcBef>
+              <a:spcAft>
+                <a:spcPts val="600"/>
+              </a:spcAft>
+              <a:buSzPct val="100000"/>
+              <a:buFont typeface="Lucida Grande"/>
+              <a:buChar char="-"/>
+              <a:defRPr sz="1800" kern="1200">
+                <a:solidFill>
+                  <a:srgbClr val="00A5DF"/>
+                </a:solidFill>
+                <a:latin typeface="+mn-lt"/>
+                <a:ea typeface="MS PGothic" pitchFamily="34" charset="-128"/>
+                <a:cs typeface="+mn-cs"/>
+              </a:defRPr>
+            </a:lvl5pPr>
+            <a:lvl6pPr marL="1885950" indent="-171450" algn="l" defTabSz="685800" rtl="0" eaLnBrk="1" latinLnBrk="0" hangingPunct="1">
+              <a:lnSpc>
+                <a:spcPct val="90000"/>
+              </a:lnSpc>
+              <a:spcBef>
+                <a:spcPts val="375"/>
+              </a:spcBef>
+              <a:buFont typeface="Arial" panose="020B0604020202020204" pitchFamily="34" charset="0"/>
+              <a:buChar char="•"/>
+              <a:defRPr sz="1350" kern="1200">
+                <a:solidFill>
+                  <a:schemeClr val="tx1"/>
+                </a:solidFill>
+                <a:latin typeface="+mn-lt"/>
+                <a:ea typeface="+mn-ea"/>
+                <a:cs typeface="+mn-cs"/>
+              </a:defRPr>
+            </a:lvl6pPr>
+            <a:lvl7pPr marL="2228850" indent="-171450" algn="l" defTabSz="685800" rtl="0" eaLnBrk="1" latinLnBrk="0" hangingPunct="1">
+              <a:lnSpc>
+                <a:spcPct val="90000"/>
+              </a:lnSpc>
+              <a:spcBef>
+                <a:spcPts val="375"/>
+              </a:spcBef>
+              <a:buFont typeface="Arial" panose="020B0604020202020204" pitchFamily="34" charset="0"/>
+              <a:buChar char="•"/>
+              <a:defRPr sz="1350" kern="1200">
+                <a:solidFill>
+                  <a:schemeClr val="tx1"/>
+                </a:solidFill>
+                <a:latin typeface="+mn-lt"/>
+                <a:ea typeface="+mn-ea"/>
+                <a:cs typeface="+mn-cs"/>
+              </a:defRPr>
+            </a:lvl7pPr>
+            <a:lvl8pPr marL="2571750" indent="-171450" algn="l" defTabSz="685800" rtl="0" eaLnBrk="1" latinLnBrk="0" hangingPunct="1">
+              <a:lnSpc>
+                <a:spcPct val="90000"/>
+              </a:lnSpc>
+              <a:spcBef>
+                <a:spcPts val="375"/>
+              </a:spcBef>
+              <a:buFont typeface="Arial" panose="020B0604020202020204" pitchFamily="34" charset="0"/>
+              <a:buChar char="•"/>
+              <a:defRPr sz="1350" kern="1200">
+                <a:solidFill>
+                  <a:schemeClr val="tx1"/>
+                </a:solidFill>
+                <a:latin typeface="+mn-lt"/>
+                <a:ea typeface="+mn-ea"/>
+                <a:cs typeface="+mn-cs"/>
+              </a:defRPr>
+            </a:lvl8pPr>
+            <a:lvl9pPr marL="2914650" indent="-171450" algn="l" defTabSz="685800" rtl="0" eaLnBrk="1" latinLnBrk="0" hangingPunct="1">
+              <a:lnSpc>
+                <a:spcPct val="90000"/>
+              </a:lnSpc>
+              <a:spcBef>
+                <a:spcPts val="375"/>
+              </a:spcBef>
+              <a:buFont typeface="Arial" panose="020B0604020202020204" pitchFamily="34" charset="0"/>
+              <a:buChar char="•"/>
+              <a:defRPr sz="1350" kern="1200">
+                <a:solidFill>
+                  <a:schemeClr val="tx1"/>
+                </a:solidFill>
+                <a:latin typeface="+mn-lt"/>
+                <a:ea typeface="+mn-ea"/>
+                <a:cs typeface="+mn-cs"/>
+              </a:defRPr>
+            </a:lvl9pPr>
+          </a:lstStyle>
+          <a:p>
+            <a:pPr marL="0" indent="0"/>
+            <a:r>
+              <a:rPr lang="en-US" sz="1400" dirty="0">
+                <a:solidFill>
+                  <a:schemeClr val="bg2">
+                    <a:lumMod val="10000"/>
+                  </a:schemeClr>
+                </a:solidFill>
+              </a:rPr>
+              <a:t>SP 72-51 Cautions Report</a:t>
+            </a:r>
+          </a:p>
+        </p:txBody>
+      </p:sp>
+    </p:spTree>
+    <p:extLst>
+      <p:ext uri="{BB962C8B-B14F-4D97-AF65-F5344CB8AC3E}">
+        <p14:creationId xmlns:p14="http://schemas.microsoft.com/office/powerpoint/2010/main" val="1556442716"/>
       </p:ext>
     </p:extLst>
   </p:cSld>
@@ -36593,7 +37489,7 @@
           <p:nvPr>
             <p:extLst>
               <p:ext uri="{D42A27DB-BD31-4B8C-83A1-F6EECF244321}">
-                <p14:modId xmlns:p14="http://schemas.microsoft.com/office/powerpoint/2010/main" val="415363521"/>
+                <p14:modId xmlns:p14="http://schemas.microsoft.com/office/powerpoint/2010/main" val="3778831970"/>
               </p:ext>
             </p:extLst>
           </p:nvPr>
@@ -37089,7 +37985,7 @@
                         <a:rPr lang="en-US" sz="1300" u="sng" dirty="0">
                           <a:hlinkClick r:id="rId7" action="ppaction://hlinksldjump"/>
                         </a:rPr>
-                        <a:t>8-13</a:t>
+                        <a:t>8-14</a:t>
                       </a:r>
                       <a:endParaRPr lang="en-US" sz="1300" u="sng" dirty="0"/>
                     </a:p>
@@ -37166,13 +38062,43 @@
                     <a:bodyPr/>
                     <a:lstStyle/>
                     <a:p>
+                      <a:pPr marL="0" marR="0" lvl="0" indent="0" algn="l" defTabSz="685800" rtl="0" eaLnBrk="1" fontAlgn="auto" latinLnBrk="0" hangingPunct="1">
+                        <a:lnSpc>
+                          <a:spcPct val="100000"/>
+                        </a:lnSpc>
+                        <a:spcBef>
+                          <a:spcPts val="0"/>
+                        </a:spcBef>
+                        <a:spcAft>
+                          <a:spcPts val="0"/>
+                        </a:spcAft>
+                        <a:buClrTx/>
+                        <a:buSzTx/>
+                        <a:buFontTx/>
+                        <a:buNone/>
+                        <a:tabLst/>
+                        <a:defRPr/>
+                      </a:pPr>
                       <a:r>
-                        <a:rPr lang="en-US" u="sng" dirty="0">
+                        <a:rPr lang="en-US" sz="1300" u="sng" kern="1200" dirty="0">
+                          <a:solidFill>
+                            <a:schemeClr val="dk1"/>
+                          </a:solidFill>
+                          <a:latin typeface="+mn-lt"/>
+                          <a:ea typeface="+mn-ea"/>
+                          <a:cs typeface="+mn-cs"/>
                           <a:hlinkClick r:id="rId8" action="ppaction://hlinksldjump"/>
                         </a:rPr>
-                        <a:t>14</a:t>
+                        <a:t>15-19</a:t>
                       </a:r>
-                      <a:endParaRPr lang="en-US" u="sng" dirty="0"/>
+                      <a:endParaRPr lang="en-US" sz="1300" u="sng" kern="1200" dirty="0">
+                        <a:solidFill>
+                          <a:schemeClr val="dk1"/>
+                        </a:solidFill>
+                        <a:latin typeface="+mn-lt"/>
+                        <a:ea typeface="+mn-ea"/>
+                        <a:cs typeface="+mn-cs"/>
+                      </a:endParaRPr>
                     </a:p>
                   </a:txBody>
                   <a:tcPr/>
@@ -37239,13 +38165,27 @@
                     <a:bodyPr/>
                     <a:lstStyle/>
                     <a:p>
+                      <a:pPr marL="0" algn="l" defTabSz="685800" rtl="0" eaLnBrk="1" latinLnBrk="0" hangingPunct="1"/>
                       <a:r>
-                        <a:rPr lang="en-US" u="sng" dirty="0">
+                        <a:rPr lang="en-US" sz="1300" u="sng" kern="1200" dirty="0">
+                          <a:solidFill>
+                            <a:schemeClr val="dk1"/>
+                          </a:solidFill>
+                          <a:latin typeface="+mn-lt"/>
+                          <a:ea typeface="+mn-ea"/>
+                          <a:cs typeface="+mn-cs"/>
                           <a:hlinkClick r:id="rId9" action="ppaction://hlinksldjump"/>
                         </a:rPr>
-                        <a:t>15</a:t>
+                        <a:t>20</a:t>
                       </a:r>
-                      <a:endParaRPr lang="en-US" u="sng" dirty="0"/>
+                      <a:endParaRPr lang="en-US" sz="1300" u="sng" kern="1200" dirty="0">
+                        <a:solidFill>
+                          <a:schemeClr val="dk1"/>
+                        </a:solidFill>
+                        <a:latin typeface="+mn-lt"/>
+                        <a:ea typeface="+mn-ea"/>
+                        <a:cs typeface="+mn-cs"/>
+                      </a:endParaRPr>
                     </a:p>
                   </a:txBody>
                   <a:tcPr/>
@@ -37264,6 +38204,920 @@
     <p:extLst>
       <p:ext uri="{BB962C8B-B14F-4D97-AF65-F5344CB8AC3E}">
         <p14:creationId xmlns:p14="http://schemas.microsoft.com/office/powerpoint/2010/main" val="2189463810"/>
+      </p:ext>
+    </p:extLst>
+  </p:cSld>
+  <p:clrMapOvr>
+    <a:masterClrMapping/>
+  </p:clrMapOvr>
+</p:sld>
+</file>
+
+<file path=ppt/slides/slide20.xml><?xml version="1.0" encoding="utf-8"?>
+<p:sld xmlns:a="http://schemas.openxmlformats.org/drawingml/2006/main" xmlns:r="http://schemas.openxmlformats.org/officeDocument/2006/relationships" xmlns:p="http://schemas.openxmlformats.org/presentationml/2006/main">
+  <p:cSld>
+    <p:spTree>
+      <p:nvGrpSpPr>
+        <p:cNvPr id="1" name=""/>
+        <p:cNvGrpSpPr/>
+        <p:nvPr/>
+      </p:nvGrpSpPr>
+      <p:grpSpPr>
+        <a:xfrm>
+          <a:off x="0" y="0"/>
+          <a:ext cx="0" cy="0"/>
+          <a:chOff x="0" y="0"/>
+          <a:chExt cx="0" cy="0"/>
+        </a:xfrm>
+      </p:grpSpPr>
+      <p:sp>
+        <p:nvSpPr>
+          <p:cNvPr id="2" name="Content Placeholder 1">
+            <a:extLst>
+              <a:ext uri="{FF2B5EF4-FFF2-40B4-BE49-F238E27FC236}">
+                <a16:creationId xmlns:a16="http://schemas.microsoft.com/office/drawing/2014/main" id="{1BE494C2-133A-4197-87DB-AFF1D59C4328}"/>
+              </a:ext>
+            </a:extLst>
+          </p:cNvPr>
+          <p:cNvSpPr>
+            <a:spLocks noGrp="1"/>
+          </p:cNvSpPr>
+          <p:nvPr>
+            <p:ph sz="quarter" idx="13"/>
+          </p:nvPr>
+        </p:nvSpPr>
+        <p:spPr>
+          <a:xfrm>
+            <a:off x="2104372" y="1455371"/>
+            <a:ext cx="4935255" cy="1175096"/>
+          </a:xfrm>
+        </p:spPr>
+        <p:txBody>
+          <a:bodyPr/>
+          <a:lstStyle/>
+          <a:p>
+            <a:pPr marL="0" indent="0">
+              <a:lnSpc>
+                <a:spcPct val="150000"/>
+              </a:lnSpc>
+            </a:pPr>
+            <a:r>
+              <a:rPr lang="en-US" sz="1200" dirty="0"/>
+              <a:t>IHI</a:t>
+            </a:r>
+            <a:r>
+              <a:rPr lang="en-US" sz="1200" b="0" dirty="0"/>
+              <a:t>    		Tatsuya Ito-San 	</a:t>
+            </a:r>
+            <a:r>
+              <a:rPr lang="en-US" sz="1200" b="0" dirty="0">
+                <a:hlinkClick r:id="rId2"/>
+              </a:rPr>
+              <a:t>ito0114@ihi-g.com</a:t>
+            </a:r>
+            <a:endParaRPr lang="en-US" sz="1200" b="0" dirty="0"/>
+          </a:p>
+          <a:p>
+            <a:pPr marL="0" indent="0">
+              <a:lnSpc>
+                <a:spcPct val="150000"/>
+              </a:lnSpc>
+            </a:pPr>
+            <a:r>
+              <a:rPr lang="en-US" sz="1200" dirty="0"/>
+              <a:t>CYIENT Onsite </a:t>
+            </a:r>
+            <a:r>
+              <a:rPr lang="en-US" sz="1200" b="0" dirty="0"/>
+              <a:t>	Suraj Prakash</a:t>
+            </a:r>
+            <a:r>
+              <a:rPr lang="en-US" sz="1200" b="0"/>
+              <a:t>	</a:t>
+            </a:r>
+            <a:r>
+              <a:rPr lang="en-US" sz="1200" b="0">
+                <a:hlinkClick r:id="rId3"/>
+              </a:rPr>
+              <a:t>prakash7808@ihi-g.com</a:t>
+            </a:r>
+            <a:endParaRPr lang="en-US" sz="1200" b="0" dirty="0"/>
+          </a:p>
+          <a:p>
+            <a:pPr marL="0" indent="0">
+              <a:lnSpc>
+                <a:spcPct val="150000"/>
+              </a:lnSpc>
+            </a:pPr>
+            <a:r>
+              <a:rPr lang="en-US" sz="1200" dirty="0"/>
+              <a:t>CYIENT Offshore </a:t>
+            </a:r>
+            <a:r>
+              <a:rPr lang="en-US" sz="1200" b="0" dirty="0"/>
+              <a:t>	Veerendra Kotari	</a:t>
+            </a:r>
+            <a:r>
+              <a:rPr lang="en-US" sz="1200" b="0" dirty="0">
+                <a:hlinkClick r:id="rId4"/>
+              </a:rPr>
+              <a:t>Veerendra.Kotari@cyient.com</a:t>
+            </a:r>
+            <a:endParaRPr lang="en-US" sz="1200" b="0" dirty="0"/>
+          </a:p>
+          <a:p>
+            <a:pPr marL="0" indent="0">
+              <a:lnSpc>
+                <a:spcPct val="150000"/>
+              </a:lnSpc>
+            </a:pPr>
+            <a:endParaRPr lang="pt-BR" sz="1200" b="0" dirty="0"/>
+          </a:p>
+        </p:txBody>
+      </p:sp>
+      <p:sp>
+        <p:nvSpPr>
+          <p:cNvPr id="4" name="Slide Number Placeholder 3">
+            <a:extLst>
+              <a:ext uri="{FF2B5EF4-FFF2-40B4-BE49-F238E27FC236}">
+                <a16:creationId xmlns:a16="http://schemas.microsoft.com/office/drawing/2014/main" id="{DB967E03-8311-4878-A0F4-83A51F6C3235}"/>
+              </a:ext>
+            </a:extLst>
+          </p:cNvPr>
+          <p:cNvSpPr>
+            <a:spLocks noGrp="1"/>
+          </p:cNvSpPr>
+          <p:nvPr>
+            <p:ph type="sldNum" sz="quarter" idx="14"/>
+          </p:nvPr>
+        </p:nvSpPr>
+        <p:spPr/>
+        <p:txBody>
+          <a:bodyPr/>
+          <a:lstStyle/>
+          <a:p>
+            <a:fld id="{8A4A04CF-1BC9-4C63-AE06-A38D4D08020F}" type="slidenum">
+              <a:rPr lang="en-GB" altLang="en-US" smtClean="0"/>
+              <a:pPr/>
+              <a:t>20</a:t>
+            </a:fld>
+            <a:endParaRPr lang="en-GB" altLang="en-US" dirty="0"/>
+          </a:p>
+        </p:txBody>
+      </p:sp>
+      <p:sp>
+        <p:nvSpPr>
+          <p:cNvPr id="6" name="Title 2">
+            <a:extLst>
+              <a:ext uri="{FF2B5EF4-FFF2-40B4-BE49-F238E27FC236}">
+                <a16:creationId xmlns:a16="http://schemas.microsoft.com/office/drawing/2014/main" id="{3E22D8D7-B261-487B-BE5C-95FC09F51493}"/>
+              </a:ext>
+            </a:extLst>
+          </p:cNvPr>
+          <p:cNvSpPr txBox="1">
+            <a:spLocks/>
+          </p:cNvSpPr>
+          <p:nvPr/>
+        </p:nvSpPr>
+        <p:spPr bwMode="auto">
+          <a:xfrm>
+            <a:off x="473902" y="33822"/>
+            <a:ext cx="7965738" cy="448224"/>
+          </a:xfrm>
+          <a:prstGeom prst="rect">
+            <a:avLst/>
+          </a:prstGeom>
+          <a:noFill/>
+          <a:ln>
+            <a:noFill/>
+          </a:ln>
+          <a:extLst>
+            <a:ext uri="{909E8E84-426E-40DD-AFC4-6F175D3DCCD1}">
+              <a14:hiddenFill xmlns:a14="http://schemas.microsoft.com/office/drawing/2010/main">
+                <a:solidFill>
+                  <a:srgbClr val="FFFFFF"/>
+                </a:solidFill>
+              </a14:hiddenFill>
+            </a:ext>
+            <a:ext uri="{91240B29-F687-4F45-9708-019B960494DF}">
+              <a14:hiddenLine xmlns:a14="http://schemas.microsoft.com/office/drawing/2010/main" w="9525">
+                <a:solidFill>
+                  <a:srgbClr val="000000"/>
+                </a:solidFill>
+                <a:miter lim="800000"/>
+                <a:headEnd/>
+                <a:tailEnd/>
+              </a14:hiddenLine>
+            </a:ext>
+          </a:extLst>
+        </p:spPr>
+        <p:txBody>
+          <a:bodyPr vert="horz" wrap="square" lIns="0" tIns="0" rIns="0" bIns="0" numCol="1" anchor="ctr" anchorCtr="0" compatLnSpc="1">
+            <a:prstTxWarp prst="textNoShape">
+              <a:avLst/>
+            </a:prstTxWarp>
+          </a:bodyPr>
+          <a:lstStyle>
+            <a:lvl1pPr algn="l" defTabSz="685800" rtl="0" eaLnBrk="0" fontAlgn="base" hangingPunct="0">
+              <a:lnSpc>
+                <a:spcPct val="90000"/>
+              </a:lnSpc>
+              <a:spcBef>
+                <a:spcPct val="0"/>
+              </a:spcBef>
+              <a:spcAft>
+                <a:spcPct val="0"/>
+              </a:spcAft>
+              <a:defRPr sz="3000" b="1" kern="1200">
+                <a:solidFill>
+                  <a:srgbClr val="00A5DF"/>
+                </a:solidFill>
+                <a:latin typeface="Effra"/>
+                <a:ea typeface="MS PGothic" pitchFamily="34" charset="-128"/>
+                <a:cs typeface="Effra"/>
+              </a:defRPr>
+            </a:lvl1pPr>
+            <a:lvl2pPr algn="l" defTabSz="685800" rtl="0" eaLnBrk="0" fontAlgn="base" hangingPunct="0">
+              <a:lnSpc>
+                <a:spcPct val="90000"/>
+              </a:lnSpc>
+              <a:spcBef>
+                <a:spcPct val="0"/>
+              </a:spcBef>
+              <a:spcAft>
+                <a:spcPct val="0"/>
+              </a:spcAft>
+              <a:defRPr sz="3000" b="1">
+                <a:solidFill>
+                  <a:srgbClr val="00A5DF"/>
+                </a:solidFill>
+                <a:latin typeface="Effra" charset="0"/>
+                <a:ea typeface="MS PGothic" pitchFamily="34" charset="-128"/>
+                <a:cs typeface="Effra" pitchFamily="34" charset="0"/>
+              </a:defRPr>
+            </a:lvl2pPr>
+            <a:lvl3pPr algn="l" defTabSz="685800" rtl="0" eaLnBrk="0" fontAlgn="base" hangingPunct="0">
+              <a:lnSpc>
+                <a:spcPct val="90000"/>
+              </a:lnSpc>
+              <a:spcBef>
+                <a:spcPct val="0"/>
+              </a:spcBef>
+              <a:spcAft>
+                <a:spcPct val="0"/>
+              </a:spcAft>
+              <a:defRPr sz="3000" b="1">
+                <a:solidFill>
+                  <a:srgbClr val="00A5DF"/>
+                </a:solidFill>
+                <a:latin typeface="Effra" charset="0"/>
+                <a:ea typeface="MS PGothic" pitchFamily="34" charset="-128"/>
+                <a:cs typeface="Effra" pitchFamily="34" charset="0"/>
+              </a:defRPr>
+            </a:lvl3pPr>
+            <a:lvl4pPr algn="l" defTabSz="685800" rtl="0" eaLnBrk="0" fontAlgn="base" hangingPunct="0">
+              <a:lnSpc>
+                <a:spcPct val="90000"/>
+              </a:lnSpc>
+              <a:spcBef>
+                <a:spcPct val="0"/>
+              </a:spcBef>
+              <a:spcAft>
+                <a:spcPct val="0"/>
+              </a:spcAft>
+              <a:defRPr sz="3000" b="1">
+                <a:solidFill>
+                  <a:srgbClr val="00A5DF"/>
+                </a:solidFill>
+                <a:latin typeface="Effra" charset="0"/>
+                <a:ea typeface="MS PGothic" pitchFamily="34" charset="-128"/>
+                <a:cs typeface="Effra" pitchFamily="34" charset="0"/>
+              </a:defRPr>
+            </a:lvl4pPr>
+            <a:lvl5pPr algn="l" defTabSz="685800" rtl="0" eaLnBrk="0" fontAlgn="base" hangingPunct="0">
+              <a:lnSpc>
+                <a:spcPct val="90000"/>
+              </a:lnSpc>
+              <a:spcBef>
+                <a:spcPct val="0"/>
+              </a:spcBef>
+              <a:spcAft>
+                <a:spcPct val="0"/>
+              </a:spcAft>
+              <a:defRPr sz="3000" b="1">
+                <a:solidFill>
+                  <a:srgbClr val="00A5DF"/>
+                </a:solidFill>
+                <a:latin typeface="Effra" charset="0"/>
+                <a:ea typeface="MS PGothic" pitchFamily="34" charset="-128"/>
+                <a:cs typeface="Effra" pitchFamily="34" charset="0"/>
+              </a:defRPr>
+            </a:lvl5pPr>
+            <a:lvl6pPr marL="457200" algn="l" defTabSz="685800" rtl="0" eaLnBrk="1" fontAlgn="base" hangingPunct="1">
+              <a:lnSpc>
+                <a:spcPct val="90000"/>
+              </a:lnSpc>
+              <a:spcBef>
+                <a:spcPct val="0"/>
+              </a:spcBef>
+              <a:spcAft>
+                <a:spcPct val="0"/>
+              </a:spcAft>
+              <a:defRPr sz="2500" b="1">
+                <a:solidFill>
+                  <a:schemeClr val="accent1"/>
+                </a:solidFill>
+                <a:latin typeface="Effra" charset="0"/>
+                <a:ea typeface="ＭＳ Ｐゴシック" charset="0"/>
+                <a:cs typeface="ＭＳ Ｐゴシック" charset="0"/>
+              </a:defRPr>
+            </a:lvl6pPr>
+            <a:lvl7pPr marL="914400" algn="l" defTabSz="685800" rtl="0" eaLnBrk="1" fontAlgn="base" hangingPunct="1">
+              <a:lnSpc>
+                <a:spcPct val="90000"/>
+              </a:lnSpc>
+              <a:spcBef>
+                <a:spcPct val="0"/>
+              </a:spcBef>
+              <a:spcAft>
+                <a:spcPct val="0"/>
+              </a:spcAft>
+              <a:defRPr sz="2500" b="1">
+                <a:solidFill>
+                  <a:schemeClr val="accent1"/>
+                </a:solidFill>
+                <a:latin typeface="Effra" charset="0"/>
+                <a:ea typeface="ＭＳ Ｐゴシック" charset="0"/>
+                <a:cs typeface="ＭＳ Ｐゴシック" charset="0"/>
+              </a:defRPr>
+            </a:lvl7pPr>
+            <a:lvl8pPr marL="1371600" algn="l" defTabSz="685800" rtl="0" eaLnBrk="1" fontAlgn="base" hangingPunct="1">
+              <a:lnSpc>
+                <a:spcPct val="90000"/>
+              </a:lnSpc>
+              <a:spcBef>
+                <a:spcPct val="0"/>
+              </a:spcBef>
+              <a:spcAft>
+                <a:spcPct val="0"/>
+              </a:spcAft>
+              <a:defRPr sz="2500" b="1">
+                <a:solidFill>
+                  <a:schemeClr val="accent1"/>
+                </a:solidFill>
+                <a:latin typeface="Effra" charset="0"/>
+                <a:ea typeface="ＭＳ Ｐゴシック" charset="0"/>
+                <a:cs typeface="ＭＳ Ｐゴシック" charset="0"/>
+              </a:defRPr>
+            </a:lvl8pPr>
+            <a:lvl9pPr marL="1828800" algn="l" defTabSz="685800" rtl="0" eaLnBrk="1" fontAlgn="base" hangingPunct="1">
+              <a:lnSpc>
+                <a:spcPct val="90000"/>
+              </a:lnSpc>
+              <a:spcBef>
+                <a:spcPct val="0"/>
+              </a:spcBef>
+              <a:spcAft>
+                <a:spcPct val="0"/>
+              </a:spcAft>
+              <a:defRPr sz="2500" b="1">
+                <a:solidFill>
+                  <a:schemeClr val="accent1"/>
+                </a:solidFill>
+                <a:latin typeface="Effra" charset="0"/>
+                <a:ea typeface="ＭＳ Ｐゴシック" charset="0"/>
+                <a:cs typeface="ＭＳ Ｐゴシック" charset="0"/>
+              </a:defRPr>
+            </a:lvl9pPr>
+          </a:lstStyle>
+          <a:p>
+            <a:pPr eaLnBrk="1" hangingPunct="1">
+              <a:lnSpc>
+                <a:spcPct val="110000"/>
+              </a:lnSpc>
+            </a:pPr>
+            <a:r>
+              <a:rPr lang="en-US" sz="1800" dirty="0">
+                <a:latin typeface="Effra" pitchFamily="34" charset="0"/>
+              </a:rPr>
+              <a:t>Contact</a:t>
+            </a:r>
+          </a:p>
+        </p:txBody>
+      </p:sp>
+    </p:spTree>
+    <p:extLst>
+      <p:ext uri="{BB962C8B-B14F-4D97-AF65-F5344CB8AC3E}">
+        <p14:creationId xmlns:p14="http://schemas.microsoft.com/office/powerpoint/2010/main" val="3638767675"/>
+      </p:ext>
+    </p:extLst>
+  </p:cSld>
+  <p:clrMapOvr>
+    <a:masterClrMapping/>
+  </p:clrMapOvr>
+</p:sld>
+</file>
+
+<file path=ppt/slides/slide21.xml><?xml version="1.0" encoding="utf-8"?>
+<p:sld xmlns:a="http://schemas.openxmlformats.org/drawingml/2006/main" xmlns:r="http://schemas.openxmlformats.org/officeDocument/2006/relationships" xmlns:p="http://schemas.openxmlformats.org/presentationml/2006/main">
+  <p:cSld>
+    <p:spTree>
+      <p:nvGrpSpPr>
+        <p:cNvPr id="1" name=""/>
+        <p:cNvGrpSpPr/>
+        <p:nvPr/>
+      </p:nvGrpSpPr>
+      <p:grpSpPr>
+        <a:xfrm>
+          <a:off x="0" y="0"/>
+          <a:ext cx="0" cy="0"/>
+          <a:chOff x="0" y="0"/>
+          <a:chExt cx="0" cy="0"/>
+        </a:xfrm>
+      </p:grpSpPr>
+      <p:sp>
+        <p:nvSpPr>
+          <p:cNvPr id="80898" name="Rectangle 4"/>
+          <p:cNvSpPr>
+            <a:spLocks noChangeArrowheads="1"/>
+          </p:cNvSpPr>
+          <p:nvPr/>
+        </p:nvSpPr>
+        <p:spPr bwMode="auto">
+          <a:xfrm>
+            <a:off x="655638" y="1122363"/>
+            <a:ext cx="2754985" cy="707886"/>
+          </a:xfrm>
+          <a:prstGeom prst="rect">
+            <a:avLst/>
+          </a:prstGeom>
+          <a:noFill/>
+          <a:ln>
+            <a:noFill/>
+          </a:ln>
+          <a:extLst>
+            <a:ext uri="{909E8E84-426E-40DD-AFC4-6F175D3DCCD1}">
+              <a14:hiddenFill xmlns:a14="http://schemas.microsoft.com/office/drawing/2010/main">
+                <a:solidFill>
+                  <a:srgbClr val="FFFFFF"/>
+                </a:solidFill>
+              </a14:hiddenFill>
+            </a:ext>
+            <a:ext uri="{91240B29-F687-4F45-9708-019B960494DF}">
+              <a14:hiddenLine xmlns:a14="http://schemas.microsoft.com/office/drawing/2010/main" w="9525">
+                <a:solidFill>
+                  <a:srgbClr val="000000"/>
+                </a:solidFill>
+                <a:miter lim="800000"/>
+                <a:headEnd/>
+                <a:tailEnd/>
+              </a14:hiddenLine>
+            </a:ext>
+          </a:extLst>
+        </p:spPr>
+        <p:txBody>
+          <a:bodyPr wrap="none">
+            <a:spAutoFit/>
+          </a:bodyPr>
+          <a:lstStyle>
+            <a:lvl1pPr>
+              <a:defRPr sz="1400">
+                <a:solidFill>
+                  <a:schemeClr val="tx1"/>
+                </a:solidFill>
+                <a:latin typeface="Effra" panose="020B0603020203020204" pitchFamily="34" charset="0"/>
+                <a:ea typeface="MS PGothic" panose="020B0600070205080204" pitchFamily="34" charset="-128"/>
+              </a:defRPr>
+            </a:lvl1pPr>
+            <a:lvl2pPr marL="742950" indent="-285750">
+              <a:defRPr sz="1400">
+                <a:solidFill>
+                  <a:schemeClr val="tx1"/>
+                </a:solidFill>
+                <a:latin typeface="Effra" panose="020B0603020203020204" pitchFamily="34" charset="0"/>
+                <a:ea typeface="MS PGothic" panose="020B0600070205080204" pitchFamily="34" charset="-128"/>
+              </a:defRPr>
+            </a:lvl2pPr>
+            <a:lvl3pPr marL="1143000" indent="-228600">
+              <a:defRPr sz="1400">
+                <a:solidFill>
+                  <a:schemeClr val="tx1"/>
+                </a:solidFill>
+                <a:latin typeface="Effra" panose="020B0603020203020204" pitchFamily="34" charset="0"/>
+                <a:ea typeface="MS PGothic" panose="020B0600070205080204" pitchFamily="34" charset="-128"/>
+              </a:defRPr>
+            </a:lvl3pPr>
+            <a:lvl4pPr marL="1600200" indent="-228600">
+              <a:defRPr sz="1400">
+                <a:solidFill>
+                  <a:schemeClr val="tx1"/>
+                </a:solidFill>
+                <a:latin typeface="Effra" panose="020B0603020203020204" pitchFamily="34" charset="0"/>
+                <a:ea typeface="MS PGothic" panose="020B0600070205080204" pitchFamily="34" charset="-128"/>
+              </a:defRPr>
+            </a:lvl4pPr>
+            <a:lvl5pPr marL="2057400" indent="-228600">
+              <a:defRPr sz="1400">
+                <a:solidFill>
+                  <a:schemeClr val="tx1"/>
+                </a:solidFill>
+                <a:latin typeface="Effra" panose="020B0603020203020204" pitchFamily="34" charset="0"/>
+                <a:ea typeface="MS PGothic" panose="020B0600070205080204" pitchFamily="34" charset="-128"/>
+              </a:defRPr>
+            </a:lvl5pPr>
+            <a:lvl6pPr marL="2514600" indent="-228600" defTabSz="712788" eaLnBrk="0" fontAlgn="base" hangingPunct="0">
+              <a:spcBef>
+                <a:spcPct val="0"/>
+              </a:spcBef>
+              <a:spcAft>
+                <a:spcPct val="0"/>
+              </a:spcAft>
+              <a:defRPr sz="1400">
+                <a:solidFill>
+                  <a:schemeClr val="tx1"/>
+                </a:solidFill>
+                <a:latin typeface="Effra" panose="020B0603020203020204" pitchFamily="34" charset="0"/>
+                <a:ea typeface="MS PGothic" panose="020B0600070205080204" pitchFamily="34" charset="-128"/>
+              </a:defRPr>
+            </a:lvl6pPr>
+            <a:lvl7pPr marL="2971800" indent="-228600" defTabSz="712788" eaLnBrk="0" fontAlgn="base" hangingPunct="0">
+              <a:spcBef>
+                <a:spcPct val="0"/>
+              </a:spcBef>
+              <a:spcAft>
+                <a:spcPct val="0"/>
+              </a:spcAft>
+              <a:defRPr sz="1400">
+                <a:solidFill>
+                  <a:schemeClr val="tx1"/>
+                </a:solidFill>
+                <a:latin typeface="Effra" panose="020B0603020203020204" pitchFamily="34" charset="0"/>
+                <a:ea typeface="MS PGothic" panose="020B0600070205080204" pitchFamily="34" charset="-128"/>
+              </a:defRPr>
+            </a:lvl7pPr>
+            <a:lvl8pPr marL="3429000" indent="-228600" defTabSz="712788" eaLnBrk="0" fontAlgn="base" hangingPunct="0">
+              <a:spcBef>
+                <a:spcPct val="0"/>
+              </a:spcBef>
+              <a:spcAft>
+                <a:spcPct val="0"/>
+              </a:spcAft>
+              <a:defRPr sz="1400">
+                <a:solidFill>
+                  <a:schemeClr val="tx1"/>
+                </a:solidFill>
+                <a:latin typeface="Effra" panose="020B0603020203020204" pitchFamily="34" charset="0"/>
+                <a:ea typeface="MS PGothic" panose="020B0600070205080204" pitchFamily="34" charset="-128"/>
+              </a:defRPr>
+            </a:lvl8pPr>
+            <a:lvl9pPr marL="3886200" indent="-228600" defTabSz="712788" eaLnBrk="0" fontAlgn="base" hangingPunct="0">
+              <a:spcBef>
+                <a:spcPct val="0"/>
+              </a:spcBef>
+              <a:spcAft>
+                <a:spcPct val="0"/>
+              </a:spcAft>
+              <a:defRPr sz="1400">
+                <a:solidFill>
+                  <a:schemeClr val="tx1"/>
+                </a:solidFill>
+                <a:latin typeface="Effra" panose="020B0603020203020204" pitchFamily="34" charset="0"/>
+                <a:ea typeface="MS PGothic" panose="020B0600070205080204" pitchFamily="34" charset="-128"/>
+              </a:defRPr>
+            </a:lvl9pPr>
+          </a:lstStyle>
+          <a:p>
+            <a:pPr eaLnBrk="1" hangingPunct="1"/>
+            <a:r>
+              <a:rPr lang="en-US" altLang="en-US" sz="4000" b="1" dirty="0">
+                <a:solidFill>
+                  <a:srgbClr val="FFFFFF"/>
+                </a:solidFill>
+                <a:latin typeface="Arial" panose="020B0604020202020204" pitchFamily="34" charset="0"/>
+                <a:cs typeface="Arial" panose="020B0604020202020204" pitchFamily="34" charset="0"/>
+              </a:rPr>
+              <a:t>Thank You</a:t>
+            </a:r>
+            <a:endParaRPr lang="en-US" altLang="en-US" sz="4000" dirty="0">
+              <a:latin typeface="Arial" panose="020B0604020202020204" pitchFamily="34" charset="0"/>
+              <a:cs typeface="Arial" panose="020B0604020202020204" pitchFamily="34" charset="0"/>
+            </a:endParaRPr>
+          </a:p>
+        </p:txBody>
+      </p:sp>
+      <p:sp>
+        <p:nvSpPr>
+          <p:cNvPr id="80899" name="Rectangle 5"/>
+          <p:cNvSpPr>
+            <a:spLocks noChangeArrowheads="1"/>
+          </p:cNvSpPr>
+          <p:nvPr/>
+        </p:nvSpPr>
+        <p:spPr bwMode="auto">
+          <a:xfrm>
+            <a:off x="655638" y="2282825"/>
+            <a:ext cx="2557462" cy="1816100"/>
+          </a:xfrm>
+          <a:prstGeom prst="rect">
+            <a:avLst/>
+          </a:prstGeom>
+          <a:noFill/>
+          <a:ln>
+            <a:noFill/>
+          </a:ln>
+          <a:extLst>
+            <a:ext uri="{909E8E84-426E-40DD-AFC4-6F175D3DCCD1}">
+              <a14:hiddenFill xmlns:a14="http://schemas.microsoft.com/office/drawing/2010/main">
+                <a:solidFill>
+                  <a:srgbClr val="FFFFFF"/>
+                </a:solidFill>
+              </a14:hiddenFill>
+            </a:ext>
+            <a:ext uri="{91240B29-F687-4F45-9708-019B960494DF}">
+              <a14:hiddenLine xmlns:a14="http://schemas.microsoft.com/office/drawing/2010/main" w="9525">
+                <a:solidFill>
+                  <a:srgbClr val="000000"/>
+                </a:solidFill>
+                <a:miter lim="800000"/>
+                <a:headEnd/>
+                <a:tailEnd/>
+              </a14:hiddenLine>
+            </a:ext>
+          </a:extLst>
+        </p:spPr>
+        <p:txBody>
+          <a:bodyPr>
+            <a:spAutoFit/>
+          </a:bodyPr>
+          <a:lstStyle>
+            <a:lvl1pPr>
+              <a:defRPr sz="1400">
+                <a:solidFill>
+                  <a:schemeClr val="tx1"/>
+                </a:solidFill>
+                <a:latin typeface="Effra" panose="020B0603020203020204" pitchFamily="34" charset="0"/>
+                <a:ea typeface="MS PGothic" panose="020B0600070205080204" pitchFamily="34" charset="-128"/>
+              </a:defRPr>
+            </a:lvl1pPr>
+            <a:lvl2pPr marL="742950" indent="-285750">
+              <a:defRPr sz="1400">
+                <a:solidFill>
+                  <a:schemeClr val="tx1"/>
+                </a:solidFill>
+                <a:latin typeface="Effra" panose="020B0603020203020204" pitchFamily="34" charset="0"/>
+                <a:ea typeface="MS PGothic" panose="020B0600070205080204" pitchFamily="34" charset="-128"/>
+              </a:defRPr>
+            </a:lvl2pPr>
+            <a:lvl3pPr marL="1143000" indent="-228600">
+              <a:defRPr sz="1400">
+                <a:solidFill>
+                  <a:schemeClr val="tx1"/>
+                </a:solidFill>
+                <a:latin typeface="Effra" panose="020B0603020203020204" pitchFamily="34" charset="0"/>
+                <a:ea typeface="MS PGothic" panose="020B0600070205080204" pitchFamily="34" charset="-128"/>
+              </a:defRPr>
+            </a:lvl3pPr>
+            <a:lvl4pPr marL="1600200" indent="-228600">
+              <a:defRPr sz="1400">
+                <a:solidFill>
+                  <a:schemeClr val="tx1"/>
+                </a:solidFill>
+                <a:latin typeface="Effra" panose="020B0603020203020204" pitchFamily="34" charset="0"/>
+                <a:ea typeface="MS PGothic" panose="020B0600070205080204" pitchFamily="34" charset="-128"/>
+              </a:defRPr>
+            </a:lvl4pPr>
+            <a:lvl5pPr marL="2057400" indent="-228600">
+              <a:defRPr sz="1400">
+                <a:solidFill>
+                  <a:schemeClr val="tx1"/>
+                </a:solidFill>
+                <a:latin typeface="Effra" panose="020B0603020203020204" pitchFamily="34" charset="0"/>
+                <a:ea typeface="MS PGothic" panose="020B0600070205080204" pitchFamily="34" charset="-128"/>
+              </a:defRPr>
+            </a:lvl5pPr>
+            <a:lvl6pPr marL="2514600" indent="-228600" defTabSz="712788" eaLnBrk="0" fontAlgn="base" hangingPunct="0">
+              <a:spcBef>
+                <a:spcPct val="0"/>
+              </a:spcBef>
+              <a:spcAft>
+                <a:spcPct val="0"/>
+              </a:spcAft>
+              <a:defRPr sz="1400">
+                <a:solidFill>
+                  <a:schemeClr val="tx1"/>
+                </a:solidFill>
+                <a:latin typeface="Effra" panose="020B0603020203020204" pitchFamily="34" charset="0"/>
+                <a:ea typeface="MS PGothic" panose="020B0600070205080204" pitchFamily="34" charset="-128"/>
+              </a:defRPr>
+            </a:lvl6pPr>
+            <a:lvl7pPr marL="2971800" indent="-228600" defTabSz="712788" eaLnBrk="0" fontAlgn="base" hangingPunct="0">
+              <a:spcBef>
+                <a:spcPct val="0"/>
+              </a:spcBef>
+              <a:spcAft>
+                <a:spcPct val="0"/>
+              </a:spcAft>
+              <a:defRPr sz="1400">
+                <a:solidFill>
+                  <a:schemeClr val="tx1"/>
+                </a:solidFill>
+                <a:latin typeface="Effra" panose="020B0603020203020204" pitchFamily="34" charset="0"/>
+                <a:ea typeface="MS PGothic" panose="020B0600070205080204" pitchFamily="34" charset="-128"/>
+              </a:defRPr>
+            </a:lvl7pPr>
+            <a:lvl8pPr marL="3429000" indent="-228600" defTabSz="712788" eaLnBrk="0" fontAlgn="base" hangingPunct="0">
+              <a:spcBef>
+                <a:spcPct val="0"/>
+              </a:spcBef>
+              <a:spcAft>
+                <a:spcPct val="0"/>
+              </a:spcAft>
+              <a:defRPr sz="1400">
+                <a:solidFill>
+                  <a:schemeClr val="tx1"/>
+                </a:solidFill>
+                <a:latin typeface="Effra" panose="020B0603020203020204" pitchFamily="34" charset="0"/>
+                <a:ea typeface="MS PGothic" panose="020B0600070205080204" pitchFamily="34" charset="-128"/>
+              </a:defRPr>
+            </a:lvl8pPr>
+            <a:lvl9pPr marL="3886200" indent="-228600" defTabSz="712788" eaLnBrk="0" fontAlgn="base" hangingPunct="0">
+              <a:spcBef>
+                <a:spcPct val="0"/>
+              </a:spcBef>
+              <a:spcAft>
+                <a:spcPct val="0"/>
+              </a:spcAft>
+              <a:defRPr sz="1400">
+                <a:solidFill>
+                  <a:schemeClr val="tx1"/>
+                </a:solidFill>
+                <a:latin typeface="Effra" panose="020B0603020203020204" pitchFamily="34" charset="0"/>
+                <a:ea typeface="MS PGothic" panose="020B0600070205080204" pitchFamily="34" charset="-128"/>
+              </a:defRPr>
+            </a:lvl9pPr>
+          </a:lstStyle>
+          <a:p>
+            <a:pPr eaLnBrk="1" hangingPunct="1"/>
+            <a:r>
+              <a:rPr lang="en-US" altLang="en-US" sz="1600" dirty="0">
+                <a:solidFill>
+                  <a:schemeClr val="bg1"/>
+                </a:solidFill>
+                <a:latin typeface="Arial" panose="020B0604020202020204" pitchFamily="34" charset="0"/>
+                <a:cs typeface="Arial" panose="020B0604020202020204" pitchFamily="34" charset="0"/>
+              </a:rPr>
+              <a:t>Merci</a:t>
+            </a:r>
+          </a:p>
+          <a:p>
+            <a:pPr eaLnBrk="1" hangingPunct="1"/>
+            <a:r>
+              <a:rPr lang="en-US" altLang="en-US" sz="1600" dirty="0">
+                <a:solidFill>
+                  <a:schemeClr val="bg1"/>
+                </a:solidFill>
+                <a:latin typeface="Arial" panose="020B0604020202020204" pitchFamily="34" charset="0"/>
+                <a:cs typeface="Arial" panose="020B0604020202020204" pitchFamily="34" charset="0"/>
+              </a:rPr>
+              <a:t>Dank u </a:t>
+            </a:r>
+            <a:r>
+              <a:rPr lang="en-US" altLang="en-US" sz="1600" dirty="0" err="1">
+                <a:solidFill>
+                  <a:schemeClr val="bg1"/>
+                </a:solidFill>
+                <a:latin typeface="Arial" panose="020B0604020202020204" pitchFamily="34" charset="0"/>
+                <a:cs typeface="Arial" panose="020B0604020202020204" pitchFamily="34" charset="0"/>
+              </a:rPr>
+              <a:t>wel</a:t>
+            </a:r>
+            <a:endParaRPr lang="en-US" altLang="en-US" sz="1600" dirty="0">
+              <a:solidFill>
+                <a:schemeClr val="bg1"/>
+              </a:solidFill>
+              <a:latin typeface="Arial" panose="020B0604020202020204" pitchFamily="34" charset="0"/>
+              <a:cs typeface="Arial" panose="020B0604020202020204" pitchFamily="34" charset="0"/>
+            </a:endParaRPr>
+          </a:p>
+          <a:p>
+            <a:pPr eaLnBrk="1" hangingPunct="1"/>
+            <a:r>
+              <a:rPr lang="en-US" altLang="en-US" sz="1600" dirty="0" err="1">
+                <a:solidFill>
+                  <a:schemeClr val="bg1"/>
+                </a:solidFill>
+                <a:latin typeface="Arial" panose="020B0604020202020204" pitchFamily="34" charset="0"/>
+                <a:cs typeface="Arial" panose="020B0604020202020204" pitchFamily="34" charset="0"/>
+              </a:rPr>
+              <a:t>Danke</a:t>
+            </a:r>
+            <a:endParaRPr lang="en-US" altLang="en-US" sz="1600" dirty="0">
+              <a:solidFill>
+                <a:schemeClr val="bg1"/>
+              </a:solidFill>
+              <a:latin typeface="Arial" panose="020B0604020202020204" pitchFamily="34" charset="0"/>
+              <a:cs typeface="Arial" panose="020B0604020202020204" pitchFamily="34" charset="0"/>
+            </a:endParaRPr>
+          </a:p>
+          <a:p>
+            <a:pPr eaLnBrk="1" hangingPunct="1"/>
+            <a:r>
+              <a:rPr lang="en-US" altLang="en-US" sz="1600" dirty="0">
+                <a:solidFill>
+                  <a:schemeClr val="bg1"/>
+                </a:solidFill>
+                <a:latin typeface="Arial" panose="020B0604020202020204" pitchFamily="34" charset="0"/>
+                <a:cs typeface="Arial" panose="020B0604020202020204" pitchFamily="34" charset="0"/>
+              </a:rPr>
+              <a:t>Gracias</a:t>
+            </a:r>
+          </a:p>
+          <a:p>
+            <a:pPr eaLnBrk="1" hangingPunct="1"/>
+            <a:r>
+              <a:rPr lang="ja-JP" altLang="en-US" sz="1600" dirty="0">
+                <a:solidFill>
+                  <a:schemeClr val="bg1"/>
+                </a:solidFill>
+                <a:latin typeface="Arial" panose="020B0604020202020204" pitchFamily="34" charset="0"/>
+                <a:cs typeface="Arial" panose="020B0604020202020204" pitchFamily="34" charset="0"/>
+              </a:rPr>
+              <a:t>ありがとうございました</a:t>
+            </a:r>
+            <a:endParaRPr lang="en-US" altLang="ja-JP" sz="1600" dirty="0">
+              <a:solidFill>
+                <a:schemeClr val="bg1"/>
+              </a:solidFill>
+              <a:latin typeface="Arial" panose="020B0604020202020204" pitchFamily="34" charset="0"/>
+              <a:cs typeface="Arial" panose="020B0604020202020204" pitchFamily="34" charset="0"/>
+            </a:endParaRPr>
+          </a:p>
+          <a:p>
+            <a:pPr eaLnBrk="1" hangingPunct="1"/>
+            <a:r>
+              <a:rPr lang="ar-SA" altLang="en-US" sz="1600" b="1" dirty="0">
+                <a:solidFill>
+                  <a:schemeClr val="bg1"/>
+                </a:solidFill>
+                <a:latin typeface="Arial" panose="020B0604020202020204" pitchFamily="34" charset="0"/>
+                <a:cs typeface="Arial" panose="020B0604020202020204" pitchFamily="34" charset="0"/>
+              </a:rPr>
+              <a:t>شكرا</a:t>
+            </a:r>
+            <a:endParaRPr lang="en-US" altLang="en-US" sz="1600" b="1" dirty="0">
+              <a:solidFill>
+                <a:schemeClr val="bg1"/>
+              </a:solidFill>
+              <a:latin typeface="Arial" panose="020B0604020202020204" pitchFamily="34" charset="0"/>
+              <a:cs typeface="Arial" panose="020B0604020202020204" pitchFamily="34" charset="0"/>
+            </a:endParaRPr>
+          </a:p>
+          <a:p>
+            <a:pPr eaLnBrk="1" hangingPunct="1"/>
+            <a:endParaRPr lang="en-US" altLang="en-US" sz="1600" dirty="0">
+              <a:solidFill>
+                <a:schemeClr val="bg1"/>
+              </a:solidFill>
+              <a:latin typeface="Arial" panose="020B0604020202020204" pitchFamily="34" charset="0"/>
+              <a:cs typeface="Arial" panose="020B0604020202020204" pitchFamily="34" charset="0"/>
+            </a:endParaRPr>
+          </a:p>
+        </p:txBody>
+      </p:sp>
+      <p:sp>
+        <p:nvSpPr>
+          <p:cNvPr id="2" name="Slide Number Placeholder 1">
+            <a:extLst>
+              <a:ext uri="{FF2B5EF4-FFF2-40B4-BE49-F238E27FC236}">
+                <a16:creationId xmlns:a16="http://schemas.microsoft.com/office/drawing/2014/main" id="{1E2AE2C9-144D-4638-B388-2744DB6B7853}"/>
+              </a:ext>
+            </a:extLst>
+          </p:cNvPr>
+          <p:cNvSpPr>
+            <a:spLocks noGrp="1"/>
+          </p:cNvSpPr>
+          <p:nvPr>
+            <p:ph type="sldNum" sz="quarter" idx="10"/>
+          </p:nvPr>
+        </p:nvSpPr>
+        <p:spPr/>
+        <p:txBody>
+          <a:bodyPr/>
+          <a:lstStyle/>
+          <a:p>
+            <a:fld id="{82DD3993-69B2-42D4-A33C-1B42906A94F6}" type="slidenum">
+              <a:rPr lang="en-GB" altLang="en-US" smtClean="0"/>
+              <a:pPr/>
+              <a:t>21</a:t>
+            </a:fld>
+            <a:endParaRPr lang="en-GB" altLang="en-US"/>
+          </a:p>
+        </p:txBody>
+      </p:sp>
+    </p:spTree>
+    <p:extLst>
+      <p:ext uri="{BB962C8B-B14F-4D97-AF65-F5344CB8AC3E}">
+        <p14:creationId xmlns:p14="http://schemas.microsoft.com/office/powerpoint/2010/main" val="1995908282"/>
       </p:ext>
     </p:extLst>
   </p:cSld>
@@ -38215,7 +40069,7 @@
           <p:nvPr>
             <p:extLst>
               <p:ext uri="{D42A27DB-BD31-4B8C-83A1-F6EECF244321}">
-                <p14:modId xmlns:p14="http://schemas.microsoft.com/office/powerpoint/2010/main" val="1567092569"/>
+                <p14:modId xmlns:p14="http://schemas.microsoft.com/office/powerpoint/2010/main" val="859087864"/>
               </p:ext>
             </p:extLst>
           </p:nvPr>
@@ -38325,7 +40179,7 @@
                       <a:pPr algn="ctr"/>
                       <a:r>
                         <a:rPr lang="en-US" dirty="0"/>
-                        <a:t>25-Aug-2026</a:t>
+                        <a:t>26-Aug-2026</a:t>
                       </a:r>
                     </a:p>
                   </a:txBody>
@@ -40745,45 +42599,6 @@
           </a:prstGeom>
         </p:spPr>
       </p:pic>
-      <p:sp>
-        <p:nvSpPr>
-          <p:cNvPr id="3" name="TextBox 2">
-            <a:extLst>
-              <a:ext uri="{FF2B5EF4-FFF2-40B4-BE49-F238E27FC236}">
-                <a16:creationId xmlns:a16="http://schemas.microsoft.com/office/drawing/2014/main" id="{B81FF75A-05C9-DF48-736C-3E8B23D8E0CF}"/>
-              </a:ext>
-            </a:extLst>
-          </p:cNvPr>
-          <p:cNvSpPr txBox="1"/>
-          <p:nvPr/>
-        </p:nvSpPr>
-        <p:spPr>
-          <a:xfrm>
-            <a:off x="481402" y="4788555"/>
-            <a:ext cx="8424604" cy="523220"/>
-          </a:xfrm>
-          <a:prstGeom prst="rect">
-            <a:avLst/>
-          </a:prstGeom>
-          <a:noFill/>
-        </p:spPr>
-        <p:txBody>
-          <a:bodyPr wrap="square">
-            <a:spAutoFit/>
-          </a:bodyPr>
-          <a:lstStyle/>
-          <a:p>
-            <a:r>
-              <a:rPr lang="en-US" dirty="0">
-                <a:solidFill>
-                  <a:srgbClr val="00B0F0"/>
-                </a:solidFill>
-              </a:rPr>
-              <a:t>For the Engine Manual link, only tasks with INFORMATION CODE "-3xx" are fetched, and cautions are extracted from those task pages.</a:t>
-            </a:r>
-          </a:p>
-        </p:txBody>
-      </p:sp>
     </p:spTree>
     <p:extLst>
       <p:ext uri="{BB962C8B-B14F-4D97-AF65-F5344CB8AC3E}">
@@ -41992,12 +43807,22 @@
 </file>
 
 <file path=customXml/item1.xml><?xml version="1.0" encoding="utf-8"?>
-<?mso-contentType ?>
-<FormTemplates xmlns="http://schemas.microsoft.com/sharepoint/v3/contenttype/forms">
-  <Display>DocumentLibraryForm</Display>
-  <Edit>DocumentLibraryForm</Edit>
-  <New>DocumentLibraryForm</New>
-</FormTemplates>
+<p:properties xmlns:p="http://schemas.microsoft.com/office/2006/metadata/properties" xmlns:xsi="http://www.w3.org/2001/XMLSchema-instance" xmlns:pc="http://schemas.microsoft.com/office/infopath/2007/PartnerControls">
+  <documentManagement>
+    <TaxCatchAll xmlns="077667ae-fd08-4bd8-a603-c9f8c202c5e0">
+      <Value>2720</Value>
+    </TaxCatchAll>
+    <KpiDescription xmlns="http://schemas.microsoft.com/sharepoint/v3" xsi:nil="true"/>
+    <DocumentTypeTaxHTField0 xmlns="2613b0ce-4e5a-4068-84c6-4aae3ccc9c8a">
+      <Terms xmlns="http://schemas.microsoft.com/office/infopath/2007/PartnerControls">
+        <TermInfo xmlns="http://schemas.microsoft.com/office/infopath/2007/PartnerControls">
+          <TermName xmlns="http://schemas.microsoft.com/office/infopath/2007/PartnerControls">Presentation</TermName>
+          <TermId xmlns="http://schemas.microsoft.com/office/infopath/2007/PartnerControls">c7776749-3f71-458e-9ba5-93d6c492bea1</TermId>
+        </TermInfo>
+      </Terms>
+    </DocumentTypeTaxHTField0>
+  </documentManagement>
+</p:properties>
 </file>
 
 <file path=customXml/item2.xml><?xml version="1.0" encoding="utf-8"?>
@@ -42159,28 +43984,28 @@
 </file>
 
 <file path=customXml/item3.xml><?xml version="1.0" encoding="utf-8"?>
-<p:properties xmlns:p="http://schemas.microsoft.com/office/2006/metadata/properties" xmlns:xsi="http://www.w3.org/2001/XMLSchema-instance" xmlns:pc="http://schemas.microsoft.com/office/infopath/2007/PartnerControls">
-  <documentManagement>
-    <TaxCatchAll xmlns="077667ae-fd08-4bd8-a603-c9f8c202c5e0">
-      <Value>2720</Value>
-    </TaxCatchAll>
-    <KpiDescription xmlns="http://schemas.microsoft.com/sharepoint/v3" xsi:nil="true"/>
-    <DocumentTypeTaxHTField0 xmlns="2613b0ce-4e5a-4068-84c6-4aae3ccc9c8a">
-      <Terms xmlns="http://schemas.microsoft.com/office/infopath/2007/PartnerControls">
-        <TermInfo xmlns="http://schemas.microsoft.com/office/infopath/2007/PartnerControls">
-          <TermName xmlns="http://schemas.microsoft.com/office/infopath/2007/PartnerControls">Presentation</TermName>
-          <TermId xmlns="http://schemas.microsoft.com/office/infopath/2007/PartnerControls">c7776749-3f71-458e-9ba5-93d6c492bea1</TermId>
-        </TermInfo>
-      </Terms>
-    </DocumentTypeTaxHTField0>
-  </documentManagement>
-</p:properties>
+<?mso-contentType ?>
+<FormTemplates xmlns="http://schemas.microsoft.com/sharepoint/v3/contenttype/forms">
+  <Display>DocumentLibraryForm</Display>
+  <Edit>DocumentLibraryForm</Edit>
+  <New>DocumentLibraryForm</New>
+</FormTemplates>
 </file>
 
 <file path=customXml/itemProps1.xml><?xml version="1.0" encoding="utf-8"?>
-<ds:datastoreItem xmlns:ds="http://schemas.openxmlformats.org/officeDocument/2006/customXml" ds:itemID="{EC84B35E-1715-4D43-A2FB-C60A34588830}">
+<ds:datastoreItem xmlns:ds="http://schemas.openxmlformats.org/officeDocument/2006/customXml" ds:itemID="{05FFBBF1-4683-4EE9-8FE4-EED661D9A09E}">
   <ds:schemaRefs>
-    <ds:schemaRef ds:uri="http://schemas.microsoft.com/sharepoint/v3/contenttype/forms"/>
+    <ds:schemaRef ds:uri="http://schemas.microsoft.com/office/2006/metadata/properties"/>
+    <ds:schemaRef ds:uri="http://www.w3.org/XML/1998/namespace"/>
+    <ds:schemaRef ds:uri="http://purl.org/dc/terms/"/>
+    <ds:schemaRef ds:uri="http://purl.org/dc/dcmitype/"/>
+    <ds:schemaRef ds:uri="http://schemas.microsoft.com/sharepoint/v3"/>
+    <ds:schemaRef ds:uri="077667ae-fd08-4bd8-a603-c9f8c202c5e0"/>
+    <ds:schemaRef ds:uri="2613b0ce-4e5a-4068-84c6-4aae3ccc9c8a"/>
+    <ds:schemaRef ds:uri="http://schemas.microsoft.com/office/2006/documentManagement/types"/>
+    <ds:schemaRef ds:uri="http://schemas.microsoft.com/office/infopath/2007/PartnerControls"/>
+    <ds:schemaRef ds:uri="http://schemas.openxmlformats.org/package/2006/metadata/core-properties"/>
+    <ds:schemaRef ds:uri="http://purl.org/dc/elements/1.1/"/>
   </ds:schemaRefs>
 </ds:datastoreItem>
 </file>
@@ -42206,19 +44031,9 @@
 </file>
 
 <file path=customXml/itemProps3.xml><?xml version="1.0" encoding="utf-8"?>
-<ds:datastoreItem xmlns:ds="http://schemas.openxmlformats.org/officeDocument/2006/customXml" ds:itemID="{05FFBBF1-4683-4EE9-8FE4-EED661D9A09E}">
+<ds:datastoreItem xmlns:ds="http://schemas.openxmlformats.org/officeDocument/2006/customXml" ds:itemID="{EC84B35E-1715-4D43-A2FB-C60A34588830}">
   <ds:schemaRefs>
-    <ds:schemaRef ds:uri="http://schemas.microsoft.com/office/2006/metadata/properties"/>
-    <ds:schemaRef ds:uri="http://www.w3.org/XML/1998/namespace"/>
-    <ds:schemaRef ds:uri="http://purl.org/dc/terms/"/>
-    <ds:schemaRef ds:uri="http://purl.org/dc/dcmitype/"/>
-    <ds:schemaRef ds:uri="http://schemas.microsoft.com/sharepoint/v3"/>
-    <ds:schemaRef ds:uri="077667ae-fd08-4bd8-a603-c9f8c202c5e0"/>
-    <ds:schemaRef ds:uri="2613b0ce-4e5a-4068-84c6-4aae3ccc9c8a"/>
-    <ds:schemaRef ds:uri="http://schemas.microsoft.com/office/2006/documentManagement/types"/>
-    <ds:schemaRef ds:uri="http://schemas.microsoft.com/office/infopath/2007/PartnerControls"/>
-    <ds:schemaRef ds:uri="http://schemas.openxmlformats.org/package/2006/metadata/core-properties"/>
-    <ds:schemaRef ds:uri="http://purl.org/dc/elements/1.1/"/>
+    <ds:schemaRef ds:uri="http://schemas.microsoft.com/sharepoint/v3/contenttype/forms"/>
   </ds:schemaRefs>
 </ds:datastoreItem>
 </file>
</xml_diff>

<commit_message>
Fixed ppt & pdf
</commit_message>
<xml_diff>
--- a/ExtractCautionsForEM/bin/Debug/bin/ExtractCautionsFromEngineManualTool.pptx
+++ b/ExtractCautionsForEM/bin/Debug/bin/ExtractCautionsFromEngineManualTool.pptx
@@ -350,7 +350,7 @@
               <a:pPr>
                 <a:defRPr/>
               </a:pPr>
-              <a:t>8/25/2026</a:t>
+              <a:t>8/28/2026</a:t>
             </a:fld>
             <a:endParaRPr lang="en-GB" dirty="0"/>
           </a:p>
@@ -568,7 +568,7 @@
               <a:pPr>
                 <a:defRPr/>
               </a:pPr>
-              <a:t>8/25/2026</a:t>
+              <a:t>8/28/2026</a:t>
             </a:fld>
             <a:endParaRPr lang="en-GB" dirty="0"/>
           </a:p>
@@ -3305,7 +3305,7 @@
               <a:pPr eaLnBrk="1" hangingPunct="1">
                 <a:defRPr/>
               </a:pPr>
-              <a:t>8/25/2026</a:t>
+              <a:t>8/28/2026</a:t>
             </a:fld>
             <a:endParaRPr lang="en-GB" dirty="0">
               <a:solidFill>
@@ -3739,7 +3739,7 @@
               <a:pPr eaLnBrk="1" hangingPunct="1">
                 <a:defRPr/>
               </a:pPr>
-              <a:t>8/25/2026</a:t>
+              <a:t>8/28/2026</a:t>
             </a:fld>
             <a:endParaRPr lang="en-GB" dirty="0">
               <a:solidFill>
@@ -4197,7 +4197,7 @@
               <a:pPr eaLnBrk="1" hangingPunct="1">
                 <a:defRPr/>
               </a:pPr>
-              <a:t>8/25/2026</a:t>
+              <a:t>8/28/2026</a:t>
             </a:fld>
             <a:endParaRPr lang="en-GB" dirty="0">
               <a:solidFill>
@@ -4627,7 +4627,7 @@
               <a:pPr eaLnBrk="1" hangingPunct="1">
                 <a:defRPr/>
               </a:pPr>
-              <a:t>8/25/2026</a:t>
+              <a:t>8/28/2026</a:t>
             </a:fld>
             <a:endParaRPr lang="en-GB" dirty="0">
               <a:solidFill>
@@ -5234,7 +5234,7 @@
               <a:pPr eaLnBrk="1" hangingPunct="1">
                 <a:defRPr/>
               </a:pPr>
-              <a:t>8/25/2026</a:t>
+              <a:t>8/28/2026</a:t>
             </a:fld>
             <a:endParaRPr lang="en-GB" dirty="0">
               <a:solidFill>
@@ -8646,7 +8646,7 @@
               <a:pPr eaLnBrk="1" hangingPunct="1">
                 <a:defRPr/>
               </a:pPr>
-              <a:t>8/25/2026</a:t>
+              <a:t>8/28/2026</a:t>
             </a:fld>
             <a:endParaRPr lang="en-GB" dirty="0">
               <a:solidFill>
@@ -9461,7 +9461,7 @@
               <a:pPr eaLnBrk="1" hangingPunct="1">
                 <a:defRPr/>
               </a:pPr>
-              <a:t>8/25/2026</a:t>
+              <a:t>8/28/2026</a:t>
             </a:fld>
             <a:endParaRPr lang="en-GB" dirty="0">
               <a:solidFill>
@@ -10282,7 +10282,7 @@
               <a:pPr eaLnBrk="1" hangingPunct="1">
                 <a:defRPr/>
               </a:pPr>
-              <a:t>8/25/2026</a:t>
+              <a:t>8/28/2026</a:t>
             </a:fld>
             <a:endParaRPr lang="en-GB" dirty="0">
               <a:solidFill>
@@ -12134,7 +12134,7 @@
               <a:pPr eaLnBrk="1" hangingPunct="1">
                 <a:defRPr/>
               </a:pPr>
-              <a:t>8/25/2026</a:t>
+              <a:t>8/28/2026</a:t>
             </a:fld>
             <a:endParaRPr lang="en-GB" dirty="0">
               <a:solidFill>
@@ -12655,7 +12655,7 @@
               <a:pPr eaLnBrk="1" hangingPunct="1">
                 <a:defRPr/>
               </a:pPr>
-              <a:t>8/25/2026</a:t>
+              <a:t>8/28/2026</a:t>
             </a:fld>
             <a:endParaRPr lang="en-GB" dirty="0">
               <a:solidFill>
@@ -13177,7 +13177,7 @@
               <a:pPr eaLnBrk="1" hangingPunct="1">
                 <a:defRPr/>
               </a:pPr>
-              <a:t>8/25/2026</a:t>
+              <a:t>8/28/2026</a:t>
             </a:fld>
             <a:endParaRPr lang="en-GB" dirty="0">
               <a:solidFill>
@@ -14805,7 +14805,7 @@
               <a:pPr eaLnBrk="1" hangingPunct="1">
                 <a:defRPr/>
               </a:pPr>
-              <a:t>8/25/2026</a:t>
+              <a:t>8/28/2026</a:t>
             </a:fld>
             <a:endParaRPr lang="en-GB" dirty="0">
               <a:solidFill>
@@ -17321,7 +17321,7 @@
               <a:pPr eaLnBrk="1" hangingPunct="1">
                 <a:defRPr/>
               </a:pPr>
-              <a:t>8/25/2026</a:t>
+              <a:t>8/28/2026</a:t>
             </a:fld>
             <a:endParaRPr lang="en-GB" dirty="0">
               <a:solidFill>
@@ -17899,7 +17899,7 @@
               <a:pPr eaLnBrk="1" hangingPunct="1">
                 <a:defRPr/>
               </a:pPr>
-              <a:t>8/25/2026</a:t>
+              <a:t>8/28/2026</a:t>
             </a:fld>
             <a:endParaRPr lang="en-GB" dirty="0">
               <a:solidFill>
@@ -18614,7 +18614,7 @@
               <a:pPr eaLnBrk="1" hangingPunct="1">
                 <a:defRPr/>
               </a:pPr>
-              <a:t>8/25/2026</a:t>
+              <a:t>8/28/2026</a:t>
             </a:fld>
             <a:endParaRPr lang="en-GB" dirty="0">
               <a:solidFill>
@@ -19326,7 +19326,7 @@
               <a:pPr eaLnBrk="1" hangingPunct="1">
                 <a:defRPr/>
               </a:pPr>
-              <a:t>8/25/2026</a:t>
+              <a:t>8/28/2026</a:t>
             </a:fld>
             <a:endParaRPr lang="en-GB" dirty="0">
               <a:solidFill>
@@ -19760,7 +19760,7 @@
               <a:pPr eaLnBrk="1" hangingPunct="1">
                 <a:defRPr/>
               </a:pPr>
-              <a:t>8/25/2026</a:t>
+              <a:t>8/28/2026</a:t>
             </a:fld>
             <a:endParaRPr lang="en-GB" dirty="0">
               <a:solidFill>
@@ -20218,7 +20218,7 @@
               <a:pPr eaLnBrk="1" hangingPunct="1">
                 <a:defRPr/>
               </a:pPr>
-              <a:t>8/25/2026</a:t>
+              <a:t>8/28/2026</a:t>
             </a:fld>
             <a:endParaRPr lang="en-GB" dirty="0">
               <a:solidFill>
@@ -21831,7 +21831,7 @@
               <a:pPr eaLnBrk="1" hangingPunct="1">
                 <a:defRPr/>
               </a:pPr>
-              <a:t>8/25/2026</a:t>
+              <a:t>8/28/2026</a:t>
             </a:fld>
             <a:endParaRPr lang="en-GB" dirty="0">
               <a:solidFill>
@@ -27452,7 +27452,7 @@
               <a:pPr eaLnBrk="1" hangingPunct="1">
                 <a:defRPr/>
               </a:pPr>
-              <a:t>8/25/2026</a:t>
+              <a:t>8/28/2026</a:t>
             </a:fld>
             <a:endParaRPr lang="en-GB" dirty="0">
               <a:solidFill>
@@ -29968,7 +29968,7 @@
               <a:pPr eaLnBrk="1" hangingPunct="1">
                 <a:defRPr/>
               </a:pPr>
-              <a:t>8/25/2026</a:t>
+              <a:t>8/28/2026</a:t>
             </a:fld>
             <a:endParaRPr lang="en-GB" dirty="0">
               <a:solidFill>
@@ -30546,7 +30546,7 @@
               <a:pPr eaLnBrk="1" hangingPunct="1">
                 <a:defRPr/>
               </a:pPr>
-              <a:t>8/25/2026</a:t>
+              <a:t>8/28/2026</a:t>
             </a:fld>
             <a:endParaRPr lang="en-GB" dirty="0">
               <a:solidFill>
@@ -31261,7 +31261,7 @@
               <a:pPr eaLnBrk="1" hangingPunct="1">
                 <a:defRPr/>
               </a:pPr>
-              <a:t>8/25/2026</a:t>
+              <a:t>8/28/2026</a:t>
             </a:fld>
             <a:endParaRPr lang="en-GB" dirty="0">
               <a:solidFill>
@@ -33562,7 +33562,15 @@
             </a:pPr>
             <a:r>
               <a:rPr lang="en-US" altLang="ja-JP" sz="2800" b="1" dirty="0"/>
-              <a:t>PW1100G Inspection Task_Caution Extraction Tool</a:t>
+              <a:t>PW1100G </a:t>
+            </a:r>
+            <a:r>
+              <a:rPr lang="en-US" altLang="ja-JP" sz="2800" b="1" dirty="0" err="1"/>
+              <a:t>MANUAL_CautionS</a:t>
+            </a:r>
+            <a:r>
+              <a:rPr lang="en-US" altLang="ja-JP" sz="2800" b="1" dirty="0"/>
+              <a:t> Extraction Tool</a:t>
             </a:r>
             <a:endParaRPr lang="en-GB" altLang="en-US" sz="1800" b="1" dirty="0">
               <a:latin typeface="Arial" panose="020B0604020202020204" pitchFamily="34" charset="0"/>
@@ -33651,7 +33659,7 @@
                   <a:schemeClr val="bg1"/>
                 </a:solidFill>
               </a:rPr>
-              <a:t>Last Update : 26-August-26</a:t>
+              <a:t>Last Update : 28-August-26</a:t>
             </a:r>
           </a:p>
         </p:txBody>
@@ -35395,36 +35403,6 @@
           </a:prstGeom>
         </p:spPr>
       </p:pic>
-      <p:pic>
-        <p:nvPicPr>
-          <p:cNvPr id="4" name="Picture 3">
-            <a:extLst>
-              <a:ext uri="{FF2B5EF4-FFF2-40B4-BE49-F238E27FC236}">
-                <a16:creationId xmlns:a16="http://schemas.microsoft.com/office/drawing/2014/main" id="{41DF47A3-6765-02AC-9662-3BE4888994E7}"/>
-              </a:ext>
-            </a:extLst>
-          </p:cNvPr>
-          <p:cNvPicPr>
-            <a:picLocks noChangeAspect="1"/>
-          </p:cNvPicPr>
-          <p:nvPr/>
-        </p:nvPicPr>
-        <p:blipFill>
-          <a:blip r:embed="rId4"/>
-          <a:stretch>
-            <a:fillRect/>
-          </a:stretch>
-        </p:blipFill>
-        <p:spPr>
-          <a:xfrm>
-            <a:off x="386817" y="1291754"/>
-            <a:ext cx="8001934" cy="3808854"/>
-          </a:xfrm>
-          <a:prstGeom prst="rect">
-            <a:avLst/>
-          </a:prstGeom>
-        </p:spPr>
-      </p:pic>
       <p:sp>
         <p:nvSpPr>
           <p:cNvPr id="6" name="Content Placeholder 4">
@@ -35441,7 +35419,7 @@
         </p:nvSpPr>
         <p:spPr bwMode="auto">
           <a:xfrm>
-            <a:off x="3546507" y="5162626"/>
+            <a:off x="3546507" y="5187678"/>
             <a:ext cx="3405438" cy="173038"/>
           </a:xfrm>
           <a:prstGeom prst="rect">
@@ -35673,6 +35651,36 @@
           </a:p>
         </p:txBody>
       </p:sp>
+      <p:pic>
+        <p:nvPicPr>
+          <p:cNvPr id="3" name="Picture 2">
+            <a:extLst>
+              <a:ext uri="{FF2B5EF4-FFF2-40B4-BE49-F238E27FC236}">
+                <a16:creationId xmlns:a16="http://schemas.microsoft.com/office/drawing/2014/main" id="{F696E5C7-6FFD-B49B-8624-BAABC43805A2}"/>
+              </a:ext>
+            </a:extLst>
+          </p:cNvPr>
+          <p:cNvPicPr>
+            <a:picLocks noChangeAspect="1"/>
+          </p:cNvPicPr>
+          <p:nvPr/>
+        </p:nvPicPr>
+        <p:blipFill>
+          <a:blip r:embed="rId4"/>
+          <a:stretch>
+            <a:fillRect/>
+          </a:stretch>
+        </p:blipFill>
+        <p:spPr>
+          <a:xfrm>
+            <a:off x="212942" y="1317008"/>
+            <a:ext cx="8668011" cy="3845618"/>
+          </a:xfrm>
+          <a:prstGeom prst="rect">
+            <a:avLst/>
+          </a:prstGeom>
+        </p:spPr>
+      </p:pic>
     </p:spTree>
     <p:extLst>
       <p:ext uri="{BB962C8B-B14F-4D97-AF65-F5344CB8AC3E}">
@@ -35733,36 +35741,6 @@
           </a:p>
         </p:txBody>
       </p:sp>
-      <p:pic>
-        <p:nvPicPr>
-          <p:cNvPr id="6" name="Picture 5">
-            <a:extLst>
-              <a:ext uri="{FF2B5EF4-FFF2-40B4-BE49-F238E27FC236}">
-                <a16:creationId xmlns:a16="http://schemas.microsoft.com/office/drawing/2014/main" id="{945C1F14-7675-8444-48AB-C2A67E2CF3E5}"/>
-              </a:ext>
-            </a:extLst>
-          </p:cNvPr>
-          <p:cNvPicPr>
-            <a:picLocks noChangeAspect="1"/>
-          </p:cNvPicPr>
-          <p:nvPr/>
-        </p:nvPicPr>
-        <p:blipFill>
-          <a:blip r:embed="rId2"/>
-          <a:stretch>
-            <a:fillRect/>
-          </a:stretch>
-        </p:blipFill>
-        <p:spPr>
-          <a:xfrm>
-            <a:off x="137786" y="364316"/>
-            <a:ext cx="8793272" cy="4635639"/>
-          </a:xfrm>
-          <a:prstGeom prst="rect">
-            <a:avLst/>
-          </a:prstGeom>
-        </p:spPr>
-      </p:pic>
       <p:sp>
         <p:nvSpPr>
           <p:cNvPr id="8" name="Content Placeholder 4">
@@ -36006,11 +35984,41 @@
                   </a:schemeClr>
                 </a:solidFill>
               </a:rPr>
-              <a:t>EM Cautions (3Series) Report</a:t>
+              <a:t>EM Cautions (IC-3xx) Report</a:t>
             </a:r>
           </a:p>
         </p:txBody>
       </p:sp>
+      <p:pic>
+        <p:nvPicPr>
+          <p:cNvPr id="3" name="Picture 2">
+            <a:extLst>
+              <a:ext uri="{FF2B5EF4-FFF2-40B4-BE49-F238E27FC236}">
+                <a16:creationId xmlns:a16="http://schemas.microsoft.com/office/drawing/2014/main" id="{B9E4CC76-4921-CB5E-3F1A-D69145F2B983}"/>
+              </a:ext>
+            </a:extLst>
+          </p:cNvPr>
+          <p:cNvPicPr>
+            <a:picLocks noChangeAspect="1"/>
+          </p:cNvPicPr>
+          <p:nvPr/>
+        </p:nvPicPr>
+        <p:blipFill>
+          <a:blip r:embed="rId2"/>
+          <a:stretch>
+            <a:fillRect/>
+          </a:stretch>
+        </p:blipFill>
+        <p:spPr>
+          <a:xfrm>
+            <a:off x="275573" y="365922"/>
+            <a:ext cx="8642960" cy="4682532"/>
+          </a:xfrm>
+          <a:prstGeom prst="rect">
+            <a:avLst/>
+          </a:prstGeom>
+        </p:spPr>
+      </p:pic>
     </p:spTree>
     <p:extLst>
       <p:ext uri="{BB962C8B-B14F-4D97-AF65-F5344CB8AC3E}">
@@ -36071,36 +36079,6 @@
           </a:p>
         </p:txBody>
       </p:sp>
-      <p:pic>
-        <p:nvPicPr>
-          <p:cNvPr id="6" name="Picture 5">
-            <a:extLst>
-              <a:ext uri="{FF2B5EF4-FFF2-40B4-BE49-F238E27FC236}">
-                <a16:creationId xmlns:a16="http://schemas.microsoft.com/office/drawing/2014/main" id="{9614D226-2F36-D739-4352-9971A02B3564}"/>
-              </a:ext>
-            </a:extLst>
-          </p:cNvPr>
-          <p:cNvPicPr>
-            <a:picLocks noChangeAspect="1"/>
-          </p:cNvPicPr>
-          <p:nvPr/>
-        </p:nvPicPr>
-        <p:blipFill>
-          <a:blip r:embed="rId2"/>
-          <a:stretch>
-            <a:fillRect/>
-          </a:stretch>
-        </p:blipFill>
-        <p:spPr>
-          <a:xfrm>
-            <a:off x="187890" y="360095"/>
-            <a:ext cx="8693063" cy="4669134"/>
-          </a:xfrm>
-          <a:prstGeom prst="rect">
-            <a:avLst/>
-          </a:prstGeom>
-        </p:spPr>
-      </p:pic>
       <p:sp>
         <p:nvSpPr>
           <p:cNvPr id="8" name="Content Placeholder 4">
@@ -36344,11 +36322,41 @@
                   </a:schemeClr>
                 </a:solidFill>
               </a:rPr>
-              <a:t>EM_CIR Cautions Report</a:t>
+              <a:t>CIR Cautions Report</a:t>
             </a:r>
           </a:p>
         </p:txBody>
       </p:sp>
+      <p:pic>
+        <p:nvPicPr>
+          <p:cNvPr id="7" name="Picture 6">
+            <a:extLst>
+              <a:ext uri="{FF2B5EF4-FFF2-40B4-BE49-F238E27FC236}">
+                <a16:creationId xmlns:a16="http://schemas.microsoft.com/office/drawing/2014/main" id="{F27DD873-0504-86D7-3AAA-4BDC4BA67412}"/>
+              </a:ext>
+            </a:extLst>
+          </p:cNvPr>
+          <p:cNvPicPr>
+            <a:picLocks noChangeAspect="1"/>
+          </p:cNvPicPr>
+          <p:nvPr/>
+        </p:nvPicPr>
+        <p:blipFill>
+          <a:blip r:embed="rId2"/>
+          <a:stretch>
+            <a:fillRect/>
+          </a:stretch>
+        </p:blipFill>
+        <p:spPr>
+          <a:xfrm>
+            <a:off x="237995" y="347569"/>
+            <a:ext cx="8693064" cy="4669134"/>
+          </a:xfrm>
+          <a:prstGeom prst="rect">
+            <a:avLst/>
+          </a:prstGeom>
+        </p:spPr>
+      </p:pic>
     </p:spTree>
     <p:extLst>
       <p:ext uri="{BB962C8B-B14F-4D97-AF65-F5344CB8AC3E}">
@@ -36409,36 +36417,6 @@
           </a:p>
         </p:txBody>
       </p:sp>
-      <p:pic>
-        <p:nvPicPr>
-          <p:cNvPr id="6" name="Picture 5">
-            <a:extLst>
-              <a:ext uri="{FF2B5EF4-FFF2-40B4-BE49-F238E27FC236}">
-                <a16:creationId xmlns:a16="http://schemas.microsoft.com/office/drawing/2014/main" id="{5582F9CE-270D-9AD3-CD3A-7B350775E511}"/>
-              </a:ext>
-            </a:extLst>
-          </p:cNvPr>
-          <p:cNvPicPr>
-            <a:picLocks noChangeAspect="1"/>
-          </p:cNvPicPr>
-          <p:nvPr/>
-        </p:nvPicPr>
-        <p:blipFill>
-          <a:blip r:embed="rId2"/>
-          <a:stretch>
-            <a:fillRect/>
-          </a:stretch>
-        </p:blipFill>
-        <p:spPr>
-          <a:xfrm>
-            <a:off x="200416" y="392609"/>
-            <a:ext cx="8780746" cy="4679261"/>
-          </a:xfrm>
-          <a:prstGeom prst="rect">
-            <a:avLst/>
-          </a:prstGeom>
-        </p:spPr>
-      </p:pic>
       <p:sp>
         <p:nvSpPr>
           <p:cNvPr id="8" name="Content Placeholder 4">
@@ -36687,6 +36665,36 @@
           </a:p>
         </p:txBody>
       </p:sp>
+      <p:pic>
+        <p:nvPicPr>
+          <p:cNvPr id="7" name="Picture 6">
+            <a:extLst>
+              <a:ext uri="{FF2B5EF4-FFF2-40B4-BE49-F238E27FC236}">
+                <a16:creationId xmlns:a16="http://schemas.microsoft.com/office/drawing/2014/main" id="{05F8967B-FE31-1E10-583D-551A1C4A85B2}"/>
+              </a:ext>
+            </a:extLst>
+          </p:cNvPr>
+          <p:cNvPicPr>
+            <a:picLocks noChangeAspect="1"/>
+          </p:cNvPicPr>
+          <p:nvPr/>
+        </p:nvPicPr>
+        <p:blipFill>
+          <a:blip r:embed="rId2"/>
+          <a:stretch>
+            <a:fillRect/>
+          </a:stretch>
+        </p:blipFill>
+        <p:spPr>
+          <a:xfrm>
+            <a:off x="225468" y="344219"/>
+            <a:ext cx="8718116" cy="4675833"/>
+          </a:xfrm>
+          <a:prstGeom prst="rect">
+            <a:avLst/>
+          </a:prstGeom>
+        </p:spPr>
+      </p:pic>
     </p:spTree>
     <p:extLst>
       <p:ext uri="{BB962C8B-B14F-4D97-AF65-F5344CB8AC3E}">
@@ -36747,36 +36755,6 @@
           </a:p>
         </p:txBody>
       </p:sp>
-      <p:pic>
-        <p:nvPicPr>
-          <p:cNvPr id="6" name="Picture 5">
-            <a:extLst>
-              <a:ext uri="{FF2B5EF4-FFF2-40B4-BE49-F238E27FC236}">
-                <a16:creationId xmlns:a16="http://schemas.microsoft.com/office/drawing/2014/main" id="{7594E130-9C51-19E4-E4AF-DAE50C263CA1}"/>
-              </a:ext>
-            </a:extLst>
-          </p:cNvPr>
-          <p:cNvPicPr>
-            <a:picLocks noChangeAspect="1"/>
-          </p:cNvPicPr>
-          <p:nvPr/>
-        </p:nvPicPr>
-        <p:blipFill>
-          <a:blip r:embed="rId2"/>
-          <a:stretch>
-            <a:fillRect/>
-          </a:stretch>
-        </p:blipFill>
-        <p:spPr>
-          <a:xfrm>
-            <a:off x="187890" y="367557"/>
-            <a:ext cx="8880954" cy="4679261"/>
-          </a:xfrm>
-          <a:prstGeom prst="rect">
-            <a:avLst/>
-          </a:prstGeom>
-        </p:spPr>
-      </p:pic>
       <p:sp>
         <p:nvSpPr>
           <p:cNvPr id="8" name="Content Placeholder 4">
@@ -36793,7 +36771,7 @@
         </p:nvSpPr>
         <p:spPr bwMode="auto">
           <a:xfrm>
-            <a:off x="3478688" y="5120802"/>
+            <a:off x="3478688" y="5108276"/>
             <a:ext cx="3961771" cy="378123"/>
           </a:xfrm>
           <a:prstGeom prst="rect">
@@ -37025,6 +37003,36 @@
           </a:p>
         </p:txBody>
       </p:sp>
+      <p:pic>
+        <p:nvPicPr>
+          <p:cNvPr id="3" name="Picture 2">
+            <a:extLst>
+              <a:ext uri="{FF2B5EF4-FFF2-40B4-BE49-F238E27FC236}">
+                <a16:creationId xmlns:a16="http://schemas.microsoft.com/office/drawing/2014/main" id="{0364DF5C-A5EE-2E95-9864-D888F4C986A8}"/>
+              </a:ext>
+            </a:extLst>
+          </p:cNvPr>
+          <p:cNvPicPr>
+            <a:picLocks noChangeAspect="1"/>
+          </p:cNvPicPr>
+          <p:nvPr/>
+        </p:nvPicPr>
+        <p:blipFill>
+          <a:blip r:embed="rId2"/>
+          <a:stretch>
+            <a:fillRect/>
+          </a:stretch>
+        </p:blipFill>
+        <p:spPr>
+          <a:xfrm>
+            <a:off x="225468" y="329979"/>
+            <a:ext cx="8680537" cy="4679261"/>
+          </a:xfrm>
+          <a:prstGeom prst="rect">
+            <a:avLst/>
+          </a:prstGeom>
+        </p:spPr>
+      </p:pic>
     </p:spTree>
     <p:extLst>
       <p:ext uri="{BB962C8B-B14F-4D97-AF65-F5344CB8AC3E}">
@@ -39452,18 +39460,13 @@
               <a:buChar char="•"/>
             </a:pPr>
             <a:r>
-              <a:rPr lang="en-US" sz="1400" b="0">
+              <a:rPr lang="en-US" sz="1400" b="0" dirty="0">
                 <a:solidFill>
                   <a:schemeClr val="accent2"/>
                 </a:solidFill>
               </a:rPr>
               <a:t>SP 72-51 (EM &amp; CIR)</a:t>
             </a:r>
-            <a:endParaRPr lang="en-US" sz="1400" b="0" dirty="0">
-              <a:solidFill>
-                <a:schemeClr val="accent2"/>
-              </a:solidFill>
-            </a:endParaRPr>
           </a:p>
           <a:p>
             <a:endParaRPr lang="en-US" sz="1400" b="0" dirty="0">
@@ -40069,7 +40072,7 @@
           <p:nvPr>
             <p:extLst>
               <p:ext uri="{D42A27DB-BD31-4B8C-83A1-F6EECF244321}">
-                <p14:modId xmlns:p14="http://schemas.microsoft.com/office/powerpoint/2010/main" val="859087864"/>
+                <p14:modId xmlns:p14="http://schemas.microsoft.com/office/powerpoint/2010/main" val="1342030970"/>
               </p:ext>
             </p:extLst>
           </p:nvPr>
@@ -40179,7 +40182,7 @@
                       <a:pPr algn="ctr"/>
                       <a:r>
                         <a:rPr lang="en-US" dirty="0"/>
-                        <a:t>26-Aug-2026</a:t>
+                        <a:t>28-Aug-2026</a:t>
                       </a:r>
                     </a:p>
                   </a:txBody>
@@ -40275,7 +40278,15 @@
             </a:r>
             <a:r>
               <a:rPr lang="en-US" sz="1600" dirty="0"/>
-              <a:t>PW1100G Inspection Task_Caution Extraction Tool</a:t>
+              <a:t>PW1100G </a:t>
+            </a:r>
+            <a:r>
+              <a:rPr lang="en-US" sz="1600" dirty="0" err="1"/>
+              <a:t>Manual_CAUTIONS</a:t>
+            </a:r>
+            <a:r>
+              <a:rPr lang="en-US" sz="1600" dirty="0"/>
+              <a:t> Extraction Tool</a:t>
             </a:r>
             <a:r>
               <a:rPr lang="en-US" sz="1600" b="0" dirty="0"/>
@@ -40668,10 +40679,10 @@
       </p:sp>
       <p:pic>
         <p:nvPicPr>
-          <p:cNvPr id="8" name="Picture 7">
+          <p:cNvPr id="3" name="Picture 2">
             <a:extLst>
               <a:ext uri="{FF2B5EF4-FFF2-40B4-BE49-F238E27FC236}">
-                <a16:creationId xmlns:a16="http://schemas.microsoft.com/office/drawing/2014/main" id="{BA70ECE1-F3FC-3CB5-E158-3AFBE1B39C9D}"/>
+                <a16:creationId xmlns:a16="http://schemas.microsoft.com/office/drawing/2014/main" id="{FC0049E0-279A-5ED7-86C7-6B2FFBD8351F}"/>
               </a:ext>
             </a:extLst>
           </p:cNvPr>
@@ -40688,8 +40699,8 @@
         </p:blipFill>
         <p:spPr>
           <a:xfrm>
-            <a:off x="580468" y="1266603"/>
-            <a:ext cx="7983064" cy="3181794"/>
+            <a:off x="570941" y="1242787"/>
+            <a:ext cx="8002117" cy="3229426"/>
           </a:xfrm>
           <a:prstGeom prst="rect">
             <a:avLst/>
@@ -40901,10 +40912,10 @@
       </p:sp>
       <p:pic>
         <p:nvPicPr>
-          <p:cNvPr id="5" name="Picture 4">
+          <p:cNvPr id="3" name="Picture 2">
             <a:extLst>
               <a:ext uri="{FF2B5EF4-FFF2-40B4-BE49-F238E27FC236}">
-                <a16:creationId xmlns:a16="http://schemas.microsoft.com/office/drawing/2014/main" id="{C605929B-3343-BA97-6880-A48E400BED6F}"/>
+                <a16:creationId xmlns:a16="http://schemas.microsoft.com/office/drawing/2014/main" id="{842EA972-C3FE-FD00-9A00-87425C835432}"/>
               </a:ext>
             </a:extLst>
           </p:cNvPr>
@@ -40921,8 +40932,8 @@
         </p:blipFill>
         <p:spPr>
           <a:xfrm>
-            <a:off x="561415" y="1257076"/>
-            <a:ext cx="8021169" cy="3200847"/>
+            <a:off x="570941" y="1247550"/>
+            <a:ext cx="8002117" cy="3219899"/>
           </a:xfrm>
           <a:prstGeom prst="rect">
             <a:avLst/>
@@ -40965,6 +40976,36 @@
           <a:chExt cx="0" cy="0"/>
         </a:xfrm>
       </p:grpSpPr>
+      <p:pic>
+        <p:nvPicPr>
+          <p:cNvPr id="15" name="Picture 14">
+            <a:extLst>
+              <a:ext uri="{FF2B5EF4-FFF2-40B4-BE49-F238E27FC236}">
+                <a16:creationId xmlns:a16="http://schemas.microsoft.com/office/drawing/2014/main" id="{2AC9509A-66A2-6AFF-1465-E3A3C35D7854}"/>
+              </a:ext>
+            </a:extLst>
+          </p:cNvPr>
+          <p:cNvPicPr>
+            <a:picLocks noChangeAspect="1"/>
+          </p:cNvPicPr>
+          <p:nvPr/>
+        </p:nvPicPr>
+        <p:blipFill>
+          <a:blip r:embed="rId2"/>
+          <a:stretch>
+            <a:fillRect/>
+          </a:stretch>
+        </p:blipFill>
+        <p:spPr>
+          <a:xfrm>
+            <a:off x="570941" y="1247550"/>
+            <a:ext cx="8002117" cy="3219899"/>
+          </a:xfrm>
+          <a:prstGeom prst="rect">
+            <a:avLst/>
+          </a:prstGeom>
+        </p:spPr>
+      </p:pic>
       <p:sp>
         <p:nvSpPr>
           <p:cNvPr id="4" name="Slide Number Placeholder 3">
@@ -41138,36 +41179,6 @@
           </a:p>
         </p:txBody>
       </p:sp>
-      <p:pic>
-        <p:nvPicPr>
-          <p:cNvPr id="5" name="Picture 4">
-            <a:extLst>
-              <a:ext uri="{FF2B5EF4-FFF2-40B4-BE49-F238E27FC236}">
-                <a16:creationId xmlns:a16="http://schemas.microsoft.com/office/drawing/2014/main" id="{5B7B31AD-DD0E-E566-5E35-7E09EE8EFE14}"/>
-              </a:ext>
-            </a:extLst>
-          </p:cNvPr>
-          <p:cNvPicPr>
-            <a:picLocks noChangeAspect="1"/>
-          </p:cNvPicPr>
-          <p:nvPr/>
-        </p:nvPicPr>
-        <p:blipFill>
-          <a:blip r:embed="rId2"/>
-          <a:stretch>
-            <a:fillRect/>
-          </a:stretch>
-        </p:blipFill>
-        <p:spPr>
-          <a:xfrm>
-            <a:off x="561415" y="1257076"/>
-            <a:ext cx="8021169" cy="3200847"/>
-          </a:xfrm>
-          <a:prstGeom prst="rect">
-            <a:avLst/>
-          </a:prstGeom>
-        </p:spPr>
-      </p:pic>
       <p:sp>
         <p:nvSpPr>
           <p:cNvPr id="2" name="Title 4">
@@ -43826,6 +43837,15 @@
 </file>
 
 <file path=customXml/item2.xml><?xml version="1.0" encoding="utf-8"?>
+<?mso-contentType ?>
+<FormTemplates xmlns="http://schemas.microsoft.com/sharepoint/v3/contenttype/forms">
+  <Display>DocumentLibraryForm</Display>
+  <Edit>DocumentLibraryForm</Edit>
+  <New>DocumentLibraryForm</New>
+</FormTemplates>
+</file>
+
+<file path=customXml/item3.xml><?xml version="1.0" encoding="utf-8"?>
 <ct:contentTypeSchema xmlns:ct="http://schemas.microsoft.com/office/2006/metadata/contentType" xmlns:ma="http://schemas.microsoft.com/office/2006/metadata/properties/metaAttributes" ct:_="" ma:_="" ma:contentTypeName="Document" ma:contentTypeID="0x010100AADF239F2ED0534CBEE452B336985728" ma:contentTypeVersion="4" ma:contentTypeDescription="Create a new document." ma:contentTypeScope="" ma:versionID="6a7824fc007c3b206678c4e4d6201abd">
   <xsd:schema xmlns:xsd="http://www.w3.org/2001/XMLSchema" xmlns:xs="http://www.w3.org/2001/XMLSchema" xmlns:p="http://schemas.microsoft.com/office/2006/metadata/properties" xmlns:ns1="http://schemas.microsoft.com/sharepoint/v3" xmlns:ns2="2613b0ce-4e5a-4068-84c6-4aae3ccc9c8a" xmlns:ns3="077667ae-fd08-4bd8-a603-c9f8c202c5e0" targetNamespace="http://schemas.microsoft.com/office/2006/metadata/properties" ma:root="true" ma:fieldsID="86c3fa7aeb19401307e35c1f80bf319a" ns1:_="" ns2:_="" ns3:_="">
     <xsd:import namespace="http://schemas.microsoft.com/sharepoint/v3"/>
@@ -43983,15 +44003,6 @@
 </ct:contentTypeSchema>
 </file>
 
-<file path=customXml/item3.xml><?xml version="1.0" encoding="utf-8"?>
-<?mso-contentType ?>
-<FormTemplates xmlns="http://schemas.microsoft.com/sharepoint/v3/contenttype/forms">
-  <Display>DocumentLibraryForm</Display>
-  <Edit>DocumentLibraryForm</Edit>
-  <New>DocumentLibraryForm</New>
-</FormTemplates>
-</file>
-
 <file path=customXml/itemProps1.xml><?xml version="1.0" encoding="utf-8"?>
 <ds:datastoreItem xmlns:ds="http://schemas.openxmlformats.org/officeDocument/2006/customXml" ds:itemID="{05FFBBF1-4683-4EE9-8FE4-EED661D9A09E}">
   <ds:schemaRefs>
@@ -44011,6 +44022,14 @@
 </file>
 
 <file path=customXml/itemProps2.xml><?xml version="1.0" encoding="utf-8"?>
+<ds:datastoreItem xmlns:ds="http://schemas.openxmlformats.org/officeDocument/2006/customXml" ds:itemID="{EC84B35E-1715-4D43-A2FB-C60A34588830}">
+  <ds:schemaRefs>
+    <ds:schemaRef ds:uri="http://schemas.microsoft.com/sharepoint/v3/contenttype/forms"/>
+  </ds:schemaRefs>
+</ds:datastoreItem>
+</file>
+
+<file path=customXml/itemProps3.xml><?xml version="1.0" encoding="utf-8"?>
 <ds:datastoreItem xmlns:ds="http://schemas.openxmlformats.org/officeDocument/2006/customXml" ds:itemID="{51FB943C-7FAA-4048-9A7F-254B30072A5E}">
   <ds:schemaRefs>
     <ds:schemaRef ds:uri="http://schemas.microsoft.com/office/2006/metadata/contentType"/>
@@ -44028,12 +44047,4 @@
     <ds:schemaRef ds:uri="http://schemas.microsoft.com/internal/obd"/>
   </ds:schemaRefs>
 </ds:datastoreItem>
-</file>
-
-<file path=customXml/itemProps3.xml><?xml version="1.0" encoding="utf-8"?>
-<ds:datastoreItem xmlns:ds="http://schemas.openxmlformats.org/officeDocument/2006/customXml" ds:itemID="{EC84B35E-1715-4D43-A2FB-C60A34588830}">
-  <ds:schemaRefs>
-    <ds:schemaRef ds:uri="http://schemas.microsoft.com/sharepoint/v3/contenttype/forms"/>
-  </ds:schemaRefs>
-</ds:datastoreItem>
 </file>
</xml_diff>